<commit_message>
Corrige dados de NA periférica e do 65 trial
- Timing e via: metanálise de Tran 2020 com 7% de complicações (96%
  leves); retiradas afirmações sem fonte (9 estudos, cateter ≥20G).
  Notas: corrigida a relação entre dose em sal e em base.
- Alvo de PAM (notas): exposição a vasopressor no 65 trial com os
  valores do artigo (46,0 vs. 55,9 h; 31,5 vs. 44,3 mg).
- PPTX regenerado e resumo para o Codex atualizado.

Co-Authored-By: Claude Opus 5.5 <noreply@anthropic.com>
Claude-Session: https://claude.ai/code/session_01W6cLQUtwNHu1UUeBJH2XLT
</commit_message>
<xml_diff>
--- a/apresentacao/Aminas_Vasoativas.pptx
+++ b/apresentacao/Aminas_Vasoativas.pptx
@@ -128,20 +128,20 @@
   <p:extLst>
     <p:ext uri="{521415D9-36F7-43E2-AB2F-B90AF26B5E84}">
       <p14:sectionLst xmlns:p14="http://schemas.microsoft.com/office/powerpoint/2010/main">
-        <p14:section name="Abertura e roteiro" id="{51df6777-851e-eb0f-0cd0-aeda559ea2cc}">
+        <p14:section name="Abertura e roteiro" id="{e1b2a64c-7e60-5387-44b7-be2cd275187f}">
           <p14:sldIdLst>
             <p14:sldId id="256"/>
             <p14:sldId id="257"/>
           </p14:sldIdLst>
         </p14:section>
-        <p14:section name="Fisiologia da pressão arterial e farmacologia dos receptores" id="{86a57b49-d400-ff15-cde9-f0645d64ffb6}">
+        <p14:section name="Fisiologia da pressão arterial e farmacologia dos receptores" id="{03e225b2-38ee-47dd-2b2e-1e58ec70fa46}">
           <p14:sldIdLst>
             <p14:sldId id="258"/>
             <p14:sldId id="259"/>
             <p14:sldId id="260"/>
           </p14:sldIdLst>
         </p14:section>
-        <p14:section name="Drogas individuais e síntese comparativa" id="{2c2d34e2-f23e-18f7-d565-33d89477515e}">
+        <p14:section name="Drogas individuais e síntese comparativa" id="{afc0e402-b9a6-8b38-4bb3-d9f83f212c58}">
           <p14:sldIdLst>
             <p14:sldId id="261"/>
             <p14:sldId id="262"/>
@@ -153,26 +153,26 @@
             <p14:sldId id="268"/>
           </p14:sldIdLst>
         </p14:section>
-        <p14:section name="Além das aminas: vasopressina e adjuvantes do choque refratário" id="{9ffd17c6-56f9-4d37-2cde-a6147efc91e3}">
+        <p14:section name="Além das aminas: vasopressina e adjuvantes do choque refratário" id="{06a0f500-d39f-1757-9227-3521e5a86d1b}">
           <p14:sldIdLst>
             <p14:sldId id="269"/>
             <p14:sldId id="270"/>
           </p14:sldIdLst>
         </p14:section>
-        <p14:section name="Choque séptico: sequência, alvo de PAM e timing" id="{fbcafcae-848b-cc96-778d-04e6acbf032e}">
+        <p14:section name="Choque séptico: sequência, alvo de PAM e timing" id="{282a41b7-bc78-1350-bec1-e0ce561b49ea}">
           <p14:sldIdLst>
             <p14:sldId id="271"/>
             <p14:sldId id="272"/>
             <p14:sldId id="273"/>
           </p14:sldIdLst>
         </p14:section>
-        <p14:section name="Perioperatório: escolha da droga e alvo de PA" id="{49d5a5fa-c253-ffde-5f9d-262dacf2a226}">
+        <p14:section name="Perioperatório: escolha da droga e alvo de PA" id="{01c62c60-8023-ff2e-4df8-1287455a4ec8}">
           <p14:sldIdLst>
             <p14:sldId id="274"/>
             <p14:sldId id="275"/>
           </p14:sldIdLst>
         </p14:section>
-        <p14:section name="Síntese e referências" id="{ad4830b4-855d-947c-f359-db534c273499}">
+        <p14:section name="Síntese e referências" id="{6d129c41-769d-c7ab-0bf8-da3038a0f546}">
           <p14:sldIdLst>
             <p14:sldId id="276"/>
             <p14:sldId id="277"/>
@@ -1286,7 +1286,7 @@
           <a:p>
             <a:r>
               <a:rPr lang="en-US" dirty="0"/>
-              <a:t>65 trial (n = 2.463 na análise primária): a dose mediana de noradrenalina-equivalente caiu de 26,4 para 17,7 mg e a duração de 38 para 33 h, sem sinal de dano; a OR ajustada favoreceu a hipotensão permissiva (0,82). OPTPRESS (29 hospitais japoneses) foi interrompido precocemente por dano: diferença absoluta de 10,7 pontos percentuais (IC 95% 2,6–18,9), com menos dias livres de terapia renal substitutiva no alvo alto. O protocolo associava vasopressina cedo, com NA ≥ 0,1 mcg/kg/min. A ESICM 2025 também sugere alvo menor no trauma com sangramento ativo sem TCE e PAM ≥80 mmHg no TCE grave.</a:t>
+              <a:t>65 trial (n = 2.463 na análise primária): menos exposição a vasopressor no grupo permissivo (duração média 46,0 vs. 55,9 h; dose total média de noradrenalina-equivalente 31,5 vs. 44,3 mg), sem sinal de dano; a OR ajustada favoreceu a hipotensão permissiva (0,82). OPTPRESS (29 hospitais japoneses) foi interrompido precocemente por dano: diferença absoluta de 10,7 pontos percentuais (IC 95% 2,6–18,9), com menos dias livres de terapia renal substitutiva no alvo alto. O protocolo associava vasopressina cedo, com NA ≥ 0,1 mcg/kg/min. A ESICM 2025 também sugere alvo menor no trauma com sangramento ativo sem TCE e PAM ≥80 mmHg no TCE grave.</a:t>
             </a:r>
             <a:endParaRPr lang="en-US" dirty="0"/>
           </a:p>
@@ -1374,7 +1374,7 @@
           <a:p>
             <a:r>
               <a:rPr lang="en-US" dirty="0"/>
-              <a:t>CENSER (n = 310): dose fixa, não titulada, por 24 h; mortalidade em 28 dias 15,5% vs. 21,9% (NS). Na revisão de Tran, alguns estudos relataram infusão periférica segura até 0,1 mcg/kg/min por até 24 h; a maioria era observacional. Na prática: veia calibrosa e proximal, inspeção frequente do sítio, plano para acesso central se a dose subir ou a infusão se prolongar; em extravasamento, fentolamina local. Dose em sal versus base: a carta de Ibarra-Estrada (ICM 2024) defende reportar sempre como base, porque o rótulo em sal subestima a dose real em cerca de metade.</a:t>
+              <a:t>CENSER (n = 310): dose fixa, não titulada, por 24 h; mortalidade em 28 dias 15,5% vs. 21,9% (NS). Na metanálise de Tran (Am J Emerg Med 2020), houve 122 complicações em 1.835 pacientes (7%), 96% delas leves. Na prática: veia calibrosa e proximal, inspeção frequente do sítio, plano para acesso central se a dose subir ou a infusão se prolongar; em extravasamento, fentolamina local. Dose em sal versus base: Ibarra-Estrada, Kattan e Jung (ICM 2024) defendem padronizar logo o relato da dose; a mesma infusão expressa em sal dá o dobro do número em base (0,1 mcg/kg/min de sal ≈ 0,05 de base).</a:t>
             </a:r>
             <a:endParaRPr lang="en-US" dirty="0"/>
           </a:p>
@@ -13783,14 +13783,14 @@
       </p:sp>
       <p:sp>
         <p:nvSpPr>
-          <p:cNvPr id="11" name="Revisão de 9 estudos (n = 1.835): ~9% de"/>
+          <p:cNvPr id="11" name="Metanálise de Tran (n = 1.835): 7% de co"/>
           <p:cNvSpPr txBox="1"/>
           <p:nvPr/>
         </p:nvSpPr>
         <p:spPr>
           <a:xfrm>
             <a:off x="4662984" y="2517088"/>
-            <a:ext cx="2884984" cy="1739801"/>
+            <a:ext cx="2884984" cy="1491258"/>
           </a:xfrm>
           <a:prstGeom prst="rect">
             <a:avLst/>
@@ -13817,7 +13817,7 @@
                 <a:ea typeface="Arial" pitchFamily="34" charset="-122"/>
                 <a:cs typeface="Arial" pitchFamily="34" charset="-120"/>
               </a:rPr>
-              <a:t>Revisão de 9 estudos (n = 1.835): ~9% de complicações, quase todas extravasamento e raramente com necessidade de tratamento. Cateter ≥20G associado a menos eventos. SSC 2026: iniciar periférico em vez de esperar acesso central.</a:t>
+              <a:t>Metanálise de Tran (n = 1.835): 7% de complicações, 96% delas leves. SSC 2026: iniciar o vasopressor em veia periférica em vez de esperar o acesso central (condicional, certeza muito baixa).</a:t>
             </a:r>
             <a:endParaRPr lang="en-US" sz="1350" dirty="0"/>
           </a:p>

</xml_diff>

<commit_message>
Fala da fisiologia: PAM como DC × RVS + PVC, com a PVC pesando na pressão de perfusão e no retorno venoso; nota com Magder 2018; referência 44
Co-Authored-By: Claude Fable 5.1 <noreply@anthropic.com>
Claude-Session: https://claude.ai/code/session_01W6cLQUtwNHu1UUeBJH2XLT
</commit_message>
<xml_diff>
--- a/apresentacao/Aminas_Vasoativas.pptx
+++ b/apresentacao/Aminas_Vasoativas.pptx
@@ -124,24 +124,24 @@
   <p:extLst>
     <p:ext uri="{521415D9-36F7-43E2-AB2F-B90AF26B5E84}">
       <p14:sectionLst xmlns:p14="http://schemas.microsoft.com/office/powerpoint/2010/main">
-        <p14:section name="Abertura e objetivos" id="{7e890e09-2c26-fb1c-a2d8-715c6ff55771}">
+        <p14:section name="Abertura e objetivos" id="{be187190-f2a2-6375-e3b0-0ab20b466f19}">
           <p14:sldIdLst>
             <p14:sldId id="256"/>
             <p14:sldId id="257"/>
           </p14:sldIdLst>
         </p14:section>
-        <p14:section name="01 · Fisiologia: pressão, débito e perfusão" id="{22d23242-4d59-91d5-3991-ac8b9056ca5c}">
+        <p14:section name="01 · Fisiologia: pressão, débito e perfusão" id="{ab9e0c0e-cddd-0169-7b1b-2547b802fd5a}">
           <p14:sldIdLst>
             <p14:sldId id="258"/>
             <p14:sldId id="259"/>
           </p14:sldIdLst>
         </p14:section>
-        <p14:section name="02 · Receptores e vias de sinalização" id="{093a4b0a-27e9-3356-8596-71fdf99ad4c1}">
+        <p14:section name="02 · Receptores e vias de sinalização" id="{b053aaf9-8785-a710-297c-61408172cfd5}">
           <p14:sldIdLst>
             <p14:sldId id="260"/>
           </p14:sldIdLst>
         </p14:section>
-        <p14:section name="03 · Drogas: noradrenalina, adrenalina, dobutamina (e dopamina), milrinona (escolha e falência de VD), fenilefrina e efedrina" id="{5fbb48be-c63d-0af0-276c-f98a6c08bd8e}">
+        <p14:section name="03 · Drogas: noradrenalina, adrenalina, dobutamina (e dopamina), milrinona (escolha e falência de VD), fenilefrina e efedrina" id="{f46c91cc-b951-4771-6754-c58376eaadcc}">
           <p14:sldIdLst>
             <p14:sldId id="261"/>
             <p14:sldId id="262"/>
@@ -152,23 +152,23 @@
             <p14:sldId id="267"/>
           </p14:sldIdLst>
         </p14:section>
-        <p14:section name="04 · Além das aminas: vasopressina e adjuvantes" id="{d6b6ff33-4655-fba1-3962-29e5d8b36178}">
+        <p14:section name="04 · Além das aminas: vasopressina e adjuvantes" id="{60f47da3-c0d6-f85d-b88e-45eff9658332}">
           <p14:sldIdLst>
             <p14:sldId id="268"/>
           </p14:sldIdLst>
         </p14:section>
-        <p14:section name="05 · Choque séptico: a sequência da SSC 2026" id="{818dfb28-ddba-75bc-48dd-50502df58527}">
+        <p14:section name="05 · Choque séptico: a sequência da SSC 2026" id="{3b8f62b0-9ea9-9aa4-53bb-de1d9eda4a4a}">
           <p14:sldIdLst>
             <p14:sldId id="269"/>
           </p14:sldIdLst>
         </p14:section>
-        <p14:section name="06 · Perioperatório: escolha da droga e alvo de pressão" id="{aedf97ad-865c-d55a-c843-0f96708836e9}">
+        <p14:section name="06 · Perioperatório: escolha da droga e alvo de pressão" id="{80b423df-6d8c-cc60-2200-1acc78bc3f79}">
           <p14:sldIdLst>
             <p14:sldId id="270"/>
             <p14:sldId id="271"/>
           </p14:sldIdLst>
         </p14:section>
-        <p14:section name="07 · Mensagens finais e encerramento" id="{d53d3804-6951-6612-0d80-a8c6e65294b2}">
+        <p14:section name="07 · Mensagens finais e encerramento" id="{9acaaacf-565a-ce4c-f37e-017b0a99a26c}">
           <p14:sldIdLst>
             <p14:sldId id="272"/>
             <p14:sldId id="273"/>
@@ -592,7 +592,7 @@
           <a:p>
             <a:r>
               <a:rPr lang="en-US" dirty="0"/>
-              <a:t>TEMPO: 25 s (0:00 → 0:25). Total previsto: 13 min 30 s nos 18 slides; ensaiar mirando 15 minutos.</a:t>
+              <a:t>TEMPO: 25 s (0:00 → 0:25). Total previsto: 13 min 45 s nos 18 slides; ensaiar mirando 15 minutos.</a:t>
             </a:r>
             <a:endParaRPr lang="en-US" dirty="0"/>
           </a:p>
@@ -701,7 +701,7 @@
           <a:p>
             <a:r>
               <a:rPr lang="en-US" dirty="0"/>
-              <a:t>TEMPO: 1 min 15 s (6:15 → 7:30)</a:t>
+              <a:t>TEMPO: 1 min 15 s (6:30 → 7:45)</a:t>
             </a:r>
             <a:endParaRPr lang="en-US" dirty="0"/>
           </a:p>
@@ -817,7 +817,7 @@
           <a:p>
             <a:r>
               <a:rPr lang="en-US" dirty="0"/>
-              <a:t>TEMPO: 45 s (7:30 → 8:15)</a:t>
+              <a:t>TEMPO: 45 s (7:45 → 8:30)</a:t>
             </a:r>
             <a:endParaRPr lang="en-US" dirty="0"/>
           </a:p>
@@ -933,7 +933,7 @@
           <a:p>
             <a:r>
               <a:rPr lang="en-US" dirty="0"/>
-              <a:t>TEMPO: 50 s (8:15 → 9:05)</a:t>
+              <a:t>TEMPO: 50 s (8:30 → 9:20)</a:t>
             </a:r>
             <a:endParaRPr lang="en-US" dirty="0"/>
           </a:p>
@@ -1042,7 +1042,7 @@
           <a:p>
             <a:r>
               <a:rPr lang="en-US" dirty="0"/>
-              <a:t>TEMPO: 45 s (9:05 → 9:50)</a:t>
+              <a:t>TEMPO: 45 s (9:20 → 10:05)</a:t>
             </a:r>
             <a:endParaRPr lang="en-US" dirty="0"/>
           </a:p>
@@ -1158,7 +1158,7 @@
           <a:p>
             <a:r>
               <a:rPr lang="en-US" dirty="0"/>
-              <a:t>TEMPO: 50 s (9:50 → 10:40)</a:t>
+              <a:t>TEMPO: 50 s (10:05 → 10:55)</a:t>
             </a:r>
             <a:endParaRPr lang="en-US" dirty="0"/>
           </a:p>
@@ -1274,7 +1274,7 @@
           <a:p>
             <a:r>
               <a:rPr lang="en-US" dirty="0"/>
-              <a:t>TEMPO: 1 min 5 s (10:40 → 11:45)</a:t>
+              <a:t>TEMPO: 1 min 5 s (10:55 → 12:00)</a:t>
             </a:r>
             <a:endParaRPr lang="en-US" dirty="0"/>
           </a:p>
@@ -1390,7 +1390,7 @@
           <a:p>
             <a:r>
               <a:rPr lang="en-US" dirty="0"/>
-              <a:t>TEMPO: 1 min (11:45 → 12:45)</a:t>
+              <a:t>TEMPO: 1 min (12:00 → 13:00)</a:t>
             </a:r>
             <a:endParaRPr lang="en-US" dirty="0"/>
           </a:p>
@@ -1506,7 +1506,7 @@
           <a:p>
             <a:r>
               <a:rPr lang="en-US" dirty="0"/>
-              <a:t>TEMPO: 35 s (12:45 → 13:20)</a:t>
+              <a:t>TEMPO: 35 s (13:00 → 13:35)</a:t>
             </a:r>
             <a:endParaRPr lang="en-US" dirty="0"/>
           </a:p>
@@ -1608,7 +1608,7 @@
           <a:p>
             <a:r>
               <a:rPr lang="en-US" dirty="0"/>
-              <a:t>TEMPO: 10 s (13:20 → 13:30)</a:t>
+              <a:t>TEMPO: 10 s (13:35 → 13:45)</a:t>
             </a:r>
             <a:endParaRPr lang="en-US" dirty="0"/>
           </a:p>
@@ -1812,7 +1812,7 @@
           <a:p>
             <a:r>
               <a:rPr lang="en-US" dirty="0"/>
-              <a:t>FALA: A PAM é o produto do débito cardíaco pela resistência vascular sistêmica, somado à pressão venosa central, que pesa quando está alta, porque reduz a pressão de perfusão. Na vasoplegia o problema é o tônus arterial: sepse, anestesia geral, bloqueio de neuroeixo, anafilaxia, saída de CEC; as causas anestésicas e a anafilaxia somam venodilatação. Na falência de bomba o débito é baixo, em geral com resistência alta; na sepse, a disfunção miocárdica pode coexistir com vasoplegia. Na pré-carga baixa, a hipovolemia pede volume; o α1 também contrai veias e recruta volume não estressado, elevando o retorno venoso. Para diferenciar: eco precoce, parâmetros dinâmicos e perfusão seriada.</a:t>
+              <a:t>FALA: A PAM é, aproximadamente, o débito cardíaco vezes a resistência vascular sistêmica, mais a pressão venosa central. A PVC costuma ser pequena; quando sobe, importa menos por elevar a PAM e mais porque reduz a pressão de perfusão dos órgãos, que é a PAM menos a PVC, e o gradiente do retorno venoso. Na vasoplegia o problema é o tônus arterial: sepse, anestesia geral, bloqueio de neuroeixo, anafilaxia, saída de CEC; as causas anestésicas e a anafilaxia somam venodilatação. Na falência de bomba o débito é baixo, em geral com resistência alta; na sepse, a disfunção miocárdica pode coexistir com vasoplegia. Na pré-carga baixa, a hipovolemia pede volume; o α1 também contrai veias e recruta volume não estressado, elevando o retorno venoso. Para diferenciar: eco precoce, parâmetros dinâmicos e perfusão seriada.</a:t>
             </a:r>
             <a:endParaRPr lang="en-US" dirty="0"/>
           </a:p>
@@ -1826,7 +1826,7 @@
           <a:p>
             <a:r>
               <a:rPr lang="en-US" dirty="0"/>
-              <a:t>TEMPO: 50 s (0:55 → 1:45)</a:t>
+              <a:t>TEMPO: 1 min 5 s (0:55 → 2:00)</a:t>
             </a:r>
             <a:endParaRPr lang="en-US" dirty="0"/>
           </a:p>
@@ -1840,7 +1840,7 @@
           <a:p>
             <a:r>
               <a:rPr lang="en-US" dirty="0"/>
-              <a:t>SE PERGUNTAREM: Persichini (Crit Care Med 2012; 16 pacientes com choque séptico): reduzir a dose de noradrenalina baixou a pressão sistêmica média e o retorno venoso, mais do que a resistência ao retorno venoso, com queda do débito; é a prova de que a venoconstrição α recruta volume não estressado. o esquema cobre os determinantes da PAM; a obstrução (tamponamento, embolia pulmonar, pneumotórax hipertensivo, auto-PEEP) é o quarto tipo de choque da classificação da ESICM 2014: o eco precoce a identifica, e o tratamento é da causa, não com amina. No intraoperatório, pneumotórax e compressão aortocava estão entre as causas a afastar (slide 16).</a:t>
+              <a:t>SE PERGUNTAREM: A relação PAM = DC × RVS + PVC é a definição da RVS, não uma causa (Magder, Crit Care 2018): a RVS é calculada como (PAM − PVC)/DC. A pressão a jusante efetiva do leito arterial é uma pressão crítica de fechamento, acima da PVC; a PVC importa para a pressão de perfusão dos órgãos (PAM − PVC) e para o gradiente do retorno venoso (pressão sistêmica média − pressão de átrio direito). Persichini (Crit Care Med 2012; 16 pacientes com choque séptico): reduzir a dose de noradrenalina baixou a pressão sistêmica média e o retorno venoso, mais do que a resistência ao retorno venoso, com queda do débito; é a prova de que a venoconstrição α recruta volume não estressado. o esquema cobre os determinantes da PAM; a obstrução (tamponamento, embolia pulmonar, pneumotórax hipertensivo, auto-PEEP) é o quarto tipo de choque da classificação da ESICM 2014: o eco precoce a identifica, e o tratamento é da causa, não com amina. No intraoperatório, pneumotórax e compressão aortocava estão entre as causas a afastar (slide 16).</a:t>
             </a:r>
             <a:endParaRPr lang="en-US" dirty="0"/>
           </a:p>
@@ -1942,7 +1942,7 @@
           <a:p>
             <a:r>
               <a:rPr lang="en-US" dirty="0"/>
-              <a:t>TEMPO: 45 s (1:45 → 2:30)</a:t>
+              <a:t>TEMPO: 45 s (2:00 → 2:45)</a:t>
             </a:r>
             <a:endParaRPr lang="en-US" dirty="0"/>
           </a:p>
@@ -2058,7 +2058,7 @@
           <a:p>
             <a:r>
               <a:rPr lang="en-US" dirty="0"/>
-              <a:t>TEMPO: 45 s (2:30 → 3:15)</a:t>
+              <a:t>TEMPO: 45 s (2:45 → 3:30)</a:t>
             </a:r>
             <a:endParaRPr lang="en-US" dirty="0"/>
           </a:p>
@@ -2174,7 +2174,7 @@
           <a:p>
             <a:r>
               <a:rPr lang="en-US" dirty="0"/>
-              <a:t>TEMPO: 40 s (3:15 → 3:55)</a:t>
+              <a:t>TEMPO: 40 s (3:30 → 4:10)</a:t>
             </a:r>
             <a:endParaRPr lang="en-US" dirty="0"/>
           </a:p>
@@ -2290,7 +2290,7 @@
           <a:p>
             <a:r>
               <a:rPr lang="en-US" dirty="0"/>
-              <a:t>TEMPO: 45 s (3:55 → 4:40)</a:t>
+              <a:t>TEMPO: 45 s (4:10 → 4:55)</a:t>
             </a:r>
             <a:endParaRPr lang="en-US" dirty="0"/>
           </a:p>
@@ -2406,7 +2406,7 @@
           <a:p>
             <a:r>
               <a:rPr lang="en-US" dirty="0"/>
-              <a:t>TEMPO: 50 s (4:40 → 5:30)</a:t>
+              <a:t>TEMPO: 50 s (4:55 → 5:45)</a:t>
             </a:r>
             <a:endParaRPr lang="en-US" dirty="0"/>
           </a:p>
@@ -2515,7 +2515,7 @@
           <a:p>
             <a:r>
               <a:rPr lang="en-US" dirty="0"/>
-              <a:t>TEMPO: 45 s (5:30 → 6:15)</a:t>
+              <a:t>TEMPO: 45 s (5:45 → 6:30)</a:t>
             </a:r>
             <a:endParaRPr lang="en-US" dirty="0"/>
           </a:p>

</xml_diff>

<commit_message>
Fala do slide 3 em redação mais simples (PAM, PVC e perfusão)
Co-Authored-By: Claude Fable 5.1 <noreply@anthropic.com>
Claude-Session: https://claude.ai/code/session_01W6cLQUtwNHu1UUeBJH2XLT
</commit_message>
<xml_diff>
--- a/apresentacao/Aminas_Vasoativas.pptx
+++ b/apresentacao/Aminas_Vasoativas.pptx
@@ -124,24 +124,24 @@
   <p:extLst>
     <p:ext uri="{521415D9-36F7-43E2-AB2F-B90AF26B5E84}">
       <p14:sectionLst xmlns:p14="http://schemas.microsoft.com/office/powerpoint/2010/main">
-        <p14:section name="Abertura e objetivos" id="{be187190-f2a2-6375-e3b0-0ab20b466f19}">
+        <p14:section name="Abertura e objetivos" id="{cd711a28-39c7-c1fa-0798-20d96930372e}">
           <p14:sldIdLst>
             <p14:sldId id="256"/>
             <p14:sldId id="257"/>
           </p14:sldIdLst>
         </p14:section>
-        <p14:section name="01 · Fisiologia: pressão, débito e perfusão" id="{ab9e0c0e-cddd-0169-7b1b-2547b802fd5a}">
+        <p14:section name="01 · Fisiologia: pressão, débito e perfusão" id="{d524a5dd-60af-1ad3-efc1-f0f8be6cd49f}">
           <p14:sldIdLst>
             <p14:sldId id="258"/>
             <p14:sldId id="259"/>
           </p14:sldIdLst>
         </p14:section>
-        <p14:section name="02 · Receptores e vias de sinalização" id="{b053aaf9-8785-a710-297c-61408172cfd5}">
+        <p14:section name="02 · Receptores e vias de sinalização" id="{8a95d88b-3322-7099-fb9d-c523ffe41894}">
           <p14:sldIdLst>
             <p14:sldId id="260"/>
           </p14:sldIdLst>
         </p14:section>
-        <p14:section name="03 · Drogas: noradrenalina, adrenalina, dobutamina (e dopamina), milrinona (escolha e falência de VD), fenilefrina e efedrina" id="{f46c91cc-b951-4771-6754-c58376eaadcc}">
+        <p14:section name="03 · Drogas: noradrenalina, adrenalina, dobutamina (e dopamina), milrinona (escolha e falência de VD), fenilefrina e efedrina" id="{27cf04d9-6a18-bd25-bfe6-badd75d4f49e}">
           <p14:sldIdLst>
             <p14:sldId id="261"/>
             <p14:sldId id="262"/>
@@ -152,23 +152,23 @@
             <p14:sldId id="267"/>
           </p14:sldIdLst>
         </p14:section>
-        <p14:section name="04 · Além das aminas: vasopressina e adjuvantes" id="{60f47da3-c0d6-f85d-b88e-45eff9658332}">
+        <p14:section name="04 · Além das aminas: vasopressina e adjuvantes" id="{b54529de-f742-9c03-31d1-484ebe3eb57b}">
           <p14:sldIdLst>
             <p14:sldId id="268"/>
           </p14:sldIdLst>
         </p14:section>
-        <p14:section name="05 · Choque séptico: a sequência da SSC 2026" id="{3b8f62b0-9ea9-9aa4-53bb-de1d9eda4a4a}">
+        <p14:section name="05 · Choque séptico: a sequência da SSC 2026" id="{357d9a8f-095f-0dcd-cb19-8c0f813b1c64}">
           <p14:sldIdLst>
             <p14:sldId id="269"/>
           </p14:sldIdLst>
         </p14:section>
-        <p14:section name="06 · Perioperatório: escolha da droga e alvo de pressão" id="{80b423df-6d8c-cc60-2200-1acc78bc3f79}">
+        <p14:section name="06 · Perioperatório: escolha da droga e alvo de pressão" id="{db6f7098-7067-e577-a935-5f992a4ae0ab}">
           <p14:sldIdLst>
             <p14:sldId id="270"/>
             <p14:sldId id="271"/>
           </p14:sldIdLst>
         </p14:section>
-        <p14:section name="07 · Mensagens finais e encerramento" id="{9acaaacf-565a-ce4c-f37e-017b0a99a26c}">
+        <p14:section name="07 · Mensagens finais e encerramento" id="{15985724-abfc-8480-b412-445519f8d3d0}">
           <p14:sldIdLst>
             <p14:sldId id="272"/>
             <p14:sldId id="273"/>
@@ -592,7 +592,7 @@
           <a:p>
             <a:r>
               <a:rPr lang="en-US" dirty="0"/>
-              <a:t>TEMPO: 25 s (0:00 → 0:25). Total previsto: 13 min 45 s nos 18 slides; ensaiar mirando 15 minutos.</a:t>
+              <a:t>TEMPO: 25 s (0:00 → 0:25). Total previsto: 13 min 50 s nos 18 slides; ensaiar mirando 15 minutos.</a:t>
             </a:r>
             <a:endParaRPr lang="en-US" dirty="0"/>
           </a:p>
@@ -701,7 +701,7 @@
           <a:p>
             <a:r>
               <a:rPr lang="en-US" dirty="0"/>
-              <a:t>TEMPO: 1 min 15 s (6:30 → 7:45)</a:t>
+              <a:t>TEMPO: 1 min 15 s (6:35 → 7:50)</a:t>
             </a:r>
             <a:endParaRPr lang="en-US" dirty="0"/>
           </a:p>
@@ -817,7 +817,7 @@
           <a:p>
             <a:r>
               <a:rPr lang="en-US" dirty="0"/>
-              <a:t>TEMPO: 45 s (7:45 → 8:30)</a:t>
+              <a:t>TEMPO: 45 s (7:50 → 8:35)</a:t>
             </a:r>
             <a:endParaRPr lang="en-US" dirty="0"/>
           </a:p>
@@ -933,7 +933,7 @@
           <a:p>
             <a:r>
               <a:rPr lang="en-US" dirty="0"/>
-              <a:t>TEMPO: 50 s (8:30 → 9:20)</a:t>
+              <a:t>TEMPO: 50 s (8:35 → 9:25)</a:t>
             </a:r>
             <a:endParaRPr lang="en-US" dirty="0"/>
           </a:p>
@@ -1042,7 +1042,7 @@
           <a:p>
             <a:r>
               <a:rPr lang="en-US" dirty="0"/>
-              <a:t>TEMPO: 45 s (9:20 → 10:05)</a:t>
+              <a:t>TEMPO: 45 s (9:25 → 10:10)</a:t>
             </a:r>
             <a:endParaRPr lang="en-US" dirty="0"/>
           </a:p>
@@ -1158,7 +1158,7 @@
           <a:p>
             <a:r>
               <a:rPr lang="en-US" dirty="0"/>
-              <a:t>TEMPO: 50 s (10:05 → 10:55)</a:t>
+              <a:t>TEMPO: 50 s (10:10 → 11:00)</a:t>
             </a:r>
             <a:endParaRPr lang="en-US" dirty="0"/>
           </a:p>
@@ -1274,7 +1274,7 @@
           <a:p>
             <a:r>
               <a:rPr lang="en-US" dirty="0"/>
-              <a:t>TEMPO: 1 min 5 s (10:55 → 12:00)</a:t>
+              <a:t>TEMPO: 1 min 5 s (11:00 → 12:05)</a:t>
             </a:r>
             <a:endParaRPr lang="en-US" dirty="0"/>
           </a:p>
@@ -1390,7 +1390,7 @@
           <a:p>
             <a:r>
               <a:rPr lang="en-US" dirty="0"/>
-              <a:t>TEMPO: 1 min (12:00 → 13:00)</a:t>
+              <a:t>TEMPO: 1 min (12:05 → 13:05)</a:t>
             </a:r>
             <a:endParaRPr lang="en-US" dirty="0"/>
           </a:p>
@@ -1506,7 +1506,7 @@
           <a:p>
             <a:r>
               <a:rPr lang="en-US" dirty="0"/>
-              <a:t>TEMPO: 35 s (13:00 → 13:35)</a:t>
+              <a:t>TEMPO: 35 s (13:05 → 13:40)</a:t>
             </a:r>
             <a:endParaRPr lang="en-US" dirty="0"/>
           </a:p>
@@ -1608,7 +1608,7 @@
           <a:p>
             <a:r>
               <a:rPr lang="en-US" dirty="0"/>
-              <a:t>TEMPO: 10 s (13:35 → 13:45)</a:t>
+              <a:t>TEMPO: 10 s (13:40 → 13:50)</a:t>
             </a:r>
             <a:endParaRPr lang="en-US" dirty="0"/>
           </a:p>
@@ -1812,7 +1812,7 @@
           <a:p>
             <a:r>
               <a:rPr lang="en-US" dirty="0"/>
-              <a:t>FALA: A PAM é, aproximadamente, o débito cardíaco vezes a resistência vascular sistêmica, mais a pressão venosa central. A PVC costuma ser pequena; quando sobe, importa menos por elevar a PAM e mais porque reduz a pressão de perfusão dos órgãos, que é a PAM menos a PVC, e o gradiente do retorno venoso. Na vasoplegia o problema é o tônus arterial: sepse, anestesia geral, bloqueio de neuroeixo, anafilaxia, saída de CEC; as causas anestésicas e a anafilaxia somam venodilatação. Na falência de bomba o débito é baixo, em geral com resistência alta; na sepse, a disfunção miocárdica pode coexistir com vasoplegia. Na pré-carga baixa, a hipovolemia pede volume; o α1 também contrai veias e recruta volume não estressado, elevando o retorno venoso. Para diferenciar: eco precoce, parâmetros dinâmicos e perfusão seriada.</a:t>
+              <a:t>FALA: Na prática, a PAM é o débito cardíaco multiplicado pela resistência vascular sistêmica, somado à pressão venosa central. Como a PVC costuma ser baixa, a PAM depende sobretudo do débito e da resistência. Quando a PVC sobe, o problema não é a PAM, é a perfusão: o órgão recebe a diferença entre a PAM e a PVC, e o sangue também volta com mais dificuldade ao coração. Na vasoplegia o problema é o tônus arterial: sepse, anestesia geral, bloqueio de neuroeixo, anafilaxia, saída de CEC; as causas anestésicas e a anafilaxia somam venodilatação. Na falência de bomba o débito é baixo, em geral com resistência alta; na sepse, a disfunção miocárdica pode coexistir com vasoplegia. Na pré-carga baixa, a hipovolemia pede volume; o α1 também contrai veias e recruta volume não estressado, elevando o retorno venoso. Para diferenciar: eco precoce, parâmetros dinâmicos e perfusão seriada.</a:t>
             </a:r>
             <a:endParaRPr lang="en-US" dirty="0"/>
           </a:p>
@@ -1826,7 +1826,7 @@
           <a:p>
             <a:r>
               <a:rPr lang="en-US" dirty="0"/>
-              <a:t>TEMPO: 1 min 5 s (0:55 → 2:00)</a:t>
+              <a:t>TEMPO: 1 min 10 s (0:55 → 2:05)</a:t>
             </a:r>
             <a:endParaRPr lang="en-US" dirty="0"/>
           </a:p>
@@ -1942,7 +1942,7 @@
           <a:p>
             <a:r>
               <a:rPr lang="en-US" dirty="0"/>
-              <a:t>TEMPO: 45 s (2:00 → 2:45)</a:t>
+              <a:t>TEMPO: 45 s (2:05 → 2:50)</a:t>
             </a:r>
             <a:endParaRPr lang="en-US" dirty="0"/>
           </a:p>
@@ -2058,7 +2058,7 @@
           <a:p>
             <a:r>
               <a:rPr lang="en-US" dirty="0"/>
-              <a:t>TEMPO: 45 s (2:45 → 3:30)</a:t>
+              <a:t>TEMPO: 45 s (2:50 → 3:35)</a:t>
             </a:r>
             <a:endParaRPr lang="en-US" dirty="0"/>
           </a:p>
@@ -2174,7 +2174,7 @@
           <a:p>
             <a:r>
               <a:rPr lang="en-US" dirty="0"/>
-              <a:t>TEMPO: 40 s (3:30 → 4:10)</a:t>
+              <a:t>TEMPO: 40 s (3:35 → 4:15)</a:t>
             </a:r>
             <a:endParaRPr lang="en-US" dirty="0"/>
           </a:p>
@@ -2290,7 +2290,7 @@
           <a:p>
             <a:r>
               <a:rPr lang="en-US" dirty="0"/>
-              <a:t>TEMPO: 45 s (4:10 → 4:55)</a:t>
+              <a:t>TEMPO: 45 s (4:15 → 5:00)</a:t>
             </a:r>
             <a:endParaRPr lang="en-US" dirty="0"/>
           </a:p>
@@ -2406,7 +2406,7 @@
           <a:p>
             <a:r>
               <a:rPr lang="en-US" dirty="0"/>
-              <a:t>TEMPO: 50 s (4:55 → 5:45)</a:t>
+              <a:t>TEMPO: 50 s (5:00 → 5:50)</a:t>
             </a:r>
             <a:endParaRPr lang="en-US" dirty="0"/>
           </a:p>
@@ -2515,7 +2515,7 @@
           <a:p>
             <a:r>
               <a:rPr lang="en-US" dirty="0"/>
-              <a:t>TEMPO: 45 s (5:45 → 6:30)</a:t>
+              <a:t>TEMPO: 45 s (5:50 → 6:35)</a:t>
             </a:r>
             <a:endParaRPr lang="en-US" dirty="0"/>
           </a:p>

</xml_diff>

<commit_message>
Versão 36: auditoria do Codex sobre a v35 aplicada (Gouvêa sem extrapolação, notas do slide 13, dobutamina na sepse, dopamina); 11 min 55 s
- Intraoperatório: o estudo de Gouvêa e Diaz passa a sustentar apenas o método (eco para separar
  disfunção de VD de vasoplegia); VD preservado nos momentos avaliados, 30 min após a reperfusão.
- SSC 2026: fechado o div que deixava o aside aninhado; notas presentes nos 16 slides do PPTX.
- Milrinona ou dobutamina: na sepse, dobutamina é preferência prática, sem dados contra milrinona.
- Dopamina: efeito pouco previsível, taquicardia e arritmias, dose renal não protege; uso restrito.
- Perfusão: espaçamento vertical dentro do limite de layout.
- Resumo para o Codex: contagem de palavras corrigida (1.443 na v35; 1.483 agora).

Co-Authored-By: Claude Fable 5.1 <noreply@anthropic.com>
Claude-Session: https://claude.ai/code/session_01W6cLQUtwNHu1UUeBJH2XLT
</commit_message>
<xml_diff>
--- a/apresentacao/Aminas_Vasoativas.pptx
+++ b/apresentacao/Aminas_Vasoativas.pptx
@@ -122,24 +122,24 @@
   <p:extLst>
     <p:ext uri="{521415D9-36F7-43E2-AB2F-B90AF26B5E84}">
       <p14:sectionLst xmlns:p14="http://schemas.microsoft.com/office/powerpoint/2010/main">
-        <p14:section name="Abertura e objetivos" id="{d2e79867-0ef0-773d-aca8-34f48d7ece97}">
+        <p14:section name="Abertura e objetivos" id="{fcaf0366-49be-2935-7faf-8de61a577872}">
           <p14:sldIdLst>
             <p14:sldId id="256"/>
             <p14:sldId id="257"/>
           </p14:sldIdLst>
         </p14:section>
-        <p14:section name="01 · Fisiologia: pressão, débito e perfusão" id="{24857775-b24a-5865-c560-6de925fef3b4}">
+        <p14:section name="01 · Fisiologia: pressão, débito e perfusão" id="{79275c8f-902b-fa3d-cfe7-2eedff36bfd2}">
           <p14:sldIdLst>
             <p14:sldId id="258"/>
             <p14:sldId id="259"/>
           </p14:sldIdLst>
         </p14:section>
-        <p14:section name="02 · Receptores" id="{479ccca4-aff8-4d91-e091-b2723be8baa9}">
+        <p14:section name="02 · Receptores" id="{e5c16ef7-bc61-25cc-8c67-7f178be6e84d}">
           <p14:sldIdLst>
             <p14:sldId id="260"/>
           </p14:sldIdLst>
         </p14:section>
-        <p14:section name="03 · Drogas: noradrenalina, adrenalina, dobutamina (e dopamina), milrinona (escolha), fenilefrina e efedrina" id="{1a39270c-f27b-086b-c3f5-758a6db91d7b}">
+        <p14:section name="03 · Drogas: noradrenalina, adrenalina, dobutamina (e dopamina), milrinona (escolha), fenilefrina e efedrina" id="{1fd22942-ac8c-52b6-735f-04f9b056c037}">
           <p14:sldIdLst>
             <p14:sldId id="261"/>
             <p14:sldId id="262"/>
@@ -149,22 +149,22 @@
             <p14:sldId id="266"/>
           </p14:sldIdLst>
         </p14:section>
-        <p14:section name="04 · Além das aminas: vasopressina, hidrocortisona e azul de metileno" id="{bc9558d1-ec8e-40e2-3ae8-bdc5d0a84c19}">
+        <p14:section name="04 · Além das aminas: vasopressina, hidrocortisona e azul de metileno" id="{bb9fc973-137b-0d15-a1a1-d5110dd676df}">
           <p14:sldIdLst>
             <p14:sldId id="267"/>
           </p14:sldIdLst>
         </p14:section>
-        <p14:section name="05 · Choque séptico: a sequência da SSC 2026" id="{8a8bbad7-3137-e737-a684-9f67c948ea81}">
+        <p14:section name="05 · Choque séptico: a sequência da SSC 2026" id="{1192bae1-c234-7315-e0b7-dde013c0c733}">
           <p14:sldIdLst>
             <p14:sldId id="268"/>
           </p14:sldIdLst>
         </p14:section>
-        <p14:section name="06 · Perioperatório: escolha da droga" id="{544fb746-795e-31f9-1bbf-c37017980399}">
+        <p14:section name="06 · Perioperatório: escolha da droga" id="{acb8902b-6ff1-6fb9-b923-5cde8ac3a3ec}">
           <p14:sldIdLst>
             <p14:sldId id="269"/>
           </p14:sldIdLst>
         </p14:section>
-        <p14:section name="07 · Mensagens finais e encerramento" id="{73e91f63-ee7a-715a-66f3-62e919599038}">
+        <p14:section name="07 · Mensagens finais e encerramento" id="{93325013-515c-e0c7-cfbd-a06b69218045}">
           <p14:sldIdLst>
             <p14:sldId id="270"/>
             <p14:sldId id="271"/>
@@ -581,7 +581,7 @@
           <a:p>
             <a:r>
               <a:rPr lang="en-US" dirty="0"/>
-              <a:t>TEMPO: 25 s (0:00 → 0:25). Total previsto: 11 min 30 s nos 16 slides; ensaiar mirando 15 minutos.</a:t>
+              <a:t>TEMPO: 25 s (0:00 → 0:25). Total previsto: 11 min 55 s nos 16 slides; ensaiar mirando 12 minutos.</a:t>
             </a:r>
             <a:endParaRPr lang="en-US" dirty="0"/>
           </a:p>
@@ -676,21 +676,21 @@
           <a:p>
             <a:r>
               <a:rPr lang="en-US" dirty="0"/>
-              <a:t>FALA: Então, quando escolher? Primeiro, a indicação: inotrópico quando há disfunção ventricular com baixo débito e hipoperfusão, depois de otimizar volume e PAM; se a hipotensão é por vasoplegia, a droga é o vasopressor, e um inodilatador baixa ainda mais a pressão. Depois, o perfil farmacológico, que está na tabela. Milrinona quando a circulação pulmonar e o VD são o problema, como na hipertensão pulmonar e na saída de CEC com resistência pulmonar alta, e quando o betabloqueio ou a taquicardia limitam a dobutamina; ela precisa de uma PAM sustentada, em geral com noradrenalina. Dobutamina quando a pressão está baixa ou há vasoplegia, como no choque séptico, em que a vasodilatação e a meia-vida longa da milrinona pesam contra; na insuficiência renal; e quando se quer titulação rápida, porque a meia-vida é de minutos.</a:t>
+              <a:t>FALA: Então, quando escolher? Primeiro, a indicação: inotrópico quando há disfunção ventricular com baixo débito e hipoperfusão, depois de otimizar volume e PAM; se a hipotensão é por vasoplegia, a droga é o vasopressor, e um inodilatador baixa ainda mais a pressão. Depois, o perfil farmacológico, que está na tabela. Milrinona quando a circulação pulmonar e o VD são o problema, como na hipertensão pulmonar e na saída de CEC com resistência pulmonar alta, e quando o betabloqueio ou a taquicardia limitam a dobutamina; ela precisa de uma PAM sustentada, em geral com noradrenalina. Dobutamina quando a pressão está baixa ou há vasoplegia, em que a vasodilatação e a meia-vida longa da milrinona pesam contra; na insuficiência renal; e quando se quer titulação rápida, porque a meia-vida é de minutos. No choque séptico com disfunção miocárdica, a SSC 2026 sugere dobutamina associada à noradrenalina, ou adrenalina isolada, e reconhece que faltam dados para preferir a dobutamina à milrinona: é preferência prática, não superioridade demonstrada.</a:t>
             </a:r>
             <a:endParaRPr lang="en-US" dirty="0"/>
           </a:p>
           <a:p>
             <a:r>
               <a:rPr lang="en-US" dirty="0"/>
-              <a:t>TEMPO: 1 min (6:30 → 7:30)</a:t>
+              <a:t>TEMPO: 1 min 15 s (6:30 → 7:45)</a:t>
             </a:r>
             <a:endParaRPr lang="en-US" dirty="0"/>
           </a:p>
           <a:p>
             <a:r>
               <a:rPr lang="en-US" dirty="0"/>
-              <a:t>PONTO-CHAVE: Primeiro a indicação; depois o perfil: milrinona para VD e circulação pulmonar com PAM sustentada; dobutamina com pressão baixa ou para titular rápido.</a:t>
+              <a:t>PONTO-CHAVE: Primeiro a indicação; depois o perfil: milrinona para VD e circulação pulmonar com PAM sustentada; dobutamina com pressão baixa ou para titular rápido. Na sepse, dobutamina é preferência prática, não superioridade demonstrada.</a:t>
             </a:r>
             <a:endParaRPr lang="en-US" dirty="0"/>
           </a:p>
@@ -792,7 +792,7 @@
           <a:p>
             <a:r>
               <a:rPr lang="en-US" dirty="0"/>
-              <a:t>TEMPO: 50 s (7:30 → 8:20)</a:t>
+              <a:t>TEMPO: 50 s (7:45 → 8:35)</a:t>
             </a:r>
             <a:endParaRPr lang="en-US" dirty="0"/>
           </a:p>
@@ -894,7 +894,7 @@
           <a:p>
             <a:r>
               <a:rPr lang="en-US" dirty="0"/>
-              <a:t>TEMPO: 55 s (8:20 → 9:15)</a:t>
+              <a:t>TEMPO: 55 s (8:35 → 9:30)</a:t>
             </a:r>
             <a:endParaRPr lang="en-US" dirty="0"/>
           </a:p>
@@ -996,7 +996,28 @@
           <a:p>
             <a:r>
               <a:rPr lang="en-US" dirty="0"/>
-              <a:t/>
+              <a:t>FALA: No choque séptico, a Surviving Sepsis Campaign, a diretriz internacional de sepse, atualizada em 2026, organiza os vasopressores em sequência: noradrenalina primeiro, cedo, mesmo por veia periférica; vasopressina quando a dose de noradrenalina sobe, sem limiar definido; adrenalina se a PAM continuar inadequada. É o mesmo raciocínio da aula: tônus com noradrenalina, outra via com vasopressina, e inotrópico apenas se houver disfunção cardíaca com hipoperfusão.</a:t>
+            </a:r>
+            <a:endParaRPr lang="en-US" dirty="0"/>
+          </a:p>
+          <a:p>
+            <a:r>
+              <a:rPr lang="en-US" dirty="0"/>
+              <a:t>TEMPO: 30 s (9:30 → 10:00)</a:t>
+            </a:r>
+            <a:endParaRPr lang="en-US" dirty="0"/>
+          </a:p>
+          <a:p>
+            <a:r>
+              <a:rPr lang="en-US" dirty="0"/>
+              <a:t>PONTO-CHAVE: Noradrenalina, depois vasopressina, depois adrenalina; inotrópico apenas com disfunção cardíaca e hipoperfusão.</a:t>
+            </a:r>
+            <a:endParaRPr lang="en-US" dirty="0"/>
+          </a:p>
+          <a:p>
+            <a:r>
+              <a:rPr lang="en-US" dirty="0"/>
+              <a:t>SE PERGUNTAREM: o VASSPR (JAMA 2026, n = 3.959; 13 hospitais, desenho cluster-crossover com ordem sorteada) comparou políticas hospitalares de iniciar a vasopressina com 0,1 vs. 0,4 mcg/kg/min de noradrenalina-equivalente; a vasopressina foi usada em 52,4% vs. 32,9%, e a mortalidade foi 31,8% vs. 33,0%. A antecipação sistemática não trouxe benefício, o que não exclui ganho em pacientes selecionados. No OPTPRESS, alvo de 80–85 mmHg em idosos aumentou a mortalidade.</a:t>
             </a:r>
             <a:endParaRPr lang="en-US" dirty="0"/>
           </a:p>
@@ -1084,14 +1105,14 @@
           <a:p>
             <a:r>
               <a:rPr lang="en-US" dirty="0"/>
-              <a:t>FALA: No centro cirúrgico, antes da droga, afastar causas tratáveis: plano profundo, hipovolemia, compressão aortocava, pneumotórax e anafilaxia. Depois, o mecanismo: tônus baixo com frequência normal ou alta, agonista α1; bradicardia, efedrina ou, se grave, adrenalina; baixo débito, inotrópico; vasoplegia refratária às catecolaminas, como após CEC, com IECA ou BRA ou na reperfusão do enxerto hepático, vasopressina, com azul de metileno como resgate; pré-carga baixa, volume. Um dado do nosso serviço ajuda nessa decisão: Gouvêa, Diaz e colaboradores acompanharam por ecocardiografia transesofágica o ventrículo direito de 19 pacientes selecionados em cinco fases do transplante hepático, e a função sistólica do VD se manteve preservada em todas, inclusive após a reperfusão. Ou seja, nesses pacientes a instabilidade da reperfusão não se explicou por falência de VD, o que favorece tratá-la como vasoplegia, com vasopressor, e usar o eco para confirmar antes de iniciar um inotrópico.</a:t>
+              <a:t>FALA: No centro cirúrgico, antes da droga, afastar causas tratáveis: plano profundo, hipovolemia, compressão aortocava, pneumotórax e anafilaxia. Depois, o mecanismo: tônus baixo com frequência normal ou alta, agonista α1; bradicardia, efedrina ou, se grave, adrenalina; baixo débito, inotrópico; vasoplegia refratária às catecolaminas, como após CEC, com IECA ou BRA ou na reperfusão do enxerto hepático, vasopressina, com azul de metileno como resgate; pré-carga baixa, volume. Um dado do nosso serviço ajuda nessa decisão: Gouvêa, Diaz e colaboradores acompanharam por ecocardiografia transesofágica o ventrículo direito de 19 pacientes selecionados em cinco fases do transplante hepático, e a função sistólica do VD se manteve preservada nos momentos avaliados, inclusive trinta minutos após a reperfusão. O estudo não mediu os primeiros minutos da reperfusão, então não diz se a instabilidade aguda é vasoplegia ou disfunção transitória do VD. O que ele sustenta é o método: usar o eco para separar disfunção de VD de vasoplegia antes de escolher entre inotrópico e vasopressor.</a:t>
             </a:r>
             <a:endParaRPr lang="en-US" dirty="0"/>
           </a:p>
           <a:p>
             <a:r>
               <a:rPr lang="en-US" dirty="0"/>
-              <a:t>TEMPO: 1 min 5 s (9:45 → 10:50)</a:t>
+              <a:t>TEMPO: 1 min 15 s (10:00 → 11:15)</a:t>
             </a:r>
             <a:endParaRPr lang="en-US" dirty="0"/>
           </a:p>
@@ -1105,7 +1126,7 @@
           <a:p>
             <a:r>
               <a:rPr lang="en-US" dirty="0"/>
-              <a:t>SE PERGUNTAREM: Gouvêa G, Feiner J, Joshi S, Diaz R, et al., PLoS One 2022;17(10):e0275301: estudo observacional, 19 adultos de 18 a 65 anos, TAPSE e variação fracional de área do VD em cinco fases (basal, fase de hepatectomia, fase anepática, pós-reperfusão e fechamento); função sistólica do VD preservada nas cinco fases; excluídos hipertensão portopulmonar, síndrome hepatopulmonar, doença cardiopulmonar e insuficiência hepática fulminante. População selecionada: o estudo não permite concluir que toda hipotensão na reperfusão seja vasoplegia. TAPSE e variação fracional de área dependem da carga, e o TAPSE mede apenas a excursão longitudinal do anel lateral; normais sob anestesia, com pós-carga baixa, afastam disfunção sistólica evidente nos momentos avaliados, não medem reserva contrátil.</a:t>
+              <a:t>SE PERGUNTAREM: Gouvêa G, Feiner J, Joshi S, Diaz R, et al., PLoS One 2022;17(10):e0275301: estudo observacional, 19 adultos de 18 a 65 anos, TAPSE e variação fracional de área do VD em cinco fases (basal, fase de hepatectomia, fase anepática, 30 min após a reperfusão e fechamento); função sistólica do VD preservada nos cinco momentos; excluídos hipertensão portopulmonar, síndrome hepatopulmonar, doença cardiopulmonar e insuficiência hepática fulminante. População selecionada e medida feita 30 min depois da reperfusão: o estudo não mediu os primeiros minutos, quando ocorre a síndrome pós-reperfusão, não exclui disfunção transitória do VD nesse período e não permite atribuir a instabilidade aguda a vasoplegia. TAPSE e variação fracional de área dependem da carga, e o TAPSE mede apenas a excursão longitudinal do anel lateral; normais sob anestesia, com pós-carga baixa, afastam disfunção sistólica evidente nos momentos avaliados, não medem reserva contrátil.</a:t>
             </a:r>
             <a:endParaRPr lang="en-US" dirty="0"/>
           </a:p>
@@ -1200,7 +1221,7 @@
           <a:p>
             <a:r>
               <a:rPr lang="en-US" dirty="0"/>
-              <a:t>TEMPO: 30 s (10:50 → 11:20)</a:t>
+              <a:t>TEMPO: 30 s (11:15 → 11:45)</a:t>
             </a:r>
             <a:endParaRPr lang="en-US" dirty="0"/>
           </a:p>
@@ -1302,7 +1323,7 @@
           <a:p>
             <a:r>
               <a:rPr lang="en-US" dirty="0"/>
-              <a:t>TEMPO: 10 s (11:20 → 11:30)</a:t>
+              <a:t>TEMPO: 10 s (11:45 → 11:55)</a:t>
             </a:r>
             <a:endParaRPr lang="en-US" dirty="0"/>
           </a:p>
@@ -2044,7 +2065,7 @@
           <a:p>
             <a:r>
               <a:rPr lang="en-US" dirty="0"/>
-              <a:t>FALA: Dobutamina: inotrópico β1 com vasodilatação β2; sobe o débito, baixa um pouco a resistência e pode baixar a PAM. Indicada no baixo débito com hipoperfusão, de 2,5 a 20 microgramas por quilo por minuto; se a PAM cair, associar vasopressor; taquicardia e arritmia limitam a dose. A dopamina, em uma frase: efeito dose-dependente e pouco previsível, com mais taquicardia e arritmia que as outras aminas, e a dose renal não protege o rim; hoje o uso é residual.</a:t>
+              <a:t>FALA: Dobutamina: inotrópico β1 com vasodilatação β2; sobe o débito, baixa um pouco a resistência e pode baixar a PAM. Indicada no baixo débito com hipoperfusão, de 2,5 a 20 microgramas por quilo por minuto; se a PAM cair, associar vasopressor; taquicardia e arritmia limitam a dose. A dopamina, em uma frase: efeito pouco previsível, risco de taquicardia e arritmias, e a chamada dose renal não protege o rim; hoje tem uso restrito.</a:t>
             </a:r>
             <a:endParaRPr lang="en-US" dirty="0"/>
           </a:p>
@@ -2058,7 +2079,7 @@
           <a:p>
             <a:r>
               <a:rPr lang="en-US" dirty="0"/>
-              <a:t>PONTO-CHAVE: Dobutamina para baixo débito com hipoperfusão; dopamina de uso residual.</a:t>
+              <a:t>PONTO-CHAVE: Dobutamina para baixo débito com hipoperfusão; dopamina de uso restrito.</a:t>
             </a:r>
             <a:endParaRPr lang="en-US" dirty="0"/>
           </a:p>
@@ -3864,11 +3885,11 @@
         <p:spPr>
           <a:xfrm>
             <a:off x="812800" y="4287143"/>
-            <a:ext cx="5181600" cy="1290141"/>
+            <a:ext cx="5181600" cy="1521222"/>
           </a:xfrm>
           <a:prstGeom prst="roundRect">
             <a:avLst>
-              <a:gd name="adj" fmla="val 5906"/>
+              <a:gd name="adj" fmla="val 5009"/>
             </a:avLst>
           </a:prstGeom>
           <a:solidFill>
@@ -3975,11 +3996,11 @@
         <p:spPr>
           <a:xfrm>
             <a:off x="6197600" y="4287143"/>
-            <a:ext cx="5181600" cy="1290141"/>
+            <a:ext cx="5181600" cy="1521222"/>
           </a:xfrm>
           <a:prstGeom prst="roundRect">
             <a:avLst>
-              <a:gd name="adj" fmla="val 5906"/>
+              <a:gd name="adj" fmla="val 5009"/>
             </a:avLst>
           </a:prstGeom>
           <a:solidFill>
@@ -4037,14 +4058,14 @@
       </p:sp>
       <p:sp>
         <p:nvSpPr>
-          <p:cNvPr id="11" name="Hipotensão ou vasoplegia associada, como"/>
+          <p:cNvPr id="11" name="Hipotensão ou vasoplegia associada; insu"/>
           <p:cNvSpPr txBox="1"/>
           <p:nvPr/>
         </p:nvSpPr>
         <p:spPr>
           <a:xfrm>
             <a:off x="6407150" y="4712333"/>
-            <a:ext cx="4781550" cy="693241"/>
+            <a:ext cx="4781550" cy="924322"/>
           </a:xfrm>
           <a:prstGeom prst="rect">
             <a:avLst/>
@@ -4071,7 +4092,7 @@
                 <a:ea typeface="Calibri" pitchFamily="34" charset="-122"/>
                 <a:cs typeface="Calibri" pitchFamily="34" charset="-120"/>
               </a:rPr>
-              <a:t>Hipotensão ou vasoplegia associada, como no choque séptico; insuficiência renal; necessidade de titulação rápida (meia-vida de minutos).</a:t>
+              <a:t>Hipotensão ou vasoplegia associada; insuficiência renal; necessidade de titulação rápida (meia-vida de minutos). No choque séptico, a SSC 2026 sugere dobutamina com noradrenalina, ou adrenalina; faltam dados comparando com milrinona.</a:t>
             </a:r>
             <a:endParaRPr lang="en-US" sz="1300" dirty="0"/>
           </a:p>
@@ -7674,7 +7695,7 @@
                 <a:ea typeface="Calibri" pitchFamily="34" charset="-122"/>
                 <a:cs typeface="Calibri" pitchFamily="34" charset="-120"/>
               </a:rPr>
-              <a:t> em 19 pacientes selecionados, a função sistólica do VD ao ETE manteve-se preservada nas cinco fases, inclusive após a reperfusão: a instabilidade da reperfusão não se explicou por falência de VD, o que favorece tratá-la como vasoplegia e confirmar pelo eco antes de iniciar inotrópico (Gouvêa et al., PLoS One 2022).</a:t>
+              <a:t> em 19 pacientes selecionados, a função sistólica do VD ao ETE manteve-se preservada nos momentos avaliados, inclusive 30 min após a reperfusão. O estudo não mediu os primeiros minutos da reperfusão nem a causa da instabilidade aguda; a lição é usar o eco para separar disfunção de VD de vasoplegia antes de escolher entre inotrópico e vasopressor (Gouvêa et al., PLoS One 2022).</a:t>
             </a:r>
             <a:endParaRPr lang="en-US" sz="1300" dirty="0"/>
           </a:p>
@@ -10340,12 +10361,12 @@
         </p:nvSpPr>
         <p:spPr>
           <a:xfrm>
-            <a:off x="812800" y="1879501"/>
-            <a:ext cx="3386634" cy="2473821"/>
+            <a:off x="812800" y="1803301"/>
+            <a:ext cx="3386634" cy="2372221"/>
           </a:xfrm>
           <a:prstGeom prst="roundRect">
             <a:avLst>
-              <a:gd name="adj" fmla="val 3080"/>
+              <a:gd name="adj" fmla="val 3212"/>
             </a:avLst>
           </a:prstGeom>
           <a:solidFill>
@@ -10367,8 +10388,8 @@
         </p:nvSpPr>
         <p:spPr>
           <a:xfrm>
-            <a:off x="1073150" y="2135857"/>
-            <a:ext cx="2884984" cy="259060"/>
+            <a:off x="1047750" y="2008857"/>
+            <a:ext cx="2935784" cy="259060"/>
           </a:xfrm>
           <a:prstGeom prst="rect">
             <a:avLst/>
@@ -10409,8 +10430,8 @@
         </p:nvSpPr>
         <p:spPr>
           <a:xfrm>
-            <a:off x="1073150" y="2512452"/>
-            <a:ext cx="2884984" cy="480020"/>
+            <a:off x="1047750" y="2385452"/>
+            <a:ext cx="2935784" cy="480020"/>
           </a:xfrm>
           <a:prstGeom prst="rect">
             <a:avLst/>
@@ -10452,8 +10473,8 @@
         </p:nvSpPr>
         <p:spPr>
           <a:xfrm>
-            <a:off x="1073150" y="3055972"/>
-            <a:ext cx="2884984" cy="480020"/>
+            <a:off x="1047750" y="2928972"/>
+            <a:ext cx="2935784" cy="480020"/>
           </a:xfrm>
           <a:prstGeom prst="rect">
             <a:avLst/>
@@ -10495,8 +10516,8 @@
         </p:nvSpPr>
         <p:spPr>
           <a:xfrm>
-            <a:off x="1073150" y="3599493"/>
-            <a:ext cx="2884984" cy="240010"/>
+            <a:off x="1047750" y="3472493"/>
+            <a:ext cx="2935784" cy="240010"/>
           </a:xfrm>
           <a:prstGeom prst="rect">
             <a:avLst/>
@@ -10538,12 +10559,12 @@
         </p:nvSpPr>
         <p:spPr>
           <a:xfrm>
-            <a:off x="4402634" y="1879501"/>
-            <a:ext cx="3386634" cy="2473821"/>
+            <a:off x="4402634" y="1803301"/>
+            <a:ext cx="3386634" cy="2372221"/>
           </a:xfrm>
           <a:prstGeom prst="roundRect">
             <a:avLst>
-              <a:gd name="adj" fmla="val 3080"/>
+              <a:gd name="adj" fmla="val 3212"/>
             </a:avLst>
           </a:prstGeom>
           <a:solidFill>
@@ -10565,8 +10586,8 @@
         </p:nvSpPr>
         <p:spPr>
           <a:xfrm>
-            <a:off x="4662984" y="2135857"/>
-            <a:ext cx="2884984" cy="259060"/>
+            <a:off x="4637584" y="2008857"/>
+            <a:ext cx="2935784" cy="259060"/>
           </a:xfrm>
           <a:prstGeom prst="rect">
             <a:avLst/>
@@ -10607,8 +10628,8 @@
         </p:nvSpPr>
         <p:spPr>
           <a:xfrm>
-            <a:off x="4662984" y="2512452"/>
-            <a:ext cx="2884984" cy="480020"/>
+            <a:off x="4637584" y="2385452"/>
+            <a:ext cx="2935784" cy="480020"/>
           </a:xfrm>
           <a:prstGeom prst="rect">
             <a:avLst/>
@@ -10650,8 +10671,8 @@
         </p:nvSpPr>
         <p:spPr>
           <a:xfrm>
-            <a:off x="4662984" y="3055972"/>
-            <a:ext cx="2884984" cy="480020"/>
+            <a:off x="4637584" y="2928972"/>
+            <a:ext cx="2935784" cy="480020"/>
           </a:xfrm>
           <a:prstGeom prst="rect">
             <a:avLst/>
@@ -10693,8 +10714,8 @@
         </p:nvSpPr>
         <p:spPr>
           <a:xfrm>
-            <a:off x="4662984" y="3599493"/>
-            <a:ext cx="2884984" cy="480020"/>
+            <a:off x="4637584" y="3472493"/>
+            <a:ext cx="2935784" cy="480020"/>
           </a:xfrm>
           <a:prstGeom prst="rect">
             <a:avLst/>
@@ -10736,12 +10757,12 @@
         </p:nvSpPr>
         <p:spPr>
           <a:xfrm>
-            <a:off x="7992467" y="1879501"/>
-            <a:ext cx="3386634" cy="2473821"/>
+            <a:off x="7992467" y="1803301"/>
+            <a:ext cx="3386634" cy="2372221"/>
           </a:xfrm>
           <a:prstGeom prst="roundRect">
             <a:avLst>
-              <a:gd name="adj" fmla="val 3080"/>
+              <a:gd name="adj" fmla="val 3212"/>
             </a:avLst>
           </a:prstGeom>
           <a:solidFill>
@@ -10763,8 +10784,8 @@
         </p:nvSpPr>
         <p:spPr>
           <a:xfrm>
-            <a:off x="8252817" y="2135857"/>
-            <a:ext cx="2884984" cy="259060"/>
+            <a:off x="8227417" y="2008857"/>
+            <a:ext cx="2935784" cy="259060"/>
           </a:xfrm>
           <a:prstGeom prst="rect">
             <a:avLst/>
@@ -10805,8 +10826,8 @@
         </p:nvSpPr>
         <p:spPr>
           <a:xfrm>
-            <a:off x="8252817" y="2512452"/>
-            <a:ext cx="2884984" cy="480020"/>
+            <a:off x="8227417" y="2385452"/>
+            <a:ext cx="2935784" cy="480020"/>
           </a:xfrm>
           <a:prstGeom prst="rect">
             <a:avLst/>
@@ -10881,8 +10902,8 @@
         </p:nvSpPr>
         <p:spPr>
           <a:xfrm>
-            <a:off x="8252817" y="3055972"/>
-            <a:ext cx="2884984" cy="240010"/>
+            <a:off x="8227417" y="2928972"/>
+            <a:ext cx="2935784" cy="240010"/>
           </a:xfrm>
           <a:prstGeom prst="rect">
             <a:avLst/>
@@ -10924,8 +10945,8 @@
         </p:nvSpPr>
         <p:spPr>
           <a:xfrm>
-            <a:off x="8252817" y="3359483"/>
-            <a:ext cx="2884984" cy="480020"/>
+            <a:off x="8227417" y="3232483"/>
+            <a:ext cx="2935784" cy="480020"/>
           </a:xfrm>
           <a:prstGeom prst="rect">
             <a:avLst/>
@@ -10967,12 +10988,12 @@
         </p:nvSpPr>
         <p:spPr>
           <a:xfrm>
-            <a:off x="812800" y="4658122"/>
-            <a:ext cx="10566400" cy="988020"/>
+            <a:off x="812800" y="4404122"/>
+            <a:ext cx="10566400" cy="886420"/>
           </a:xfrm>
           <a:prstGeom prst="roundRect">
             <a:avLst>
-              <a:gd name="adj" fmla="val 7712"/>
+              <a:gd name="adj" fmla="val 8596"/>
             </a:avLst>
           </a:prstGeom>
           <a:solidFill>
@@ -10994,7 +11015,7 @@
         </p:nvSpPr>
         <p:spPr>
           <a:xfrm>
-            <a:off x="1073150" y="4838817"/>
+            <a:off x="1073150" y="4534017"/>
             <a:ext cx="1476970" cy="568920"/>
           </a:xfrm>
           <a:prstGeom prst="rect">
@@ -11036,7 +11057,7 @@
         </p:nvSpPr>
         <p:spPr>
           <a:xfrm>
-            <a:off x="2937470" y="4870478"/>
+            <a:off x="2937470" y="4565678"/>
             <a:ext cx="8200430" cy="533400"/>
           </a:xfrm>
           <a:prstGeom prst="rect">
@@ -15773,14 +15794,14 @@
       </p:sp>
       <p:sp>
         <p:nvSpPr>
-          <p:cNvPr id="36" name="Efeito dose-dependente e pouco previsíve"/>
+          <p:cNvPr id="36" name="Efeito pouco previsível; risco de taquic"/>
           <p:cNvSpPr txBox="1"/>
           <p:nvPr/>
         </p:nvSpPr>
         <p:spPr>
           <a:xfrm>
             <a:off x="6457950" y="3355621"/>
-            <a:ext cx="4679950" cy="745629"/>
+            <a:ext cx="4679950" cy="497086"/>
           </a:xfrm>
           <a:prstGeom prst="rect">
             <a:avLst/>
@@ -15807,7 +15828,7 @@
                 <a:ea typeface="Calibri" pitchFamily="34" charset="-122"/>
                 <a:cs typeface="Calibri" pitchFamily="34" charset="-120"/>
               </a:rPr>
-              <a:t>Efeito dose-dependente e pouco previsível; mais taquicardia e arritmia que as outras aminas; a dose “renal” não protege o rim. Uso residual.</a:t>
+              <a:t>Efeito pouco previsível; risco de taquicardia e arritmias; a chamada dose “renal” não protege o rim. Uso restrito.</a:t>
             </a:r>
             <a:endParaRPr lang="en-US" sz="1350" dirty="0"/>
           </a:p>

</xml_diff>

<commit_message>
Versão 36.1: VTI como estimativa seriada do volume sistólico (slide 4); ressalva sobre Gouvêa na nota do slide 14
Ajuste final da conferência do Codex: o VTI isolado acompanha o volume sistólico, não o débito.
Fala correspondente ajustada; resumo atualizado com a aprovação da v36.

Co-Authored-By: Claude Fable 5.1 <noreply@anthropic.com>
Claude-Session: https://claude.ai/code/session_01W6cLQUtwNHu1UUeBJH2XLT
</commit_message>
<xml_diff>
--- a/apresentacao/Aminas_Vasoativas.pptx
+++ b/apresentacao/Aminas_Vasoativas.pptx
@@ -122,24 +122,24 @@
   <p:extLst>
     <p:ext uri="{521415D9-36F7-43E2-AB2F-B90AF26B5E84}">
       <p14:sectionLst xmlns:p14="http://schemas.microsoft.com/office/powerpoint/2010/main">
-        <p14:section name="Abertura e objetivos" id="{fcaf0366-49be-2935-7faf-8de61a577872}">
+        <p14:section name="Abertura e objetivos" id="{9c0916a4-0b57-01e3-8d48-2eb87108758a}">
           <p14:sldIdLst>
             <p14:sldId id="256"/>
             <p14:sldId id="257"/>
           </p14:sldIdLst>
         </p14:section>
-        <p14:section name="01 · Fisiologia: pressão, débito e perfusão" id="{79275c8f-902b-fa3d-cfe7-2eedff36bfd2}">
+        <p14:section name="01 · Fisiologia: pressão, débito e perfusão" id="{90b4787c-3955-5e0b-b3a1-122720dd2cdb}">
           <p14:sldIdLst>
             <p14:sldId id="258"/>
             <p14:sldId id="259"/>
           </p14:sldIdLst>
         </p14:section>
-        <p14:section name="02 · Receptores" id="{e5c16ef7-bc61-25cc-8c67-7f178be6e84d}">
+        <p14:section name="02 · Receptores" id="{e25c562e-fba1-a9fc-67d1-6ecb1970701e}">
           <p14:sldIdLst>
             <p14:sldId id="260"/>
           </p14:sldIdLst>
         </p14:section>
-        <p14:section name="03 · Drogas: noradrenalina, adrenalina, dobutamina (e dopamina), milrinona (escolha), fenilefrina e efedrina" id="{1fd22942-ac8c-52b6-735f-04f9b056c037}">
+        <p14:section name="03 · Drogas: noradrenalina, adrenalina, dobutamina (e dopamina), milrinona (escolha), fenilefrina e efedrina" id="{a00eb183-249c-a5c2-6534-83fd75b219d8}">
           <p14:sldIdLst>
             <p14:sldId id="261"/>
             <p14:sldId id="262"/>
@@ -149,22 +149,22 @@
             <p14:sldId id="266"/>
           </p14:sldIdLst>
         </p14:section>
-        <p14:section name="04 · Além das aminas: vasopressina, hidrocortisona e azul de metileno" id="{bb9fc973-137b-0d15-a1a1-d5110dd676df}">
+        <p14:section name="04 · Além das aminas: vasopressina, hidrocortisona e azul de metileno" id="{22d981da-a0b7-9fd6-fb89-4479e73742f2}">
           <p14:sldIdLst>
             <p14:sldId id="267"/>
           </p14:sldIdLst>
         </p14:section>
-        <p14:section name="05 · Choque séptico: a sequência da SSC 2026" id="{1192bae1-c234-7315-e0b7-dde013c0c733}">
+        <p14:section name="05 · Choque séptico: a sequência da SSC 2026" id="{697fce64-5a0c-56d6-21d8-9b2beb62b703}">
           <p14:sldIdLst>
             <p14:sldId id="268"/>
           </p14:sldIdLst>
         </p14:section>
-        <p14:section name="06 · Perioperatório: escolha da droga" id="{acb8902b-6ff1-6fb9-b923-5cde8ac3a3ec}">
+        <p14:section name="06 · Perioperatório: escolha da droga" id="{8d8d53ea-bd6a-3618-4ebb-1d7c2d0d13d4}">
           <p14:sldIdLst>
             <p14:sldId id="269"/>
           </p14:sldIdLst>
         </p14:section>
-        <p14:section name="07 · Mensagens finais e encerramento" id="{93325013-515c-e0c7-cfbd-a06b69218045}">
+        <p14:section name="07 · Mensagens finais e encerramento" id="{777c9e81-cb8d-3054-15e9-440ee4a44c35}">
           <p14:sldIdLst>
             <p14:sldId id="270"/>
             <p14:sldId id="271"/>
@@ -1126,7 +1126,7 @@
           <a:p>
             <a:r>
               <a:rPr lang="en-US" dirty="0"/>
-              <a:t>SE PERGUNTAREM: Gouvêa G, Feiner J, Joshi S, Diaz R, et al., PLoS One 2022;17(10):e0275301: estudo observacional, 19 adultos de 18 a 65 anos, TAPSE e variação fracional de área do VD em cinco fases (basal, fase de hepatectomia, fase anepática, 30 min após a reperfusão e fechamento); função sistólica do VD preservada nos cinco momentos; excluídos hipertensão portopulmonar, síndrome hepatopulmonar, doença cardiopulmonar e insuficiência hepática fulminante. População selecionada e medida feita 30 min depois da reperfusão: o estudo não mediu os primeiros minutos, quando ocorre a síndrome pós-reperfusão, não exclui disfunção transitória do VD nesse período e não permite atribuir a instabilidade aguda a vasoplegia. TAPSE e variação fracional de área dependem da carga, e o TAPSE mede apenas a excursão longitudinal do anel lateral; normais sob anestesia, com pós-carga baixa, afastam disfunção sistólica evidente nos momentos avaliados, não medem reserva contrátil.</a:t>
+              <a:t>SE PERGUNTAREM: Gouvêa G, Feiner J, Joshi S, Diaz R, et al., PLoS One 2022;17(10):e0275301: estudo observacional, 19 adultos de 18 a 65 anos, TAPSE e variação fracional de área do VD em cinco fases (basal, fase de hepatectomia, fase anepática, 30 min após a reperfusão e fechamento); função sistólica do VD preservada nos cinco momentos; excluídos hipertensão portopulmonar, síndrome hepatopulmonar, doença cardiopulmonar e insuficiência hepática fulminante. População selecionada e medida feita 30 min depois da reperfusão: o estudo não mediu os primeiros minutos, quando ocorre a síndrome pós-reperfusão, não exclui disfunção transitória do VD nesse período e não permite atribuir a instabilidade aguda a vasoplegia. TAPSE e variação fracional de área dependem da carga, e o TAPSE mede apenas a excursão longitudinal do anel lateral; normais sob anestesia, com pós-carga baixa, afastam disfunção sistólica evidente nos momentos avaliados, não medem reserva contrátil. O estudo mediu a função do VD; não testou a capacidade do eco de diferenciar vasoplegia de disfunção ventricular na hipotensão aguda: essa é a aplicação clínica proposta na aula, não um resultado do estudo.</a:t>
             </a:r>
             <a:endParaRPr lang="en-US" dirty="0"/>
           </a:p>
@@ -1629,7 +1629,7 @@
           <a:p>
             <a:r>
               <a:rPr lang="en-US" dirty="0"/>
-              <a:t>FALA: Mas pressão não é fluxo: uma resistência alta pode manter a PAM com débito baixo. No intraoperatório a perfusão raramente é medida de forma direta, então o caminho é combinar métodos. O eco, transesofágico ou à beira do leito, é o mais rápido para definir o tipo de choque: função dos ventrículos, volemia, pericárdio e o VTI na via de saída como estimativa do débito. Os monitores de débito, por contorno de pulso, termodiluição ou Doppler esofágico, dão o número e a resposta a volume, junto com VPP e VVS, elevação passiva das pernas ou um minidesafio hídrico. E os marcadores de perfusão tissular dizem se o fluxo está bastando: lactato e sua tendência, saturação venosa central, gap de CO₂, diurese, enchimento capilar e temperatura das extremidades. A decisão de usar inotrópico vem daí, não da pressão.</a:t>
+              <a:t>FALA: Mas pressão não é fluxo: uma resistência alta pode manter a PAM com débito baixo. No intraoperatório a perfusão raramente é medida de forma direta, então o caminho é combinar métodos. O eco, transesofágico ou à beira do leito, é o mais rápido para definir o tipo de choque: função dos ventrículos, volemia, pericárdio e o VTI na via de saída, que permite acompanhar o volume sistólico e a resposta às intervenções. Os monitores de débito, por contorno de pulso, termodiluição ou Doppler esofágico, dão o número e a resposta a volume, junto com VPP e VVS, elevação passiva das pernas ou um minidesafio hídrico. E os marcadores de perfusão tissular dizem se o fluxo está bastando: lactato e sua tendência, saturação venosa central, gap de CO₂, diurese, enchimento capilar e temperatura das extremidades. A decisão de usar inotrópico vem daí, não da pressão.</a:t>
             </a:r>
             <a:endParaRPr lang="en-US" dirty="0"/>
           </a:p>
@@ -10467,7 +10467,7 @@
       </p:sp>
       <p:sp>
         <p:nvSpPr>
-          <p:cNvPr id="7" name="VTI na via de saída do VE: estimativa do"/>
+          <p:cNvPr id="7" name="VTI na via de saída do VE: estimativa se"/>
           <p:cNvSpPr txBox="1"/>
           <p:nvPr/>
         </p:nvSpPr>
@@ -10502,7 +10502,7 @@
                 <a:ea typeface="Calibri" pitchFamily="34" charset="-122"/>
                 <a:cs typeface="Calibri" pitchFamily="34" charset="-120"/>
               </a:rPr>
-              <a:t>VTI na via de saída do VE: estimativa do débito</a:t>
+              <a:t>VTI na via de saída do VE: estimativa seriada do volume sistólico</a:t>
             </a:r>
             <a:endParaRPr lang="en-US" sz="1350" dirty="0"/>
           </a:p>

</xml_diff>

<commit_message>
Versão 37: revisão final de conceito e texto (seis lentes com verificação adversarial); 12 min 05 s
- Nenhum erro conceitual confirmado; ajustes de precisão e consistência: referência cruzada da nota do
  slide 3, DC da noradrenalina (pode subir pelo retorno venoso), dobutamina junto com o vasopressor,
  fenilefrina com FC normal ou alta na tabela final, Gouvêa 'o que fica para a prática é o método',
  bolus (fenilefrina e efedrina como drogas habituais), rodapé do slide 15 com capítulos do Miller.
- Tempos recalculados (milrinona ou dobutamina 80 s, SSC 2026 35 s).

Co-Authored-By: Claude Fable 5.1 <noreply@anthropic.com>
Claude-Session: https://claude.ai/code/session_01W6cLQUtwNHu1UUeBJH2XLT
</commit_message>
<xml_diff>
--- a/apresentacao/Aminas_Vasoativas.pptx
+++ b/apresentacao/Aminas_Vasoativas.pptx
@@ -122,24 +122,24 @@
   <p:extLst>
     <p:ext uri="{521415D9-36F7-43E2-AB2F-B90AF26B5E84}">
       <p14:sectionLst xmlns:p14="http://schemas.microsoft.com/office/powerpoint/2010/main">
-        <p14:section name="Abertura e objetivos" id="{9c0916a4-0b57-01e3-8d48-2eb87108758a}">
+        <p14:section name="Abertura e objetivos" id="{33094a39-0ea5-ab6a-29e1-510570928ac5}">
           <p14:sldIdLst>
             <p14:sldId id="256"/>
             <p14:sldId id="257"/>
           </p14:sldIdLst>
         </p14:section>
-        <p14:section name="01 · Fisiologia: pressão, débito e perfusão" id="{90b4787c-3955-5e0b-b3a1-122720dd2cdb}">
+        <p14:section name="01 · Fisiologia: pressão, débito e perfusão" id="{6473c764-1113-f2f0-1908-c320d659279b}">
           <p14:sldIdLst>
             <p14:sldId id="258"/>
             <p14:sldId id="259"/>
           </p14:sldIdLst>
         </p14:section>
-        <p14:section name="02 · Receptores" id="{e25c562e-fba1-a9fc-67d1-6ecb1970701e}">
+        <p14:section name="02 · Receptores" id="{2834fbbd-3c11-c0f1-9192-5a66dd218068}">
           <p14:sldIdLst>
             <p14:sldId id="260"/>
           </p14:sldIdLst>
         </p14:section>
-        <p14:section name="03 · Drogas: noradrenalina, adrenalina, dobutamina (e dopamina), milrinona (escolha), fenilefrina e efedrina" id="{a00eb183-249c-a5c2-6534-83fd75b219d8}">
+        <p14:section name="03 · Drogas: noradrenalina, adrenalina, dobutamina (e dopamina), milrinona (escolha), fenilefrina e efedrina" id="{52207988-bc6f-3e6f-0ea8-73849d27c02b}">
           <p14:sldIdLst>
             <p14:sldId id="261"/>
             <p14:sldId id="262"/>
@@ -149,22 +149,22 @@
             <p14:sldId id="266"/>
           </p14:sldIdLst>
         </p14:section>
-        <p14:section name="04 · Além das aminas: vasopressina, hidrocortisona e azul de metileno" id="{22d981da-a0b7-9fd6-fb89-4479e73742f2}">
+        <p14:section name="04 · Além das aminas: vasopressina, hidrocortisona e azul de metileno" id="{ba9978ac-695d-8489-097b-ef5886a3c4a8}">
           <p14:sldIdLst>
             <p14:sldId id="267"/>
           </p14:sldIdLst>
         </p14:section>
-        <p14:section name="05 · Choque séptico: a sequência da SSC 2026" id="{697fce64-5a0c-56d6-21d8-9b2beb62b703}">
+        <p14:section name="05 · Choque séptico: a sequência da SSC 2026" id="{c9a33e56-0fd4-1370-44db-e56943887ed9}">
           <p14:sldIdLst>
             <p14:sldId id="268"/>
           </p14:sldIdLst>
         </p14:section>
-        <p14:section name="06 · Perioperatório: escolha da droga" id="{8d8d53ea-bd6a-3618-4ebb-1d7c2d0d13d4}">
+        <p14:section name="06 · Perioperatório: escolha da droga" id="{4ef29285-ec94-4a7d-8331-e29e452b925d}">
           <p14:sldIdLst>
             <p14:sldId id="269"/>
           </p14:sldIdLst>
         </p14:section>
-        <p14:section name="07 · Mensagens finais e encerramento" id="{777c9e81-cb8d-3054-15e9-440ee4a44c35}">
+        <p14:section name="07 · Mensagens finais e encerramento" id="{bb3d8ab3-e455-a7a3-af42-3975aaf8e499}">
           <p14:sldIdLst>
             <p14:sldId id="270"/>
             <p14:sldId id="271"/>
@@ -581,7 +581,7 @@
           <a:p>
             <a:r>
               <a:rPr lang="en-US" dirty="0"/>
-              <a:t>TEMPO: 25 s (0:00 → 0:25). Total previsto: 11 min 55 s nos 16 slides; ensaiar mirando 12 minutos.</a:t>
+              <a:t>TEMPO: 25 s (0:00 → 0:25). Total previsto: 12 min 05 s nos 16 slides; ensaiar mirando 12 minutos.</a:t>
             </a:r>
             <a:endParaRPr lang="en-US" dirty="0"/>
           </a:p>
@@ -676,14 +676,14 @@
           <a:p>
             <a:r>
               <a:rPr lang="en-US" dirty="0"/>
-              <a:t>FALA: Então, quando escolher? Primeiro, a indicação: inotrópico quando há disfunção ventricular com baixo débito e hipoperfusão, depois de otimizar volume e PAM; se a hipotensão é por vasoplegia, a droga é o vasopressor, e um inodilatador baixa ainda mais a pressão. Depois, o perfil farmacológico, que está na tabela. Milrinona quando a circulação pulmonar e o VD são o problema, como na hipertensão pulmonar e na saída de CEC com resistência pulmonar alta, e quando o betabloqueio ou a taquicardia limitam a dobutamina; ela precisa de uma PAM sustentada, em geral com noradrenalina. Dobutamina quando a pressão está baixa ou há vasoplegia, em que a vasodilatação e a meia-vida longa da milrinona pesam contra; na insuficiência renal; e quando se quer titulação rápida, porque a meia-vida é de minutos. No choque séptico com disfunção miocárdica, a SSC 2026 sugere dobutamina associada à noradrenalina, ou adrenalina isolada, e reconhece que faltam dados para preferir a dobutamina à milrinona: é preferência prática, não superioridade demonstrada.</a:t>
+              <a:t>FALA: Então, quando escolher? Primeiro, a indicação: inotrópico quando há disfunção ventricular com baixo débito e hipoperfusão, depois de otimizar volume e PAM; se a hipotensão é por vasoplegia, a droga é o vasopressor, e um inodilatador baixa ainda mais a pressão. Depois, o perfil farmacológico, que está na tabela. Milrinona quando a circulação pulmonar e o VD são o problema, como na hipertensão pulmonar e na saída de CEC com resistência pulmonar alta, e quando o betabloqueio ou a taquicardia limitam a dobutamina; ela precisa de uma PAM sustentada, em geral com noradrenalina. Dobutamina, junto com o vasopressor, quando o baixo débito vem acompanhado de hipotensão ou vasoplegia, em que a vasodilatação e a meia-vida longa da milrinona pesam contra; na insuficiência renal; e quando se quer titulação rápida, porque a meia-vida é de minutos. No choque séptico com disfunção miocárdica, a SSC 2026 sugere dobutamina associada à noradrenalina, ou adrenalina isolada, e reconhece que faltam dados para preferir a dobutamina à milrinona: é preferência prática, não superioridade demonstrada.</a:t>
             </a:r>
             <a:endParaRPr lang="en-US" dirty="0"/>
           </a:p>
           <a:p>
             <a:r>
               <a:rPr lang="en-US" dirty="0"/>
-              <a:t>TEMPO: 1 min 15 s (6:30 → 7:45)</a:t>
+              <a:t>TEMPO: 1 min 20 s (6:30 → 7:50)</a:t>
             </a:r>
             <a:endParaRPr lang="en-US" dirty="0"/>
           </a:p>
@@ -785,14 +785,14 @@
           <a:p>
             <a:r>
               <a:rPr lang="en-US" dirty="0"/>
-              <a:t>FALA: Agora duas aminas simpaticomiméticas que não são catecolaminas, as drogas de bolus do centro cirúrgico. Fenilefrina: agonista α1 direto, praticamente sem ação β; a PAM sobe pela resistência e a frequência cai por reflexo, o que pode reduzir o débito quando ele depende da frequência; é a escolha na hipotensão vasodilatadora com frequência normal ou alta. Efedrina: age diretamente em α e β e, sobretudo, libera noradrenalina das terminações; sobe pressão, frequência e débito, por isso é a escolha quando há bradicardia; perde efeito com doses repetidas, porque depleta a noradrenalina, e na cesárea atravessa a placenta e associa-se a mais acidose fetal que a fenilefrina.</a:t>
+              <a:t>FALA: Agora duas aminas simpaticomiméticas que não são catecolaminas, as drogas de bolus do centro cirúrgico. Fenilefrina: agonista α1 direto, praticamente sem ação β; a PAM sobe pela resistência e a frequência cai por reflexo, o que pode reduzir o débito quando ele depende da frequência; é a escolha na hipotensão vasodilatadora com frequência normal ou alta. Efedrina: age diretamente em α e β e, sobretudo, libera noradrenalina das terminações; sobe pressão, frequência e débito, por isso é a escolha quando há bradicardia; perde efeito com doses repetidas, em parte porque depleta a noradrenalina, e na cesárea atravessa a placenta e associa-se a mais acidose fetal que a fenilefrina.</a:t>
             </a:r>
             <a:endParaRPr lang="en-US" dirty="0"/>
           </a:p>
           <a:p>
             <a:r>
               <a:rPr lang="en-US" dirty="0"/>
-              <a:t>TEMPO: 50 s (7:45 → 8:35)</a:t>
+              <a:t>TEMPO: 50 s (7:50 → 8:40)</a:t>
             </a:r>
             <a:endParaRPr lang="en-US" dirty="0"/>
           </a:p>
@@ -894,7 +894,7 @@
           <a:p>
             <a:r>
               <a:rPr lang="en-US" dirty="0"/>
-              <a:t>TEMPO: 55 s (8:35 → 9:30)</a:t>
+              <a:t>TEMPO: 55 s (8:40 → 9:35)</a:t>
             </a:r>
             <a:endParaRPr lang="en-US" dirty="0"/>
           </a:p>
@@ -996,14 +996,14 @@
           <a:p>
             <a:r>
               <a:rPr lang="en-US" dirty="0"/>
-              <a:t>FALA: No choque séptico, a Surviving Sepsis Campaign, a diretriz internacional de sepse, atualizada em 2026, organiza os vasopressores em sequência: noradrenalina primeiro, cedo, mesmo por veia periférica; vasopressina quando a dose de noradrenalina sobe, sem limiar definido; adrenalina se a PAM continuar inadequada. É o mesmo raciocínio da aula: tônus com noradrenalina, outra via com vasopressina, e inotrópico apenas se houver disfunção cardíaca com hipoperfusão.</a:t>
+              <a:t>FALA: No choque séptico, a Surviving Sepsis Campaign, a diretriz internacional de sepse, atualizada em 2026, organiza os vasopressores em sequência: noradrenalina primeiro, cedo, mesmo por veia periférica; vasopressina quando a dose de noradrenalina sobe, sem limiar definido; adrenalina se a PAM continuar inadequada. É o mesmo raciocínio da aula: tônus com noradrenalina, outra via com vasopressina, e inotrópico apenas se houver disfunção cardíaca com hipoperfusão, com volume e PAM já otimizados.</a:t>
             </a:r>
             <a:endParaRPr lang="en-US" dirty="0"/>
           </a:p>
           <a:p>
             <a:r>
               <a:rPr lang="en-US" dirty="0"/>
-              <a:t>TEMPO: 30 s (9:30 → 10:00)</a:t>
+              <a:t>TEMPO: 35 s (9:35 → 10:10)</a:t>
             </a:r>
             <a:endParaRPr lang="en-US" dirty="0"/>
           </a:p>
@@ -1017,7 +1017,7 @@
           <a:p>
             <a:r>
               <a:rPr lang="en-US" dirty="0"/>
-              <a:t>SE PERGUNTAREM: o VASSPR (JAMA 2026, n = 3.959; 13 hospitais, desenho cluster-crossover com ordem sorteada) comparou políticas hospitalares de iniciar a vasopressina com 0,1 vs. 0,4 mcg/kg/min de noradrenalina-equivalente; a vasopressina foi usada em 52,4% vs. 32,9%, e a mortalidade foi 31,8% vs. 33,0%. A antecipação sistemática não trouxe benefício, o que não exclui ganho em pacientes selecionados. No OPTPRESS, alvo de 80–85 mmHg em idosos aumentou a mortalidade.</a:t>
+              <a:t>SE PERGUNTAREM: o VASSPR (JAMA 2026, n = 3.959; 13 hospitais, desenho cluster-crossover com ordem sorteada) comparou políticas hospitalares de iniciar a vasopressina com 0,1 vs. 0,4 mcg/kg/min de noradrenalina-equivalente; a vasopressina foi usada em 52,4% vs. 32,9%, e a mortalidade foi 31,8% vs. 33,0%. A antecipação sistemática não trouxe benefício, o que não exclui ganho em pacientes selecionados. No OPTPRESS, alvo de PAM de 80–85 mmHg em idosos aumentou a mortalidade.</a:t>
             </a:r>
             <a:endParaRPr lang="en-US" dirty="0"/>
           </a:p>
@@ -1105,14 +1105,14 @@
           <a:p>
             <a:r>
               <a:rPr lang="en-US" dirty="0"/>
-              <a:t>FALA: No centro cirúrgico, antes da droga, afastar causas tratáveis: plano profundo, hipovolemia, compressão aortocava, pneumotórax e anafilaxia. Depois, o mecanismo: tônus baixo com frequência normal ou alta, agonista α1; bradicardia, efedrina ou, se grave, adrenalina; baixo débito, inotrópico; vasoplegia refratária às catecolaminas, como após CEC, com IECA ou BRA ou na reperfusão do enxerto hepático, vasopressina, com azul de metileno como resgate; pré-carga baixa, volume. Um dado do nosso serviço ajuda nessa decisão: Gouvêa, Diaz e colaboradores acompanharam por ecocardiografia transesofágica o ventrículo direito de 19 pacientes selecionados em cinco fases do transplante hepático, e a função sistólica do VD se manteve preservada nos momentos avaliados, inclusive trinta minutos após a reperfusão. O estudo não mediu os primeiros minutos da reperfusão, então não diz se a instabilidade aguda é vasoplegia ou disfunção transitória do VD. O que ele sustenta é o método: usar o eco para separar disfunção de VD de vasoplegia antes de escolher entre inotrópico e vasopressor.</a:t>
+              <a:t>FALA: No centro cirúrgico, antes da droga, afastar causas tratáveis: plano profundo, hipovolemia, compressão aortocava, pneumotórax e anafilaxia. Depois, o mecanismo: tônus baixo com frequência normal ou alta, agonista α1; bradicardia, efedrina ou, se grave, adrenalina; baixo débito, inotrópico; vasoplegia refratária às catecolaminas, como após CEC, com IECA ou BRA ou na reperfusão do enxerto hepático, vasopressina, com azul de metileno como resgate; pré-carga baixa, volume. Um dado do nosso serviço ajuda nessa decisão: Gouvêa, Diaz e colaboradores acompanharam por ecocardiografia transesofágica o ventrículo direito de 19 pacientes selecionados em cinco fases do transplante hepático, e a função sistólica do VD se manteve preservada nos momentos avaliados, inclusive trinta minutos após a reperfusão. O estudo não mediu os primeiros minutos da reperfusão, então não diz se a instabilidade aguda é vasoplegia ou disfunção transitória do VD. O que fica dele para a prática é o método: usar o eco para separar disfunção de VD de vasoplegia antes de escolher entre inotrópico e vasopressor.</a:t>
             </a:r>
             <a:endParaRPr lang="en-US" dirty="0"/>
           </a:p>
           <a:p>
             <a:r>
               <a:rPr lang="en-US" dirty="0"/>
-              <a:t>TEMPO: 1 min 15 s (10:00 → 11:15)</a:t>
+              <a:t>TEMPO: 1 min 15 s (10:10 → 11:25)</a:t>
             </a:r>
             <a:endParaRPr lang="en-US" dirty="0"/>
           </a:p>
@@ -1214,14 +1214,14 @@
           <a:p>
             <a:r>
               <a:rPr lang="en-US" dirty="0"/>
-              <a:t>FALA: Voltando à pergunta do início: qual componente da PAM está falhando? Vasoplegia: noradrenalina e, quando a dose sobe, vasopressina. Baixo débito com hipoperfusão: inotrópico, com a milrinona sobretudo no VD com hipertensão pulmonar. Hipotensão vasodilatadora da anestesia com bradicardia: efedrina; com taquicardia: fenilefrina. Anafilaxia: adrenalina. A droga certa corrige o componente que falha, na menor dose eficaz e pelo menor tempo.</a:t>
+              <a:t>FALA: Voltando à pergunta do início: qual componente da PAM está falhando? Vasoplegia: noradrenalina e, quando a dose sobe, vasopressina. Baixo débito com hipoperfusão: inotrópico, com a milrinona sobretudo no VD com hipertensão pulmonar. Hipotensão vasodilatadora da anestesia com bradicardia: efedrina; com frequência normal ou alta: fenilefrina. Anafilaxia: adrenalina. A droga certa corrige o componente que falha, na menor dose eficaz e pelo menor tempo.</a:t>
             </a:r>
             <a:endParaRPr lang="en-US" dirty="0"/>
           </a:p>
           <a:p>
             <a:r>
               <a:rPr lang="en-US" dirty="0"/>
-              <a:t>TEMPO: 30 s (11:15 → 11:45)</a:t>
+              <a:t>TEMPO: 30 s (11:25 → 11:55)</a:t>
             </a:r>
             <a:endParaRPr lang="en-US" dirty="0"/>
           </a:p>
@@ -1323,7 +1323,7 @@
           <a:p>
             <a:r>
               <a:rPr lang="en-US" dirty="0"/>
-              <a:t>TEMPO: 10 s (11:45 → 11:55)</a:t>
+              <a:t>TEMPO: 10 s (11:55 → 12:05)</a:t>
             </a:r>
             <a:endParaRPr lang="en-US" dirty="0"/>
           </a:p>
@@ -1520,7 +1520,7 @@
           <a:p>
             <a:r>
               <a:rPr lang="en-US" dirty="0"/>
-              <a:t>FALA: Começo pela fisiologia. Na prática, a PAM é o débito cardíaco multiplicado pela resistência vascular sistêmica, somado à pressão venosa central. Como a PVC costuma ser baixa, a PAM depende sobretudo do débito e da resistência; quando a PVC sobe, o que cai é a perfusão, porque o órgão recebe a diferença entre a PAM e a PVC. Três situações. Na vasoplegia o problema é o tônus arterial, como na sepse, na anestesia geral e no bloqueio de neuroeixo: o alvo é o vasopressor. Na falência de bomba o débito é baixo e a resistência em geral alta: o alvo é a contratilidade. Na pré-carga baixa, a hipovolemia pede volume; o α1 contrai veias e recruta volume não estressado, mas não substitui a reposição.</a:t>
+              <a:t>FALA: Começo pela fisiologia. Na prática, a PAM é o débito cardíaco multiplicado pela resistência vascular sistêmica, somado à pressão venosa central. Como a PVC costuma ser baixa, a PAM depende sobretudo do débito e da resistência; quando a PVC sobe, o que cai é a perfusão, porque a pressão de perfusão do órgão é a diferença entre a PAM e a PVC. Três situações. Na vasoplegia o problema é o tônus vascular, sobretudo arterial, como na sepse, na anestesia geral e no bloqueio de neuroeixo: a droga é o vasopressor. Na falência de bomba o débito é baixo e a resistência em geral alta: o alvo é a contratilidade. Na pré-carga baixa, a hipovolemia pede volume; o α1 contrai veias e recruta volume não estressado, mas não substitui a reposição.</a:t>
             </a:r>
             <a:endParaRPr lang="en-US" dirty="0"/>
           </a:p>
@@ -1541,7 +1541,7 @@
           <a:p>
             <a:r>
               <a:rPr lang="en-US" dirty="0"/>
-              <a:t>SE PERGUNTAREM: A relação PAM = DC × RVS + PVC é a definição da RVS, não uma causa (Magder, Crit Care 2018): a RVS é calculada como (PAM − PVC)/DC. A pressão a jusante efetiva do leito arterial é uma pressão crítica de fechamento, acima da PVC; a PVC importa para a pressão de perfusão dos órgãos (PAM − PVC) e para o gradiente do retorno venoso (pressão sistêmica média − pressão de átrio direito). Persichini (Crit Care Med 2012; 16 pacientes com choque séptico): reduzir a dose de noradrenalina baixou a pressão sistêmica média e o retorno venoso, mais do que a resistência ao retorno venoso, com queda do débito; é a prova de que a venoconstrição α recruta volume não estressado. o esquema cobre os determinantes da PAM; a obstrução (tamponamento, embolia pulmonar, pneumotórax hipertensivo, auto-PEEP) é o quarto tipo de choque da classificação da ESICM 2014: o eco precoce a identifica, e o tratamento é da causa, não com amina. No intraoperatório, pneumotórax e compressão aortocava estão entre as causas a afastar (slide 16).</a:t>
+              <a:t>SE PERGUNTAREM: A relação PAM = DC × RVS + PVC é a definição da RVS, não uma causa (Magder, Crit Care 2018): a RVS é calculada como (PAM − PVC)/DC. A pressão a jusante efetiva do leito arterial é uma pressão crítica de fechamento, acima da PVC; a PVC importa para a pressão de perfusão dos órgãos (PAM − PVC) e para o gradiente do retorno venoso (pressão sistêmica média − pressão de átrio direito). Persichini (Crit Care Med 2012; 16 pacientes com choque séptico): reduzir a dose de noradrenalina baixou a pressão sistêmica média mais do que a resistência ao retorno venoso, com queda do retorno venoso e, portanto, do débito; é evidência de que a venoconstrição α recruta volume não estressado. O esquema cobre os determinantes da PAM; a obstrução (tamponamento, embolia pulmonar, pneumotórax hipertensivo, auto-PEEP) é o quarto tipo de choque da classificação da ESICM 2014: o eco precoce a identifica, e o tratamento é da causa, não com amina. No intraoperatório, pneumotórax e compressão aortocava estão entre as causas a afastar (slide 14).</a:t>
             </a:r>
             <a:endParaRPr lang="en-US" dirty="0"/>
           </a:p>
@@ -1650,7 +1650,7 @@
           <a:p>
             <a:r>
               <a:rPr lang="en-US" dirty="0"/>
-              <a:t>SE PERGUNTAREM: no OPTIME-CHF (Cuffe, JAMA 2002; 951 pacientes com IC descompensada sem indicação clara de inotrópico), milrinona vs. placebo por 48 h: sem benefício, com mais hipotensão sustentada e arritmia atrial. Em um ECR de 2025 (Tongyoo, Ann Med; 64 pacientes em choque séptico), a milrinona aumentou o débito em 6 horas em relação ao placebo, mas a mortalidade em 28 dias foi de 50% nos dois grupos. Na sepse a SvcO₂ pode estar normal ou alta apesar da hipoperfusão (defeito de extração e shunt microcirculatório); nesse caso, a diferença venoarterial de CO₂ acima de 6 mmHg indica fluxo insuficiente para remover o CO₂ produzido (Vallée, Intensive Care Med 2008). Limites de VPP e VVS: ventilação controlada sem esforço espontâneo, volume corrente de pelo menos 8 mL/kg, ritmo regular, tórax fechado, sem disfunção de VD nem hipertensão intra-abdominal; com volume corrente baixo a sensibilidade cai. Fora dessas condições: elevação passiva das pernas ou minidesafio hídrico com medida direta do débito (ESICM 2025).</a:t>
+              <a:t>SE PERGUNTAREM: no OPTIME-CHF (Cuffe, JAMA 2002; 951 pacientes com IC descompensada sem indicação clara de inotrópico), milrinona vs. placebo por 48 h: sem benefício, com mais hipotensão sustentada e arritmia atrial. Em um ECR (Tongyoo, Ann Med 2025; 64 pacientes em choque séptico), a milrinona aumentou o débito em 6 horas em relação ao placebo, mas a mortalidade em 28 dias foi de 50% nos dois grupos. Na sepse a SvcO₂ pode estar normal ou alta apesar da hipoperfusão (defeito de extração e shunt microcirculatório); nesse caso, a diferença venoarterial de CO₂ acima de 6 mmHg indica fluxo insuficiente para remover o CO₂ produzido (Vallée, Intensive Care Med 2008). Limites de VPP e VVS: ventilação controlada sem esforço espontâneo, volume corrente de pelo menos 8 mL/kg, ritmo regular, tórax fechado, sem disfunção de VD nem hipertensão intra-abdominal; com volume corrente baixo a sensibilidade cai. Fora dessas condições: elevação passiva das pernas ou minidesafio hídrico com medida direta do débito (ESICM 2025).</a:t>
             </a:r>
             <a:endParaRPr lang="en-US" dirty="0"/>
           </a:p>
@@ -1738,7 +1738,7 @@
           <a:p>
             <a:r>
               <a:rPr lang="en-US" dirty="0"/>
-              <a:t>FALA: Uma revisão breve dos receptores, apenas o que importa para as drogas de hoje. α1 contrai artérias e veias: sobe a resistência e o retorno venoso. α2, pré-sináptico, reduz a liberação de noradrenalina; é o alvo da dexmedetomidina. β1 aumenta contratilidade e frequência. β2 dilata vasos e brônquios e eleva glicemia e lactato. D1 dilata os leitos renal e mesentérico. V1 e PDE3 estão na tabela porque vasopressina e milrinona não dependem do adrenoceptor. Dois pontos práticos: as catecolaminas têm meia-vida de minutos, por isso vão em geral em infusão; fenilefrina e efedrina duram mais e permitem bolus. E o uso prolongado dessensibiliza os receptores.</a:t>
+              <a:t>FALA: Uma revisão breve dos receptores, apenas o que importa para as drogas de hoje. α1 contrai artérias e veias: sobe a resistência e o retorno venoso. α2, pré-sináptico, reduz a liberação de noradrenalina; é o alvo da dexmedetomidina. β1 aumenta contratilidade e frequência. β2 dilata vasos e brônquios e eleva glicemia e lactato. D1 dilata os leitos renal e mesentérico. V1 e PDE3 estão na tabela porque vasopressina e milrinona não dependem do adrenoceptor. Dois pontos práticos: as catecolaminas têm meia-vida de minutos, por isso vão em geral em infusão; fenilefrina e efedrina duram mais, por isso são as drogas habituais de bolus. E o uso prolongado dessensibiliza os receptores.</a:t>
             </a:r>
             <a:endParaRPr lang="en-US" dirty="0"/>
           </a:p>
@@ -1847,7 +1847,7 @@
           <a:p>
             <a:r>
               <a:rPr lang="en-US" dirty="0"/>
-              <a:t>FALA: Começo pela noradrenalina, a droga de primeira linha no choque séptico, com ação α1 potente e β1 modesta: sobe a PAM pela resistência e pela venoconstrição, com débito em geral mantido, podendo cair pela pós-carga, e frequência estável ou menor, por reflexo. Dose de 0,01 a 0,5 microgramas por quilo por minuto, sem teto fixo no choque refratário; no centro cirúrgico, bolus de 5 a 10 microgramas; pode começar em veia periférica calibrosa. Riscos: isquemia digital e esplâncnica, além de extravasamento.</a:t>
+              <a:t>FALA: Começo pela noradrenalina, a droga de primeira linha no choque séptico, com ação α1 potente e β1 modesta: sobe a PAM pela resistência e pela venoconstrição, com débito em geral mantido, que pode subir pelo retorno venoso ou cair pela pós-carga, e frequência estável ou menor, por reflexo. Dose de 0,01 a 0,5 microgramas por quilo por minuto, sem teto fixo no choque refratário; no centro cirúrgico, bolus de 5 a 10 microgramas; pode começar em veia periférica calibrosa. Riscos: isquemia digital e esplâncnica, além de extravasamento.</a:t>
             </a:r>
             <a:endParaRPr lang="en-US" dirty="0"/>
           </a:p>
@@ -1868,7 +1868,7 @@
           <a:p>
             <a:r>
               <a:rPr lang="en-US" dirty="0"/>
-              <a:t>SE PERGUNTAREM: no SOAP II (n = 1.679), a mortalidade em 28 dias foi semelhante à da dopamina (48,5% vs. 52,5%), com metade das arritmias (12,4% vs. 24,1%); a SSC 2026 recomenda a noradrenalina em vez da dopamina (forte, certeza alta). No Brasil, a ampola de hemitartarato de 2 mg/mL equivale a 1 mg/mL de base: registrar na prescrição se a dose está em base ou em sal. Início precoce (CENSER, Permpikul 2019: controle do choque em 6 h em 76% vs. 48%) e via periférica com protocolo (Tran 2020) estão nas referências. No extravasamento, fentolamina infiltrada no local. Afinidade por β1: a da noradrenalina é da mesma ordem da adrenalina; o que é modesto é o efeito cardíaco líquido, porque o barorreflexo e a pós-carga contêm a taquicardia e o aumento do débito; a ação β2 é pequena, por isso não há vasodilatação e o lactato sobe pouco.</a:t>
+              <a:t>SE PERGUNTAREM: no SOAP II (De Backer, N Engl J Med 2010; n = 1.679), a mortalidade em 28 dias foi semelhante à da dopamina (48,5% vs. 52,5%), com metade das arritmias (12,4% vs. 24,1%); a SSC 2026 recomenda a noradrenalina em vez da dopamina (recomendação forte). No Brasil, a ampola de hemitartarato de 2 mg/mL equivale a 1 mg/mL de base: registrar na prescrição se a dose está em base ou em sal. Início precoce (CENSER, Permpikul 2019: controle do choque em 6 h em 76% vs. 48%) e via periférica com protocolo (Tran 2020) estão nas referências. No extravasamento, fentolamina infiltrada no local. Afinidade por β1: a da noradrenalina é da mesma ordem da adrenalina; o que é modesto é o efeito cardíaco líquido, porque o barorreflexo e a pós-carga contêm a taquicardia e o aumento do débito; a ação β2 é pequena, por isso praticamente não há vasodilatação e o lactato sobe pouco. As barras do slide representam o efeito clínico esperado em cada via, não a afinidade pelo receptor.</a:t>
             </a:r>
             <a:endParaRPr lang="en-US" dirty="0"/>
           </a:p>
@@ -1977,7 +1977,7 @@
           <a:p>
             <a:r>
               <a:rPr lang="en-US" dirty="0"/>
-              <a:t>SE PERGUNTAREM: no CATS (Annane, Lancet 2007), mortalidade semelhante à do grupo noradrenalina + dobutamina (40% vs. 34%, NS), com mais acidose; no CAT (Myburgh, Intensive Care Med 2008), 12,9% dos pacientes em adrenalina foram retirados do estudo por efeitos metabólicos transitórios. No OptimaCC (Levy, J Am Coll Cardiol 2018; n = 57, choque cardiogênico pós-IAM), o índice cardíaco foi semelhante, mas houve mais choque refratário com adrenalina (37% vs. 7%), que era o principal desfecho de segurança; o estudo foi interrompido precocemente. Dose no choque séptico: a bula americana de epinefrina prevê infusão de 0,05–2 mcg/kg/min, titulada pela PAM. Cartão ANZAAG/ANZCA 2022 (adulto; 1 mg em 10 mL = 100 mcg/mL): grau 2, 10–20 mcg, e 50 mcg se não houver resposta; grau 3, 50–100 mcg, e 200 mcg se não houver resposta; repetir a cada 1–2 min; após mais de três bolus, infusão de 3 mg em 50 mL, de 3 a 40 mL/h; sem acesso venoso ou sem monitorização, 500 mcg IM na face lateral da coxa, repetível a cada 5 min.</a:t>
+              <a:t>SE PERGUNTAREM: no CATS (Annane, Lancet 2007), mortalidade semelhante à do grupo noradrenalina + dobutamina (40% vs. 34%, NS), com mais acidose; no CAT (Myburgh, Intensive Care Med 2008), 12,9% dos pacientes em adrenalina foram retirados do estudo por efeitos metabólicos transitórios. No OptimaCC (Levy, J Am Coll Cardiol 2018; n = 57, choque cardiogênico pós-IAM), o índice cardíaco foi semelhante, mas houve mais choque refratário com adrenalina (37% vs. 7%), que era o principal desfecho de segurança; o estudo foi interrompido precocemente. Dose no choque séptico: a bula americana de epinefrina prevê infusão de 0,05–2 mcg/kg/min, titulada pela PAM. Cartão ANZAAG/ANZCA 2022 (adulto; 1 mg em 10 mL = 100 mcg/mL): grau 2, 10–20 mcg, e 50 mcg se não houver resposta; grau 3, 50–100 mcg, e 200 mcg se não houver resposta; repetir a cada 1–2 min; após mais de três bolus, infusão de 3 mg em 50 mL, de 3 a 40 mL/h; sem acesso venoso ou sem monitorização, 500 mcg IM na face lateral da coxa, repetível a cada 5 min. Dose no choque séptico: a bula americana de epinefrina prevê infusão de 0,05–2 mcg/kg/min, titulada pela PAM. Cartão ANZCA/ANZAAG 2022 (adulto; 1 mg em 10 mL = 100 mcg/mL): grau 2, 10–20 mcg, e 50 mcg se não houver resposta; grau 3, 50–100 mcg, e 200 mcg se não houver resposta; repetir a cada 1–2 min; após mais de três bolus, infusão de 3 mg em 50 mL, de 3 a 40 mL/h; sem acesso venoso ou sem monitorização, 500 mcg IM na face lateral da coxa, repetível a cada 5 min.</a:t>
             </a:r>
             <a:endParaRPr lang="en-US" dirty="0"/>
           </a:p>
@@ -3845,7 +3845,7 @@
                           <a:ea typeface="Calibri" pitchFamily="34" charset="-122"/>
                           <a:cs typeface="Calibri" pitchFamily="34" charset="-120"/>
                         </a:rPr>
-                        <a:t>Age após o receptor β: mantém efeito</a:t>
+                        <a:t>Age após o receptor β: efeito em grande parte preservado</a:t>
                       </a:r>
                       <a:endParaRPr lang="en-US" sz="1200" dirty="0"/>
                     </a:p>
@@ -8404,7 +8404,7 @@
                 <a:gridCol w="3592513"/>
                 <a:gridCol w="6973888"/>
               </a:tblGrid>
-              <a:tr h="420985">
+              <a:tr h="660995">
                 <a:tc>
                   <a:txBody>
                     <a:bodyPr/>
@@ -8425,7 +8425,7 @@
                           <a:ea typeface="Calibri" pitchFamily="34" charset="-122"/>
                           <a:cs typeface="Calibri" pitchFamily="34" charset="-120"/>
                         </a:rPr>
-                        <a:t>Hipotensão vasodilatadora com taquicardia</a:t>
+                        <a:t>Hipotensão vasodilatadora com FC normal ou alta</a:t>
                       </a:r>
                       <a:endParaRPr lang="en-US" sz="1200" dirty="0"/>
                     </a:p>
@@ -8517,7 +8517,7 @@
           </p:nvPr>
         </p:nvGraphicFramePr>
         <p:xfrm>
-          <a:off x="812800" y="3993952"/>
+          <a:off x="812800" y="4233962"/>
           <a:ext cx="10566400" cy="914400"/>
         </p:xfrm>
         <a:graphic>
@@ -8662,7 +8662,7 @@
                 <a:ea typeface="Calibri" pitchFamily="34" charset="-122"/>
                 <a:cs typeface="Calibri" pitchFamily="34" charset="-120"/>
               </a:rPr>
-              <a:t>SSC 2026 · ESICM 2025 · Miller’s Anesthesia, 10ª ed. (2025)</a:t>
+              <a:t>SSC 2026 · ESICM 2025 · Miller’s Anesthesia, 10ª ed. (2025), cap. 16, 79</a:t>
             </a:r>
             <a:endParaRPr lang="en-US" sz="1200" dirty="0"/>
           </a:p>
@@ -9342,14 +9342,14 @@
       </p:sp>
       <p:sp>
         <p:nvSpPr>
-          <p:cNvPr id="9" name="Doses, indicações e cuidados de cada dro"/>
+          <p:cNvPr id="9" name="Conhecer doses, indicações e cuidados de"/>
           <p:cNvSpPr txBox="1"/>
           <p:nvPr/>
         </p:nvSpPr>
         <p:spPr>
           <a:xfrm>
             <a:off x="1371600" y="3173161"/>
-            <a:ext cx="3836789" cy="280591"/>
+            <a:ext cx="4703465" cy="280591"/>
           </a:xfrm>
           <a:prstGeom prst="rect">
             <a:avLst/>
@@ -9376,7 +9376,7 @@
                 <a:ea typeface="Calibri" pitchFamily="34" charset="-122"/>
                 <a:cs typeface="Calibri" pitchFamily="34" charset="-120"/>
               </a:rPr>
-              <a:t>Doses, indicações e cuidados de cada droga</a:t>
+              <a:t>Conhecer doses, indicações e cuidados de cada droga</a:t>
             </a:r>
             <a:endParaRPr lang="en-US" sz="1700" dirty="0"/>
           </a:p>
@@ -12522,16 +12522,16 @@
         <p:spPr>
           <a:xfrm>
             <a:off x="812800" y="5344753"/>
-            <a:ext cx="10585450" cy="231080"/>
-          </a:xfrm>
-          <a:prstGeom prst="rect">
-            <a:avLst/>
-          </a:prstGeom>
-          <a:noFill/>
-          <a:ln/>
-        </p:spPr>
-        <p:txBody>
-          <a:bodyPr wrap="none" lIns="0" tIns="0" rIns="0" bIns="0" rtlCol="0" anchor="t"/>
+            <a:ext cx="10585450" cy="462161"/>
+          </a:xfrm>
+          <a:prstGeom prst="rect">
+            <a:avLst/>
+          </a:prstGeom>
+          <a:noFill/>
+          <a:ln/>
+        </p:spPr>
+        <p:txBody>
+          <a:bodyPr wrap="square" lIns="0" tIns="0" rIns="0" bIns="0" rtlCol="0" anchor="t"/>
           <a:lstStyle/>
           <a:p>
             <a:pPr algn="l" indent="0" marL="0">
@@ -12549,7 +12549,7 @@
                 <a:ea typeface="Calibri" pitchFamily="34" charset="-122"/>
                 <a:cs typeface="Calibri" pitchFamily="34" charset="-120"/>
               </a:rPr>
-              <a:t>Catecolaminas: meia-vida de minutos, em geral infusão; fenilefrina e efedrina duram mais e permitem bolus. Uso prolongado: dessensibilização.</a:t>
+              <a:t>Catecolaminas: meia-vida de minutos, em geral infusão; fenilefrina e efedrina duram mais: são as drogas habituais de bolus. Uso prolongado: dessensibilização.</a:t>
             </a:r>
             <a:endParaRPr lang="en-US" sz="1300" dirty="0"/>
           </a:p>
@@ -13369,11 +13369,11 @@
         <p:spPr>
           <a:xfrm>
             <a:off x="4064000" y="1879501"/>
-            <a:ext cx="7315200" cy="1546622"/>
+            <a:ext cx="7315200" cy="1626989"/>
           </a:xfrm>
           <a:prstGeom prst="roundRect">
             <a:avLst>
-              <a:gd name="adj" fmla="val 4927"/>
+              <a:gd name="adj" fmla="val 4683"/>
             </a:avLst>
           </a:prstGeom>
           <a:solidFill>
@@ -13438,7 +13438,7 @@
         <p:spPr>
           <a:xfrm>
             <a:off x="4324350" y="2484480"/>
-            <a:ext cx="6813550" cy="497086"/>
+            <a:ext cx="6813550" cy="745629"/>
           </a:xfrm>
           <a:prstGeom prst="rect">
             <a:avLst/>
@@ -13465,7 +13465,7 @@
                 <a:ea typeface="Calibri" pitchFamily="34" charset="-122"/>
                 <a:cs typeface="Calibri" pitchFamily="34" charset="-120"/>
               </a:rPr>
-              <a:t>α1 potente, β1 modesto: sobe a PAM pela RVS e pelo retorno venoso; DC em geral mantido, podendo cair pela pós-carga; FC estável ou menor. 1ª linha no choque séptico.</a:t>
+              <a:t>α1 potente, β1 modesto: sobe a PAM pela RVS e pelo retorno venoso; DC em geral mantido: pode subir pelo retorno venoso ou cair pela pós-carga; FC estável ou menor. 1ª linha no choque séptico.</a:t>
             </a:r>
             <a:endParaRPr lang="en-US" sz="1350" dirty="0"/>
           </a:p>
@@ -13479,12 +13479,12 @@
         </p:nvSpPr>
         <p:spPr>
           <a:xfrm>
-            <a:off x="4064000" y="3527723"/>
-            <a:ext cx="7315200" cy="1546622"/>
+            <a:off x="4064000" y="3608090"/>
+            <a:ext cx="7315200" cy="1466255"/>
           </a:xfrm>
           <a:prstGeom prst="roundRect">
             <a:avLst>
-              <a:gd name="adj" fmla="val 4927"/>
+              <a:gd name="adj" fmla="val 5197"/>
             </a:avLst>
           </a:prstGeom>
           <a:solidFill>
@@ -13506,7 +13506,7 @@
         </p:nvSpPr>
         <p:spPr>
           <a:xfrm>
-            <a:off x="4324350" y="3784079"/>
+            <a:off x="4324350" y="3864446"/>
             <a:ext cx="6813550" cy="259060"/>
           </a:xfrm>
           <a:prstGeom prst="rect">
@@ -13548,7 +13548,7 @@
         </p:nvSpPr>
         <p:spPr>
           <a:xfrm>
-            <a:off x="4324350" y="4132702"/>
+            <a:off x="4324350" y="4213069"/>
             <a:ext cx="6813550" cy="497086"/>
           </a:xfrm>
           <a:prstGeom prst="rect">

</xml_diff>

<commit_message>
Versão 40: revisão das falas aplicada (desafio de volume corrente restrito ao volume corrente baixo, α2 com locus coeruleus e tronco encefálico, vasopressina por indicação, anafilaxia pelo cartão ANZCA/ANZAAG, nota da adrenalina sem duplicação); 17 slides, 15 min 25 s
Co-Authored-By: Claude Fable 5.1 <noreply@anthropic.com>
Claude-Session: https://claude.ai/code/session_01W6cLQUtwNHu1UUeBJH2XLT
</commit_message>
<xml_diff>
--- a/apresentacao/Aminas_Vasoativas.pptx
+++ b/apresentacao/Aminas_Vasoativas.pptx
@@ -123,25 +123,25 @@
   <p:extLst>
     <p:ext uri="{521415D9-36F7-43E2-AB2F-B90AF26B5E84}">
       <p14:sectionLst xmlns:p14="http://schemas.microsoft.com/office/powerpoint/2010/main">
-        <p14:section name="Abertura e objetivos" id="{b49fe14f-ed28-7243-ce57-2525329b2b8f}">
+        <p14:section name="Abertura e objetivos" id="{a45e46ca-debf-fb47-a2c1-8fa1601f81b4}">
           <p14:sldIdLst>
             <p14:sldId id="256"/>
             <p14:sldId id="257"/>
           </p14:sldIdLst>
         </p14:section>
-        <p14:section name="01 · Fisiologia: pressão, débito e perfusão" id="{7a2c43fe-a6f1-2241-5bba-bbc2c28dd865}">
+        <p14:section name="01 · Fisiologia: pressão, débito e perfusão" id="{8277609a-068b-70ea-0f23-cd38140c143e}">
           <p14:sldIdLst>
             <p14:sldId id="258"/>
             <p14:sldId id="259"/>
             <p14:sldId id="260"/>
           </p14:sldIdLst>
         </p14:section>
-        <p14:section name="02 · Receptores" id="{b2915a70-7cea-45a0-5a21-692693c3b530}">
+        <p14:section name="02 · Receptores" id="{6b92e832-7555-b2cf-8b4a-69d89aab77fc}">
           <p14:sldIdLst>
             <p14:sldId id="261"/>
           </p14:sldIdLst>
         </p14:section>
-        <p14:section name="03 · Drogas: noradrenalina, adrenalina, dobutamina (e dopamina), milrinona (escolha), fenilefrina e efedrina" id="{929cbe61-a191-2cde-ee03-21773e5b3cfe}">
+        <p14:section name="03 · Drogas: noradrenalina, adrenalina, dobutamina (e dopamina), milrinona (escolha), fenilefrina e efedrina" id="{689cbfd3-79d1-df0e-406a-a3a6c66fc6f9}">
           <p14:sldIdLst>
             <p14:sldId id="262"/>
             <p14:sldId id="263"/>
@@ -151,22 +151,22 @@
             <p14:sldId id="267"/>
           </p14:sldIdLst>
         </p14:section>
-        <p14:section name="04 · Além das aminas: vasopressina, hidrocortisona e azul de metileno" id="{10ec66f6-f51d-0a01-39b1-3320b5cb0530}">
+        <p14:section name="04 · Além das aminas: vasopressina, hidrocortisona e azul de metileno" id="{4702f689-7f35-7330-24ac-039d1ea2f47c}">
           <p14:sldIdLst>
             <p14:sldId id="268"/>
           </p14:sldIdLst>
         </p14:section>
-        <p14:section name="05 · Choque séptico: a sequência da SSC 2026" id="{65302dea-61eb-7480-5712-9565c89a4649}">
+        <p14:section name="05 · Choque séptico: a sequência da SSC 2026" id="{823d5a81-d0d0-ee65-9199-b7d5f9a23235}">
           <p14:sldIdLst>
             <p14:sldId id="269"/>
           </p14:sldIdLst>
         </p14:section>
-        <p14:section name="06 · Perioperatório: escolha da droga" id="{2b291c55-02e9-d1f8-41eb-b7fa0ad94412}">
+        <p14:section name="06 · Perioperatório: escolha da droga" id="{bf82be20-3ebb-0702-1f29-6d620df1415e}">
           <p14:sldIdLst>
             <p14:sldId id="270"/>
           </p14:sldIdLst>
         </p14:section>
-        <p14:section name="07 · Mensagens finais e encerramento" id="{10eaae6d-2f3a-2b5e-9da5-3da2048ae4b3}">
+        <p14:section name="07 · Mensagens finais e encerramento" id="{9c8f9c8a-cf5f-1d08-708c-b60b6b4b715e}">
           <p14:sldIdLst>
             <p14:sldId id="271"/>
             <p14:sldId id="272"/>
@@ -583,7 +583,7 @@
           <a:p>
             <a:r>
               <a:rPr lang="en-US" dirty="0"/>
-              <a:t>TEMPO: 25 s (0:00 → 0:25). Total previsto: 14 min 25 s nos 17 slides; ensaiar mirando 12 minutos.</a:t>
+              <a:t>TEMPO: 25 s (0:00 → 0:25). Total previsto: 15 min 25 s nos 17 slides; ensaiar mirando 12 minutos.</a:t>
             </a:r>
             <a:endParaRPr lang="en-US" dirty="0"/>
           </a:p>
@@ -678,14 +678,14 @@
           <a:p>
             <a:r>
               <a:rPr lang="en-US" dirty="0"/>
-              <a:t>FALA: A milrinona chega ao mesmo ponto por outra via: a dobutamina aumenta a produção de AMPc pelo receptor β1; a milrinona inibe a PDE3, a enzima que degrada o AMPc, e por isso age depois do receptor. É um inodilatador: aumenta contratilidade e relaxamento e reduz as resistências sistêmica e pulmonar. A indicação é a disfunção ventricular com baixo débito que exige inotrópico, sobretudo quando há hipertensão pulmonar ou falência de VD. Dose: ataque de 50 microgramas por quilo em 10 minutos, muitas vezes omitido, e manutenção de 0,375 a 0,75 microgramas por quilo por minuto. Costuma exigir noradrenalina; tem eliminação renal e meia-vida bem mais longa que a da dobutamina, acumulando na insuficiência renal.</a:t>
+              <a:t>FALA: A milrinona chega ao mesmo ponto por outra via: a dobutamina aumenta a produção de AMPc pelo receptor β1; a milrinona inibe a PDE3, uma das fosfodiesterases que degradam o AMPc no miocárdio e no vaso, e por isso age depois do receptor. É um inodilatador: aumenta contratilidade e relaxamento e reduz as resistências sistêmica e pulmonar. A indicação é a disfunção ventricular com baixo débito que exige inotrópico, sobretudo quando há hipertensão pulmonar ou falência de VD. Dose: ataque de 50 microgramas por quilo em 10 minutos, muitas vezes omitido, e manutenção de 0,375 a 0,75 microgramas por quilo por minuto. Costuma exigir noradrenalina; tem eliminação renal e meia-vida bem mais longa que a da dobutamina, acumulando na insuficiência renal.</a:t>
             </a:r>
             <a:endParaRPr lang="en-US" dirty="0"/>
           </a:p>
           <a:p>
             <a:r>
               <a:rPr lang="en-US" dirty="0"/>
-              <a:t>TEMPO: 55 s (7:55 → 8:50)</a:t>
+              <a:t>TEMPO: 55 s (8:15 → 9:10)</a:t>
             </a:r>
             <a:endParaRPr lang="en-US" dirty="0"/>
           </a:p>
@@ -787,14 +787,14 @@
           <a:p>
             <a:r>
               <a:rPr lang="en-US" dirty="0"/>
-              <a:t>FALA: Então, quando escolher? Primeiro, a indicação: inotrópico quando há disfunção ventricular com baixo débito e hipoperfusão, depois de otimizar volume e PAM; se a hipotensão é por vasoplegia, a droga é o vasopressor, e um inodilatador baixa ainda mais a pressão. Depois, o perfil farmacológico, que está na tabela. Milrinona quando a circulação pulmonar e o VD são o problema, como na hipertensão pulmonar e na saída de CEC com resistência pulmonar alta, e quando o betabloqueio ou a taquicardia limitam a dobutamina; ela precisa de uma PAM sustentada, em geral com noradrenalina. Dobutamina, junto com o vasopressor, quando o baixo débito vem acompanhado de hipotensão ou vasoplegia, em que a vasodilatação e a meia-vida longa da milrinona pesam contra; na insuficiência renal; e quando se quer titulação rápida, porque a meia-vida é de minutos. No choque séptico com disfunção miocárdica, a SSC 2026 sugere dobutamina associada à noradrenalina, ou adrenalina isolada, e reconhece que faltam dados para preferir a dobutamina à milrinona: é preferência prática, não superioridade demonstrada.</a:t>
+              <a:t>FALA: Então, quando escolher? Primeiro, a indicação: inotrópico quando há disfunção ventricular com baixo débito e hipoperfusão, depois de otimizar volume e PAM; se a hipotensão é por vasoplegia, a droga é o vasopressor, e um inodilatador baixa ainda mais a pressão. Depois, o perfil farmacológico, que está na tabela. Milrinona quando a circulação pulmonar e o VD são o problema, como na hipertensão pulmonar e na saída de CEC com resistência pulmonar alta, e quando o betabloqueio ou a taquicardia limitam a dobutamina; a milrinona precisa de uma PAM sustentada, em geral com noradrenalina. Dobutamina, junto com o vasopressor, quando o baixo débito vem acompanhado de hipotensão ou vasoplegia, em que a vasodilatação e a meia-vida longa da milrinona pesam contra; na insuficiência renal; e quando se quer titulação rápida, porque a meia-vida é de minutos. No choque séptico com disfunção miocárdica e hipoperfusão persistente, a Surviving Sepsis Campaign de 2026, a SSC, sugere dobutamina associada à noradrenalina, ou adrenalina isolada, e reconhece que faltam dados para preferir a dobutamina à milrinona: é preferência prática, não superioridade demonstrada.</a:t>
             </a:r>
             <a:endParaRPr lang="en-US" dirty="0"/>
           </a:p>
           <a:p>
             <a:r>
               <a:rPr lang="en-US" dirty="0"/>
-              <a:t>TEMPO: 1 min 20 s (8:50 → 10:10)</a:t>
+              <a:t>TEMPO: 1 min 20 s (9:10 → 10:30)</a:t>
             </a:r>
             <a:endParaRPr lang="en-US" dirty="0"/>
           </a:p>
@@ -896,14 +896,14 @@
           <a:p>
             <a:r>
               <a:rPr lang="en-US" dirty="0"/>
-              <a:t>FALA: Agora duas aminas simpaticomiméticas que não são catecolaminas, as drogas de bolus do centro cirúrgico. Fenilefrina: agonista α1 direto, praticamente sem ação β; a PAM sobe pela resistência e a frequência cai por reflexo, o que pode reduzir o débito quando ele depende da frequência; é a escolha na hipotensão vasodilatadora com frequência normal ou alta. Efedrina: age diretamente em α e β e, sobretudo, libera noradrenalina das terminações; sobe pressão, frequência e débito, por isso é a escolha quando há bradicardia; perde efeito com doses repetidas, em parte porque depleta a noradrenalina, e na cesárea atravessa a placenta e associa-se a mais acidose fetal que a fenilefrina.</a:t>
+              <a:t>FALA: Agora duas aminas simpaticomiméticas que não são catecolaminas, as drogas habituais de bolus do centro cirúrgico. Fenilefrina: agonista α1 direto, praticamente sem ação β; a PAM sobe pela resistência e a frequência cai por reflexo, o que pode reduzir o débito quando ele depende da frequência; é a escolha na hipotensão vasodilatadora com frequência normal ou alta. Efedrina: age diretamente em α e β e também, de forma indireta, libera noradrenalina das terminações; sobe pressão, frequência e débito, por isso é a escolha quando há bradicardia; perde efeito com doses repetidas, em parte porque depleta a noradrenalina, e na cesárea atravessa a placenta e associa-se a mais acidose fetal que a fenilefrina.</a:t>
             </a:r>
             <a:endParaRPr lang="en-US" dirty="0"/>
           </a:p>
           <a:p>
             <a:r>
               <a:rPr lang="en-US" dirty="0"/>
-              <a:t>TEMPO: 50 s (10:10 → 11:00)</a:t>
+              <a:t>TEMPO: 50 s (10:30 → 11:20)</a:t>
             </a:r>
             <a:endParaRPr lang="en-US" dirty="0"/>
           </a:p>
@@ -998,14 +998,14 @@
           <a:p>
             <a:r>
               <a:rPr lang="en-US" dirty="0"/>
-              <a:t>FALA: Quando a via adrenérgica não basta, três recursos além das aminas. A vasopressina age no receptor V1, fora da via adrenérgica: poupa catecolamina e costuma manter efeito em acidose; no choque séptico há deficiência relativa do hormônio endógeno. Dose fixa, em geral 0,03 unidades por minuto, no choque séptico com noradrenalina em escalada, na vasoplegia após CEC e na hipotensão refratária com IECA ou BRA; o risco é isquemia digital e mesentérica. A hidrocortisona restaura a resposta vascular às catecolaminas, 200 mg por dia no choque séptico. O azul de metileno inibe a via do óxido nítrico e fica como resgate na vasoplegia refratária, como após CEC ou na reperfusão do enxerto hepático.</a:t>
+              <a:t>FALA: Quando a via adrenérgica não basta, três recursos além das aminas. A vasopressina age no receptor V1, fora da via adrenérgica: poupa catecolamina e costuma manter efeito em acidose; no choque séptico há deficiência relativa do hormônio endógeno. No choque séptico, com noradrenalina em escalada, a dose é em geral fixa, 0,03 unidades por minuto; na vasoplegia após CEC, o VANCS titulou de 0,01 a 0,06 unidades por minuto; na hipotensão refratária com IECA ou BRA, bolus pequenos ou infusão titulada; o risco é isquemia digital e mesentérica. A hidrocortisona restaura a resposta vascular às catecolaminas, 200 mg por dia no choque séptico. O azul de metileno inibe a óxido nítrico sintase e a guanilato ciclase solúvel, e fica como resgate na vasoplegia refratária: após CEC, onde há mais estudos, e na reperfusão do enxerto hepático, onde a base são relatos e séries; um ensaio pequeno mostrou PAM maior e menos adrenalina com a dose dada antes da reperfusão, mas uma coorte pareada de 715 transplantes não confirmou benefício do uso profilático. Outras indicações, apenas para citar: metemoglobinemia, a indicação clássica, e choque séptico refratário, ainda em estudo. Cuidados: deficiência de G6PD, interferência na oximetria e no BIS, e síndrome serotoninérgica com ISRS.</a:t>
             </a:r>
             <a:endParaRPr lang="en-US" dirty="0"/>
           </a:p>
           <a:p>
             <a:r>
               <a:rPr lang="en-US" dirty="0"/>
-              <a:t>TEMPO: 55 s (11:00 → 11:55)</a:t>
+              <a:t>TEMPO: 1 min 35 s (11:20 → 12:55)</a:t>
             </a:r>
             <a:endParaRPr lang="en-US" dirty="0"/>
           </a:p>
@@ -1019,7 +1019,7 @@
           <a:p>
             <a:r>
               <a:rPr lang="en-US" dirty="0"/>
-              <a:t>SE PERGUNTAREM: no VANCS (Hajjar, Anesthesiology 2017, InCor), na vasoplegia pós-CEC, a vasopressina teve menos morte ou complicação grave que a noradrenalina (32% vs. 49%); é uma população de cirurgia cardíaca, e o resultado não deve ser extrapolado para o choque séptico. Hidrocortisona: 200 mg/dia (50 mg de 6/6 h ou em infusão). Angiotensina II: no ATHOS-3, a resposta da PAM em 3 h ocorreu em 69,9% vs. 23,4% dos pacientes, sem diferença de mortalidade; é pouco disponível. Azul de metileno: inibe a óxido nítrico sintase e a guanilato ciclase solúvel; resgate na vasoplegia pós-CEC e na reperfusão do enxerto hepático, com evidência limitada. Contraindicado na deficiência de G6PD (hemólise); subestima a SpO₂ na oximetria de pulso e reduz o BIS; síndrome serotoninérgica com ISRS e outros serotoninérgicos, por inibir a MAO-A.</a:t>
+              <a:t>SE PERGUNTAREM: no VANCS (Hajjar, Anesthesiology 2017, InCor), na vasoplegia pós-CEC, a vasopressina teve menos morte ou complicação grave que a noradrenalina (32% vs. 49%); é uma população de cirurgia cardíaca, e o resultado não deve ser extrapolado para o choque séptico. Hidrocortisona: 200 mg/dia (50 mg de 6/6 h ou em infusão). Angiotensina II: no ATHOS-3, a resposta da PAM em 3 h ocorreu em 69,9% vs. 23,4% dos pacientes, sem diferença de mortalidade; é pouco disponível. Azul de metileno: inibe a óxido nítrico sintase e a guanilato ciclase solúvel; na vasoplegia, em geral 1,5 a 2 mg/kg EV em 20 a 30 min. Pós-CEC: ensaios pequenos e séries. Transplante hepático: ECR de 36 pacientes com 1,5 mg/kg antes da reperfusão (Koelzow, Anesth Analg 2002): PAM maior e menos adrenalina; coorte pareada por propensão de 715 transplantes, 105 com azul de metileno profilático de 1 a 1,5 mg/kg (Fukazawa, J Hepatobiliary Pancreat Sci 2011): sem redução da hipotensão da reperfusão, do vasopressor ou da transfusão, e sem efeito na função do enxerto; revisões de 2021 e 2025 apontam a falta de ECRs no transplante e a hidroxocobalamina como alternativa em estudo. Outras indicações: metemoglobinemia (1 a 2 mg/kg EV, a indicação clássica); choque séptico (metanálise de ECRs: menos tempo de vasopressor e de UTI, sem substituir a vasopressina); encefalopatia por ifosfamida; relatos em anafilaxia refratária e em intoxicação por betabloqueador ou bloqueador de canal de cálcio. Contraindicado na deficiência de G6PD (hemólise, com anemia que pode aparecer dias depois); subestima a SpO₂ e pode reduzir o BIS (a bula recomenda outro método para avaliar a profundidade anestésica); síndrome serotoninérgica com ISRS, IRSN, IMAO e alguns opioides, por inibir a MAO-A.</a:t>
             </a:r>
             <a:endParaRPr lang="en-US" dirty="0"/>
           </a:p>
@@ -1107,21 +1107,21 @@
           <a:p>
             <a:r>
               <a:rPr lang="en-US" dirty="0"/>
-              <a:t>FALA: No choque séptico, a Surviving Sepsis Campaign, a diretriz internacional de sepse, atualizada em 2026, organiza os vasopressores em sequência: noradrenalina primeiro, cedo, mesmo por veia periférica; vasopressina quando a dose de noradrenalina sobe, sem limiar definido; adrenalina se a PAM continuar inadequada. É o mesmo raciocínio da aula: tônus com noradrenalina, outra via com vasopressina, e inotrópico apenas se houver disfunção cardíaca com hipoperfusão, com volume e PAM já otimizados.</a:t>
+              <a:t>FALA: No choque séptico, a Surviving Sepsis Campaign, a diretriz internacional de sepse, atualizada em 2026, organiza os vasopressores em sequência: noradrenalina primeiro, cedo, mesmo por veia periférica; vasopressina quando a dose de noradrenalina sobe, sem limiar definido; adrenalina se a PAM continuar inadequada. É o mesmo raciocínio da aula: tônus com noradrenalina, outra via com vasopressina, e inotrópico reservado à disfunção cardíaca com hipoperfusão, com volume e PAM já otimizados.</a:t>
             </a:r>
             <a:endParaRPr lang="en-US" dirty="0"/>
           </a:p>
           <a:p>
             <a:r>
               <a:rPr lang="en-US" dirty="0"/>
-              <a:t>TEMPO: 35 s (11:55 → 12:30)</a:t>
+              <a:t>TEMPO: 35 s (12:55 → 13:30)</a:t>
             </a:r>
             <a:endParaRPr lang="en-US" dirty="0"/>
           </a:p>
           <a:p>
             <a:r>
               <a:rPr lang="en-US" dirty="0"/>
-              <a:t>PONTO-CHAVE: Noradrenalina, depois vasopressina, depois adrenalina; inotrópico apenas com disfunção cardíaca e hipoperfusão.</a:t>
+              <a:t>PONTO-CHAVE: Noradrenalina, depois vasopressina, depois adrenalina; inotrópico reservado à disfunção cardíaca com hipoperfusão.</a:t>
             </a:r>
             <a:endParaRPr lang="en-US" dirty="0"/>
           </a:p>
@@ -1216,14 +1216,14 @@
           <a:p>
             <a:r>
               <a:rPr lang="en-US" dirty="0"/>
-              <a:t>FALA: No centro cirúrgico, antes da droga, afastar causas tratáveis: plano profundo, hipovolemia, compressão aortocava, pneumotórax e anafilaxia. Depois, o mecanismo: tônus baixo com frequência normal ou alta, agonista α1; bradicardia, efedrina ou, se grave, adrenalina; baixo débito, inotrópico; vasoplegia refratária às catecolaminas, como após CEC, com IECA ou BRA ou na reperfusão do enxerto hepático, vasopressina, com azul de metileno como resgate; pré-carga baixa, volume. Um dado do nosso serviço ajuda nessa decisão: Gouvêa, Diaz e colaboradores acompanharam por ecocardiografia transesofágica o ventrículo direito de 19 pacientes selecionados em cinco fases do transplante hepático, e a função sistólica do VD se manteve preservada nos momentos avaliados, inclusive trinta minutos após a reperfusão. O estudo não mediu os primeiros minutos da reperfusão, então não diz se a instabilidade aguda é vasoplegia ou disfunção transitória do VD. O que fica dele para a prática é o método: usar o eco para separar disfunção de VD de vasoplegia antes de escolher entre inotrópico e vasopressor.</a:t>
+              <a:t>FALA: No centro cirúrgico, antes da droga, afastar causas tratáveis: plano profundo, hipovolemia, compressão aortocava, pneumotórax e anafilaxia. Depois, o mecanismo: tônus baixo com frequência normal ou alta, agonista α1; bradicardia, efedrina ou, se grave, adrenalina; baixo débito, inotrópico; vasoplegia refratária às catecolaminas, que é a do pós-CEC, do paciente em IECA ou BRA e da reperfusão do enxerto hepático: vasopressina, e azul de metileno como resgate; pré-carga baixa, volume. Um dado do nosso serviço ajuda nessa decisão: Gouvêa, Diaz e colaboradores acompanharam por ecocardiografia transesofágica o ventrículo direito de 19 pacientes selecionados em cinco fases do transplante hepático, e a função sistólica do VD se manteve preservada nos momentos avaliados, inclusive trinta minutos após a reperfusão. O estudo não mediu os primeiros minutos da reperfusão, então não diz se a instabilidade aguda é vasoplegia ou disfunção transitória do VD. O que fica dele para a prática é o método: usar o eco para separar disfunção de VD de vasoplegia antes de escolher entre inotrópico e vasopressor.</a:t>
             </a:r>
             <a:endParaRPr lang="en-US" dirty="0"/>
           </a:p>
           <a:p>
             <a:r>
               <a:rPr lang="en-US" dirty="0"/>
-              <a:t>TEMPO: 1 min 15 s (12:30 → 13:45)</a:t>
+              <a:t>TEMPO: 1 min 15 s (13:30 → 14:45)</a:t>
             </a:r>
             <a:endParaRPr lang="en-US" dirty="0"/>
           </a:p>
@@ -1332,7 +1332,7 @@
           <a:p>
             <a:r>
               <a:rPr lang="en-US" dirty="0"/>
-              <a:t>TEMPO: 30 s (13:45 → 14:15)</a:t>
+              <a:t>TEMPO: 30 s (14:45 → 15:15)</a:t>
             </a:r>
             <a:endParaRPr lang="en-US" dirty="0"/>
           </a:p>
@@ -1434,7 +1434,7 @@
           <a:p>
             <a:r>
               <a:rPr lang="en-US" dirty="0"/>
-              <a:t>TEMPO: 10 s (14:15 → 14:25)</a:t>
+              <a:t>TEMPO: 10 s (15:15 → 15:25)</a:t>
             </a:r>
             <a:endParaRPr lang="en-US" dirty="0"/>
           </a:p>
@@ -1631,7 +1631,7 @@
           <a:p>
             <a:r>
               <a:rPr lang="en-US" dirty="0"/>
-              <a:t>FALA: Começo pela fisiologia. Na prática, a PAM é o débito cardíaco multiplicado pela resistência vascular sistêmica, somado à pressão venosa central. Como a PVC costuma ser baixa, a PAM depende sobretudo do débito e da resistência; quando a PVC sobe, o que cai é a perfusão, porque a pressão de perfusão do órgão é a diferença entre a PAM e a PVC. Três situações. Na vasoplegia o problema é o tônus vascular, sobretudo arterial, como na sepse, na anestesia geral e no bloqueio de neuroeixo: a droga é o vasopressor. Na falência de bomba o débito é baixo e a resistência em geral alta: o alvo é a contratilidade. Na pré-carga baixa, a hipovolemia pede volume; o α1 contrai veias e recruta volume não estressado, mas não substitui a reposição.</a:t>
+              <a:t>FALA: Começo pela fisiologia. Na prática, a PAM é o débito cardíaco multiplicado pela resistência vascular sistêmica, somado à pressão venosa central. Como a PVC costuma ser baixa, a PAM depende sobretudo do débito e da resistência; quando a PVC sobe, o que cai é a perfusão, porque, na prática, a pressão de perfusão do órgão aproxima-se da diferença entre a PAM e a PVC. Três situações. Na vasoplegia o problema é o tônus vascular, sobretudo arterial, como na sepse, na anestesia geral e no bloqueio de neuroeixo: a droga é o vasopressor. Na falência de bomba o débito é baixo e a resistência em geral alta: o alvo é a contratilidade. Na pré-carga baixa, a hipovolemia pede volume; o α1 contrai veias e recruta volume não estressado, mas não substitui a reposição.</a:t>
             </a:r>
             <a:endParaRPr lang="en-US" dirty="0"/>
           </a:p>
@@ -1652,7 +1652,7 @@
           <a:p>
             <a:r>
               <a:rPr lang="en-US" dirty="0"/>
-              <a:t>SE PERGUNTAREM: A relação PAM = DC × RVS + PVC é a definição da RVS, não uma causa (Magder, Crit Care 2018): a RVS é calculada como (PAM − PVC)/DC. A pressão a jusante efetiva do leito arterial é uma pressão crítica de fechamento, acima da PVC; a PVC importa para a pressão de perfusão dos órgãos (PAM − PVC) e para o gradiente do retorno venoso (pressão sistêmica média − pressão de átrio direito). Persichini (Crit Care Med 2012; 16 pacientes com choque séptico): reduzir a dose de noradrenalina baixou a pressão sistêmica média mais do que a resistência ao retorno venoso, com queda do retorno venoso e, portanto, do débito; é evidência de que a venoconstrição α recruta volume não estressado. O esquema cobre os determinantes da PAM; a obstrução (tamponamento, embolia pulmonar, pneumotórax hipertensivo, auto-PEEP) é o quarto tipo de choque da classificação da ESICM 2014: o eco precoce a identifica, e o tratamento é da causa, não com amina. No intraoperatório, pneumotórax e compressão aortocava estão entre as causas a afastar (slide 14).</a:t>
+              <a:t>SE PERGUNTAREM: A relação PAM = DC × RVS + PVC é a definição da RVS, não uma causa (Magder, Crit Care 2018): a RVS é calculada como (PAM − PVC)/DC. A pressão a jusante efetiva do leito arterial é uma pressão crítica de fechamento, acima da PVC; a PVC importa para a pressão de perfusão dos órgãos (PAM − PVC) e para o gradiente do retorno venoso (pressão sistêmica média − pressão de átrio direito). Persichini (Crit Care Med 2012; 16 pacientes com choque séptico): reduzir a dose de noradrenalina baixou a pressão sistêmica média mais do que a resistência ao retorno venoso, com queda do retorno venoso e, portanto, do débito; é evidência de que a venoconstrição α recruta volume não estressado. O esquema cobre os determinantes da PAM; a obstrução (tamponamento, embolia pulmonar, pneumotórax hipertensivo, auto-PEEP) é o quarto tipo de choque da classificação da ESICM 2014: o eco precoce a identifica, e o tratamento é da causa, não com amina. No intraoperatório, pneumotórax e compressão aortocava estão entre as causas a afastar (slide 15).</a:t>
             </a:r>
             <a:endParaRPr lang="en-US" dirty="0"/>
           </a:p>
@@ -1740,7 +1740,7 @@
           <a:p>
             <a:r>
               <a:rPr lang="en-US" dirty="0"/>
-              <a:t>FALA: Mas pressão não é fluxo: uma resistência alta pode manter a PAM com débito baixo. No intraoperatório a perfusão raramente é medida de forma direta, então o caminho é combinar métodos. O eco, transesofágico ou à beira do leito, é o mais rápido para definir o tipo de choque, e a ESICM 2025 o coloca como primeira linha para isso: função do VE e do VD, com a fração de variação de área e o TAPSE para o VD; volemia, pela área do VE ao fim da diástole; pericárdio; e o VTI na via de saída, que multiplicado pela área da via de saída dá o volume sistólico e, repetido, mostra a resposta a volume ou a droga. Os monitores de débito dão o número contínuo e a resposta a uma intervenção. E os marcadores de perfusão tissular dizem se o fluxo está bastando: lactato e sua tendência, saturação venosa central, gap de CO₂, diurese, enchimento capilar e temperatura das extremidades. A decisão de usar inotrópico vem daí, não da pressão.</a:t>
+              <a:t>FALA: Mas pressão não é fluxo: uma resistência alta pode manter a PAM com débito baixo. No intraoperatório a perfusão raramente é medida de forma direta, então o caminho é combinar métodos. O eco, transesofágico ou à beira do leito, é o primeiro recurso para definir o tipo de choque, e a diretriz europeia de terapia intensiva de 2025 o sugere como primeira linha de imagem para isso: função do VE e do VD, com a variação fracional de área e o TAPSE para o VD; volemia, pela área do VE ao fim da diástole; pericárdio; e o VTI na via de saída, que multiplicado pela área da via de saída dá o volume sistólico e, repetido, mostra a resposta a volume ou a droga. Os monitores de débito dão o número, contínuo ou seriado, e a resposta a uma intervenção. E os marcadores de perfusão tissular dizem se o fluxo está bastando: lactato e sua tendência, saturação venosa central, gap de CO₂, diurese, enchimento capilar e temperatura das extremidades. A decisão de usar inotrópico vem daí, não da pressão.</a:t>
             </a:r>
             <a:endParaRPr lang="en-US" dirty="0"/>
           </a:p>
@@ -1761,7 +1761,7 @@
           <a:p>
             <a:r>
               <a:rPr lang="en-US" dirty="0"/>
-              <a:t>SE PERGUNTAREM: no OPTIME-CHF (Cuffe, JAMA 2002; 951 pacientes com IC descompensada sem indicação clara de inotrópico), milrinona vs. placebo por 48 h: sem benefício, com mais hipotensão sustentada e arritmia atrial. Em um ECR (Tongyoo, Ann Med 2025; 64 pacientes em choque séptico), a milrinona aumentou o débito em 6 horas em relação ao placebo, mas a mortalidade em 28 dias foi de 50% nos dois grupos. Na sepse a SvcO₂ pode estar normal ou alta apesar da hipoperfusão (defeito de extração e shunt microcirculatório); nesse caso, a diferença venoarterial de CO₂ acima de 6 mmHg indica fluxo insuficiente para remover o CO₂ produzido (Vallée, Intensive Care Med 2008). Limites de VPP e VVS: ventilação controlada sem esforço espontâneo, volume corrente de pelo menos 8 mL/kg, ritmo regular, tórax fechado, sem disfunção de VD nem hipertensão intra-abdominal; com volume corrente baixo a sensibilidade cai. Fora dessas condições: elevação passiva das pernas ou minidesafio hídrico com medida direta do débito (ESICM 2025).</a:t>
+              <a:t>SE PERGUNTAREM: no OPTIME-CHF (Cuffe, JAMA 2002; 951 pacientes com IC descompensada sem indicação clara de inotrópico), milrinona vs. placebo por 48 h: sem benefício, com mais hipotensão sustentada e arritmia atrial. Em um ECR (Tongyoo, Ann Med 2025; 64 pacientes em choque séptico), a milrinona aumentou o débito em 6 horas em relação ao placebo, mas a mortalidade em 28 dias foi de 50% nos dois grupos. Na sepse a SvcO₂ pode estar normal ou alta apesar da hipoperfusão (defeito de extração e shunt microcirculatório); nesse caso, a diferença venoarterial de CO₂ acima de 6 mmHg sugere fluxo insuficiente para remover o CO₂ produzido (Vallée, Intensive Care Med 2008). Limites de VPP e VVS: ventilação controlada sem esforço espontâneo, volume corrente de pelo menos 8 mL/kg, ritmo regular, tórax fechado, sem disfunção de VD nem hipertensão intra-abdominal; com volume corrente baixo a sensibilidade cai. Fora dessas condições: elevação passiva das pernas ou minidesafio hídrico com medida direta do débito (ESICM 2025).</a:t>
             </a:r>
             <a:endParaRPr lang="en-US" dirty="0"/>
           </a:p>
@@ -1849,14 +1849,14 @@
           <a:p>
             <a:r>
               <a:rPr lang="en-US" dirty="0"/>
-              <a:t>FALA: Monitores de débito: o que cada um mede e onde falha. A termodiluição pelo cateter de artéria pulmonar continua a referência clínica: bolus frio no átrio direito e curva de temperatura na artéria pulmonar; dá também as pressões pulmonares e a saturação venosa mista; é invasiva e intermitente, reservada ao choque refratário, à disfunção de VD e à hipertensão pulmonar. A termodiluição transpulmonar, como o PiCCO, lê o bolus em artéria femoral, calibra o contorno de pulso e estima volumes cardíacos e água pulmonar extravascular. O contorno de pulso não calibrado, como o FloTrac, estima o volume sistólico pela forma da onda arterial; é contínuo e pouco invasivo, mas perde acurácia quando o tônus vascular muda, com resistência baixa ou vasopressor: no cirrótico, o erro contra a termodiluição chegou a 54%, bem acima dos 30% aceitáveis. O Doppler esofágico estima o volume sistólico pela velocidade na aorta descendente e um nomograma; depende da posição e do ângulo da sonda. VPP e VVS exigem ventilação controlada sem esforço, volume corrente de pelo menos 8 mL/kg, ritmo regular, tórax fechado, sem disfunção de VD nem hipertensão intra-abdominal; entre 9 e 13% há uma zona cinzenta. Fora disso: desafio de volume corrente, de 6 para 8 mL/kg por um minuto; elevação passiva das pernas, com aumento do débito de 10% ou mais; ou minidesafio de 100 mL, medindo o débito, não a pressão.</a:t>
+              <a:t>FALA: Monitores de débito: o que cada um mede e onde falha. A termodiluição pelo cateter de artéria pulmonar continua a referência clínica: bolus frio no átrio direito e curva de temperatura na artéria pulmonar; dá também as pressões pulmonares e a saturação venosa mista; é invasiva e, no modo clássico, intermitente; fica sugerida sobretudo no choque refratário, na disfunção de VD e na hipertensão pulmonar. A termodiluição transpulmonar, como o PiCCO, lê o bolus em artéria femoral, calibra o contorno de pulso e estima volumes cardíacos e água pulmonar extravascular. O contorno de pulso não calibrado, como o FloTrac, estima o volume sistólico pela forma da onda arterial; é contínuo e pouco invasivo, mas perde acurácia quando o tônus vascular muda, com resistência baixa ou vasopressor: no cirrótico, o erro contra a termodiluição chegou a 54%, bem acima dos 30% aceitáveis. O Doppler esofágico estima o volume sistólico pela velocidade na aorta descendente e um nomograma; depende da posição e do ângulo da sonda. VPP e VVS exigem ventilação controlada sem esforço, volume corrente de pelo menos 8 mL/kg, ritmo regular, tórax fechado, sem disfunção de VD nem hipertensão intra-abdominal; para a VPP, entre 9 e 13% há uma zona cinzenta. Quando a limitação é o volume corrente baixo, mantidas as demais condições: desafio de volume corrente, de 6 para 8 mL/kg por um minuto. Fora dessas condições: elevação passiva das pernas, com aumento do débito de 10% ou mais, ou minidesafio de 100 mL, medindo o débito, não a pressão.</a:t>
             </a:r>
             <a:endParaRPr lang="en-US" dirty="0"/>
           </a:p>
           <a:p>
             <a:r>
               <a:rPr lang="en-US" dirty="0"/>
-              <a:t>TEMPO: 1 min 50 s (3:10 → 5:00)</a:t>
+              <a:t>TEMPO: 1 min 55 s (3:10 → 5:05)</a:t>
             </a:r>
             <a:endParaRPr lang="en-US" dirty="0"/>
           </a:p>
@@ -1870,7 +1870,7 @@
           <a:p>
             <a:r>
               <a:rPr lang="en-US" dirty="0"/>
-              <a:t>SE PERGUNTAREM: Cannesson (Anesthesiology 2011): zona cinzenta da VPP entre 9 e 13% em pacientes sob anestesia geral e ventilação mecânica. Myatra (Crit Care Med 2017; 20 pacientes ventilados com 6 mL/kg): o aumento da VPP ou da VVS após elevar o volume corrente para 8 mL/kg por 1 min previu a resposta a volume. Monnet (Intensive Care Med 2016; metanálise, 21 estudos, 991 pacientes): elevação passiva das pernas com aumento do débito de 10% ou mais tem sensibilidade de 85% e especificidade de 91%; medida pela pressão de pulso, a sensibilidade cai para 56%. Biais (Anesthesiology 2017; 44 pacientes em neurocirurgia): 100 mL de cristaloide em 1 min, aumento do índice sistólico acima de 6% ao contorno de pulso previu a resposta a 250 mL (sensibilidade 93%, especificidade 85%; zona cinzenta de 4 a 7%). Biancofiore (Br J Anaesth 2009; cirróticos em cirurgia hepática): FloTrac/Vigileo de segunda geração vs. termodiluição pulmonar, erro percentual de 54% (limite aceito de 30%), pior com resistência baixa; o software seguinte ficou em 52%, e um estudo de 2022 com a quarta geração no transplante hepático manteve erro em torno de 54%. ESICM 2025: eco como primeira linha para definir o tipo de choque; monitorização de débito ou volume sistólico em quem não responde ao tratamento inicial; avaliar a responsividade antes de mais volume; perfusão tissular avaliada de forma seriada. Doppler esofágico: supõe que cerca de 70% do débito passa pela aorta descendente, proporção que varia entre pacientes. Sob anestesia, o ETE também permite ver a variação do diâmetro da veia cava superior com a ventilação, outro índice dinâmico, e a área diastólica final do VE para estimar a volemia.</a:t>
+              <a:t>SE PERGUNTAREM: Cannesson (Anesthesiology 2011): zona cinzenta da VPP entre 9 e 13% em pacientes sob anestesia geral e ventilação mecânica. Myatra (Crit Care Med 2017; 20 pacientes ventilados com 6 mL/kg): o aumento da VPP ou da VVS após elevar o volume corrente para 8 mL/kg por 1 min previu a resposta a volume. Monnet (Intensive Care Med 2016; metanálise, 21 estudos, 991 pacientes): elevação passiva das pernas com aumento do débito de 10% ou mais tem sensibilidade de 85% e especificidade de 91%; medida pela pressão de pulso, a sensibilidade cai para 56%. Biais (Anesthesiology 2017; 44 pacientes em neurocirurgia): 100 mL de cristaloide em dois passos de 50 mL, 1 min cada, com o índice sistólico medido ao contorno de pulso após cada passo; aumento acima de 6% após os 100 mL previu a resposta a 250 mL (sensibilidade 93%, especificidade 85%; zona cinzenta de 4 a 7%). Biancofiore (Br J Anaesth 2009; cirróticos em cirurgia hepática): FloTrac/Vigileo de segunda geração vs. termodiluição pulmonar, erro percentual de 54% (limite aceito de 30%), pior com resistência baixa; o software seguinte ficou em 52%, e um estudo de 2022 com a quarta geração no transplante hepático manteve erro em torno de 54%. ESICM 2025: eco como primeira linha para definir o tipo de choque; monitorização de débito ou volume sistólico em quem não responde ao tratamento inicial; avaliar a responsividade antes de mais volume; perfusão tissular avaliada de forma seriada. Doppler esofágico: supõe que cerca de 70% do débito passa pela aorta descendente, proporção que varia entre pacientes. Sob anestesia, o ETE também permite ver a variação do diâmetro da veia cava superior com a ventilação, outro índice dinâmico, e a área diastólica final do VE para estimar a volemia.</a:t>
             </a:r>
             <a:endParaRPr lang="en-US" dirty="0"/>
           </a:p>
@@ -1958,14 +1958,14 @@
           <a:p>
             <a:r>
               <a:rPr lang="en-US" dirty="0"/>
-              <a:t>FALA: Uma revisão breve dos receptores, apenas o que importa para as drogas de hoje. α1 contrai artérias e veias: sobe a resistência e o retorno venoso. α2 está em três lugares: pré-sináptico, reduzindo a liberação de noradrenalina; no locus coeruleus, com sedação e simpatólise, que é o efeito da dexmedetomidina; e no músculo liso vascular, onde contrai o vaso e explica a hipertensão inicial do bolus. β1 aumenta contratilidade e frequência. β2 dilata vasos e brônquios e eleva glicemia e lactato. D1 dilata os leitos renal e mesentérico. V1 e PDE3 estão na tabela porque vasopressina e milrinona não dependem do adrenoceptor. Dois pontos práticos: as catecolaminas têm meia-vida de minutos, por isso vão em geral em infusão; fenilefrina e efedrina duram mais, por isso são as drogas habituais de bolus. E o uso prolongado dessensibiliza os receptores.</a:t>
+              <a:t>FALA: Uma revisão breve dos receptores, apenas o que importa para as drogas de hoje. α1 contrai artérias e veias: sobe a resistência e o retorno venoso. α2 está em três lugares que importam aqui: pré-sináptico, reduzindo a liberação de noradrenalina; no sistema nervoso central, com sedação pelo locus coeruleus e simpatólise pelos centros vasomotores do tronco encefálico, que é o efeito da dexmedetomidina; e no músculo liso vascular, onde a noradrenalina e a adrenalina também agem, somando vasoconstrição, e onde um bolus de dexmedetomidina causa hipertensão transitória. β1 aumenta contratilidade e frequência. β2 dilata vasos e brônquios e eleva glicemia e lactato. D1 dilata os leitos renal e mesentérico. V1 e PDE3 estão na tabela porque vasopressina e milrinona não dependem do adrenoceptor. Dois pontos práticos: as catecolaminas têm meia-vida de minutos, por isso vão em geral em infusão; fenilefrina e efedrina duram mais, por isso são as drogas habituais de bolus. E o uso prolongado dessensibiliza os receptores, sobretudo os β.</a:t>
             </a:r>
             <a:endParaRPr lang="en-US" dirty="0"/>
           </a:p>
           <a:p>
             <a:r>
               <a:rPr lang="en-US" dirty="0"/>
-              <a:t>TEMPO: 1 min 5 s (5:00 → 6:05)</a:t>
+              <a:t>TEMPO: 1 min 15 s (5:05 → 6:20)</a:t>
             </a:r>
             <a:endParaRPr lang="en-US" dirty="0"/>
           </a:p>
@@ -1979,7 +1979,7 @@
           <a:p>
             <a:r>
               <a:rPr lang="en-US" dirty="0"/>
-              <a:t>SE PERGUNTAREM: Subtipos: α2A, no locus coeruleus, medeia sedação e simpatólise; α2B, no músculo liso vascular, a vasoconstrição e a hipertensão transitória do bolus; a hipotensão e a bradicardia que se seguem vêm da simpatólise e do aumento do tônus vagal. A clonidina tem o mesmo perfil.</a:t>
+              <a:t>SE PERGUNTAREM: Subtipos: α2A medeia a sedação (locus coeruleus) e a simpatólise (centros vasomotores do tronco encefálico); α2B, no músculo liso vascular, a vasoconstrição e a hipertensão transitória do bolus de dexmedetomidina; a hipotensão e a bradicardia que se seguem vêm da simpatólise e do aumento do tônus vagal. A clonidina tem perfil semelhante, com menor seletividade para α2.</a:t>
             </a:r>
             <a:endParaRPr lang="en-US" dirty="0"/>
           </a:p>
@@ -2067,14 +2067,14 @@
           <a:p>
             <a:r>
               <a:rPr lang="en-US" dirty="0"/>
-              <a:t>FALA: Começo pela noradrenalina, a droga de primeira linha no choque séptico, com ação α1 potente e β1 modesta: sobe a PAM pela resistência e pela venoconstrição, com débito em geral mantido, que pode subir pelo retorno venoso ou cair pela pós-carga, e frequência estável ou menor, por reflexo. Dose de 0,01 a 0,5 microgramas por quilo por minuto, sem teto fixo no choque refratário; no centro cirúrgico, bolus de 5 a 10 microgramas; pode começar em veia periférica calibrosa. Riscos: isquemia digital e esplâncnica, além de extravasamento.</a:t>
+              <a:t>FALA: Começo pela noradrenalina, a droga de primeira linha no choque séptico, com ação α1 potente e efeito β1 clinicamente modesto: sobe a PAM pela resistência e pela venoconstrição, com débito em geral mantido, que pode subir pelo retorno venoso ou cair pela pós-carga, e frequência estável ou menor, por reflexo. Dose de 0,01 a 0,5 microgramas por quilo por minuto, sem teto fixo no choque refratário; no centro cirúrgico, bolus de 5 a 10 microgramas; pode começar em veia periférica calibrosa. Riscos: isquemia digital e esplâncnica, além de extravasamento.</a:t>
             </a:r>
             <a:endParaRPr lang="en-US" dirty="0"/>
           </a:p>
           <a:p>
             <a:r>
               <a:rPr lang="en-US" dirty="0"/>
-              <a:t>TEMPO: 40 s (6:05 → 6:45)</a:t>
+              <a:t>TEMPO: 40 s (6:20 → 7:00)</a:t>
             </a:r>
             <a:endParaRPr lang="en-US" dirty="0"/>
           </a:p>
@@ -2088,7 +2088,7 @@
           <a:p>
             <a:r>
               <a:rPr lang="en-US" dirty="0"/>
-              <a:t>SE PERGUNTAREM: no SOAP II (De Backer, N Engl J Med 2010; n = 1.679), a mortalidade em 28 dias foi semelhante à da dopamina (48,5% vs. 52,5%), com metade das arritmias (12,4% vs. 24,1%); a SSC 2026 recomenda a noradrenalina em vez da dopamina (recomendação forte). No Brasil, a ampola de hemitartarato de 2 mg/mL equivale a 1 mg/mL de base: registrar na prescrição se a dose está em base ou em sal. Início precoce (CENSER, Permpikul 2019: controle do choque em 6 h em 76% vs. 48%) e via periférica com protocolo (Tran 2020) estão nas referências. No extravasamento, fentolamina infiltrada no local. Afinidade por β1: a da noradrenalina é da mesma ordem da adrenalina; o que é modesto é o efeito cardíaco líquido, porque o barorreflexo e a pós-carga contêm a taquicardia e o aumento do débito; a ação β2 é pequena, por isso praticamente não há vasodilatação e o lactato sobe pouco. As barras do slide representam o efeito clínico esperado em cada via, não a afinidade pelo receptor.</a:t>
+              <a:t>SE PERGUNTAREM: no SOAP II (De Backer, N Engl J Med 2010; n = 1.679), a mortalidade em 28 dias foi semelhante à da dopamina (48,5% vs. 52,5%), com metade das arritmias (12,4% vs. 24,1%); a SSC 2026 mantém a noradrenalina como primeira linha, à frente da dopamina. No Brasil, a ampola de hemitartarato de 2 mg/mL equivale a 1 mg/mL de base: registrar na prescrição se a dose está em base ou em sal. Início precoce (CENSER, Permpikul 2019: controle do choque em 6 h em 76% vs. 48%) e via periférica com protocolo (Tran 2020) estão nas referências. No extravasamento, fentolamina infiltrada no local. Afinidade por β1: a da noradrenalina é da mesma ordem da adrenalina; o que é modesto é o efeito cardíaco líquido, porque o barorreflexo e a pós-carga contêm a taquicardia e o aumento do débito; a ação β2 é pequena, por isso praticamente não há vasodilatação e o lactato sobe pouco. As barras do slide representam o efeito clínico esperado em cada via, não a afinidade pelo receptor.</a:t>
             </a:r>
             <a:endParaRPr lang="en-US" dirty="0"/>
           </a:p>
@@ -2176,14 +2176,14 @@
           <a:p>
             <a:r>
               <a:rPr lang="en-US" dirty="0"/>
-              <a:t>FALA: Adrenalina: potente em α1, β1 e β2. O efeito depende da dose: em dose baixa predominam β1 e β2, com débito alto e resistência que pode cair; em dose alta prevalece o α1. É a droga da anafilaxia e, no choque séptico, a terceira droga. Na anafilaxia, bolus endovenosos pequenos e titulados, com infusão se for preciso repetir. O lactato pode subir por efeito β2, e isso não autoriza ignorar hipoperfusão.</a:t>
+              <a:t>FALA: Adrenalina: potente em α1, β1 e β2. O efeito depende da dose: em dose baixa predominam β1 e β2, com débito alto e resistência que pode cair; em dose alta prevalece o α1. É a droga da anafilaxia e, no choque séptico, a terceira droga. Na anafilaxia, bolus endovenosos pequenos e titulados, repetíveis a cada um ou dois minutos, com infusão se forem necessários mais de três bolus. O lactato pode subir por efeito β2, e isso não autoriza ignorar hipoperfusão.</a:t>
             </a:r>
             <a:endParaRPr lang="en-US" dirty="0"/>
           </a:p>
           <a:p>
             <a:r>
               <a:rPr lang="en-US" dirty="0"/>
-              <a:t>TEMPO: 35 s (6:45 → 7:20)</a:t>
+              <a:t>TEMPO: 40 s (7:00 → 7:40)</a:t>
             </a:r>
             <a:endParaRPr lang="en-US" dirty="0"/>
           </a:p>
@@ -2197,7 +2197,7 @@
           <a:p>
             <a:r>
               <a:rPr lang="en-US" dirty="0"/>
-              <a:t>SE PERGUNTAREM: no CATS (Annane, Lancet 2007), mortalidade semelhante à do grupo noradrenalina + dobutamina (40% vs. 34%, NS), com mais acidose; no CAT (Myburgh, Intensive Care Med 2008), 12,9% dos pacientes em adrenalina foram retirados do estudo por efeitos metabólicos transitórios. No OptimaCC (Levy, J Am Coll Cardiol 2018; n = 57, choque cardiogênico pós-IAM), o índice cardíaco foi semelhante, mas houve mais choque refratário com adrenalina (37% vs. 7%), que era o principal desfecho de segurança; o estudo foi interrompido precocemente. Dose no choque séptico: a bula americana de epinefrina prevê infusão de 0,05–2 mcg/kg/min, titulada pela PAM. Cartão ANZAAG/ANZCA 2022 (adulto; 1 mg em 10 mL = 100 mcg/mL): grau 2, 10–20 mcg, e 50 mcg se não houver resposta; grau 3, 50–100 mcg, e 200 mcg se não houver resposta; repetir a cada 1–2 min; após mais de três bolus, infusão de 3 mg em 50 mL, de 3 a 40 mL/h; sem acesso venoso ou sem monitorização, 500 mcg IM na face lateral da coxa, repetível a cada 5 min. Dose no choque séptico: a bula americana de epinefrina prevê infusão de 0,05–2 mcg/kg/min, titulada pela PAM. Cartão ANZCA/ANZAAG 2022 (adulto; 1 mg em 10 mL = 100 mcg/mL): grau 2, 10–20 mcg, e 50 mcg se não houver resposta; grau 3, 50–100 mcg, e 200 mcg se não houver resposta; repetir a cada 1–2 min; após mais de três bolus, infusão de 3 mg em 50 mL, de 3 a 40 mL/h; sem acesso venoso ou sem monitorização, 500 mcg IM na face lateral da coxa, repetível a cada 5 min.</a:t>
+              <a:t>SE PERGUNTAREM: no CATS (Annane, Lancet 2007), mortalidade semelhante à do grupo noradrenalina + dobutamina (40% vs. 34%, NS), com mais acidose; no CAT (Myburgh, Intensive Care Med 2008), 12,9% dos pacientes em adrenalina foram retirados do estudo por efeitos metabólicos transitórios. No OptimaCC (Levy, J Am Coll Cardiol 2018; n = 57, choque cardiogênico pós-IAM), o índice cardíaco foi semelhante, mas houve mais choque refratário com adrenalina (37% vs. 7%), que o artigo apresenta como desfecho de segurança; o estudo foi interrompido precocemente. Dose no choque séptico: a bula americana de epinefrina prevê infusão de 0,05–2 mcg/kg/min, titulada pela PAM. Cartão ANZCA/ANZAAG 2022 (adulto; 1 mg em 10 mL = 100 mcg/mL): reação moderada (grau 2), 10–20 mcg, e 50 mcg se não houver resposta; reação ameaçadora à vida (grau 3), 50–100 mcg, e 200 mcg se não houver resposta; repetir a cada 1–2 min; após mais de três bolus, infusão de 3 mg em 50 mL, de 3 a 40 mL/h; sem acesso venoso ou sem monitorização, 500 mcg IM na face lateral da coxa, repetível a cada 5 min.</a:t>
             </a:r>
             <a:endParaRPr lang="en-US" dirty="0"/>
           </a:p>
@@ -2292,7 +2292,7 @@
           <a:p>
             <a:r>
               <a:rPr lang="en-US" dirty="0"/>
-              <a:t>TEMPO: 35 s (7:20 → 7:55)</a:t>
+              <a:t>TEMPO: 35 s (7:40 → 8:15)</a:t>
             </a:r>
             <a:endParaRPr lang="en-US" dirty="0"/>
           </a:p>
@@ -2521,6 +2521,80 @@
 
 <file path=ppt/slideLayouts/slideLayout4.xml><?xml version="1.0" encoding="utf-8"?>
 <p:sldLayout xmlns:a="http://schemas.openxmlformats.org/drawingml/2006/main" xmlns:r="http://schemas.openxmlformats.org/officeDocument/2006/relationships" xmlns:p="http://schemas.openxmlformats.org/presentationml/2006/main" preserve="1">
+  <p:cSld name="Conteúdo 2">
+    <p:bg>
+      <p:bgPr>
+        <a:solidFill>
+          <a:srgbClr val="F5F3EE"/>
+        </a:solidFill>
+      </p:bgPr>
+    </p:bg>
+    <p:spTree>
+      <p:nvGrpSpPr>
+        <p:cNvPr id="1" name=""/>
+        <p:cNvGrpSpPr/>
+        <p:nvPr/>
+      </p:nvGrpSpPr>
+      <p:grpSpPr>
+        <a:xfrm>
+          <a:off x="0" y="0"/>
+          <a:ext cx="0" cy="0"/>
+          <a:chOff x="0" y="0"/>
+          <a:chExt cx="0" cy="0"/>
+        </a:xfrm>
+      </p:grpSpPr>
+      <p:sp>
+        <p:nvSpPr>
+          <p:cNvPr id="2" name="Text 0"/>
+          <p:cNvSpPr/>
+          <p:nvPr>
+            <p:ph type="title"/>
+          </p:nvPr>
+        </p:nvSpPr>
+        <p:spPr>
+          <a:xfrm>
+            <a:off x="812800" y="1110042"/>
+            <a:ext cx="10718800" cy="894080"/>
+          </a:xfrm>
+          <a:prstGeom prst="rect">
+            <a:avLst/>
+          </a:prstGeom>
+          <a:noFill/>
+          <a:ln/>
+        </p:spPr>
+        <p:txBody>
+          <a:bodyPr wrap="square" rtlCol="0"/>
+          <a:lstStyle>
+            <a:lvl1pPr algn="l" indent="0" marL="0">
+              <a:buNone/>
+              <a:defRPr lang="en-US" sz="3200" dirty="0">
+                <a:solidFill>
+                  <a:srgbClr val="1B2A3A"/>
+                </a:solidFill>
+                <a:latin typeface="Georgia" pitchFamily="34" charset="0"/>
+                <a:ea typeface="Georgia" pitchFamily="34" charset="-122"/>
+                <a:cs typeface="Georgia" pitchFamily="34" charset="-120"/>
+              </a:defRPr>
+            </a:lvl1pPr>
+          </a:lstStyle>
+          <a:p>
+            <a:pPr algn="l" indent="0" marL="0">
+              <a:buNone/>
+            </a:pPr>
+            <a:endParaRPr lang="en-US" sz="3200" dirty="0"/>
+          </a:p>
+        </p:txBody>
+      </p:sp>
+    </p:spTree>
+  </p:cSld>
+  <p:clrMapOvr>
+    <a:masterClrMapping/>
+  </p:clrMapOvr>
+</p:sldLayout>
+</file>
+
+<file path=ppt/slideLayouts/slideLayout5.xml><?xml version="1.0" encoding="utf-8"?>
+<p:sldLayout xmlns:a="http://schemas.openxmlformats.org/drawingml/2006/main" xmlns:r="http://schemas.openxmlformats.org/officeDocument/2006/relationships" xmlns:p="http://schemas.openxmlformats.org/presentationml/2006/main" preserve="1">
   <p:cSld name="Encerramento">
     <p:bg>
       <p:bgPr>
@@ -2618,6 +2692,7 @@
     <p:sldLayoutId id="2147483650" r:id="rId2"/>
     <p:sldLayoutId id="2147483651" r:id="rId3"/>
     <p:sldLayoutId id="2147483652" r:id="rId4"/>
+    <p:sldLayoutId id="2147483653" r:id="rId5"/>
   </p:sldLayoutIdLst>
   <p:hf sldNum="0" hdr="0" ftr="0" dt="0"/>
   <p:txStyles>
@@ -6459,11 +6534,11 @@
         <p:spPr>
           <a:xfrm>
             <a:off x="812800" y="1879501"/>
-            <a:ext cx="4064000" cy="3268762"/>
+            <a:ext cx="4064000" cy="3517305"/>
           </a:xfrm>
           <a:prstGeom prst="roundRect">
             <a:avLst>
-              <a:gd name="adj" fmla="val 2331"/>
+              <a:gd name="adj" fmla="val 2166"/>
             </a:avLst>
           </a:prstGeom>
           <a:solidFill>
@@ -6558,14 +6633,14 @@
       </p:sp>
       <p:sp>
         <p:nvSpPr>
-          <p:cNvPr id="7" name="Em geral, dose fixa (até 0,04 U/min); co"/>
+          <p:cNvPr id="7" name="Choque séptico: dose em geral fixa, até "/>
           <p:cNvSpPr txBox="1"/>
           <p:nvPr/>
         </p:nvSpPr>
         <p:spPr>
           <a:xfrm>
             <a:off x="1066800" y="3036831"/>
-            <a:ext cx="3575050" cy="745629"/>
+            <a:ext cx="3575050" cy="994172"/>
           </a:xfrm>
           <a:prstGeom prst="rect">
             <a:avLst/>
@@ -6592,7 +6667,7 @@
                 <a:ea typeface="Calibri" pitchFamily="34" charset="-122"/>
                 <a:cs typeface="Calibri" pitchFamily="34" charset="-120"/>
               </a:rPr>
-              <a:t>Em geral, dose fixa (até 0,04 U/min); costuma manter efeito com acidose e dessensibilização adrenérgica.</a:t>
+              <a:t>Choque séptico: dose em geral fixa, até 0,04 U/min. Vasoplegia pós-CEC: titulada (0,01–0,06 U/min no VANCS). Costuma manter efeito com acidose e dessensibilização adrenérgica.</a:t>
             </a:r>
             <a:endParaRPr lang="en-US" sz="1350" dirty="0"/>
           </a:p>
@@ -6606,7 +6681,7 @@
         </p:nvSpPr>
         <p:spPr>
           <a:xfrm>
-            <a:off x="1066800" y="3884060"/>
+            <a:off x="1066800" y="4132603"/>
             <a:ext cx="3575050" cy="994172"/>
           </a:xfrm>
           <a:prstGeom prst="rect">
@@ -6760,11 +6835,11 @@
         <p:spPr>
           <a:xfrm>
             <a:off x="5080000" y="2809081"/>
-            <a:ext cx="6299200" cy="1059061"/>
+            <a:ext cx="6299200" cy="1290141"/>
           </a:xfrm>
           <a:prstGeom prst="roundRect">
             <a:avLst>
-              <a:gd name="adj" fmla="val 7195"/>
+              <a:gd name="adj" fmla="val 5906"/>
             </a:avLst>
           </a:prstGeom>
           <a:solidFill>
@@ -6829,7 +6904,7 @@
         <p:spPr>
           <a:xfrm>
             <a:off x="5289550" y="3234271"/>
-            <a:ext cx="5899150" cy="462161"/>
+            <a:ext cx="5899150" cy="693241"/>
           </a:xfrm>
           <a:prstGeom prst="rect">
             <a:avLst/>
@@ -6856,7 +6931,7 @@
                 <a:ea typeface="Calibri" pitchFamily="34" charset="-122"/>
                 <a:cs typeface="Calibri" pitchFamily="34" charset="-120"/>
               </a:rPr>
-              <a:t>Inibe a via óxido nítrico–GMPc: resgate na vasoplegia refratária (pós-CEC, reperfusão hepática).</a:t>
+              <a:t>Inibe a via óxido nítrico–GMPc: resgate na vasoplegia refratária (pós-CEC; reperfusão do enxerto hepático, com base em relatos e séries). Também: metemoglobinemia; choque séptico refratário, em estudo.</a:t>
             </a:r>
             <a:endParaRPr lang="en-US" sz="1300" dirty="0"/>
           </a:p>
@@ -6870,8 +6945,8 @@
         </p:nvSpPr>
         <p:spPr>
           <a:xfrm>
-            <a:off x="812800" y="6226316"/>
-            <a:ext cx="10433050" cy="213320"/>
+            <a:off x="812800" y="6245073"/>
+            <a:ext cx="10433050" cy="195560"/>
           </a:xfrm>
           <a:prstGeom prst="rect">
             <a:avLst/>
@@ -6885,12 +6960,12 @@
           <a:p>
             <a:pPr algn="l" indent="0" marL="0">
               <a:lnSpc>
-                <a:spcPts val="1680"/>
-              </a:lnSpc>
-              <a:buNone/>
-            </a:pPr>
-            <a:r>
-              <a:rPr lang="pt-BR" altLang="en-US" sz="1200" dirty="0">
+                <a:spcPts val="1540"/>
+              </a:lnSpc>
+              <a:buNone/>
+            </a:pPr>
+            <a:r>
+              <a:rPr lang="pt-BR" altLang="en-US" sz="1100" dirty="0">
                 <a:solidFill>
                   <a:srgbClr val="56606B"/>
                 </a:solidFill>
@@ -6898,9 +6973,9 @@
                 <a:ea typeface="Calibri" pitchFamily="34" charset="-122"/>
                 <a:cs typeface="Calibri" pitchFamily="34" charset="-120"/>
               </a:rPr>
-              <a:t>SSC 2026 · Hajjar, Anesthesiology 2017 (VANCS) · Miller’s Anesthesia, 10ª ed. (2025), cap. 79</a:t>
-            </a:r>
-            <a:endParaRPr lang="en-US" sz="1200" dirty="0"/>
+              <a:t>SSC 2026 · Hajjar, Anesthesiology 2017 (VANCS) · Koelzow, Anesth Analg 2002 · Fukazawa, J Hepatobiliary Pancreat Sci 2011 · Miller’s Anesthesia, 10ª ed. (2025), cap. 79</a:t>
+            </a:r>
+            <a:endParaRPr lang="en-US" sz="1100" dirty="0"/>
           </a:p>
         </p:txBody>
       </p:sp>
@@ -7682,7 +7757,7 @@
                 <a:ea typeface="Calibri" pitchFamily="34" charset="-122"/>
                 <a:cs typeface="Calibri" pitchFamily="34" charset="-120"/>
               </a:rPr>
-              <a:t>Vasopressor cedo, pelo mecanismo: tônus com noradrenalina, outra via com vasopressina, e adrenalina quando as duas não bastam. Inotrópico apenas se houver disfunção cardíaca com hipoperfusão.</a:t>
+              <a:t>Vasopressor cedo, pelo mecanismo: tônus com noradrenalina, outra via com vasopressina, e adrenalina quando as duas não bastam. Inotrópico reservado à disfunção cardíaca com hipoperfusão.</a:t>
             </a:r>
             <a:endParaRPr lang="en-US" sz="1500" dirty="0"/>
           </a:p>
@@ -8291,23 +8366,23 @@
       </p:sp>
       <p:sp>
         <p:nvSpPr>
-          <p:cNvPr id="14" name="Efedrina 5–10 mg"/>
+          <p:cNvPr id="14" name="Efedrina 5–10 mg; adrenalina se grave"/>
           <p:cNvSpPr txBox="1"/>
           <p:nvPr/>
         </p:nvSpPr>
         <p:spPr>
           <a:xfrm>
             <a:off x="3084810" y="3170165"/>
-            <a:ext cx="1764010" cy="231378"/>
-          </a:xfrm>
-          <a:prstGeom prst="rect">
-            <a:avLst/>
-          </a:prstGeom>
-          <a:noFill/>
-          <a:ln/>
-        </p:spPr>
-        <p:txBody>
-          <a:bodyPr wrap="none" lIns="0" tIns="0" rIns="0" bIns="0" rtlCol="0" anchor="t"/>
+            <a:ext cx="1764010" cy="462756"/>
+          </a:xfrm>
+          <a:prstGeom prst="rect">
+            <a:avLst/>
+          </a:prstGeom>
+          <a:noFill/>
+          <a:ln/>
+        </p:spPr>
+        <p:txBody>
+          <a:bodyPr wrap="square" lIns="0" tIns="0" rIns="0" bIns="0" rtlCol="0" anchor="t"/>
           <a:lstStyle/>
           <a:p>
             <a:pPr algn="l" indent="0" marL="0">
@@ -8325,7 +8400,7 @@
                 <a:ea typeface="Calibri" pitchFamily="34" charset="-122"/>
                 <a:cs typeface="Calibri" pitchFamily="34" charset="-120"/>
               </a:rPr>
-              <a:t>Efedrina 5–10 mg</a:t>
+              <a:t>Efedrina 5–10 mg; adrenalina se grave</a:t>
             </a:r>
             <a:endParaRPr lang="en-US" sz="1350" dirty="0"/>
           </a:p>
@@ -9184,7 +9259,7 @@
                 <a:gridCol w="3592513"/>
                 <a:gridCol w="6973888"/>
               </a:tblGrid>
-              <a:tr h="420985">
+              <a:tr h="660995">
                 <a:tc>
                   <a:txBody>
                     <a:bodyPr/>
@@ -9251,7 +9326,7 @@
                           <a:ea typeface="Calibri" pitchFamily="34" charset="-122"/>
                           <a:cs typeface="Calibri" pitchFamily="34" charset="-120"/>
                         </a:rPr>
-                        <a:t>Dobutamina ou adrenalina; milrinona sobretudo no VD com hipertensão pulmonar</a:t>
+                        <a:t>Dobutamina (ou adrenalina, no choque séptico); milrinona sobretudo no VD com hipertensão pulmonar</a:t>
                       </a:r>
                       <a:endParaRPr lang="en-US" sz="1200" dirty="0"/>
                     </a:p>
@@ -9297,7 +9372,7 @@
           </p:nvPr>
         </p:nvGraphicFramePr>
         <p:xfrm>
-          <a:off x="812800" y="3145631"/>
+          <a:off x="812800" y="3385641"/>
           <a:ext cx="10566400" cy="914400"/>
         </p:xfrm>
         <a:graphic>
@@ -9329,7 +9404,7 @@
                           <a:ea typeface="Calibri" pitchFamily="34" charset="-122"/>
                           <a:cs typeface="Calibri" pitchFamily="34" charset="-120"/>
                         </a:rPr>
-                        <a:t>Hipotensão vasodilatadora com bradicardia</a:t>
+                        <a:t>Hipotensão da anestesia com bradicardia</a:t>
                       </a:r>
                       <a:endParaRPr lang="en-US" sz="1200" dirty="0"/>
                     </a:p>
@@ -9421,7 +9496,7 @@
           </p:nvPr>
         </p:nvGraphicFramePr>
         <p:xfrm>
-          <a:off x="812800" y="3569791"/>
+          <a:off x="812800" y="3809802"/>
           <a:ext cx="10566400" cy="914400"/>
         </p:xfrm>
         <a:graphic>
@@ -9453,7 +9528,7 @@
                           <a:ea typeface="Calibri" pitchFamily="34" charset="-122"/>
                           <a:cs typeface="Calibri" pitchFamily="34" charset="-120"/>
                         </a:rPr>
-                        <a:t>Hipotensão vasodilatadora com FC normal ou alta</a:t>
+                        <a:t>Hipotensão da anestesia com FC normal ou alta</a:t>
                       </a:r>
                       <a:endParaRPr lang="en-US" sz="1200" dirty="0"/>
                     </a:p>
@@ -9545,7 +9620,7 @@
           </p:nvPr>
         </p:nvGraphicFramePr>
         <p:xfrm>
-          <a:off x="812800" y="4233962"/>
+          <a:off x="812800" y="4473972"/>
           <a:ext cx="10566400" cy="914400"/>
         </p:xfrm>
         <a:graphic>
@@ -9656,7 +9731,7 @@
       </p:graphicFrame>
       <p:sp>
         <p:nvSpPr>
-          <p:cNvPr id="10" name="SSC 2026 · ESICM 2025 · Miller’s Anesthe"/>
+          <p:cNvPr id="10" name="SSC 2026 · Miller’s Anesthesia, 10ª ed. "/>
           <p:cNvSpPr txBox="1"/>
           <p:nvPr/>
         </p:nvSpPr>
@@ -9690,7 +9765,7 @@
                 <a:ea typeface="Calibri" pitchFamily="34" charset="-122"/>
                 <a:cs typeface="Calibri" pitchFamily="34" charset="-120"/>
               </a:rPr>
-              <a:t>SSC 2026 · ESICM 2025 · Miller’s Anesthesia, 10ª ed. (2025), cap. 16, 79</a:t>
+              <a:t>SSC 2026 · Miller’s Anesthesia, 10ª ed. (2025), cap. 16, 79</a:t>
             </a:r>
             <a:endParaRPr lang="en-US" sz="1200" dirty="0"/>
           </a:p>
@@ -11390,11 +11465,11 @@
         <p:spPr>
           <a:xfrm>
             <a:off x="812800" y="1803301"/>
-            <a:ext cx="3386634" cy="2372221"/>
+            <a:ext cx="3386634" cy="2612231"/>
           </a:xfrm>
           <a:prstGeom prst="roundRect">
             <a:avLst>
-              <a:gd name="adj" fmla="val 3212"/>
+              <a:gd name="adj" fmla="val 2917"/>
             </a:avLst>
           </a:prstGeom>
           <a:solidFill>
@@ -11588,11 +11663,11 @@
         <p:spPr>
           <a:xfrm>
             <a:off x="4402634" y="1803301"/>
-            <a:ext cx="3386634" cy="2372221"/>
+            <a:ext cx="3386634" cy="2612231"/>
           </a:xfrm>
           <a:prstGeom prst="roundRect">
             <a:avLst>
-              <a:gd name="adj" fmla="val 3212"/>
+              <a:gd name="adj" fmla="val 2917"/>
             </a:avLst>
           </a:prstGeom>
           <a:solidFill>
@@ -11736,14 +11811,14 @@
       </p:sp>
       <p:sp>
         <p:nvSpPr>
-          <p:cNvPr id="13" name="Elevação passiva das pernas ou minidesaf"/>
+          <p:cNvPr id="13" name="Minidesafio hídrico ou, se o posicioname"/>
           <p:cNvSpPr txBox="1"/>
           <p:nvPr/>
         </p:nvSpPr>
         <p:spPr>
           <a:xfrm>
             <a:off x="4637584" y="3472493"/>
-            <a:ext cx="2935784" cy="480020"/>
+            <a:ext cx="2935784" cy="720030"/>
           </a:xfrm>
           <a:prstGeom prst="rect">
             <a:avLst/>
@@ -11771,7 +11846,7 @@
                 <a:ea typeface="Calibri" pitchFamily="34" charset="-122"/>
                 <a:cs typeface="Calibri" pitchFamily="34" charset="-120"/>
               </a:rPr>
-              <a:t>Elevação passiva das pernas ou minidesafio hídrico, medindo o débito</a:t>
+              <a:t>Minidesafio hídrico ou, se o posicionamento permitir, elevação passiva das pernas, medindo o débito</a:t>
             </a:r>
             <a:endParaRPr lang="en-US" sz="1350" dirty="0"/>
           </a:p>
@@ -11786,11 +11861,11 @@
         <p:spPr>
           <a:xfrm>
             <a:off x="7992467" y="1803301"/>
-            <a:ext cx="3386634" cy="2372221"/>
+            <a:ext cx="3386634" cy="2612231"/>
           </a:xfrm>
           <a:prstGeom prst="roundRect">
             <a:avLst>
-              <a:gd name="adj" fmla="val 3212"/>
+              <a:gd name="adj" fmla="val 2917"/>
             </a:avLst>
           </a:prstGeom>
           <a:solidFill>
@@ -12016,7 +12091,7 @@
         </p:nvSpPr>
         <p:spPr>
           <a:xfrm>
-            <a:off x="812800" y="4404122"/>
+            <a:off x="812800" y="4644132"/>
             <a:ext cx="10566400" cy="886420"/>
           </a:xfrm>
           <a:prstGeom prst="roundRect">
@@ -12043,7 +12118,7 @@
         </p:nvSpPr>
         <p:spPr>
           <a:xfrm>
-            <a:off x="1073150" y="4534017"/>
+            <a:off x="1073150" y="4774028"/>
             <a:ext cx="1476970" cy="568920"/>
           </a:xfrm>
           <a:prstGeom prst="rect">
@@ -12085,7 +12160,7 @@
         </p:nvSpPr>
         <p:spPr>
           <a:xfrm>
-            <a:off x="2937470" y="4565678"/>
+            <a:off x="2937470" y="4805688"/>
             <a:ext cx="8200430" cy="533400"/>
           </a:xfrm>
           <a:prstGeom prst="rect">
@@ -12272,7 +12347,7 @@
         </p:nvSpPr>
         <p:spPr>
           <a:xfrm>
-            <a:off x="812800" y="1135442"/>
+            <a:off x="812800" y="1110042"/>
             <a:ext cx="10718800" cy="894080"/>
           </a:xfrm>
           <a:prstGeom prst="rect">
@@ -12321,7 +12396,7 @@
           </p:nvPr>
         </p:nvGraphicFramePr>
         <p:xfrm>
-          <a:off x="812800" y="1727101"/>
+          <a:off x="812800" y="1676301"/>
           <a:ext cx="10566400" cy="914400"/>
         </p:xfrm>
         <a:graphic>
@@ -12588,7 +12663,7 @@
                           <a:ea typeface="Calibri" pitchFamily="34" charset="-122"/>
                           <a:cs typeface="Calibri" pitchFamily="34" charset="-120"/>
                         </a:rPr>
-                        <a:t>Invasivo e intermitente; reservado ao choque refratário, à disfunção de VD e à hipertensão pulmonar</a:t>
+                        <a:t>Invasivo; intermitente ou semicontínuo; sobretudo em choque refratário, disfunção de VD e hipertensão pulmonar</a:t>
                       </a:r>
                       <a:endParaRPr lang="en-US" sz="1200" dirty="0"/>
                     </a:p>
@@ -12728,7 +12803,7 @@
                           <a:ea typeface="Calibri" pitchFamily="34" charset="-122"/>
                           <a:cs typeface="Calibri" pitchFamily="34" charset="-120"/>
                         </a:rPr>
-                        <a:t>Exige cateter central e arterial femoral; recalibrar quando o tônus vascular muda</a:t>
+                        <a:t>Exige cateter central e arterial calibroso, em geral femoral; recalibrar quando o tônus vascular muda</a:t>
                       </a:r>
                       <a:endParaRPr lang="en-US" sz="1200" dirty="0"/>
                     </a:p>
@@ -12822,7 +12897,7 @@
                           <a:ea typeface="Calibri" pitchFamily="34" charset="-122"/>
                           <a:cs typeface="Calibri" pitchFamily="34" charset="-120"/>
                         </a:rPr>
-                        <a:t>Estima o volume sistólico pela forma da onda arterial e dados demográficos; contínuo, pouco invasivo; fornece a VVS</a:t>
+                        <a:t>Estima o volume sistólico pela forma da onda arterial e dados demográficos; contínuo; pouco invasivo (FloTrac) ou não invasivo (ClearSight); fornece a VVS</a:t>
                       </a:r>
                       <a:endParaRPr lang="en-US" sz="1200" dirty="0"/>
                     </a:p>
@@ -13102,7 +13177,7 @@
                           <a:ea typeface="Calibri" pitchFamily="34" charset="-122"/>
                           <a:cs typeface="Calibri" pitchFamily="34" charset="-120"/>
                         </a:rPr>
-                        <a:t>Volume sistólico = VTI × área da via de saída do VE; função de VE e VD (FAC, TAPSE), volemia, pericárdio</a:t>
+                        <a:t>Volume sistólico = VTI × área da via de saída do VE; função de VE e VD (variação fracional de área, TAPSE), volemia, pericárdio</a:t>
                       </a:r>
                       <a:endParaRPr lang="en-US" sz="1200" dirty="0"/>
                     </a:p>
@@ -13187,12 +13262,12 @@
         </p:nvSpPr>
         <p:spPr>
           <a:xfrm>
-            <a:off x="812800" y="4544814"/>
-            <a:ext cx="10566400" cy="807343"/>
+            <a:off x="812800" y="4468614"/>
+            <a:ext cx="10566400" cy="781447"/>
           </a:xfrm>
           <a:prstGeom prst="roundRect">
             <a:avLst>
-              <a:gd name="adj" fmla="val 9438"/>
+              <a:gd name="adj" fmla="val 9751"/>
             </a:avLst>
           </a:prstGeom>
           <a:solidFill>
@@ -13214,7 +13289,7 @@
         </p:nvSpPr>
         <p:spPr>
           <a:xfrm>
-            <a:off x="1022350" y="4701054"/>
+            <a:off x="1022350" y="4611956"/>
             <a:ext cx="1924050" cy="496491"/>
           </a:xfrm>
           <a:prstGeom prst="rect">
@@ -13256,8 +13331,8 @@
         </p:nvSpPr>
         <p:spPr>
           <a:xfrm>
-            <a:off x="3105150" y="4643490"/>
-            <a:ext cx="8083550" cy="591443"/>
+            <a:off x="3105150" y="4567693"/>
+            <a:ext cx="8083550" cy="565547"/>
           </a:xfrm>
           <a:prstGeom prst="rect">
             <a:avLst/>
@@ -13271,12 +13346,12 @@
           <a:p>
             <a:pPr algn="l" indent="0" marL="0">
               <a:lnSpc>
-                <a:spcPts val="1553"/>
-              </a:lnSpc>
-              <a:buNone/>
-            </a:pPr>
-            <a:r>
-              <a:rPr lang="pt-BR" altLang="en-US" sz="1150" dirty="0">
+                <a:spcPts val="1485"/>
+              </a:lnSpc>
+              <a:buNone/>
+            </a:pPr>
+            <a:r>
+              <a:rPr lang="pt-BR" altLang="en-US" sz="1100" dirty="0">
                 <a:solidFill>
                   <a:srgbClr val="1B2A3A"/>
                 </a:solidFill>
@@ -13284,9 +13359,9 @@
                 <a:ea typeface="Calibri" pitchFamily="34" charset="-122"/>
                 <a:cs typeface="Calibri" pitchFamily="34" charset="-120"/>
               </a:rPr>
-              <a:t>VPP e VVS: ventilação controlada sem esforço, volume corrente ≥ 8 mL/kg, ritmo regular, tórax fechado, sem disfunção de VD nem hipertensão intra-abdominal; zona cinzenta de 9–13%. Fora disso: desafio de volume corrente (6 → 8 mL/kg por 1 min), elevação passiva das pernas (↑DC ≥ 10%) ou minidesafio de 100 mL, medindo o débito.</a:t>
-            </a:r>
-            <a:endParaRPr lang="en-US" sz="1150" dirty="0"/>
+              <a:t>VPP e VVS: ventilação controlada sem esforço, volume corrente ≥ 8 mL/kg, ritmo regular, tórax fechado, sem disfunção de VD nem hipertensão intra-abdominal; zona cinzenta da VPP de 9–13%. Limitação apenas do volume corrente: desafio de volume corrente (6 → 8 mL/kg por 1 min). Demais situações: elevação passiva das pernas (↑DC ≥ 10%) ou minidesafio de 100 mL, medindo o débito.</a:t>
+            </a:r>
+            <a:endParaRPr lang="en-US" sz="1100" dirty="0"/>
           </a:p>
         </p:txBody>
       </p:sp>
@@ -13842,7 +13917,7 @@
                           <a:ea typeface="Calibri" pitchFamily="34" charset="-122"/>
                           <a:cs typeface="Calibri" pitchFamily="34" charset="-120"/>
                         </a:rPr>
-                        <a:t>Pré-sináptico; SNC (locus coeruleus); músculo liso vascular</a:t>
+                        <a:t>Pré-sináptico; SNC (locus coeruleus e tronco encefálico); músculo liso vascular</a:t>
                       </a:r>
                       <a:endParaRPr lang="en-US" sz="1200" dirty="0"/>
                     </a:p>
@@ -13888,7 +13963,7 @@
                           <a:ea typeface="Calibri" pitchFamily="34" charset="-122"/>
                           <a:cs typeface="Calibri" pitchFamily="34" charset="-120"/>
                         </a:rPr>
-                        <a:t>↓liberação de NA; sedação e simpatólise central (dexmedetomidina); vasoconstrição pós-sináptica (hipertensão inicial do bolus)</a:t>
+                        <a:t>↓liberação de NA; sedação e simpatólise central (dexmedetomidina); vasoconstrição pós-sináptica (hipertensão transitória do bolus de dexmedetomidina)</a:t>
                       </a:r>
                       <a:endParaRPr lang="en-US" sz="1200" dirty="0"/>
                     </a:p>
@@ -15630,7 +15705,7 @@
       </p:sp>
       <p:sp>
         <p:nvSpPr>
-          <p:cNvPr id="23" name="α1 potente, β1 modesto: sobe a PAM pela "/>
+          <p:cNvPr id="23" name="α1 potente, β1 de efeito modesto: sobe a"/>
           <p:cNvSpPr txBox="1"/>
           <p:nvPr/>
         </p:nvSpPr>
@@ -15664,7 +15739,7 @@
                 <a:ea typeface="Calibri" pitchFamily="34" charset="-122"/>
                 <a:cs typeface="Calibri" pitchFamily="34" charset="-120"/>
               </a:rPr>
-              <a:t>α1 potente, β1 modesto: sobe a PAM pela RVS e pelo retorno venoso; DC em geral mantido: pode subir pelo retorno venoso ou cair pela pós-carga; FC estável ou menor. 1ª linha no choque séptico.</a:t>
+              <a:t>α1 potente, β1 de efeito modesto: sobe a PAM pela RVS e pelo retorno venoso; DC em geral mantido: pode subir pelo retorno venoso ou cair pela pós-carga; FC estável ou menor. 1ª linha no choque séptico.</a:t>
             </a:r>
             <a:endParaRPr lang="en-US" sz="1350" dirty="0"/>
           </a:p>
@@ -16824,7 +16899,7 @@
                 <a:ea typeface="Calibri" pitchFamily="34" charset="-122"/>
                 <a:cs typeface="Calibri" pitchFamily="34" charset="-120"/>
               </a:rPr>
-              <a:t>0,01–0,1 mcg/kg/min (em geral, predomínio β); no choque, dose maior, titulada pela PAM. Anafilaxia: bolus endovenosos pequenos e titulados; infusão se precisar repetir. Riscos: taquiarritmia, hiperglicemia; lactato ↑ por β2.</a:t>
+              <a:t>0,01–0,1 mcg/kg/min (em geral, predomínio β); no choque, dose maior, titulada pela PAM. Anafilaxia: bolus endovenosos pequenos e titulados, repetidos a cada 1–2 min; infusão após mais de três bolus. Riscos: taquiarritmia, hiperglicemia; lactato ↑ por β2.</a:t>
             </a:r>
             <a:endParaRPr lang="en-US" sz="1350" dirty="0"/>
           </a:p>

</xml_diff>

<commit_message>
Áudios da versão 40, 17 slides (voz pm_alex, ritmo 0,9); arquivos antigos removidos; ajustes de tela no cateter de artéria pulmonar e no α2
Co-Authored-By: Claude Fable 5.1 <noreply@anthropic.com>
Claude-Session: https://claude.ai/code/session_01W6cLQUtwNHu1UUeBJH2XLT
</commit_message>
<xml_diff>
--- a/apresentacao/Aminas_Vasoativas.pptx
+++ b/apresentacao/Aminas_Vasoativas.pptx
@@ -123,25 +123,25 @@
   <p:extLst>
     <p:ext uri="{521415D9-36F7-43E2-AB2F-B90AF26B5E84}">
       <p14:sectionLst xmlns:p14="http://schemas.microsoft.com/office/powerpoint/2010/main">
-        <p14:section name="Abertura e objetivos" id="{a45e46ca-debf-fb47-a2c1-8fa1601f81b4}">
+        <p14:section name="Abertura e objetivos" id="{a66204d7-c19f-fc1b-d18b-e99d1dbbd916}">
           <p14:sldIdLst>
             <p14:sldId id="256"/>
             <p14:sldId id="257"/>
           </p14:sldIdLst>
         </p14:section>
-        <p14:section name="01 · Fisiologia: pressão, débito e perfusão" id="{8277609a-068b-70ea-0f23-cd38140c143e}">
+        <p14:section name="01 · Fisiologia: pressão, débito e perfusão" id="{6c3d3519-1fdf-883f-e31f-dce10762132c}">
           <p14:sldIdLst>
             <p14:sldId id="258"/>
             <p14:sldId id="259"/>
             <p14:sldId id="260"/>
           </p14:sldIdLst>
         </p14:section>
-        <p14:section name="02 · Receptores" id="{6b92e832-7555-b2cf-8b4a-69d89aab77fc}">
+        <p14:section name="02 · Receptores" id="{cd154a0b-0e8e-aff4-2aff-ce95da5c8748}">
           <p14:sldIdLst>
             <p14:sldId id="261"/>
           </p14:sldIdLst>
         </p14:section>
-        <p14:section name="03 · Drogas: noradrenalina, adrenalina, dobutamina (e dopamina), milrinona (escolha), fenilefrina e efedrina" id="{689cbfd3-79d1-df0e-406a-a3a6c66fc6f9}">
+        <p14:section name="03 · Drogas: noradrenalina, adrenalina, dobutamina (e dopamina), milrinona (escolha), fenilefrina e efedrina" id="{3b933a81-1015-cf0e-b756-dffe9d8e482c}">
           <p14:sldIdLst>
             <p14:sldId id="262"/>
             <p14:sldId id="263"/>
@@ -151,22 +151,22 @@
             <p14:sldId id="267"/>
           </p14:sldIdLst>
         </p14:section>
-        <p14:section name="04 · Além das aminas: vasopressina, hidrocortisona e azul de metileno" id="{4702f689-7f35-7330-24ac-039d1ea2f47c}">
+        <p14:section name="04 · Além das aminas: vasopressina, hidrocortisona e azul de metileno" id="{43101700-b553-9886-872d-a9e8097ed859}">
           <p14:sldIdLst>
             <p14:sldId id="268"/>
           </p14:sldIdLst>
         </p14:section>
-        <p14:section name="05 · Choque séptico: a sequência da SSC 2026" id="{823d5a81-d0d0-ee65-9199-b7d5f9a23235}">
+        <p14:section name="05 · Choque séptico: a sequência da SSC 2026" id="{f9e85a44-d712-4fc8-dd2b-be926719a494}">
           <p14:sldIdLst>
             <p14:sldId id="269"/>
           </p14:sldIdLst>
         </p14:section>
-        <p14:section name="06 · Perioperatório: escolha da droga" id="{bf82be20-3ebb-0702-1f29-6d620df1415e}">
+        <p14:section name="06 · Perioperatório: escolha da droga" id="{68b403d1-ef42-58a8-ee41-56e8347abb46}">
           <p14:sldIdLst>
             <p14:sldId id="270"/>
           </p14:sldIdLst>
         </p14:section>
-        <p14:section name="07 · Mensagens finais e encerramento" id="{9c8f9c8a-cf5f-1d08-708c-b60b6b4b715e}">
+        <p14:section name="07 · Mensagens finais e encerramento" id="{05065cf1-2e7c-5ab9-9387-636771b1f00e}">
           <p14:sldIdLst>
             <p14:sldId id="271"/>
             <p14:sldId id="272"/>
@@ -12539,7 +12539,7 @@
                   </a:tcPr>
                 </a:tc>
               </a:tr>
-              <a:tr h="467916">
+              <a:tr h="649486">
                 <a:tc>
                   <a:txBody>
                     <a:bodyPr/>
@@ -12663,7 +12663,7 @@
                           <a:ea typeface="Calibri" pitchFamily="34" charset="-122"/>
                           <a:cs typeface="Calibri" pitchFamily="34" charset="-120"/>
                         </a:rPr>
-                        <a:t>Invasivo; intermitente ou semicontínuo; sobretudo em choque refratário, disfunção de VD e hipertensão pulmonar</a:t>
+                        <a:t>Invasivo; intermitente ou semicontínuo; sugerido no choque refratário e na disfunção de VD (ESICM); usado também na hipertensão pulmonar</a:t>
                       </a:r>
                       <a:endParaRPr lang="en-US" sz="1200" dirty="0"/>
                     </a:p>
@@ -13262,7 +13262,7 @@
         </p:nvSpPr>
         <p:spPr>
           <a:xfrm>
-            <a:off x="812800" y="4468614"/>
+            <a:off x="812800" y="4650184"/>
             <a:ext cx="10566400" cy="781447"/>
           </a:xfrm>
           <a:prstGeom prst="roundRect">
@@ -13289,7 +13289,7 @@
         </p:nvSpPr>
         <p:spPr>
           <a:xfrm>
-            <a:off x="1022350" y="4611956"/>
+            <a:off x="1022350" y="4793526"/>
             <a:ext cx="1924050" cy="496491"/>
           </a:xfrm>
           <a:prstGeom prst="rect">
@@ -13331,7 +13331,7 @@
         </p:nvSpPr>
         <p:spPr>
           <a:xfrm>
-            <a:off x="3105150" y="4567693"/>
+            <a:off x="3105150" y="4749263"/>
             <a:ext cx="8083550" cy="565547"/>
           </a:xfrm>
           <a:prstGeom prst="rect">
@@ -13917,7 +13917,7 @@
                           <a:ea typeface="Calibri" pitchFamily="34" charset="-122"/>
                           <a:cs typeface="Calibri" pitchFamily="34" charset="-120"/>
                         </a:rPr>
-                        <a:t>Pré-sináptico; SNC (locus coeruleus e tronco encefálico); músculo liso vascular</a:t>
+                        <a:t>Pré-sináptico; tronco encefálico (locus coeruleus e centros vasomotores); músculo liso vascular</a:t>
                       </a:r>
                       <a:endParaRPr lang="en-US" sz="1200" dirty="0"/>
                     </a:p>

</xml_diff>

<commit_message>
Versão 41: ressalvas do Codex sobre a v40 (área diastólica do VE como pista de enchimento; erro de 54% do FloTrac datado em 2009 e versão antiga; serotoninérgicos inclusive opioides); eco transesofágico ou transtorácico
Co-Authored-By: Claude Fable 5.1 <noreply@anthropic.com>
Claude-Session: https://claude.ai/code/session_01W6cLQUtwNHu1UUeBJH2XLT
</commit_message>
<xml_diff>
--- a/apresentacao/Aminas_Vasoativas.pptx
+++ b/apresentacao/Aminas_Vasoativas.pptx
@@ -123,25 +123,25 @@
   <p:extLst>
     <p:ext uri="{521415D9-36F7-43E2-AB2F-B90AF26B5E84}">
       <p14:sectionLst xmlns:p14="http://schemas.microsoft.com/office/powerpoint/2010/main">
-        <p14:section name="Abertura e objetivos" id="{a66204d7-c19f-fc1b-d18b-e99d1dbbd916}">
+        <p14:section name="Abertura e objetivos" id="{4750fe30-4418-6a83-9bea-42a6255d423e}">
           <p14:sldIdLst>
             <p14:sldId id="256"/>
             <p14:sldId id="257"/>
           </p14:sldIdLst>
         </p14:section>
-        <p14:section name="01 · Fisiologia: pressão, débito e perfusão" id="{6c3d3519-1fdf-883f-e31f-dce10762132c}">
+        <p14:section name="01 · Fisiologia: pressão, débito e perfusão" id="{ec17183f-5f01-6684-434d-b990a3d82cc6}">
           <p14:sldIdLst>
             <p14:sldId id="258"/>
             <p14:sldId id="259"/>
             <p14:sldId id="260"/>
           </p14:sldIdLst>
         </p14:section>
-        <p14:section name="02 · Receptores" id="{cd154a0b-0e8e-aff4-2aff-ce95da5c8748}">
+        <p14:section name="02 · Receptores" id="{cc8712c9-0ebd-5bac-9116-396719dbe108}">
           <p14:sldIdLst>
             <p14:sldId id="261"/>
           </p14:sldIdLst>
         </p14:section>
-        <p14:section name="03 · Drogas: noradrenalina, adrenalina, dobutamina (e dopamina), milrinona (escolha), fenilefrina e efedrina" id="{3b933a81-1015-cf0e-b756-dffe9d8e482c}">
+        <p14:section name="03 · Drogas: noradrenalina, adrenalina, dobutamina (e dopamina), milrinona (escolha), fenilefrina e efedrina" id="{a3c5034f-e156-de0c-7877-3d6b15b00e74}">
           <p14:sldIdLst>
             <p14:sldId id="262"/>
             <p14:sldId id="263"/>
@@ -151,22 +151,22 @@
             <p14:sldId id="267"/>
           </p14:sldIdLst>
         </p14:section>
-        <p14:section name="04 · Além das aminas: vasopressina, hidrocortisona e azul de metileno" id="{43101700-b553-9886-872d-a9e8097ed859}">
+        <p14:section name="04 · Além das aminas: vasopressina, hidrocortisona e azul de metileno" id="{c3a34828-079e-78c8-fcef-46d23204f92f}">
           <p14:sldIdLst>
             <p14:sldId id="268"/>
           </p14:sldIdLst>
         </p14:section>
-        <p14:section name="05 · Choque séptico: a sequência da SSC 2026" id="{f9e85a44-d712-4fc8-dd2b-be926719a494}">
+        <p14:section name="05 · Choque séptico: a sequência da SSC 2026" id="{6035ed89-68ff-6efc-d807-9612e507f37d}">
           <p14:sldIdLst>
             <p14:sldId id="269"/>
           </p14:sldIdLst>
         </p14:section>
-        <p14:section name="06 · Perioperatório: escolha da droga" id="{68b403d1-ef42-58a8-ee41-56e8347abb46}">
+        <p14:section name="06 · Perioperatório: escolha da droga" id="{92065686-7731-ded1-053b-225461f6dcf4}">
           <p14:sldIdLst>
             <p14:sldId id="270"/>
           </p14:sldIdLst>
         </p14:section>
-        <p14:section name="07 · Mensagens finais e encerramento" id="{05065cf1-2e7c-5ab9-9387-636771b1f00e}">
+        <p14:section name="07 · Mensagens finais e encerramento" id="{8e7c6245-28dd-05ba-125c-2a25a99c7c45}">
           <p14:sldIdLst>
             <p14:sldId id="271"/>
             <p14:sldId id="272"/>
@@ -998,7 +998,7 @@
           <a:p>
             <a:r>
               <a:rPr lang="en-US" dirty="0"/>
-              <a:t>FALA: Quando a via adrenérgica não basta, três recursos além das aminas. A vasopressina age no receptor V1, fora da via adrenérgica: poupa catecolamina e costuma manter efeito em acidose; no choque séptico há deficiência relativa do hormônio endógeno. No choque séptico, com noradrenalina em escalada, a dose é em geral fixa, 0,03 unidades por minuto; na vasoplegia após CEC, o VANCS titulou de 0,01 a 0,06 unidades por minuto; na hipotensão refratária com IECA ou BRA, bolus pequenos ou infusão titulada; o risco é isquemia digital e mesentérica. A hidrocortisona restaura a resposta vascular às catecolaminas, 200 mg por dia no choque séptico. O azul de metileno inibe a óxido nítrico sintase e a guanilato ciclase solúvel, e fica como resgate na vasoplegia refratária: após CEC, onde há mais estudos, e na reperfusão do enxerto hepático, onde a base são relatos e séries; um ensaio pequeno mostrou PAM maior e menos adrenalina com a dose dada antes da reperfusão, mas uma coorte pareada de 715 transplantes não confirmou benefício do uso profilático. Outras indicações, apenas para citar: metemoglobinemia, a indicação clássica, e choque séptico refratário, ainda em estudo. Cuidados: deficiência de G6PD, interferência na oximetria e no BIS, e síndrome serotoninérgica com ISRS.</a:t>
+              <a:t>FALA: Quando a via adrenérgica não basta, três recursos além das aminas. A vasopressina age no receptor V1, fora da via adrenérgica: poupa catecolamina e costuma manter efeito em acidose; no choque séptico há deficiência relativa do hormônio endógeno. No choque séptico, com noradrenalina em escalada, a dose é em geral fixa, 0,03 unidades por minuto; na vasoplegia após CEC, o VANCS titulou de 0,01 a 0,06 unidades por minuto; na hipotensão refratária com IECA ou BRA, bolus pequenos ou infusão titulada; o risco é isquemia digital e mesentérica. A hidrocortisona restaura a resposta vascular às catecolaminas, 200 mg por dia no choque séptico. O azul de metileno inibe a óxido nítrico sintase e a guanilato ciclase solúvel, e fica como resgate na vasoplegia refratária: após CEC, onde há mais estudos, e na reperfusão do enxerto hepático, onde a base são relatos e séries; um ensaio pequeno mostrou PAM maior e menos adrenalina com a dose dada antes da reperfusão, mas uma coorte pareada de 715 transplantes não confirmou benefício do uso profilático. Outras indicações, apenas para citar: metemoglobinemia, a indicação clássica, e choque séptico refratário, ainda em estudo. Cuidados: deficiência de G6PD, interferência na oximetria e no BIS, e síndrome serotoninérgica com serotoninérgicos, inclusive certos opioides.</a:t>
             </a:r>
             <a:endParaRPr lang="en-US" dirty="0"/>
           </a:p>
@@ -1740,7 +1740,7 @@
           <a:p>
             <a:r>
               <a:rPr lang="en-US" dirty="0"/>
-              <a:t>FALA: Mas pressão não é fluxo: uma resistência alta pode manter a PAM com débito baixo. No intraoperatório a perfusão raramente é medida de forma direta, então o caminho é combinar métodos. O eco, transesofágico ou à beira do leito, é o primeiro recurso para definir o tipo de choque, e a diretriz europeia de terapia intensiva de 2025 o sugere como primeira linha de imagem para isso: função do VE e do VD, com a variação fracional de área e o TAPSE para o VD; volemia, pela área do VE ao fim da diástole; pericárdio; e o VTI na via de saída, que multiplicado pela área da via de saída dá o volume sistólico e, repetido, mostra a resposta a volume ou a droga. Os monitores de débito dão o número, contínuo ou seriado, e a resposta a uma intervenção. E os marcadores de perfusão tissular dizem se o fluxo está bastando: lactato e sua tendência, saturação venosa central, gap de CO₂, diurese, enchimento capilar e temperatura das extremidades. A decisão de usar inotrópico vem daí, não da pressão.</a:t>
+              <a:t>FALA: Mas pressão não é fluxo: uma resistência alta pode manter a PAM com débito baixo. No intraoperatório a perfusão raramente é medida de forma direta, então o caminho é combinar métodos. O eco, transesofágico ou transtorácico à beira do leito, é o primeiro recurso para definir o tipo de choque, e a diretriz europeia de terapia intensiva de 2025 o sugere como primeira linha de imagem para isso: função do VE e do VD, com a variação fracional de área e o TAPSE para o VD; dimensões cavitárias como pistas de enchimento, sem definir isoladamente a resposta a volume; pericárdio; e o VTI na via de saída, que multiplicado pela área da via de saída dá o volume sistólico e, repetido, mostra a resposta a volume ou a droga. Os monitores de débito dão o número, contínuo ou seriado, e a resposta a uma intervenção. E os marcadores de perfusão tissular dizem se o fluxo está bastando: lactato e sua tendência, saturação venosa central, gap de CO₂, diurese, enchimento capilar e temperatura das extremidades. A decisão de usar inotrópico vem daí, não da pressão.</a:t>
             </a:r>
             <a:endParaRPr lang="en-US" dirty="0"/>
           </a:p>
@@ -1849,7 +1849,7 @@
           <a:p>
             <a:r>
               <a:rPr lang="en-US" dirty="0"/>
-              <a:t>FALA: Monitores de débito: o que cada um mede e onde falha. A termodiluição pelo cateter de artéria pulmonar continua a referência clínica: bolus frio no átrio direito e curva de temperatura na artéria pulmonar; dá também as pressões pulmonares e a saturação venosa mista; é invasiva e, no modo clássico, intermitente; fica sugerida sobretudo no choque refratário, na disfunção de VD e na hipertensão pulmonar. A termodiluição transpulmonar, como o PiCCO, lê o bolus em artéria femoral, calibra o contorno de pulso e estima volumes cardíacos e água pulmonar extravascular. O contorno de pulso não calibrado, como o FloTrac, estima o volume sistólico pela forma da onda arterial; é contínuo e pouco invasivo, mas perde acurácia quando o tônus vascular muda, com resistência baixa ou vasopressor: no cirrótico, o erro contra a termodiluição chegou a 54%, bem acima dos 30% aceitáveis. O Doppler esofágico estima o volume sistólico pela velocidade na aorta descendente e um nomograma; depende da posição e do ângulo da sonda. VPP e VVS exigem ventilação controlada sem esforço, volume corrente de pelo menos 8 mL/kg, ritmo regular, tórax fechado, sem disfunção de VD nem hipertensão intra-abdominal; para a VPP, entre 9 e 13% há uma zona cinzenta. Quando a limitação é o volume corrente baixo, mantidas as demais condições: desafio de volume corrente, de 6 para 8 mL/kg por um minuto. Fora dessas condições: elevação passiva das pernas, com aumento do débito de 10% ou mais, ou minidesafio de 100 mL, medindo o débito, não a pressão.</a:t>
+              <a:t>FALA: Monitores de débito: o que cada um mede e onde falha. A termodiluição pelo cateter de artéria pulmonar continua a referência clínica: bolus frio no átrio direito e curva de temperatura na artéria pulmonar; dá também as pressões pulmonares e a saturação venosa mista; é invasiva e, no modo clássico, intermitente; fica sugerida sobretudo no choque refratário, na disfunção de VD e na hipertensão pulmonar. A termodiluição transpulmonar, como o PiCCO, lê o bolus em artéria femoral, calibra o contorno de pulso e estima volumes cardíacos e água pulmonar extravascular. O contorno de pulso não calibrado, como o FloTrac, estima o volume sistólico pela forma da onda arterial; é contínuo e pouco invasivo, mas perde acurácia quando o tônus vascular muda, com resistência baixa ou vasopressor: no cirrótico, em um estudo de 2009 com uma versão anterior do FloTrac, o erro contra a termodiluição chegou a 54%, bem acima dos 30% aceitáveis. O Doppler esofágico estima o volume sistólico pela velocidade na aorta descendente e um nomograma; depende da posição e do ângulo da sonda. VPP e VVS exigem ventilação controlada sem esforço, volume corrente de pelo menos 8 mL/kg, ritmo regular, tórax fechado, sem disfunção de VD nem hipertensão intra-abdominal; para a VPP, entre 9 e 13% há uma zona cinzenta. Quando a limitação é o volume corrente baixo, mantidas as demais condições: desafio de volume corrente, de 6 para 8 mL/kg por um minuto. Fora dessas condições: elevação passiva das pernas, com aumento do débito de 10% ou mais, ou minidesafio de 100 mL, medindo o débito, não a pressão.</a:t>
             </a:r>
             <a:endParaRPr lang="en-US" dirty="0"/>
           </a:p>
@@ -12830,7 +12830,7 @@
                   </a:tcPr>
                 </a:tc>
               </a:tr>
-              <a:tr h="471091">
+              <a:tr h="652661">
                 <a:tc>
                   <a:txBody>
                     <a:bodyPr/>
@@ -12943,7 +12943,7 @@
                           <a:ea typeface="Calibri" pitchFamily="34" charset="-122"/>
                           <a:cs typeface="Calibri" pitchFamily="34" charset="-120"/>
                         </a:rPr>
-                        <a:t>Perde acurácia com RVS baixa e vasopressor: no cirrótico, erro de 54% vs. termodiluição (limite aceito: 30%)</a:t>
+                        <a:t>Perde acurácia com RVS baixa e vasopressor: em cirróticos, versão antiga do FloTrac com erro de 54% vs. termodiluição (limite aceito: 30%)</a:t>
                       </a:r>
                       <a:endParaRPr lang="en-US" sz="1200" dirty="0"/>
                     </a:p>
@@ -13262,7 +13262,7 @@
         </p:nvSpPr>
         <p:spPr>
           <a:xfrm>
-            <a:off x="812800" y="4650184"/>
+            <a:off x="812800" y="4831755"/>
             <a:ext cx="10566400" cy="781447"/>
           </a:xfrm>
           <a:prstGeom prst="roundRect">
@@ -13289,7 +13289,7 @@
         </p:nvSpPr>
         <p:spPr>
           <a:xfrm>
-            <a:off x="1022350" y="4793526"/>
+            <a:off x="1022350" y="4975096"/>
             <a:ext cx="1924050" cy="496491"/>
           </a:xfrm>
           <a:prstGeom prst="rect">
@@ -13331,7 +13331,7 @@
         </p:nvSpPr>
         <p:spPr>
           <a:xfrm>
-            <a:off x="3105150" y="4749263"/>
+            <a:off x="3105150" y="4930834"/>
             <a:ext cx="8083550" cy="565547"/>
           </a:xfrm>
           <a:prstGeom prst="rect">

</xml_diff>

<commit_message>
Versão 43: slide de receptores em tabela única (colunas alinhadas), linha do α2 mais curta, fala reduzida; 12 min 25 s
Co-Authored-By: Claude Fable 5.1 <noreply@anthropic.com>
Claude-Session: https://claude.ai/code/session_01W6cLQUtwNHu1UUeBJH2XLT
</commit_message>
<xml_diff>
--- a/apresentacao/Aminas_Vasoativas.pptx
+++ b/apresentacao/Aminas_Vasoativas.pptx
@@ -122,24 +122,24 @@
   <p:extLst>
     <p:ext uri="{521415D9-36F7-43E2-AB2F-B90AF26B5E84}">
       <p14:sectionLst xmlns:p14="http://schemas.microsoft.com/office/powerpoint/2010/main">
-        <p14:section name="Abertura e objetivos" id="{85d1af41-3d03-15ad-ba34-92c370442e0f}">
+        <p14:section name="Abertura e objetivos" id="{76842dbc-ef0f-b700-c57c-58f4220c3a9e}">
           <p14:sldIdLst>
             <p14:sldId id="256"/>
             <p14:sldId id="257"/>
           </p14:sldIdLst>
         </p14:section>
-        <p14:section name="01 · Fisiologia: pressão, débito e perfusão" id="{c81757a5-021e-ab70-25e2-6eb3f6ecefa2}">
+        <p14:section name="01 · Fisiologia: pressão, débito e perfusão" id="{f6ab8c14-3b1c-2356-1857-ed88a34975dc}">
           <p14:sldIdLst>
             <p14:sldId id="258"/>
             <p14:sldId id="259"/>
           </p14:sldIdLst>
         </p14:section>
-        <p14:section name="02 · Receptores" id="{5b31f04a-3f2c-f52c-6391-aaa1f6910276}">
+        <p14:section name="02 · Receptores" id="{0528d84a-d34d-8301-4a5c-6d845fe1d83c}">
           <p14:sldIdLst>
             <p14:sldId id="260"/>
           </p14:sldIdLst>
         </p14:section>
-        <p14:section name="03 · Drogas: noradrenalina, adrenalina, dobutamina (e dopamina), milrinona (escolha), fenilefrina e efedrina" id="{a4b135f2-228d-d593-3e7f-6cb9a324c2f4}">
+        <p14:section name="03 · Drogas: noradrenalina, adrenalina, dobutamina (e dopamina), milrinona (escolha), fenilefrina e efedrina" id="{17357479-016a-74d6-d8a5-f9d24d383bea}">
           <p14:sldIdLst>
             <p14:sldId id="261"/>
             <p14:sldId id="262"/>
@@ -149,22 +149,22 @@
             <p14:sldId id="266"/>
           </p14:sldIdLst>
         </p14:section>
-        <p14:section name="04 · Além das aminas: vasopressina, hidrocortisona e azul de metileno" id="{91619335-87d3-459e-5966-23afe5f829d8}">
+        <p14:section name="04 · Além das aminas: vasopressina, hidrocortisona e azul de metileno" id="{0e85d24b-4503-7a36-5690-ad52c0099428}">
           <p14:sldIdLst>
             <p14:sldId id="267"/>
           </p14:sldIdLst>
         </p14:section>
-        <p14:section name="05 · Choque séptico: a sequência da SSC 2026" id="{a7f97a38-2dea-e97c-1554-a6b1c0f9fece}">
+        <p14:section name="05 · Choque séptico: a sequência da SSC 2026" id="{7d632dab-38f9-6e63-34e4-5fdfa66997c5}">
           <p14:sldIdLst>
             <p14:sldId id="268"/>
           </p14:sldIdLst>
         </p14:section>
-        <p14:section name="06 · Perioperatório: escolha da droga" id="{111deaf7-017a-a0ee-67ad-46e8141ab53f}">
+        <p14:section name="06 · Perioperatório: escolha da droga" id="{a42979ce-ca67-2280-b408-7253cb46f4f7}">
           <p14:sldIdLst>
             <p14:sldId id="269"/>
           </p14:sldIdLst>
         </p14:section>
-        <p14:section name="07 · Mensagens finais e encerramento" id="{054dcc67-847e-56a0-79a4-8498b818b47c}">
+        <p14:section name="07 · Mensagens finais e encerramento" id="{4659c61d-bfd4-4c88-1871-63cabab9f0e9}">
           <p14:sldIdLst>
             <p14:sldId id="270"/>
             <p14:sldId id="271"/>
@@ -581,7 +581,7 @@
           <a:p>
             <a:r>
               <a:rPr lang="en-US" dirty="0"/>
-              <a:t>TEMPO: 25 s (0:00 → 0:25). Total previsto: 12 min 35 s nos 16 slides; ensaiar mirando 12 minutos.</a:t>
+              <a:t>TEMPO: 25 s (0:00 → 0:25). Total previsto: 12 min 25 s nos 16 slides; ensaiar mirando 12 minutos.</a:t>
             </a:r>
             <a:endParaRPr lang="en-US" dirty="0"/>
           </a:p>
@@ -683,7 +683,7 @@
           <a:p>
             <a:r>
               <a:rPr lang="en-US" dirty="0"/>
-              <a:t>TEMPO: 1 min 15 s (6:45 → 8:00)</a:t>
+              <a:t>TEMPO: 1 min 15 s (6:35 → 7:50)</a:t>
             </a:r>
             <a:endParaRPr lang="en-US" dirty="0"/>
           </a:p>
@@ -792,7 +792,7 @@
           <a:p>
             <a:r>
               <a:rPr lang="en-US" dirty="0"/>
-              <a:t>TEMPO: 50 s (8:00 → 8:50)</a:t>
+              <a:t>TEMPO: 50 s (7:50 → 8:40)</a:t>
             </a:r>
             <a:endParaRPr lang="en-US" dirty="0"/>
           </a:p>
@@ -894,7 +894,7 @@
           <a:p>
             <a:r>
               <a:rPr lang="en-US" dirty="0"/>
-              <a:t>TEMPO: 1 min 15 s (8:50 → 10:05)</a:t>
+              <a:t>TEMPO: 1 min 15 s (8:40 → 9:55)</a:t>
             </a:r>
             <a:endParaRPr lang="en-US" dirty="0"/>
           </a:p>
@@ -1003,7 +1003,7 @@
           <a:p>
             <a:r>
               <a:rPr lang="en-US" dirty="0"/>
-              <a:t>TEMPO: 35 s (10:05 → 10:40)</a:t>
+              <a:t>TEMPO: 35 s (9:55 → 10:30)</a:t>
             </a:r>
             <a:endParaRPr lang="en-US" dirty="0"/>
           </a:p>
@@ -1112,7 +1112,7 @@
           <a:p>
             <a:r>
               <a:rPr lang="en-US" dirty="0"/>
-              <a:t>TEMPO: 1 min 15 s (10:40 → 11:55)</a:t>
+              <a:t>TEMPO: 1 min 15 s (10:30 → 11:45)</a:t>
             </a:r>
             <a:endParaRPr lang="en-US" dirty="0"/>
           </a:p>
@@ -1221,7 +1221,7 @@
           <a:p>
             <a:r>
               <a:rPr lang="en-US" dirty="0"/>
-              <a:t>TEMPO: 30 s (11:55 → 12:25)</a:t>
+              <a:t>TEMPO: 30 s (11:45 → 12:15)</a:t>
             </a:r>
             <a:endParaRPr lang="en-US" dirty="0"/>
           </a:p>
@@ -1323,7 +1323,7 @@
           <a:p>
             <a:r>
               <a:rPr lang="en-US" dirty="0"/>
-              <a:t>TEMPO: 10 s (12:25 → 12:35)</a:t>
+              <a:t>TEMPO: 10 s (12:15 → 12:25)</a:t>
             </a:r>
             <a:endParaRPr lang="en-US" dirty="0"/>
           </a:p>
@@ -1738,14 +1738,14 @@
           <a:p>
             <a:r>
               <a:rPr lang="en-US" dirty="0"/>
-              <a:t>FALA: Uma revisão breve dos receptores, apenas o que importa para as drogas de hoje. α1 contrai artérias e veias: sobe a resistência e o retorno venoso. α2: pré-sináptico, reduz a liberação de noradrenalina; no tronco encefálico, sedação e simpatólise, o efeito da dexmedetomidina; no músculo liso vascular, vasoconstrição, que explica a hipertensão transitória do bolus de dexmedetomidina. β1 aumenta contratilidade e frequência. β2 dilata vasos e brônquios e eleva glicemia e lactato. D1 dilata os leitos renal e mesentérico. V1 e PDE3 estão na tabela porque vasopressina e milrinona não dependem do adrenoceptor. Dois pontos práticos: as catecolaminas têm meia-vida de minutos, por isso vão em geral em infusão; fenilefrina e efedrina duram mais, por isso são as drogas habituais de bolus. E o uso prolongado dessensibiliza os receptores, sobretudo os β.</a:t>
+              <a:t>FALA: Uma revisão breve dos receptores, apenas o que importa para as drogas de hoje. α1 contrai artérias e veias: sobe a resistência e o retorno venoso. α2 reduz a liberação de noradrenalina no terminal pré-sináptico e, no tronco encefálico, dá sedação e simpatólise, o efeito da dexmedetomidina. β1 aumenta contratilidade e frequência. β2 dilata vasos e brônquios e eleva glicemia e lactato. D1 dilata os leitos renal e mesentérico. V1 e PDE3 estão na tabela porque vasopressina e milrinona não dependem do adrenoceptor. Catecolaminas têm meia-vida de minutos e vão em infusão; fenilefrina e efedrina duram mais e são as drogas habituais de bolus. O uso prolongado dessensibiliza os receptores, sobretudo os β.</a:t>
             </a:r>
             <a:endParaRPr lang="en-US" dirty="0"/>
           </a:p>
           <a:p>
             <a:r>
               <a:rPr lang="en-US" dirty="0"/>
-              <a:t>TEMPO: 1 min (2:55 → 3:55)</a:t>
+              <a:t>TEMPO: 50 s (2:55 → 3:45)</a:t>
             </a:r>
             <a:endParaRPr lang="en-US" dirty="0"/>
           </a:p>
@@ -1854,7 +1854,7 @@
           <a:p>
             <a:r>
               <a:rPr lang="en-US" dirty="0"/>
-              <a:t>TEMPO: 40 s (3:55 → 4:35)</a:t>
+              <a:t>TEMPO: 40 s (3:45 → 4:25)</a:t>
             </a:r>
             <a:endParaRPr lang="en-US" dirty="0"/>
           </a:p>
@@ -1963,7 +1963,7 @@
           <a:p>
             <a:r>
               <a:rPr lang="en-US" dirty="0"/>
-              <a:t>TEMPO: 40 s (4:35 → 5:15)</a:t>
+              <a:t>TEMPO: 40 s (4:25 → 5:05)</a:t>
             </a:r>
             <a:endParaRPr lang="en-US" dirty="0"/>
           </a:p>
@@ -2072,7 +2072,7 @@
           <a:p>
             <a:r>
               <a:rPr lang="en-US" dirty="0"/>
-              <a:t>TEMPO: 35 s (5:15 → 5:50)</a:t>
+              <a:t>TEMPO: 35 s (5:05 → 5:40)</a:t>
             </a:r>
             <a:endParaRPr lang="en-US" dirty="0"/>
           </a:p>
@@ -2174,7 +2174,7 @@
           <a:p>
             <a:r>
               <a:rPr lang="en-US" dirty="0"/>
-              <a:t>TEMPO: 55 s (5:50 → 6:45)</a:t>
+              <a:t>TEMPO: 55 s (5:40 → 6:35)</a:t>
             </a:r>
             <a:endParaRPr lang="en-US" dirty="0"/>
           </a:p>
@@ -11302,8 +11302,8 @@
               <a:tblPr/>
               <a:tblGrid>
                 <a:gridCol w="1056580"/>
-                <a:gridCol w="3698180"/>
-                <a:gridCol w="5811639"/>
+                <a:gridCol w="3803848"/>
+                <a:gridCol w="5705971"/>
               </a:tblGrid>
               <a:tr h="353020">
                 <a:tc>
@@ -11462,7 +11462,7 @@
                       <a:endParaRPr lang="en-US" sz="1200" dirty="0"/>
                     </a:p>
                   </a:txBody>
-                  <a:tcPr marL="127000" marR="127000" marT="69850" marB="69850" anchor="ctr">
+                  <a:tcPr marL="127000" marR="127000" marT="69850" marB="69850" anchor="t">
                     <a:lnL w="0" cap="flat" cmpd="sng" algn="ctr">
                       <a:noFill/>
                     </a:lnL>
@@ -11508,7 +11508,7 @@
                       <a:endParaRPr lang="en-US" sz="1200" dirty="0"/>
                     </a:p>
                   </a:txBody>
-                  <a:tcPr marL="127000" marR="127000" marT="69850" marB="69850" anchor="ctr">
+                  <a:tcPr marL="127000" marR="127000" marT="69850" marB="69850" anchor="t">
                     <a:lnL w="0" cap="flat" cmpd="sng" algn="ctr">
                       <a:noFill/>
                     </a:lnL>
@@ -11554,7 +11554,7 @@
                       <a:endParaRPr lang="en-US" sz="1200" dirty="0"/>
                     </a:p>
                   </a:txBody>
-                  <a:tcPr marL="127000" marR="127000" marT="69850" marB="69850" anchor="ctr">
+                  <a:tcPr marL="127000" marR="127000" marT="69850" marB="69850" anchor="t">
                     <a:lnL w="0" cap="flat" cmpd="sng" algn="ctr">
                       <a:noFill/>
                     </a:lnL>
@@ -11602,7 +11602,7 @@
                       <a:endParaRPr lang="en-US" sz="1200" dirty="0"/>
                     </a:p>
                   </a:txBody>
-                  <a:tcPr marL="127000" marR="127000" marT="69850" marB="69850" anchor="ctr">
+                  <a:tcPr marL="127000" marR="127000" marT="69850" marB="69850" anchor="t">
                     <a:lnL w="0" cap="flat" cmpd="sng" algn="ctr">
                       <a:noFill/>
                     </a:lnL>
@@ -11643,12 +11643,12 @@
                           <a:ea typeface="Calibri" pitchFamily="34" charset="-122"/>
                           <a:cs typeface="Calibri" pitchFamily="34" charset="-120"/>
                         </a:rPr>
-                        <a:t>Pré-sináptico; tronco encefálico (locus coeruleus e centros vasomotores); músculo liso vascular</a:t>
+                        <a:t>Pré-sináptico; tronco encefálico; músculo liso vascular</a:t>
                       </a:r>
                       <a:endParaRPr lang="en-US" sz="1200" dirty="0"/>
                     </a:p>
                   </a:txBody>
-                  <a:tcPr marL="127000" marR="127000" marT="69850" marB="69850" anchor="ctr">
+                  <a:tcPr marL="127000" marR="127000" marT="69850" marB="69850" anchor="t">
                     <a:lnL w="0" cap="flat" cmpd="sng" algn="ctr">
                       <a:noFill/>
                     </a:lnL>
@@ -11689,12 +11689,12 @@
                           <a:ea typeface="Calibri" pitchFamily="34" charset="-122"/>
                           <a:cs typeface="Calibri" pitchFamily="34" charset="-120"/>
                         </a:rPr>
-                        <a:t>↓liberação de NA; sedação e simpatólise central (dexmedetomidina); vasoconstrição pós-sináptica (hipertensão transitória do bolus de dexmedetomidina)</a:t>
+                        <a:t>↓liberação de NA; sedação e simpatólise (dexmedetomidina); vasoconstrição (hipertensão transitória do bolus)</a:t>
                       </a:r>
                       <a:endParaRPr lang="en-US" sz="1200" dirty="0"/>
                     </a:p>
                   </a:txBody>
-                  <a:tcPr marL="127000" marR="127000" marT="69850" marB="69850" anchor="ctr">
+                  <a:tcPr marL="127000" marR="127000" marT="69850" marB="69850" anchor="t">
                     <a:lnL w="0" cap="flat" cmpd="sng" algn="ctr">
                       <a:noFill/>
                     </a:lnL>
@@ -11716,38 +11716,7 @@
                   </a:tcPr>
                 </a:tc>
               </a:tr>
-            </a:tbl>
-          </a:graphicData>
-        </a:graphic>
-      </p:graphicFrame>
-      <p:graphicFrame>
-        <p:nvGraphicFramePr>
-          <p:cNvPr id="5" name="Tabela"/>
-          <p:cNvGraphicFramePr>
-            <a:graphicFrameLocks noGrp="1"/>
-          </p:cNvGraphicFramePr>
-          <p:nvPr>
-            <p:extLst>
-              <p:ext uri="{D42A27DB-BD31-4B8C-83A1-F6EECF244321}">
-                <p14:modId xmlns:p14="http://schemas.microsoft.com/office/powerpoint/2010/main" val="1579011935"/>
-              </p:ext>
-            </p:extLst>
-          </p:nvPr>
-        </p:nvGraphicFramePr>
-        <p:xfrm>
-          <a:off x="812800" y="3164582"/>
-          <a:ext cx="10566400" cy="914400"/>
-        </p:xfrm>
-        <a:graphic>
-          <a:graphicData uri="http://schemas.openxmlformats.org/drawingml/2006/table">
-            <a:tbl>
-              <a:tblPr/>
-              <a:tblGrid>
-                <a:gridCol w="1320701"/>
-                <a:gridCol w="3962301"/>
-                <a:gridCol w="5283398"/>
-              </a:tblGrid>
-              <a:tr h="356195">
+              <a:tr h="359370">
                 <a:tc>
                   <a:txBody>
                     <a:bodyPr/>
@@ -11773,7 +11742,7 @@
                       <a:endParaRPr lang="en-US" sz="1200" dirty="0"/>
                     </a:p>
                   </a:txBody>
-                  <a:tcPr marL="127000" marR="127000" marT="69850" marB="69850" anchor="ctr">
+                  <a:tcPr marL="127000" marR="127000" marT="69850" marB="69850" anchor="t">
                     <a:lnL w="0" cap="flat" cmpd="sng" algn="ctr">
                       <a:noFill/>
                     </a:lnL>
@@ -11819,7 +11788,7 @@
                       <a:endParaRPr lang="en-US" sz="1200" dirty="0"/>
                     </a:p>
                   </a:txBody>
-                  <a:tcPr marL="127000" marR="127000" marT="69850" marB="69850" anchor="ctr">
+                  <a:tcPr marL="127000" marR="127000" marT="69850" marB="69850" anchor="t">
                     <a:lnL w="0" cap="flat" cmpd="sng" algn="ctr">
                       <a:noFill/>
                     </a:lnL>
@@ -11865,7 +11834,7 @@
                       <a:endParaRPr lang="en-US" sz="1200" dirty="0"/>
                     </a:p>
                   </a:txBody>
-                  <a:tcPr marL="127000" marR="127000" marT="69850" marB="69850" anchor="ctr">
+                  <a:tcPr marL="127000" marR="127000" marT="69850" marB="69850" anchor="t">
                     <a:lnL w="0" cap="flat" cmpd="sng" algn="ctr">
                       <a:noFill/>
                     </a:lnL>
@@ -11913,7 +11882,7 @@
                       <a:endParaRPr lang="en-US" sz="1200" dirty="0"/>
                     </a:p>
                   </a:txBody>
-                  <a:tcPr marL="127000" marR="127000" marT="69850" marB="69850" anchor="ctr">
+                  <a:tcPr marL="127000" marR="127000" marT="69850" marB="69850" anchor="t">
                     <a:lnL w="0" cap="flat" cmpd="sng" algn="ctr">
                       <a:noFill/>
                     </a:lnL>
@@ -11959,7 +11928,7 @@
                       <a:endParaRPr lang="en-US" sz="1200" dirty="0"/>
                     </a:p>
                   </a:txBody>
-                  <a:tcPr marL="127000" marR="127000" marT="69850" marB="69850" anchor="ctr">
+                  <a:tcPr marL="127000" marR="127000" marT="69850" marB="69850" anchor="t">
                     <a:lnL w="0" cap="flat" cmpd="sng" algn="ctr">
                       <a:noFill/>
                     </a:lnL>
@@ -12005,7 +11974,7 @@
                       <a:endParaRPr lang="en-US" sz="1200" dirty="0"/>
                     </a:p>
                   </a:txBody>
-                  <a:tcPr marL="127000" marR="127000" marT="69850" marB="69850" anchor="ctr">
+                  <a:tcPr marL="127000" marR="127000" marT="69850" marB="69850" anchor="t">
                     <a:lnL w="0" cap="flat" cmpd="sng" algn="ctr">
                       <a:noFill/>
                     </a:lnL>
@@ -12027,38 +11996,7 @@
                   </a:tcPr>
                 </a:tc>
               </a:tr>
-            </a:tbl>
-          </a:graphicData>
-        </a:graphic>
-      </p:graphicFrame>
-      <p:graphicFrame>
-        <p:nvGraphicFramePr>
-          <p:cNvPr id="6" name="Tabela"/>
-          <p:cNvGraphicFramePr>
-            <a:graphicFrameLocks noGrp="1"/>
-          </p:cNvGraphicFramePr>
-          <p:nvPr>
-            <p:extLst>
-              <p:ext uri="{D42A27DB-BD31-4B8C-83A1-F6EECF244321}">
-                <p14:modId xmlns:p14="http://schemas.microsoft.com/office/powerpoint/2010/main" val="1579011935"/>
-              </p:ext>
-            </p:extLst>
-          </p:nvPr>
-        </p:nvGraphicFramePr>
-        <p:xfrm>
-          <a:off x="812800" y="3883323"/>
-          <a:ext cx="10566400" cy="914400"/>
-        </p:xfrm>
-        <a:graphic>
-          <a:graphicData uri="http://schemas.openxmlformats.org/drawingml/2006/table">
-            <a:tbl>
-              <a:tblPr/>
-              <a:tblGrid>
-                <a:gridCol w="1320701"/>
-                <a:gridCol w="3962301"/>
-                <a:gridCol w="5283398"/>
-              </a:tblGrid>
-              <a:tr h="356195">
+              <a:tr h="359370">
                 <a:tc>
                   <a:txBody>
                     <a:bodyPr/>
@@ -12084,7 +12022,7 @@
                       <a:endParaRPr lang="en-US" sz="1200" dirty="0"/>
                     </a:p>
                   </a:txBody>
-                  <a:tcPr marL="127000" marR="127000" marT="69850" marB="69850" anchor="ctr">
+                  <a:tcPr marL="127000" marR="127000" marT="69850" marB="69850" anchor="t">
                     <a:lnL w="0" cap="flat" cmpd="sng" algn="ctr">
                       <a:noFill/>
                     </a:lnL>
@@ -12130,7 +12068,7 @@
                       <a:endParaRPr lang="en-US" sz="1200" dirty="0"/>
                     </a:p>
                   </a:txBody>
-                  <a:tcPr marL="127000" marR="127000" marT="69850" marB="69850" anchor="ctr">
+                  <a:tcPr marL="127000" marR="127000" marT="69850" marB="69850" anchor="t">
                     <a:lnL w="0" cap="flat" cmpd="sng" algn="ctr">
                       <a:noFill/>
                     </a:lnL>
@@ -12176,7 +12114,7 @@
                       <a:endParaRPr lang="en-US" sz="1200" dirty="0"/>
                     </a:p>
                   </a:txBody>
-                  <a:tcPr marL="127000" marR="127000" marT="69850" marB="69850" anchor="ctr">
+                  <a:tcPr marL="127000" marR="127000" marT="69850" marB="69850" anchor="t">
                     <a:lnL w="0" cap="flat" cmpd="sng" algn="ctr">
                       <a:noFill/>
                     </a:lnL>
@@ -12198,38 +12136,7 @@
                   </a:tcPr>
                 </a:tc>
               </a:tr>
-            </a:tbl>
-          </a:graphicData>
-        </a:graphic>
-      </p:graphicFrame>
-      <p:graphicFrame>
-        <p:nvGraphicFramePr>
-          <p:cNvPr id="7" name="Tabela"/>
-          <p:cNvGraphicFramePr>
-            <a:graphicFrameLocks noGrp="1"/>
-          </p:cNvGraphicFramePr>
-          <p:nvPr>
-            <p:extLst>
-              <p:ext uri="{D42A27DB-BD31-4B8C-83A1-F6EECF244321}">
-                <p14:modId xmlns:p14="http://schemas.microsoft.com/office/powerpoint/2010/main" val="1579011935"/>
-              </p:ext>
-            </p:extLst>
-          </p:nvPr>
-        </p:nvGraphicFramePr>
-        <p:xfrm>
-          <a:off x="812800" y="4242693"/>
-          <a:ext cx="10566400" cy="914400"/>
-        </p:xfrm>
-        <a:graphic>
-          <a:graphicData uri="http://schemas.openxmlformats.org/drawingml/2006/table">
-            <a:tbl>
-              <a:tblPr/>
-              <a:tblGrid>
-                <a:gridCol w="1320701"/>
-                <a:gridCol w="3962301"/>
-                <a:gridCol w="5283398"/>
-              </a:tblGrid>
-              <a:tr h="356195">
+              <a:tr h="359370">
                 <a:tc>
                   <a:txBody>
                     <a:bodyPr/>
@@ -12255,7 +12162,7 @@
                       <a:endParaRPr lang="en-US" sz="1200" dirty="0"/>
                     </a:p>
                   </a:txBody>
-                  <a:tcPr marL="127000" marR="127000" marT="69850" marB="69850" anchor="ctr">
+                  <a:tcPr marL="127000" marR="127000" marT="69850" marB="69850" anchor="t">
                     <a:lnL w="0" cap="flat" cmpd="sng" algn="ctr">
                       <a:noFill/>
                     </a:lnL>
@@ -12301,7 +12208,7 @@
                       <a:endParaRPr lang="en-US" sz="1200" dirty="0"/>
                     </a:p>
                   </a:txBody>
-                  <a:tcPr marL="127000" marR="127000" marT="69850" marB="69850" anchor="ctr">
+                  <a:tcPr marL="127000" marR="127000" marT="69850" marB="69850" anchor="t">
                     <a:lnL w="0" cap="flat" cmpd="sng" algn="ctr">
                       <a:noFill/>
                     </a:lnL>
@@ -12347,7 +12254,7 @@
                       <a:endParaRPr lang="en-US" sz="1200" dirty="0"/>
                     </a:p>
                   </a:txBody>
-                  <a:tcPr marL="127000" marR="127000" marT="69850" marB="69850" anchor="ctr">
+                  <a:tcPr marL="127000" marR="127000" marT="69850" marB="69850" anchor="t">
                     <a:lnL w="0" cap="flat" cmpd="sng" algn="ctr">
                       <a:noFill/>
                     </a:lnL>
@@ -12395,7 +12302,7 @@
                       <a:endParaRPr lang="en-US" sz="1200" dirty="0"/>
                     </a:p>
                   </a:txBody>
-                  <a:tcPr marL="127000" marR="127000" marT="69850" marB="69850" anchor="ctr">
+                  <a:tcPr marL="127000" marR="127000" marT="69850" marB="69850" anchor="t">
                     <a:lnL w="0" cap="flat" cmpd="sng" algn="ctr">
                       <a:noFill/>
                     </a:lnL>
@@ -12441,7 +12348,7 @@
                       <a:endParaRPr lang="en-US" sz="1200" dirty="0"/>
                     </a:p>
                   </a:txBody>
-                  <a:tcPr marL="127000" marR="127000" marT="69850" marB="69850" anchor="ctr">
+                  <a:tcPr marL="127000" marR="127000" marT="69850" marB="69850" anchor="t">
                     <a:lnL w="0" cap="flat" cmpd="sng" algn="ctr">
                       <a:noFill/>
                     </a:lnL>
@@ -12487,7 +12394,7 @@
                       <a:endParaRPr lang="en-US" sz="1200" dirty="0"/>
                     </a:p>
                   </a:txBody>
-                  <a:tcPr marL="127000" marR="127000" marT="69850" marB="69850" anchor="ctr">
+                  <a:tcPr marL="127000" marR="127000" marT="69850" marB="69850" anchor="t">
                     <a:lnL w="0" cap="flat" cmpd="sng" algn="ctr">
                       <a:noFill/>
                     </a:lnL>
@@ -12515,7 +12422,7 @@
       </p:graphicFrame>
       <p:sp>
         <p:nvSpPr>
-          <p:cNvPr id="8" name="Catecolaminas: meia-vida de minutos, em "/>
+          <p:cNvPr id="5" name="Catecolaminas: meia-vida de minutos, em "/>
           <p:cNvSpPr txBox="1"/>
           <p:nvPr/>
         </p:nvSpPr>
@@ -12557,7 +12464,7 @@
       </p:sp>
       <p:sp>
         <p:nvSpPr>
-          <p:cNvPr id="9" name="Miller’s Anesthesia, 10ª ed. (2025), cap"/>
+          <p:cNvPr id="6" name="Miller’s Anesthesia, 10ª ed. (2025), cap"/>
           <p:cNvSpPr txBox="1"/>
           <p:nvPr/>
         </p:nvSpPr>
@@ -12599,7 +12506,7 @@
       </p:sp>
       <p:pic>
         <p:nvPicPr>
-          <p:cNvPr id="10" name="Símbolo da UFRJ" descr="Símbolo da UFRJ">    </p:cNvPr>
+          <p:cNvPr id="7" name="Símbolo da UFRJ" descr="Símbolo da UFRJ">    </p:cNvPr>
           <p:cNvPicPr>
             <a:picLocks noChangeAspect="1"/>
           </p:cNvPicPr>

</xml_diff>

<commit_message>
Versão 43: fala do eco mais curta no slide 4, com pontos de corte conferidos na nota (ASE 2015, ESICM 2025, VTI × área); 12 min 20 s
Co-Authored-By: Claude Fable 5.1 <noreply@anthropic.com>
Claude-Session: https://claude.ai/code/session_01W6cLQUtwNHu1UUeBJH2XLT
</commit_message>
<xml_diff>
--- a/apresentacao/Aminas_Vasoativas.pptx
+++ b/apresentacao/Aminas_Vasoativas.pptx
@@ -122,24 +122,24 @@
   <p:extLst>
     <p:ext uri="{521415D9-36F7-43E2-AB2F-B90AF26B5E84}">
       <p14:sectionLst xmlns:p14="http://schemas.microsoft.com/office/powerpoint/2010/main">
-        <p14:section name="Abertura e objetivos" id="{76842dbc-ef0f-b700-c57c-58f4220c3a9e}">
+        <p14:section name="Abertura e objetivos" id="{1b364beb-3545-28e5-75d3-71f2ad8d10fa}">
           <p14:sldIdLst>
             <p14:sldId id="256"/>
             <p14:sldId id="257"/>
           </p14:sldIdLst>
         </p14:section>
-        <p14:section name="01 · Fisiologia: pressão, débito e perfusão" id="{f6ab8c14-3b1c-2356-1857-ed88a34975dc}">
+        <p14:section name="01 · Fisiologia: pressão, débito e perfusão" id="{97a2495e-9ac7-589a-e675-f5336fae40d2}">
           <p14:sldIdLst>
             <p14:sldId id="258"/>
             <p14:sldId id="259"/>
           </p14:sldIdLst>
         </p14:section>
-        <p14:section name="02 · Receptores" id="{0528d84a-d34d-8301-4a5c-6d845fe1d83c}">
+        <p14:section name="02 · Receptores" id="{7baace15-31bb-a81b-c7d9-2f59d406103c}">
           <p14:sldIdLst>
             <p14:sldId id="260"/>
           </p14:sldIdLst>
         </p14:section>
-        <p14:section name="03 · Drogas: noradrenalina, adrenalina, dobutamina (e dopamina), milrinona (escolha), fenilefrina e efedrina" id="{17357479-016a-74d6-d8a5-f9d24d383bea}">
+        <p14:section name="03 · Drogas: noradrenalina, adrenalina, dobutamina (e dopamina), milrinona (escolha), fenilefrina e efedrina" id="{95b3dbb7-a4df-a218-d4f5-e92b8a96a91d}">
           <p14:sldIdLst>
             <p14:sldId id="261"/>
             <p14:sldId id="262"/>
@@ -149,22 +149,22 @@
             <p14:sldId id="266"/>
           </p14:sldIdLst>
         </p14:section>
-        <p14:section name="04 · Além das aminas: vasopressina, hidrocortisona e azul de metileno" id="{0e85d24b-4503-7a36-5690-ad52c0099428}">
+        <p14:section name="04 · Além das aminas: vasopressina, hidrocortisona e azul de metileno" id="{bc2363a8-ef26-59da-8f61-e6db232b8b49}">
           <p14:sldIdLst>
             <p14:sldId id="267"/>
           </p14:sldIdLst>
         </p14:section>
-        <p14:section name="05 · Choque séptico: a sequência da SSC 2026" id="{7d632dab-38f9-6e63-34e4-5fdfa66997c5}">
+        <p14:section name="05 · Choque séptico: a sequência da SSC 2026" id="{99ff683a-a9dd-26fa-a763-6caa973fa041}">
           <p14:sldIdLst>
             <p14:sldId id="268"/>
           </p14:sldIdLst>
         </p14:section>
-        <p14:section name="06 · Perioperatório: escolha da droga" id="{a42979ce-ca67-2280-b408-7253cb46f4f7}">
+        <p14:section name="06 · Perioperatório: escolha da droga" id="{68c94bb0-ea36-c7bd-2235-567da0b01e49}">
           <p14:sldIdLst>
             <p14:sldId id="269"/>
           </p14:sldIdLst>
         </p14:section>
-        <p14:section name="07 · Mensagens finais e encerramento" id="{4659c61d-bfd4-4c88-1871-63cabab9f0e9}">
+        <p14:section name="07 · Mensagens finais e encerramento" id="{6a82c084-147d-60d6-c0a6-cfb33b2e7bbc}">
           <p14:sldIdLst>
             <p14:sldId id="270"/>
             <p14:sldId id="271"/>
@@ -581,7 +581,7 @@
           <a:p>
             <a:r>
               <a:rPr lang="en-US" dirty="0"/>
-              <a:t>TEMPO: 25 s (0:00 → 0:25). Total previsto: 12 min 25 s nos 16 slides; ensaiar mirando 12 minutos.</a:t>
+              <a:t>TEMPO: 25 s (0:00 → 0:25). Total previsto: 12 min 20 s nos 16 slides; ensaiar mirando 12 minutos.</a:t>
             </a:r>
             <a:endParaRPr lang="en-US" dirty="0"/>
           </a:p>
@@ -683,7 +683,7 @@
           <a:p>
             <a:r>
               <a:rPr lang="en-US" dirty="0"/>
-              <a:t>TEMPO: 1 min 15 s (6:35 → 7:50)</a:t>
+              <a:t>TEMPO: 1 min 15 s (6:30 → 7:45)</a:t>
             </a:r>
             <a:endParaRPr lang="en-US" dirty="0"/>
           </a:p>
@@ -792,7 +792,7 @@
           <a:p>
             <a:r>
               <a:rPr lang="en-US" dirty="0"/>
-              <a:t>TEMPO: 50 s (7:50 → 8:40)</a:t>
+              <a:t>TEMPO: 50 s (7:45 → 8:35)</a:t>
             </a:r>
             <a:endParaRPr lang="en-US" dirty="0"/>
           </a:p>
@@ -894,7 +894,7 @@
           <a:p>
             <a:r>
               <a:rPr lang="en-US" dirty="0"/>
-              <a:t>TEMPO: 1 min 15 s (8:40 → 9:55)</a:t>
+              <a:t>TEMPO: 1 min 15 s (8:35 → 9:50)</a:t>
             </a:r>
             <a:endParaRPr lang="en-US" dirty="0"/>
           </a:p>
@@ -1003,7 +1003,7 @@
           <a:p>
             <a:r>
               <a:rPr lang="en-US" dirty="0"/>
-              <a:t>TEMPO: 35 s (9:55 → 10:30)</a:t>
+              <a:t>TEMPO: 35 s (9:50 → 10:25)</a:t>
             </a:r>
             <a:endParaRPr lang="en-US" dirty="0"/>
           </a:p>
@@ -1112,7 +1112,7 @@
           <a:p>
             <a:r>
               <a:rPr lang="en-US" dirty="0"/>
-              <a:t>TEMPO: 1 min 15 s (10:30 → 11:45)</a:t>
+              <a:t>TEMPO: 1 min 15 s (10:25 → 11:40)</a:t>
             </a:r>
             <a:endParaRPr lang="en-US" dirty="0"/>
           </a:p>
@@ -1221,7 +1221,7 @@
           <a:p>
             <a:r>
               <a:rPr lang="en-US" dirty="0"/>
-              <a:t>TEMPO: 30 s (11:45 → 12:15)</a:t>
+              <a:t>TEMPO: 30 s (11:40 → 12:10)</a:t>
             </a:r>
             <a:endParaRPr lang="en-US" dirty="0"/>
           </a:p>
@@ -1323,7 +1323,7 @@
           <a:p>
             <a:r>
               <a:rPr lang="en-US" dirty="0"/>
-              <a:t>TEMPO: 10 s (12:15 → 12:25)</a:t>
+              <a:t>TEMPO: 10 s (12:10 → 12:20)</a:t>
             </a:r>
             <a:endParaRPr lang="en-US" dirty="0"/>
           </a:p>
@@ -1629,14 +1629,14 @@
           <a:p>
             <a:r>
               <a:rPr lang="en-US" dirty="0"/>
-              <a:t>FALA: Mas pressão não é fluxo: uma resistência alta pode manter a PAM com débito baixo. No intraoperatório o caminho é combinar métodos. O eco, transesofágico ou transtorácico à beira do leito, é o primeiro recurso para definir o tipo de choque: função do VE e do VD, com a variação fracional de área e o TAPSE; dimensões cavitárias como pistas de enchimento; pericárdio; e o VTI na via de saída, que vezes a área dá o volume sistólico e, repetido, mostra a resposta a volume ou a droga. Os monitores de débito dão o número e a resposta a uma intervenção. E os marcadores de perfusão tissular dizem se o fluxo está bastando: lactato e sua tendência, saturação venosa central, gap de CO₂, diurese, enchimento capilar e temperatura das extremidades. A decisão de usar inotrópico vem daí, não da pressão.</a:t>
+              <a:t>FALA: Mas pressão não é fluxo: uma resistência alta pode manter a PAM com débito baixo. O eco, transesofágico ou transtorácico, é a primeira linha para definir o tipo de choque: função do VE e do VD, com a variação fracional de área e o TAPSE; tamanho das cavidades como pista de enchimento; pericárdio; e o VTI na via de saída, que vezes a área dá o volume sistólico e, repetido, mostra a resposta a volume ou a droga. Os monitores de débito dão o número e a resposta a uma intervenção. Os marcadores de perfusão tissular dizem se o fluxo está bastando: lactato e sua tendência, saturação venosa central, gap de CO₂, diurese, enchimento capilar e temperatura das extremidades. A decisão de usar inotrópico vem daí, não da pressão.</a:t>
             </a:r>
             <a:endParaRPr lang="en-US" dirty="0"/>
           </a:p>
           <a:p>
             <a:r>
               <a:rPr lang="en-US" dirty="0"/>
-              <a:t>TEMPO: 1 min 5 s (1:50 → 2:55)</a:t>
+              <a:t>TEMPO: 1 min (1:50 → 2:50)</a:t>
             </a:r>
             <a:endParaRPr lang="en-US" dirty="0"/>
           </a:p>
@@ -1650,7 +1650,7 @@
           <a:p>
             <a:r>
               <a:rPr lang="en-US" dirty="0"/>
-              <a:t>SE PERGUNTAREM: no OPTIME-CHF (Cuffe, JAMA 2002; 951 pacientes com IC descompensada sem indicação clara de inotrópico), milrinona vs. placebo por 48 h: sem benefício, com mais hipotensão sustentada e arritmia atrial. Em um ECR (Tongyoo, Ann Med 2025; 64 pacientes em choque séptico), a milrinona aumentou o débito em 6 horas em relação ao placebo, mas a mortalidade em 28 dias foi de 50% nos dois grupos. Na sepse a SvcO₂ pode estar normal ou alta apesar da hipoperfusão (defeito de extração e shunt microcirculatório); nesse caso, a diferença venoarterial de CO₂ acima de 6 mmHg sugere fluxo insuficiente para remover o CO₂ produzido (Vallée, Intensive Care Med 2008). Limites de VPP e VVS: ventilação controlada sem esforço espontâneo, volume corrente de pelo menos 8 mL/kg, ritmo regular, tórax fechado, sem disfunção de VD nem hipertensão intra-abdominal; com volume corrente baixo a sensibilidade cai. Fora dessas condições: elevação passiva das pernas ou minidesafio hídrico com medida direta do débito (ESICM 2025). Monitores de débito: termodiluição pelo cateter de artéria pulmonar é a referência clínica (invasiva, intermitente ou semicontínua; sugerida no choque refratário e na disfunção de VD); termodiluição transpulmonar (PiCCO) calibra o contorno de pulso e estima volumes e água pulmonar extravascular; contorno de pulso não calibrado (FloTrac, ClearSight) perde acurácia com RVS baixa e vasopressor: em cirróticos, versão antiga do FloTrac teve erro percentual de 54% vs. termodiluição, limite aceito 30% (Biancofiore, Br J Anaesth 2009); Doppler esofágico depende da posição e do ângulo da sonda e assume o diâmetro aórtico. Zona cinzenta da VPP de 9–13% (Cannesson, Anesthesiology 2011); desafio de volume corrente 6 → 8 mL/kg por 1 min quando a limitação é apenas o volume corrente baixo (Myatra, Crit Care Med 2017); elevação passiva das pernas com ↑DC ≥ 10%: sensibilidade 85%, especificidade 91% (Monnet, Intensive Care Med 2016, metanálise de 21 estudos); minidesafio de 100 mL em dois passos de 50 mL, ↑índice sistólico &gt; 6% (Biais, Anesthesiology 2017; 44 pacientes em neurocirurgia).</a:t>
+              <a:t>SE PERGUNTAREM: Eco: a ESICM 2025 sugere a ecocardiografia como imagem de primeira linha para definir o tipo de choque. VD: TAPSE abaixo de 17 mm e variação fracional de área abaixo de 35% indicam disfunção sistólica (ASE 2015); ao ETE, o TAPSE sofre com o alinhamento do feixe, por isso usa-se a variação fracional de área no corte médio-esofágico de quatro câmaras ou o TAPSE modificado. Volume sistólico = área da via de saída do VE × VTI; débito = volume sistólico × FC; como a área é fixa no mesmo paciente, a variação do VTI acompanha a do volume sistólico, e um aumento de cerca de 10 a 15% após elevação passiva das pernas ou volume indica resposta (estudos pequenos). A área diastólica final do VE no corte transgástrico é índice estático de pré-carga, útil nos extremos, e não prediz isoladamente a resposta a volume. No OPTIME-CHF (Cuffe, JAMA 2002; 951 pacientes com IC descompensada sem indicação clara de inotrópico), milrinona vs. placebo por 48 h: sem benefício, com mais hipotensão sustentada e arritmia atrial. Em um ECR (Tongyoo, Ann Med 2025; 64 pacientes em choque séptico), a milrinona aumentou o débito em 6 horas em relação ao placebo, mas a mortalidade em 28 dias foi de 50% nos dois grupos. Na sepse a SvcO₂ pode estar normal ou alta apesar da hipoperfusão (defeito de extração e shunt microcirculatório); nesse caso, a diferença venoarterial de CO₂ acima de 6 mmHg sugere fluxo insuficiente para remover o CO₂ produzido (Vallée, Intensive Care Med 2008). Limites de VPP e VVS: ventilação controlada sem esforço espontâneo, volume corrente de pelo menos 8 mL/kg, ritmo regular, tórax fechado, sem disfunção de VD nem hipertensão intra-abdominal; com volume corrente baixo a sensibilidade cai. Fora dessas condições: elevação passiva das pernas ou minidesafio hídrico com medida direta do débito (ESICM 2025). Monitores de débito: termodiluição pelo cateter de artéria pulmonar é a referência clínica (invasiva, intermitente ou semicontínua; sugerida no choque refratário e na disfunção de VD); termodiluição transpulmonar (PiCCO) calibra o contorno de pulso e estima volumes e água pulmonar extravascular; contorno de pulso não calibrado (FloTrac, ClearSight) perde acurácia com RVS baixa e vasopressor: em cirróticos, versão antiga do FloTrac teve erro percentual de 54% vs. termodiluição, limite aceito 30% (Biancofiore, Br J Anaesth 2009); Doppler esofágico depende da posição e do ângulo da sonda e assume o diâmetro aórtico. Zona cinzenta da VPP de 9–13% (Cannesson, Anesthesiology 2011); desafio de volume corrente 6 → 8 mL/kg por 1 min quando a limitação é apenas o volume corrente baixo (Myatra, Crit Care Med 2017); elevação passiva das pernas com ↑DC ≥ 10%: sensibilidade 85%, especificidade 91% (Monnet, Intensive Care Med 2016, metanálise de 21 estudos); minidesafio de 100 mL em dois passos de 50 mL, ↑índice sistólico &gt; 6% (Biais, Anesthesiology 2017; 44 pacientes em neurocirurgia).</a:t>
             </a:r>
             <a:endParaRPr lang="en-US" dirty="0"/>
           </a:p>
@@ -1745,7 +1745,7 @@
           <a:p>
             <a:r>
               <a:rPr lang="en-US" dirty="0"/>
-              <a:t>TEMPO: 50 s (2:55 → 3:45)</a:t>
+              <a:t>TEMPO: 50 s (2:50 → 3:40)</a:t>
             </a:r>
             <a:endParaRPr lang="en-US" dirty="0"/>
           </a:p>
@@ -1854,7 +1854,7 @@
           <a:p>
             <a:r>
               <a:rPr lang="en-US" dirty="0"/>
-              <a:t>TEMPO: 40 s (3:45 → 4:25)</a:t>
+              <a:t>TEMPO: 40 s (3:40 → 4:20)</a:t>
             </a:r>
             <a:endParaRPr lang="en-US" dirty="0"/>
           </a:p>
@@ -1963,7 +1963,7 @@
           <a:p>
             <a:r>
               <a:rPr lang="en-US" dirty="0"/>
-              <a:t>TEMPO: 40 s (4:25 → 5:05)</a:t>
+              <a:t>TEMPO: 40 s (4:20 → 5:00)</a:t>
             </a:r>
             <a:endParaRPr lang="en-US" dirty="0"/>
           </a:p>
@@ -2072,7 +2072,7 @@
           <a:p>
             <a:r>
               <a:rPr lang="en-US" dirty="0"/>
-              <a:t>TEMPO: 35 s (5:05 → 5:40)</a:t>
+              <a:t>TEMPO: 35 s (5:00 → 5:35)</a:t>
             </a:r>
             <a:endParaRPr lang="en-US" dirty="0"/>
           </a:p>
@@ -2174,7 +2174,7 @@
           <a:p>
             <a:r>
               <a:rPr lang="en-US" dirty="0"/>
-              <a:t>TEMPO: 55 s (5:40 → 6:35)</a:t>
+              <a:t>TEMPO: 55 s (5:35 → 6:30)</a:t>
             </a:r>
             <a:endParaRPr lang="en-US" dirty="0"/>
           </a:p>

</xml_diff>

<commit_message>
Versão 43: fala do eco conferida por três verificadores com fontes; 'sugerido como imagem de primeira linha'; FAC, TAPSE e VTI × área na nota; limiares de resposta a volume separados; 12 min 15 s
Co-Authored-By: Claude Fable 5.1 <noreply@anthropic.com>
Claude-Session: https://claude.ai/code/session_01W6cLQUtwNHu1UUeBJH2XLT
</commit_message>
<xml_diff>
--- a/apresentacao/Aminas_Vasoativas.pptx
+++ b/apresentacao/Aminas_Vasoativas.pptx
@@ -122,24 +122,24 @@
   <p:extLst>
     <p:ext uri="{521415D9-36F7-43E2-AB2F-B90AF26B5E84}">
       <p14:sectionLst xmlns:p14="http://schemas.microsoft.com/office/powerpoint/2010/main">
-        <p14:section name="Abertura e objetivos" id="{1b364beb-3545-28e5-75d3-71f2ad8d10fa}">
+        <p14:section name="Abertura e objetivos" id="{bc7fb97f-2d7c-0c43-22a4-0ce9c48f870b}">
           <p14:sldIdLst>
             <p14:sldId id="256"/>
             <p14:sldId id="257"/>
           </p14:sldIdLst>
         </p14:section>
-        <p14:section name="01 · Fisiologia: pressão, débito e perfusão" id="{97a2495e-9ac7-589a-e675-f5336fae40d2}">
+        <p14:section name="01 · Fisiologia: pressão, débito e perfusão" id="{d636bac3-2873-415c-d765-3b40d2829437}">
           <p14:sldIdLst>
             <p14:sldId id="258"/>
             <p14:sldId id="259"/>
           </p14:sldIdLst>
         </p14:section>
-        <p14:section name="02 · Receptores" id="{7baace15-31bb-a81b-c7d9-2f59d406103c}">
+        <p14:section name="02 · Receptores" id="{168166fb-07d0-f4e0-ca30-b88426f442b0}">
           <p14:sldIdLst>
             <p14:sldId id="260"/>
           </p14:sldIdLst>
         </p14:section>
-        <p14:section name="03 · Drogas: noradrenalina, adrenalina, dobutamina (e dopamina), milrinona (escolha), fenilefrina e efedrina" id="{95b3dbb7-a4df-a218-d4f5-e92b8a96a91d}">
+        <p14:section name="03 · Drogas: noradrenalina, adrenalina, dobutamina (e dopamina), milrinona (escolha), fenilefrina e efedrina" id="{bdb28524-6bf9-ceba-5bf5-6cb03a29110a}">
           <p14:sldIdLst>
             <p14:sldId id="261"/>
             <p14:sldId id="262"/>
@@ -149,22 +149,22 @@
             <p14:sldId id="266"/>
           </p14:sldIdLst>
         </p14:section>
-        <p14:section name="04 · Além das aminas: vasopressina, hidrocortisona e azul de metileno" id="{bc2363a8-ef26-59da-8f61-e6db232b8b49}">
+        <p14:section name="04 · Além das aminas: vasopressina, hidrocortisona e azul de metileno" id="{199cb4fd-5a47-38a0-ab84-4e4777e3a7d3}">
           <p14:sldIdLst>
             <p14:sldId id="267"/>
           </p14:sldIdLst>
         </p14:section>
-        <p14:section name="05 · Choque séptico: a sequência da SSC 2026" id="{99ff683a-a9dd-26fa-a763-6caa973fa041}">
+        <p14:section name="05 · Choque séptico: a sequência da SSC 2026" id="{ccb79233-f2b8-a38f-e6ef-69cbf13732be}">
           <p14:sldIdLst>
             <p14:sldId id="268"/>
           </p14:sldIdLst>
         </p14:section>
-        <p14:section name="06 · Perioperatório: escolha da droga" id="{68c94bb0-ea36-c7bd-2235-567da0b01e49}">
+        <p14:section name="06 · Perioperatório: escolha da droga" id="{3e7b433e-b501-04b3-9a04-6335429f680f}">
           <p14:sldIdLst>
             <p14:sldId id="269"/>
           </p14:sldIdLst>
         </p14:section>
-        <p14:section name="07 · Mensagens finais e encerramento" id="{6a82c084-147d-60d6-c0a6-cfb33b2e7bbc}">
+        <p14:section name="07 · Mensagens finais e encerramento" id="{5a9fad88-14b7-e0d3-ae2c-26b2b4a17c4e}">
           <p14:sldIdLst>
             <p14:sldId id="270"/>
             <p14:sldId id="271"/>
@@ -581,7 +581,7 @@
           <a:p>
             <a:r>
               <a:rPr lang="en-US" dirty="0"/>
-              <a:t>TEMPO: 25 s (0:00 → 0:25). Total previsto: 12 min 20 s nos 16 slides; ensaiar mirando 12 minutos.</a:t>
+              <a:t>TEMPO: 25 s (0:00 → 0:25). Total previsto: 12 min 15 s nos 16 slides; ensaiar mirando 12 minutos.</a:t>
             </a:r>
             <a:endParaRPr lang="en-US" dirty="0"/>
           </a:p>
@@ -683,7 +683,7 @@
           <a:p>
             <a:r>
               <a:rPr lang="en-US" dirty="0"/>
-              <a:t>TEMPO: 1 min 15 s (6:30 → 7:45)</a:t>
+              <a:t>TEMPO: 1 min 15 s (6:25 → 7:40)</a:t>
             </a:r>
             <a:endParaRPr lang="en-US" dirty="0"/>
           </a:p>
@@ -792,7 +792,7 @@
           <a:p>
             <a:r>
               <a:rPr lang="en-US" dirty="0"/>
-              <a:t>TEMPO: 50 s (7:45 → 8:35)</a:t>
+              <a:t>TEMPO: 50 s (7:40 → 8:30)</a:t>
             </a:r>
             <a:endParaRPr lang="en-US" dirty="0"/>
           </a:p>
@@ -894,7 +894,7 @@
           <a:p>
             <a:r>
               <a:rPr lang="en-US" dirty="0"/>
-              <a:t>TEMPO: 1 min 15 s (8:35 → 9:50)</a:t>
+              <a:t>TEMPO: 1 min 15 s (8:30 → 9:45)</a:t>
             </a:r>
             <a:endParaRPr lang="en-US" dirty="0"/>
           </a:p>
@@ -1003,7 +1003,7 @@
           <a:p>
             <a:r>
               <a:rPr lang="en-US" dirty="0"/>
-              <a:t>TEMPO: 35 s (9:50 → 10:25)</a:t>
+              <a:t>TEMPO: 35 s (9:45 → 10:20)</a:t>
             </a:r>
             <a:endParaRPr lang="en-US" dirty="0"/>
           </a:p>
@@ -1112,7 +1112,7 @@
           <a:p>
             <a:r>
               <a:rPr lang="en-US" dirty="0"/>
-              <a:t>TEMPO: 1 min 15 s (10:25 → 11:40)</a:t>
+              <a:t>TEMPO: 1 min 15 s (10:20 → 11:35)</a:t>
             </a:r>
             <a:endParaRPr lang="en-US" dirty="0"/>
           </a:p>
@@ -1221,7 +1221,7 @@
           <a:p>
             <a:r>
               <a:rPr lang="en-US" dirty="0"/>
-              <a:t>TEMPO: 30 s (11:40 → 12:10)</a:t>
+              <a:t>TEMPO: 30 s (11:35 → 12:05)</a:t>
             </a:r>
             <a:endParaRPr lang="en-US" dirty="0"/>
           </a:p>
@@ -1323,7 +1323,7 @@
           <a:p>
             <a:r>
               <a:rPr lang="en-US" dirty="0"/>
-              <a:t>TEMPO: 10 s (12:10 → 12:20)</a:t>
+              <a:t>TEMPO: 10 s (12:05 → 12:15)</a:t>
             </a:r>
             <a:endParaRPr lang="en-US" dirty="0"/>
           </a:p>
@@ -1629,14 +1629,14 @@
           <a:p>
             <a:r>
               <a:rPr lang="en-US" dirty="0"/>
-              <a:t>FALA: Mas pressão não é fluxo: uma resistência alta pode manter a PAM com débito baixo. O eco, transesofágico ou transtorácico, é a primeira linha para definir o tipo de choque: função do VE e do VD, com a variação fracional de área e o TAPSE; tamanho das cavidades como pista de enchimento; pericárdio; e o VTI na via de saída, que vezes a área dá o volume sistólico e, repetido, mostra a resposta a volume ou a droga. Os monitores de débito dão o número e a resposta a uma intervenção. Os marcadores de perfusão tissular dizem se o fluxo está bastando: lactato e sua tendência, saturação venosa central, gap de CO₂, diurese, enchimento capilar e temperatura das extremidades. A decisão de usar inotrópico vem daí, não da pressão.</a:t>
+              <a:t>FALA: Mas pressão não é fluxo: uma resistência alta pode manter a PAM com débito baixo. O eco, transesofágico ou transtorácico, é sugerido como imagem de primeira linha para definir o tipo de choque: função do VE e do VD, tamanho das cavidades, pericárdio e o VTI na via de saída, que estima o volume sistólico e, repetido, mostra a resposta a volume ou a droga. Os monitores de débito dão o número e a resposta a uma intervenção. Os marcadores de perfusão tissular, lidos em conjunto, dizem se o fluxo está bastando: lactato e sua tendência, saturação venosa central, gap de CO₂, diurese, enchimento capilar e temperatura das extremidades. A decisão de usar inotrópico vem daí, não da pressão.</a:t>
             </a:r>
             <a:endParaRPr lang="en-US" dirty="0"/>
           </a:p>
           <a:p>
             <a:r>
               <a:rPr lang="en-US" dirty="0"/>
-              <a:t>TEMPO: 1 min (1:50 → 2:50)</a:t>
+              <a:t>TEMPO: 55 s (1:50 → 2:45)</a:t>
             </a:r>
             <a:endParaRPr lang="en-US" dirty="0"/>
           </a:p>
@@ -1650,7 +1650,7 @@
           <a:p>
             <a:r>
               <a:rPr lang="en-US" dirty="0"/>
-              <a:t>SE PERGUNTAREM: Eco: a ESICM 2025 sugere a ecocardiografia como imagem de primeira linha para definir o tipo de choque. VD: TAPSE abaixo de 17 mm e variação fracional de área abaixo de 35% indicam disfunção sistólica (ASE 2015); ao ETE, o TAPSE sofre com o alinhamento do feixe, por isso usa-se a variação fracional de área no corte médio-esofágico de quatro câmaras ou o TAPSE modificado. Volume sistólico = área da via de saída do VE × VTI; débito = volume sistólico × FC; como a área é fixa no mesmo paciente, a variação do VTI acompanha a do volume sistólico, e um aumento de cerca de 10 a 15% após elevação passiva das pernas ou volume indica resposta (estudos pequenos). A área diastólica final do VE no corte transgástrico é índice estático de pré-carga, útil nos extremos, e não prediz isoladamente a resposta a volume. No OPTIME-CHF (Cuffe, JAMA 2002; 951 pacientes com IC descompensada sem indicação clara de inotrópico), milrinona vs. placebo por 48 h: sem benefício, com mais hipotensão sustentada e arritmia atrial. Em um ECR (Tongyoo, Ann Med 2025; 64 pacientes em choque séptico), a milrinona aumentou o débito em 6 horas em relação ao placebo, mas a mortalidade em 28 dias foi de 50% nos dois grupos. Na sepse a SvcO₂ pode estar normal ou alta apesar da hipoperfusão (defeito de extração e shunt microcirculatório); nesse caso, a diferença venoarterial de CO₂ acima de 6 mmHg sugere fluxo insuficiente para remover o CO₂ produzido (Vallée, Intensive Care Med 2008). Limites de VPP e VVS: ventilação controlada sem esforço espontâneo, volume corrente de pelo menos 8 mL/kg, ritmo regular, tórax fechado, sem disfunção de VD nem hipertensão intra-abdominal; com volume corrente baixo a sensibilidade cai. Fora dessas condições: elevação passiva das pernas ou minidesafio hídrico com medida direta do débito (ESICM 2025). Monitores de débito: termodiluição pelo cateter de artéria pulmonar é a referência clínica (invasiva, intermitente ou semicontínua; sugerida no choque refratário e na disfunção de VD); termodiluição transpulmonar (PiCCO) calibra o contorno de pulso e estima volumes e água pulmonar extravascular; contorno de pulso não calibrado (FloTrac, ClearSight) perde acurácia com RVS baixa e vasopressor: em cirróticos, versão antiga do FloTrac teve erro percentual de 54% vs. termodiluição, limite aceito 30% (Biancofiore, Br J Anaesth 2009); Doppler esofágico depende da posição e do ângulo da sonda e assume o diâmetro aórtico. Zona cinzenta da VPP de 9–13% (Cannesson, Anesthesiology 2011); desafio de volume corrente 6 → 8 mL/kg por 1 min quando a limitação é apenas o volume corrente baixo (Myatra, Crit Care Med 2017); elevação passiva das pernas com ↑DC ≥ 10%: sensibilidade 85%, especificidade 91% (Monnet, Intensive Care Med 2016, metanálise de 21 estudos); minidesafio de 100 mL em dois passos de 50 mL, ↑índice sistólico &gt; 6% (Biais, Anesthesiology 2017; 44 pacientes em neurocirurgia).</a:t>
+              <a:t>SE PERGUNTAREM: Eco: a ESICM 2025 sugere a ecocardiografia como imagem de primeira linha para definir o tipo de choque. VD: TAPSE abaixo de 17 mm e variação fracional de área abaixo de 35% indicam disfunção sistólica (ASE/EACVI 2015, quantificação de câmaras); ao ETE, o TAPSE sofre com o alinhamento do feixe nos cortes médio-esofágicos, por isso usa-se a variação fracional de área no corte médio-esofágico de quatro câmaras, o TAPSE por M-mode anatômico nos cortes transgástricos ou o TAPSE modificado (distância ânulo-ápice). Volume sistólico = área da via de saída do VE × VTI; débito = volume sistólico × FC; como a área é fixa no mesmo paciente, a variação do VTI acompanha a do volume sistólico, Na elevação passiva das pernas, aumento do débito de cerca de 10% prediz resposta (Monnet, Intensive Care Med 2016, metanálise de 21 estudos e 991 pacientes); nos estudos ecocardiográficos, pequenos, o limiar do VTI ficou em torno de 12%; após a prova de volume, aumento do VTI de 10 a 15% é a definição usual de respondedor. A área diastólica final do VE no corte transgástrico é índice estático de pré-carga, útil nos extremos, e não prediz isoladamente a resposta a volume. No OPTIME-CHF (Cuffe, JAMA 2002; 951 pacientes com IC descompensada sem indicação clara de inotrópico), milrinona vs. placebo por 48 h: sem benefício, com mais hipotensão sustentada e arritmia atrial. Em um ECR (Tongyoo, Ann Med 2025; 64 pacientes em choque séptico), a milrinona aumentou o débito em 6 horas em relação ao placebo, mas a mortalidade em 28 dias foi de 50% nos dois grupos. Na sepse a SvcO₂ pode estar normal ou alta apesar da hipoperfusão (defeito de extração e shunt microcirculatório); nesse caso, a diferença venoarterial de CO₂ acima de 6 mmHg sugere fluxo insuficiente para remover o CO₂ produzido (Vallée, Intensive Care Med 2008). Limites de VPP e VVS: ventilação controlada sem esforço espontâneo, volume corrente de pelo menos 8 mL/kg, ritmo regular, tórax fechado, sem disfunção de VD nem hipertensão intra-abdominal; com volume corrente baixo a sensibilidade cai. Fora dessas condições: elevação passiva das pernas ou minidesafio hídrico com medida direta do débito (ESICM 2025). Monitores de débito: termodiluição pelo cateter de artéria pulmonar é a referência clínica (invasiva, intermitente ou semicontínua; sugerida no choque refratário e na disfunção de VD); contorno de pulso não calibrado (FloTrac, ClearSight) perde acurácia com RVS baixa e vasopressor: em cirróticos, versão antiga do FloTrac teve erro percentual de 54% vs. termodiluição, limite aceito 30% (Biancofiore, Br J Anaesth 2009); Zona cinzenta da VPP de 9–13% (Cannesson, Anesthesiology 2011); desafio de volume corrente 6 → 8 mL/kg por 1 min quando a limitação é apenas o volume corrente baixo (Myatra, Crit Care Med 2017); elevação passiva das pernas com ↑DC ≥ 10%: sensibilidade 85%, especificidade 91% (Monnet, Intensive Care Med 2016, metanálise de 21 estudos); minidesafio de 100 mL, ↑índice sistólico &gt; 6% (Biais, Anesthesiology 2017).</a:t>
             </a:r>
             <a:endParaRPr lang="en-US" dirty="0"/>
           </a:p>
@@ -1745,7 +1745,7 @@
           <a:p>
             <a:r>
               <a:rPr lang="en-US" dirty="0"/>
-              <a:t>TEMPO: 50 s (2:50 → 3:40)</a:t>
+              <a:t>TEMPO: 50 s (2:45 → 3:35)</a:t>
             </a:r>
             <a:endParaRPr lang="en-US" dirty="0"/>
           </a:p>
@@ -1854,7 +1854,7 @@
           <a:p>
             <a:r>
               <a:rPr lang="en-US" dirty="0"/>
-              <a:t>TEMPO: 40 s (3:40 → 4:20)</a:t>
+              <a:t>TEMPO: 40 s (3:35 → 4:15)</a:t>
             </a:r>
             <a:endParaRPr lang="en-US" dirty="0"/>
           </a:p>
@@ -1963,7 +1963,7 @@
           <a:p>
             <a:r>
               <a:rPr lang="en-US" dirty="0"/>
-              <a:t>TEMPO: 40 s (4:20 → 5:00)</a:t>
+              <a:t>TEMPO: 40 s (4:15 → 4:55)</a:t>
             </a:r>
             <a:endParaRPr lang="en-US" dirty="0"/>
           </a:p>
@@ -2072,7 +2072,7 @@
           <a:p>
             <a:r>
               <a:rPr lang="en-US" dirty="0"/>
-              <a:t>TEMPO: 35 s (5:00 → 5:35)</a:t>
+              <a:t>TEMPO: 35 s (4:55 → 5:30)</a:t>
             </a:r>
             <a:endParaRPr lang="en-US" dirty="0"/>
           </a:p>
@@ -2174,7 +2174,7 @@
           <a:p>
             <a:r>
               <a:rPr lang="en-US" dirty="0"/>
-              <a:t>TEMPO: 55 s (5:35 → 6:30)</a:t>
+              <a:t>TEMPO: 55 s (5:30 → 6:25)</a:t>
             </a:r>
             <a:endParaRPr lang="en-US" dirty="0"/>
           </a:p>

</xml_diff>

<commit_message>
Versão 43 final: pontuação na nota do slide 4; aprovação definitiva do Codex registrada
Co-Authored-By: Claude Fable 5.1 <noreply@anthropic.com>
Claude-Session: https://claude.ai/code/session_01W6cLQUtwNHu1UUeBJH2XLT
</commit_message>
<xml_diff>
--- a/apresentacao/Aminas_Vasoativas.pptx
+++ b/apresentacao/Aminas_Vasoativas.pptx
@@ -122,24 +122,24 @@
   <p:extLst>
     <p:ext uri="{521415D9-36F7-43E2-AB2F-B90AF26B5E84}">
       <p14:sectionLst xmlns:p14="http://schemas.microsoft.com/office/powerpoint/2010/main">
-        <p14:section name="Abertura e objetivos" id="{bc7fb97f-2d7c-0c43-22a4-0ce9c48f870b}">
+        <p14:section name="Abertura e objetivos" id="{c5b9d56e-6271-03ac-0b7f-915e3acbc3c8}">
           <p14:sldIdLst>
             <p14:sldId id="256"/>
             <p14:sldId id="257"/>
           </p14:sldIdLst>
         </p14:section>
-        <p14:section name="01 · Fisiologia: pressão, débito e perfusão" id="{d636bac3-2873-415c-d765-3b40d2829437}">
+        <p14:section name="01 · Fisiologia: pressão, débito e perfusão" id="{0d211aef-7264-d7b3-dc8d-fd5a292edfbc}">
           <p14:sldIdLst>
             <p14:sldId id="258"/>
             <p14:sldId id="259"/>
           </p14:sldIdLst>
         </p14:section>
-        <p14:section name="02 · Receptores" id="{168166fb-07d0-f4e0-ca30-b88426f442b0}">
+        <p14:section name="02 · Receptores" id="{d0514519-1fa5-f6c0-895e-1601e88d968a}">
           <p14:sldIdLst>
             <p14:sldId id="260"/>
           </p14:sldIdLst>
         </p14:section>
-        <p14:section name="03 · Drogas: noradrenalina, adrenalina, dobutamina (e dopamina), milrinona (escolha), fenilefrina e efedrina" id="{bdb28524-6bf9-ceba-5bf5-6cb03a29110a}">
+        <p14:section name="03 · Drogas: noradrenalina, adrenalina, dobutamina (e dopamina), milrinona (escolha), fenilefrina e efedrina" id="{b65bb93a-8b18-966e-1ea3-78895525de0f}">
           <p14:sldIdLst>
             <p14:sldId id="261"/>
             <p14:sldId id="262"/>
@@ -149,22 +149,22 @@
             <p14:sldId id="266"/>
           </p14:sldIdLst>
         </p14:section>
-        <p14:section name="04 · Além das aminas: vasopressina, hidrocortisona e azul de metileno" id="{199cb4fd-5a47-38a0-ab84-4e4777e3a7d3}">
+        <p14:section name="04 · Além das aminas: vasopressina, hidrocortisona e azul de metileno" id="{05dc4851-93b1-6f43-397f-999571f5915a}">
           <p14:sldIdLst>
             <p14:sldId id="267"/>
           </p14:sldIdLst>
         </p14:section>
-        <p14:section name="05 · Choque séptico: a sequência da SSC 2026" id="{ccb79233-f2b8-a38f-e6ef-69cbf13732be}">
+        <p14:section name="05 · Choque séptico: a sequência da SSC 2026" id="{fb2c9d30-3bf2-6eee-5170-584680abbc21}">
           <p14:sldIdLst>
             <p14:sldId id="268"/>
           </p14:sldIdLst>
         </p14:section>
-        <p14:section name="06 · Perioperatório: escolha da droga" id="{3e7b433e-b501-04b3-9a04-6335429f680f}">
+        <p14:section name="06 · Perioperatório: escolha da droga" id="{05933bee-86e0-fa64-f9ca-b7a38bc88779}">
           <p14:sldIdLst>
             <p14:sldId id="269"/>
           </p14:sldIdLst>
         </p14:section>
-        <p14:section name="07 · Mensagens finais e encerramento" id="{5a9fad88-14b7-e0d3-ae2c-26b2b4a17c4e}">
+        <p14:section name="07 · Mensagens finais e encerramento" id="{41c37686-5580-1250-bddf-9a6068b96686}">
           <p14:sldIdLst>
             <p14:sldId id="270"/>
             <p14:sldId id="271"/>
@@ -1650,7 +1650,7 @@
           <a:p>
             <a:r>
               <a:rPr lang="en-US" dirty="0"/>
-              <a:t>SE PERGUNTAREM: Eco: a ESICM 2025 sugere a ecocardiografia como imagem de primeira linha para definir o tipo de choque. VD: TAPSE abaixo de 17 mm e variação fracional de área abaixo de 35% indicam disfunção sistólica (ASE/EACVI 2015, quantificação de câmaras); ao ETE, o TAPSE sofre com o alinhamento do feixe nos cortes médio-esofágicos, por isso usa-se a variação fracional de área no corte médio-esofágico de quatro câmaras, o TAPSE por M-mode anatômico nos cortes transgástricos ou o TAPSE modificado (distância ânulo-ápice). Volume sistólico = área da via de saída do VE × VTI; débito = volume sistólico × FC; como a área é fixa no mesmo paciente, a variação do VTI acompanha a do volume sistólico, Na elevação passiva das pernas, aumento do débito de cerca de 10% prediz resposta (Monnet, Intensive Care Med 2016, metanálise de 21 estudos e 991 pacientes); nos estudos ecocardiográficos, pequenos, o limiar do VTI ficou em torno de 12%; após a prova de volume, aumento do VTI de 10 a 15% é a definição usual de respondedor. A área diastólica final do VE no corte transgástrico é índice estático de pré-carga, útil nos extremos, e não prediz isoladamente a resposta a volume. No OPTIME-CHF (Cuffe, JAMA 2002; 951 pacientes com IC descompensada sem indicação clara de inotrópico), milrinona vs. placebo por 48 h: sem benefício, com mais hipotensão sustentada e arritmia atrial. Em um ECR (Tongyoo, Ann Med 2025; 64 pacientes em choque séptico), a milrinona aumentou o débito em 6 horas em relação ao placebo, mas a mortalidade em 28 dias foi de 50% nos dois grupos. Na sepse a SvcO₂ pode estar normal ou alta apesar da hipoperfusão (defeito de extração e shunt microcirculatório); nesse caso, a diferença venoarterial de CO₂ acima de 6 mmHg sugere fluxo insuficiente para remover o CO₂ produzido (Vallée, Intensive Care Med 2008). Limites de VPP e VVS: ventilação controlada sem esforço espontâneo, volume corrente de pelo menos 8 mL/kg, ritmo regular, tórax fechado, sem disfunção de VD nem hipertensão intra-abdominal; com volume corrente baixo a sensibilidade cai. Fora dessas condições: elevação passiva das pernas ou minidesafio hídrico com medida direta do débito (ESICM 2025). Monitores de débito: termodiluição pelo cateter de artéria pulmonar é a referência clínica (invasiva, intermitente ou semicontínua; sugerida no choque refratário e na disfunção de VD); contorno de pulso não calibrado (FloTrac, ClearSight) perde acurácia com RVS baixa e vasopressor: em cirróticos, versão antiga do FloTrac teve erro percentual de 54% vs. termodiluição, limite aceito 30% (Biancofiore, Br J Anaesth 2009); Zona cinzenta da VPP de 9–13% (Cannesson, Anesthesiology 2011); desafio de volume corrente 6 → 8 mL/kg por 1 min quando a limitação é apenas o volume corrente baixo (Myatra, Crit Care Med 2017); elevação passiva das pernas com ↑DC ≥ 10%: sensibilidade 85%, especificidade 91% (Monnet, Intensive Care Med 2016, metanálise de 21 estudos); minidesafio de 100 mL, ↑índice sistólico &gt; 6% (Biais, Anesthesiology 2017).</a:t>
+              <a:t>SE PERGUNTAREM: Eco: a ESICM 2025 sugere a ecocardiografia como imagem de primeira linha para definir o tipo de choque. VD: TAPSE abaixo de 17 mm e variação fracional de área abaixo de 35% indicam disfunção sistólica (ASE/EACVI 2015, quantificação de câmaras); ao ETE, o TAPSE sofre com o alinhamento do feixe nos cortes médio-esofágicos, por isso usa-se a variação fracional de área no corte médio-esofágico de quatro câmaras, o TAPSE por M-mode anatômico nos cortes transgástricos ou o TAPSE modificado (distância ânulo-ápice). Volume sistólico = área da via de saída do VE × VTI; débito = volume sistólico × FC; como a área é fixa no mesmo paciente, a variação do VTI acompanha a do volume sistólico. Na elevação passiva das pernas, aumento do débito de cerca de 10% prediz resposta (Monnet, Intensive Care Med 2016, metanálise de 21 estudos e 991 pacientes); nos estudos ecocardiográficos, pequenos, o limiar do VTI ficou em torno de 12%; após a prova de volume, aumento do VTI de 10 a 15% é a definição usual de respondedor. A área diastólica final do VE no corte transgástrico é índice estático de pré-carga, útil nos extremos, e não prediz isoladamente a resposta a volume. No OPTIME-CHF (Cuffe, JAMA 2002; 951 pacientes com IC descompensada sem indicação clara de inotrópico), milrinona vs. placebo por 48 h: sem benefício, com mais hipotensão sustentada e arritmia atrial. Em um ECR (Tongyoo, Ann Med 2025; 64 pacientes em choque séptico), a milrinona aumentou o débito em 6 horas em relação ao placebo, mas a mortalidade em 28 dias foi de 50% nos dois grupos. Na sepse a SvcO₂ pode estar normal ou alta apesar da hipoperfusão (defeito de extração e shunt microcirculatório); nesse caso, a diferença venoarterial de CO₂ acima de 6 mmHg sugere fluxo insuficiente para remover o CO₂ produzido (Vallée, Intensive Care Med 2008). Limites de VPP e VVS: ventilação controlada sem esforço espontâneo, volume corrente de pelo menos 8 mL/kg, ritmo regular, tórax fechado, sem disfunção de VD nem hipertensão intra-abdominal; com volume corrente baixo a sensibilidade cai. Fora dessas condições: elevação passiva das pernas ou minidesafio hídrico com medida direta do débito (ESICM 2025). Monitores de débito: termodiluição pelo cateter de artéria pulmonar é a referência clínica (invasiva, intermitente ou semicontínua; sugerida no choque refratário e na disfunção de VD); contorno de pulso não calibrado (FloTrac, ClearSight) perde acurácia com RVS baixa e vasopressor: em cirróticos, versão antiga do FloTrac teve erro percentual de 54% vs. termodiluição, limite aceito 30% (Biancofiore, Br J Anaesth 2009); Zona cinzenta da VPP de 9–13% (Cannesson, Anesthesiology 2011); desafio de volume corrente 6 → 8 mL/kg por 1 min quando a limitação é apenas o volume corrente baixo (Myatra, Crit Care Med 2017); elevação passiva das pernas com ↑DC ≥ 10%: sensibilidade 85%, especificidade 91% (Monnet, Intensive Care Med 2016, metanálise de 21 estudos); minidesafio de 100 mL, ↑índice sistólico &gt; 6% (Biais, Anesthesiology 2017).</a:t>
             </a:r>
             <a:endParaRPr lang="en-US" dirty="0"/>
           </a:p>

</xml_diff>

<commit_message>
Versão 44: sem o slide da SSC 2026; intraoperatório e mensagens finais fundidos em 'Escolha da droga: do mecanismo à conduta'; 14 slides, 11 min 30 s
Co-Authored-By: Claude Fable 5.1 <noreply@anthropic.com>
Claude-Session: https://claude.ai/code/session_01W6cLQUtwNHu1UUeBJH2XLT
</commit_message>
<xml_diff>
--- a/apresentacao/Aminas_Vasoativas.pptx
+++ b/apresentacao/Aminas_Vasoativas.pptx
@@ -19,11 +19,9 @@
     <p:sldId id="267" r:id="rId13"/>
     <p:sldId id="268" r:id="rId14"/>
     <p:sldId id="269" r:id="rId15"/>
-    <p:sldId id="270" r:id="rId16"/>
-    <p:sldId id="271" r:id="rId17"/>
   </p:sldIdLst>
   <p:notesMasterIdLst>
-    <p:notesMasterId r:id="rId18"/>
+    <p:notesMasterId r:id="rId16"/>
   </p:notesMasterIdLst>
   <p:sldSz cx="12192000" cy="6858000"/>
   <p:notesSz cx="6858000" cy="12192000"/>
@@ -122,24 +120,24 @@
   <p:extLst>
     <p:ext uri="{521415D9-36F7-43E2-AB2F-B90AF26B5E84}">
       <p14:sectionLst xmlns:p14="http://schemas.microsoft.com/office/powerpoint/2010/main">
-        <p14:section name="Abertura e objetivos" id="{c5b9d56e-6271-03ac-0b7f-915e3acbc3c8}">
+        <p14:section name="Abertura e objetivos" id="{dcbd5c91-5621-1ac0-5a8f-572a134a23f5}">
           <p14:sldIdLst>
             <p14:sldId id="256"/>
             <p14:sldId id="257"/>
           </p14:sldIdLst>
         </p14:section>
-        <p14:section name="01 · Fisiologia: pressão, débito e perfusão" id="{0d211aef-7264-d7b3-dc8d-fd5a292edfbc}">
+        <p14:section name="01 · Fisiologia: pressão, débito e perfusão" id="{d9a92372-76d3-c3df-a335-e4c893811d43}">
           <p14:sldIdLst>
             <p14:sldId id="258"/>
             <p14:sldId id="259"/>
           </p14:sldIdLst>
         </p14:section>
-        <p14:section name="02 · Receptores" id="{d0514519-1fa5-f6c0-895e-1601e88d968a}">
+        <p14:section name="02 · Receptores" id="{8e758864-2eb3-9243-0d8b-e8c0890af6a0}">
           <p14:sldIdLst>
             <p14:sldId id="260"/>
           </p14:sldIdLst>
         </p14:section>
-        <p14:section name="03 · Drogas: noradrenalina, adrenalina, dobutamina (e dopamina), milrinona (escolha), fenilefrina e efedrina" id="{b65bb93a-8b18-966e-1ea3-78895525de0f}">
+        <p14:section name="03 · Drogas: noradrenalina, adrenalina, dobutamina (e dopamina), milrinona (escolha), fenilefrina e efedrina" id="{77eb92aa-70bb-dda4-a4e9-2b5d24eeaa8b}">
           <p14:sldIdLst>
             <p14:sldId id="261"/>
             <p14:sldId id="262"/>
@@ -149,25 +147,19 @@
             <p14:sldId id="266"/>
           </p14:sldIdLst>
         </p14:section>
-        <p14:section name="04 · Além das aminas: vasopressina, hidrocortisona e azul de metileno" id="{05dc4851-93b1-6f43-397f-999571f5915a}">
+        <p14:section name="04 · Além das aminas: vasopressina, hidrocortisona e azul de metileno" id="{48770379-1c9b-d43c-5007-f4473d321528}">
           <p14:sldIdLst>
             <p14:sldId id="267"/>
           </p14:sldIdLst>
         </p14:section>
-        <p14:section name="05 · Choque séptico: a sequência da SSC 2026" id="{fb2c9d30-3bf2-6eee-5170-584680abbc21}">
+        <p14:section name="05 · Perioperatório: escolha da droga e mensagem final" id="{c81452d9-e1d0-2a8d-5bfd-e7d52c04bb7e}">
           <p14:sldIdLst>
             <p14:sldId id="268"/>
           </p14:sldIdLst>
         </p14:section>
-        <p14:section name="06 · Perioperatório: escolha da droga" id="{05933bee-86e0-fa64-f9ca-b7a38bc88779}">
+        <p14:section name="06 · Encerramento" id="{2331789f-66fb-939b-bea9-72794b6ed4f1}">
           <p14:sldIdLst>
             <p14:sldId id="269"/>
-          </p14:sldIdLst>
-        </p14:section>
-        <p14:section name="07 · Mensagens finais e encerramento" id="{41c37686-5580-1250-bddf-9a6068b96686}">
-          <p14:sldIdLst>
-            <p14:sldId id="270"/>
-            <p14:sldId id="271"/>
           </p14:sldIdLst>
         </p14:section>
       </p14:sectionLst>
@@ -581,7 +573,7 @@
           <a:p>
             <a:r>
               <a:rPr lang="en-US" dirty="0"/>
-              <a:t>TEMPO: 25 s (0:00 → 0:25). Total previsto: 12 min 15 s nos 16 slides; ensaiar mirando 12 minutos.</a:t>
+              <a:t>TEMPO: 25 s (0:00 → 0:25). Total previsto: 11 min 30 s nos 14 slides; ensaiar mirando 12 minutos.</a:t>
             </a:r>
             <a:endParaRPr lang="en-US" dirty="0"/>
           </a:p>
@@ -996,28 +988,28 @@
           <a:p>
             <a:r>
               <a:rPr lang="en-US" dirty="0"/>
-              <a:t>FALA: No choque séptico, a Surviving Sepsis Campaign, a diretriz internacional de sepse, atualizada em 2026, organiza os vasopressores em sequência: noradrenalina primeiro, cedo, mesmo por veia periférica; vasopressina quando a dose de noradrenalina sobe, sem limiar definido; adrenalina se a PAM continuar inadequada. É o mesmo raciocínio da aula: tônus com noradrenalina, outra via com vasopressina, e inotrópico reservado à disfunção cardíaca com hipoperfusão, com volume e PAM já otimizados.</a:t>
+              <a:t>FALA: No centro cirúrgico, antes da droga, afastar causas tratáveis: plano profundo, hipovolemia, compressão aortocava, pneumotórax e anafilaxia. Depois, o mecanismo: tônus baixo com frequência normal ou alta, agonista α1; bradicardia, efedrina ou, se grave, adrenalina; baixo débito com hipoperfusão, inotrópico, com noradrenalina se a PAM cair; vasoplegia persistente, a sequência da Surviving Sepsis Campaign de 2026: noradrenalina em escalada, depois vasopressina e, se a PAM seguir inadequada, adrenalina, com azul de metileno como resgate após CEC, com IECA ou BRA e na reperfusão do enxerto hepático; pré-carga baixa, volume; anafilaxia, adrenalina. Um dado do nosso serviço ajuda nessa decisão: Gouvêa, Diaz e colaboradores acompanharam por ecocardiografia transesofágica o VD de 19 pacientes selecionados em cinco fases do transplante hepático, e a função sistólica se manteve preservada nos momentos avaliados, inclusive trinta minutos após a reperfusão. Como não mediu os primeiros minutos da reperfusão, o estudo não diz se a instabilidade aguda é vasoplegia ou disfunção transitória do VD; o que fica para a prática é o método: usar o eco para separar disfunção de VD de vasoplegia antes de escolher entre inotrópico e vasopressor. Voltando à pergunta do início: a droga certa corrige o componente da PAM que falha, na menor dose eficaz e pelo menor tempo.</a:t>
             </a:r>
             <a:endParaRPr lang="en-US" dirty="0"/>
           </a:p>
           <a:p>
             <a:r>
               <a:rPr lang="en-US" dirty="0"/>
-              <a:t>TEMPO: 35 s (9:45 → 10:20)</a:t>
+              <a:t>TEMPO: 1 min 35 s (9:45 → 11:20)</a:t>
             </a:r>
             <a:endParaRPr lang="en-US" dirty="0"/>
           </a:p>
           <a:p>
             <a:r>
               <a:rPr lang="en-US" dirty="0"/>
-              <a:t>PONTO-CHAVE: Noradrenalina, depois vasopressina, depois adrenalina; inotrópico reservado à disfunção cardíaca com hipoperfusão.</a:t>
+              <a:t>PONTO-CHAVE: Afastar causas, identificar o mecanismo, escolher a droga; o eco separa vasoplegia de falência de VD; a droga certa corrige o componente que falha.</a:t>
             </a:r>
             <a:endParaRPr lang="en-US" dirty="0"/>
           </a:p>
           <a:p>
             <a:r>
               <a:rPr lang="en-US" dirty="0"/>
-              <a:t>SE PERGUNTAREM: o VASSPR (JAMA 2026, n = 3.959; 13 hospitais, desenho cluster-crossover com ordem sorteada) comparou políticas hospitalares de iniciar a vasopressina com 0,1 vs. 0,4 mcg/kg/min de noradrenalina-equivalente; a vasopressina foi usada em 52,4% vs. 32,9%, e a mortalidade foi 31,8% vs. 33,0%. A antecipação sistemática não trouxe benefício, o que não exclui ganho em pacientes selecionados. No OPTPRESS, alvo de PAM de 80–85 mmHg em idosos aumentou a mortalidade.</a:t>
+              <a:t>SE PERGUNTAREM: Gouvêa G, Feiner J, Joshi S, Diaz R, et al., PLoS One 2022;17(10):e0275301: estudo observacional, 19 adultos de 18 a 65 anos, TAPSE e variação fracional de área do VD em cinco fases (basal, fase de hepatectomia, fase anepática, 30 min após a reperfusão e fechamento); função sistólica do VD preservada nos cinco momentos; excluídos hipertensão portopulmonar, síndrome hepatopulmonar, doença cardiopulmonar e insuficiência hepática fulminante. População selecionada e medida feita 30 min depois da reperfusão: o estudo não mediu os primeiros minutos, quando ocorre a síndrome pós-reperfusão, não exclui disfunção transitória do VD nesse período e não permite atribuir a instabilidade aguda a vasoplegia. TAPSE e variação fracional de área dependem da carga, e o TAPSE mede apenas a excursão longitudinal do anel lateral; normais sob anestesia, com pós-carga baixa, afastam disfunção sistólica evidente nos momentos avaliados, não medem reserva contrátil. O estudo mediu a função do VD; não testou a capacidade do eco de diferenciar vasoplegia de disfunção ventricular na hipotensão aguda: essa é a aplicação clínica proposta na aula, não um resultado do estudo. Choque séptico (SSC 2026): noradrenalina em primeira linha, iniciada cedo, mesmo em veia periférica; vasopressina quando a dose de noradrenalina sobe, sem limiar definido; adrenalina se a PAM continuar inadequada; inotrópico reservado à disfunção cardíaca com hipoperfusão. VASSPR (JAMA 2026, n = 3.959; cluster-crossover em 13 hospitais): iniciar vasopressina com 0,1 vs. 0,4 mcg/kg/min de noradrenalina-equivalente não mudou a mortalidade (31,8% vs. 33,0%). OPTPRESS: alvo de PAM de 80–85 mmHg em idosos aumentou a mortalidade.</a:t>
             </a:r>
             <a:endParaRPr lang="en-US" dirty="0"/>
           </a:p>
@@ -1105,28 +1097,21 @@
           <a:p>
             <a:r>
               <a:rPr lang="en-US" dirty="0"/>
-              <a:t>FALA: No centro cirúrgico, antes da droga, afastar causas tratáveis: plano profundo, hipovolemia, compressão aortocava, pneumotórax e anafilaxia. Depois, o mecanismo: tônus baixo com frequência normal ou alta, agonista α1; bradicardia, efedrina ou, se grave, adrenalina; baixo débito, inotrópico; vasoplegia refratária às catecolaminas, do pós-CEC, do uso de IECA ou BRA e da reperfusão do enxerto hepático: vasopressina, com azul de metileno como resgate; pré-carga baixa, volume. Um dado do nosso serviço ajuda nessa decisão: Gouvêa, Diaz e colaboradores acompanharam por ecocardiografia transesofágica o VD de 19 pacientes selecionados em cinco fases do transplante hepático, e a função sistólica se manteve preservada nos momentos avaliados, inclusive trinta minutos após a reperfusão. Como não mediu os primeiros minutos da reperfusão, o estudo não diz se a instabilidade aguda é vasoplegia ou disfunção transitória do VD; o que fica para a prática é o método: usar o eco para separar disfunção de VD de vasoplegia antes de escolher entre inotrópico e vasopressor.</a:t>
+              <a:t>FALA: Obrigado pela atenção. As referências completas da aula estão no QR code. Fico à disposição para perguntas.</a:t>
             </a:r>
             <a:endParaRPr lang="en-US" dirty="0"/>
           </a:p>
           <a:p>
             <a:r>
               <a:rPr lang="en-US" dirty="0"/>
-              <a:t>TEMPO: 1 min 15 s (10:20 → 11:35)</a:t>
+              <a:t>TEMPO: 10 s (11:20 → 11:30)</a:t>
             </a:r>
             <a:endParaRPr lang="en-US" dirty="0"/>
           </a:p>
           <a:p>
             <a:r>
               <a:rPr lang="en-US" dirty="0"/>
-              <a:t>PONTO-CHAVE: Afastar causas, identificar o mecanismo, escolher a droga; o eco separa vasoplegia de falência de VD.</a:t>
-            </a:r>
-            <a:endParaRPr lang="en-US" dirty="0"/>
-          </a:p>
-          <a:p>
-            <a:r>
-              <a:rPr lang="en-US" dirty="0"/>
-              <a:t>SE PERGUNTAREM: Gouvêa G, Feiner J, Joshi S, Diaz R, et al., PLoS One 2022;17(10):e0275301: estudo observacional, 19 adultos de 18 a 65 anos, TAPSE e variação fracional de área do VD em cinco fases (basal, fase de hepatectomia, fase anepática, 30 min após a reperfusão e fechamento); função sistólica do VD preservada nos cinco momentos; excluídos hipertensão portopulmonar, síndrome hepatopulmonar, doença cardiopulmonar e insuficiência hepática fulminante. População selecionada e medida feita 30 min depois da reperfusão: o estudo não mediu os primeiros minutos, quando ocorre a síndrome pós-reperfusão, não exclui disfunção transitória do VD nesse período e não permite atribuir a instabilidade aguda a vasoplegia. TAPSE e variação fracional de área dependem da carga, e o TAPSE mede apenas a excursão longitudinal do anel lateral; normais sob anestesia, com pós-carga baixa, afastam disfunção sistólica evidente nos momentos avaliados, não medem reserva contrátil. O estudo mediu a função do VD; não testou a capacidade do eco de diferenciar vasoplegia de disfunção ventricular na hipotensão aguda: essa é a aplicação clínica proposta na aula, não um resultado do estudo.</a:t>
+              <a:t>PONTO-CHAVE: Referências completas no QR code; abrir para perguntas.</a:t>
             </a:r>
             <a:endParaRPr lang="en-US" dirty="0"/>
           </a:p>
@@ -1150,210 +1135,6 @@
             <a:fld id="{F7021451-1387-4CA6-816F-3879F97B5CBC}" type="slidenum">
               <a:rPr lang="en-US"/>
               <a:t>14</a:t>
-            </a:fld>
-            <a:endParaRPr lang="en-US"/>
-          </a:p>
-        </p:txBody>
-      </p:sp>
-    </p:spTree>
-    <p:extLst>
-      <p:ext uri="{BB962C8B-B14F-4D97-AF65-F5344CB8AC3E}">
-        <p14:creationId xmlns:p14="http://schemas.microsoft.com/office/powerpoint/2010/main" val="1024086991"/>
-      </p:ext>
-    </p:extLst>
-  </p:cSld>
-  <p:clrMapOvr>
-    <a:masterClrMapping/>
-  </p:clrMapOvr>
-</p:notes>
-</file>
-
-<file path=ppt/notesSlides/notesSlide15.xml><?xml version="1.0" encoding="utf-8"?>
-<p:notes xmlns:a="http://schemas.openxmlformats.org/drawingml/2006/main" xmlns:r="http://schemas.openxmlformats.org/officeDocument/2006/relationships" xmlns:p="http://schemas.openxmlformats.org/presentationml/2006/main">
-  <p:cSld>
-    <p:spTree>
-      <p:nvGrpSpPr>
-        <p:cNvPr id="1" name=""/>
-        <p:cNvGrpSpPr/>
-        <p:nvPr/>
-      </p:nvGrpSpPr>
-      <p:grpSpPr>
-        <a:xfrm>
-          <a:off x="0" y="0"/>
-          <a:ext cx="0" cy="0"/>
-          <a:chOff x="0" y="0"/>
-          <a:chExt cx="0" cy="0"/>
-        </a:xfrm>
-      </p:grpSpPr>
-      <p:sp>
-        <p:nvSpPr>
-          <p:cNvPr id="2" name="Slide Image Placeholder 1"/>
-          <p:cNvSpPr>
-            <a:spLocks noGrp="1" noRot="1" noChangeAspect="1"/>
-          </p:cNvSpPr>
-          <p:nvPr>
-            <p:ph type="sldImg"/>
-          </p:nvPr>
-        </p:nvSpPr>
-        <p:spPr/>
-      </p:sp>
-      <p:sp>
-        <p:nvSpPr>
-          <p:cNvPr id="3" name="Notes Placeholder 2"/>
-          <p:cNvSpPr>
-            <a:spLocks noGrp="1"/>
-          </p:cNvSpPr>
-          <p:nvPr>
-            <p:ph type="body" idx="1"/>
-          </p:nvPr>
-        </p:nvSpPr>
-        <p:spPr/>
-        <p:txBody>
-          <a:bodyPr/>
-          <a:lstStyle/>
-          <a:p>
-            <a:r>
-              <a:rPr lang="en-US" dirty="0"/>
-              <a:t>FALA: Voltando à pergunta do início: qual componente da PAM está falhando? Vasoplegia: noradrenalina e, quando a dose sobe, vasopressina. Baixo débito com hipoperfusão: inotrópico, com a milrinona sobretudo no VD com hipertensão pulmonar. Hipotensão vasodilatadora da anestesia com bradicardia: efedrina; com frequência normal ou alta: fenilefrina. Anafilaxia: adrenalina. A droga certa corrige o componente que falha, na menor dose eficaz e pelo menor tempo.</a:t>
-            </a:r>
-            <a:endParaRPr lang="en-US" dirty="0"/>
-          </a:p>
-          <a:p>
-            <a:r>
-              <a:rPr lang="en-US" dirty="0"/>
-              <a:t>TEMPO: 30 s (11:35 → 12:05)</a:t>
-            </a:r>
-            <a:endParaRPr lang="en-US" dirty="0"/>
-          </a:p>
-          <a:p>
-            <a:r>
-              <a:rPr lang="en-US" dirty="0"/>
-              <a:t>PONTO-CHAVE: A droga certa corrige o componente que falha, na menor dose e pelo menor tempo.</a:t>
-            </a:r>
-            <a:endParaRPr lang="en-US" dirty="0"/>
-          </a:p>
-        </p:txBody>
-      </p:sp>
-      <p:sp>
-        <p:nvSpPr>
-          <p:cNvPr id="4" name="Slide Number Placeholder 3"/>
-          <p:cNvSpPr>
-            <a:spLocks noGrp="1"/>
-          </p:cNvSpPr>
-          <p:nvPr>
-            <p:ph type="sldNum" sz="quarter" idx="10"/>
-          </p:nvPr>
-        </p:nvSpPr>
-        <p:spPr/>
-        <p:txBody>
-          <a:bodyPr/>
-          <a:lstStyle/>
-          <a:p>
-            <a:fld id="{F7021451-1387-4CA6-816F-3879F97B5CBC}" type="slidenum">
-              <a:rPr lang="en-US"/>
-              <a:t>15</a:t>
-            </a:fld>
-            <a:endParaRPr lang="en-US"/>
-          </a:p>
-        </p:txBody>
-      </p:sp>
-    </p:spTree>
-    <p:extLst>
-      <p:ext uri="{BB962C8B-B14F-4D97-AF65-F5344CB8AC3E}">
-        <p14:creationId xmlns:p14="http://schemas.microsoft.com/office/powerpoint/2010/main" val="1024086991"/>
-      </p:ext>
-    </p:extLst>
-  </p:cSld>
-  <p:clrMapOvr>
-    <a:masterClrMapping/>
-  </p:clrMapOvr>
-</p:notes>
-</file>
-
-<file path=ppt/notesSlides/notesSlide16.xml><?xml version="1.0" encoding="utf-8"?>
-<p:notes xmlns:a="http://schemas.openxmlformats.org/drawingml/2006/main" xmlns:r="http://schemas.openxmlformats.org/officeDocument/2006/relationships" xmlns:p="http://schemas.openxmlformats.org/presentationml/2006/main">
-  <p:cSld>
-    <p:spTree>
-      <p:nvGrpSpPr>
-        <p:cNvPr id="1" name=""/>
-        <p:cNvGrpSpPr/>
-        <p:nvPr/>
-      </p:nvGrpSpPr>
-      <p:grpSpPr>
-        <a:xfrm>
-          <a:off x="0" y="0"/>
-          <a:ext cx="0" cy="0"/>
-          <a:chOff x="0" y="0"/>
-          <a:chExt cx="0" cy="0"/>
-        </a:xfrm>
-      </p:grpSpPr>
-      <p:sp>
-        <p:nvSpPr>
-          <p:cNvPr id="2" name="Slide Image Placeholder 1"/>
-          <p:cNvSpPr>
-            <a:spLocks noGrp="1" noRot="1" noChangeAspect="1"/>
-          </p:cNvSpPr>
-          <p:nvPr>
-            <p:ph type="sldImg"/>
-          </p:nvPr>
-        </p:nvSpPr>
-        <p:spPr/>
-      </p:sp>
-      <p:sp>
-        <p:nvSpPr>
-          <p:cNvPr id="3" name="Notes Placeholder 2"/>
-          <p:cNvSpPr>
-            <a:spLocks noGrp="1"/>
-          </p:cNvSpPr>
-          <p:nvPr>
-            <p:ph type="body" idx="1"/>
-          </p:nvPr>
-        </p:nvSpPr>
-        <p:spPr/>
-        <p:txBody>
-          <a:bodyPr/>
-          <a:lstStyle/>
-          <a:p>
-            <a:r>
-              <a:rPr lang="en-US" dirty="0"/>
-              <a:t>FALA: Obrigado pela atenção. As referências completas da aula estão no QR code. Fico à disposição para perguntas.</a:t>
-            </a:r>
-            <a:endParaRPr lang="en-US" dirty="0"/>
-          </a:p>
-          <a:p>
-            <a:r>
-              <a:rPr lang="en-US" dirty="0"/>
-              <a:t>TEMPO: 10 s (12:05 → 12:15)</a:t>
-            </a:r>
-            <a:endParaRPr lang="en-US" dirty="0"/>
-          </a:p>
-          <a:p>
-            <a:r>
-              <a:rPr lang="en-US" dirty="0"/>
-              <a:t>PONTO-CHAVE: Referências completas no QR code; abrir para perguntas.</a:t>
-            </a:r>
-            <a:endParaRPr lang="en-US" dirty="0"/>
-          </a:p>
-        </p:txBody>
-      </p:sp>
-      <p:sp>
-        <p:nvSpPr>
-          <p:cNvPr id="4" name="Slide Number Placeholder 3"/>
-          <p:cNvSpPr>
-            <a:spLocks noGrp="1"/>
-          </p:cNvSpPr>
-          <p:nvPr>
-            <p:ph type="sldNum" sz="quarter" idx="10"/>
-          </p:nvPr>
-        </p:nvSpPr>
-        <p:spPr/>
-        <p:txBody>
-          <a:bodyPr/>
-          <a:lstStyle/>
-          <a:p>
-            <a:fld id="{F7021451-1387-4CA6-816F-3879F97B5CBC}" type="slidenum">
-              <a:rPr lang="en-US"/>
-              <a:t>16</a:t>
             </a:fld>
             <a:endParaRPr lang="en-US"/>
           </a:p>
@@ -2410,6 +2191,80 @@
 
 <file path=ppt/slideLayouts/slideLayout4.xml><?xml version="1.0" encoding="utf-8"?>
 <p:sldLayout xmlns:a="http://schemas.openxmlformats.org/drawingml/2006/main" xmlns:r="http://schemas.openxmlformats.org/officeDocument/2006/relationships" xmlns:p="http://schemas.openxmlformats.org/presentationml/2006/main" preserve="1">
+  <p:cSld name="Conteúdo 2">
+    <p:bg>
+      <p:bgPr>
+        <a:solidFill>
+          <a:srgbClr val="F5F3EE"/>
+        </a:solidFill>
+      </p:bgPr>
+    </p:bg>
+    <p:spTree>
+      <p:nvGrpSpPr>
+        <p:cNvPr id="1" name=""/>
+        <p:cNvGrpSpPr/>
+        <p:nvPr/>
+      </p:nvGrpSpPr>
+      <p:grpSpPr>
+        <a:xfrm>
+          <a:off x="0" y="0"/>
+          <a:ext cx="0" cy="0"/>
+          <a:chOff x="0" y="0"/>
+          <a:chExt cx="0" cy="0"/>
+        </a:xfrm>
+      </p:grpSpPr>
+      <p:sp>
+        <p:nvSpPr>
+          <p:cNvPr id="2" name="Text 0"/>
+          <p:cNvSpPr/>
+          <p:nvPr>
+            <p:ph type="title"/>
+          </p:nvPr>
+        </p:nvSpPr>
+        <p:spPr>
+          <a:xfrm>
+            <a:off x="812800" y="1007959"/>
+            <a:ext cx="10718800" cy="838200"/>
+          </a:xfrm>
+          <a:prstGeom prst="rect">
+            <a:avLst/>
+          </a:prstGeom>
+          <a:noFill/>
+          <a:ln/>
+        </p:spPr>
+        <p:txBody>
+          <a:bodyPr wrap="square" rtlCol="0"/>
+          <a:lstStyle>
+            <a:lvl1pPr algn="l" indent="0" marL="0">
+              <a:buNone/>
+              <a:defRPr lang="en-US" sz="3000" dirty="0">
+                <a:solidFill>
+                  <a:srgbClr val="1B2A3A"/>
+                </a:solidFill>
+                <a:latin typeface="Georgia" pitchFamily="34" charset="0"/>
+                <a:ea typeface="Georgia" pitchFamily="34" charset="-122"/>
+                <a:cs typeface="Georgia" pitchFamily="34" charset="-120"/>
+              </a:defRPr>
+            </a:lvl1pPr>
+          </a:lstStyle>
+          <a:p>
+            <a:pPr algn="l" indent="0" marL="0">
+              <a:buNone/>
+            </a:pPr>
+            <a:endParaRPr lang="en-US" sz="3000" dirty="0"/>
+          </a:p>
+        </p:txBody>
+      </p:sp>
+    </p:spTree>
+  </p:cSld>
+  <p:clrMapOvr>
+    <a:masterClrMapping/>
+  </p:clrMapOvr>
+</p:sldLayout>
+</file>
+
+<file path=ppt/slideLayouts/slideLayout5.xml><?xml version="1.0" encoding="utf-8"?>
+<p:sldLayout xmlns:a="http://schemas.openxmlformats.org/drawingml/2006/main" xmlns:r="http://schemas.openxmlformats.org/officeDocument/2006/relationships" xmlns:p="http://schemas.openxmlformats.org/presentationml/2006/main" preserve="1">
   <p:cSld name="Encerramento">
     <p:bg>
       <p:bgPr>
@@ -2507,6 +2362,7 @@
     <p:sldLayoutId id="2147483650" r:id="rId2"/>
     <p:sldLayoutId id="2147483651" r:id="rId3"/>
     <p:sldLayoutId id="2147483652" r:id="rId4"/>
+    <p:sldLayoutId id="2147483653" r:id="rId5"/>
   </p:sldLayoutIdLst>
   <p:hf sldNum="0" hdr="0" ftr="0" dt="0"/>
   <p:txStyles>
@@ -5937,13 +5793,13 @@
       </p:grpSpPr>
       <p:sp>
         <p:nvSpPr>
-          <p:cNvPr id="2" name="05 · CHOQUE SÉPTICO"/>
-          <p:cNvSpPr txBox="1"/>
-          <p:nvPr/>
-        </p:nvSpPr>
-        <p:spPr>
-          <a:xfrm>
-            <a:off x="812800" y="800837"/>
+          <p:cNvPr id="2" name="05 · PERIOPERATÓRIO · SÍNTESE"/>
+          <p:cNvSpPr txBox="1"/>
+          <p:nvPr/>
+        </p:nvSpPr>
+        <p:spPr>
+          <a:xfrm>
+            <a:off x="812800" y="699237"/>
             <a:ext cx="10585450" cy="213320"/>
           </a:xfrm>
           <a:prstGeom prst="rect">
@@ -5971,7 +5827,7 @@
                 <a:ea typeface="Calibri" pitchFamily="34" charset="-122"/>
                 <a:cs typeface="Calibri" pitchFamily="34" charset="-120"/>
               </a:rPr>
-              <a:t>05 · CHOQUE SÉPTICO</a:t>
+              <a:t>05 · PERIOPERATÓRIO · SÍNTESE</a:t>
             </a:r>
             <a:endParaRPr lang="en-US" sz="1200" dirty="0"/>
           </a:p>
@@ -5987,8 +5843,8 @@
         </p:nvSpPr>
         <p:spPr>
           <a:xfrm>
-            <a:off x="812800" y="1135442"/>
-            <a:ext cx="10718800" cy="894080"/>
+            <a:off x="812800" y="1007959"/>
+            <a:ext cx="10718800" cy="838200"/>
           </a:xfrm>
           <a:prstGeom prst="rect">
             <a:avLst/>
@@ -6002,12 +5858,12 @@
           <a:p>
             <a:pPr algn="l" indent="0" marL="0">
               <a:lnSpc>
-                <a:spcPts val="3520"/>
-              </a:lnSpc>
-              <a:buNone/>
-            </a:pPr>
-            <a:r>
-              <a:rPr lang="pt-BR" altLang="en-US" sz="3200" dirty="0">
+                <a:spcPts val="3300"/>
+              </a:lnSpc>
+              <a:buNone/>
+            </a:pPr>
+            <a:r>
+              <a:rPr lang="pt-BR" altLang="en-US" sz="3000" dirty="0">
                 <a:solidFill>
                   <a:srgbClr val="1B2A3A"/>
                 </a:solidFill>
@@ -6015,26 +5871,26 @@
                 <a:ea typeface="Georgia" pitchFamily="34" charset="-122"/>
                 <a:cs typeface="Georgia" pitchFamily="34" charset="-120"/>
               </a:rPr>
-              <a:t>Choque séptico: a sequência da SSC 2026</a:t>
-            </a:r>
-            <a:endParaRPr lang="en-US" sz="3200" dirty="0"/>
-          </a:p>
-        </p:txBody>
-      </p:sp>
-      <p:sp>
-        <p:nvSpPr>
-          <p:cNvPr id="4" name="Cartão"/>
+              <a:t>Escolha da droga: do mecanismo à conduta</a:t>
+            </a:r>
+            <a:endParaRPr lang="en-US" sz="3000" dirty="0"/>
+          </a:p>
+        </p:txBody>
+      </p:sp>
+      <p:sp>
+        <p:nvSpPr>
+          <p:cNvPr id="4" name="Hipotensão"/>
           <p:cNvSpPr/>
           <p:nvPr/>
         </p:nvSpPr>
         <p:spPr>
           <a:xfrm>
-            <a:off x="812800" y="1879501"/>
-            <a:ext cx="3138190" cy="1457722"/>
+            <a:off x="812800" y="1574701"/>
+            <a:ext cx="920055" cy="322560"/>
           </a:xfrm>
           <a:prstGeom prst="roundRect">
             <a:avLst>
-              <a:gd name="adj" fmla="val 5227"/>
+              <a:gd name="adj" fmla="val 23624"/>
             </a:avLst>
           </a:prstGeom>
           <a:solidFill>
@@ -6042,17 +5898,41 @@
           </a:solidFill>
           <a:ln/>
         </p:spPr>
-      </p:sp>
-      <p:sp>
-        <p:nvSpPr>
-          <p:cNvPr id="5" name="PASSO 1"/>
-          <p:cNvSpPr txBox="1"/>
-          <p:nvPr/>
-        </p:nvSpPr>
-        <p:spPr>
-          <a:xfrm>
-            <a:off x="1016000" y="2070737"/>
-            <a:ext cx="2750840" cy="213320"/>
+        <p:txBody>
+          <a:bodyPr wrap="none" lIns="127000" tIns="63500" rIns="127000" bIns="63500" rtlCol="0" anchor="ctr"/>
+          <a:lstStyle/>
+          <a:p>
+            <a:pPr algn="ctr" indent="0" marL="0">
+              <a:lnSpc>
+                <a:spcPts val="1540"/>
+              </a:lnSpc>
+              <a:buNone/>
+            </a:pPr>
+            <a:r>
+              <a:rPr lang="pt-BR" altLang="en-US" sz="1100" b="1" dirty="0">
+                <a:solidFill>
+                  <a:srgbClr val="F5F3EE"/>
+                </a:solidFill>
+                <a:latin typeface="Calibri" pitchFamily="34" charset="0"/>
+                <a:ea typeface="Calibri" pitchFamily="34" charset="-122"/>
+                <a:cs typeface="Calibri" pitchFamily="34" charset="-120"/>
+              </a:rPr>
+              <a:t>Hipotensão</a:t>
+            </a:r>
+            <a:endParaRPr lang="en-US" sz="1100" dirty="0"/>
+          </a:p>
+        </p:txBody>
+      </p:sp>
+      <p:sp>
+        <p:nvSpPr>
+          <p:cNvPr id="5" name="→"/>
+          <p:cNvSpPr txBox="1"/>
+          <p:nvPr/>
+        </p:nvSpPr>
+        <p:spPr>
+          <a:xfrm>
+            <a:off x="1834455" y="1631217"/>
+            <a:ext cx="226020" cy="228600"/>
           </a:xfrm>
           <a:prstGeom prst="rect">
             <a:avLst/>
@@ -6066,62 +5946,20 @@
           <a:p>
             <a:pPr algn="l" indent="0" marL="0">
               <a:lnSpc>
-                <a:spcPts val="1680"/>
-              </a:lnSpc>
-              <a:buNone/>
-            </a:pPr>
-            <a:r>
-              <a:rPr lang="pt-BR" altLang="en-US" sz="1200" b="1" spc="100" kern="0" dirty="0">
-                <a:solidFill>
-                  <a:srgbClr val="E49A5C"/>
-                </a:solidFill>
-                <a:latin typeface="Calibri" pitchFamily="34" charset="0"/>
-                <a:ea typeface="Calibri" pitchFamily="34" charset="-122"/>
-                <a:cs typeface="Calibri" pitchFamily="34" charset="-120"/>
-              </a:rPr>
-              <a:t>PASSO 1</a:t>
-            </a:r>
-            <a:endParaRPr lang="en-US" sz="1200" dirty="0"/>
-          </a:p>
-        </p:txBody>
-      </p:sp>
-      <p:sp>
-        <p:nvSpPr>
-          <p:cNvPr id="6" name="Noradrenalina"/>
-          <p:cNvSpPr txBox="1"/>
-          <p:nvPr/>
-        </p:nvSpPr>
-        <p:spPr>
-          <a:xfrm>
-            <a:off x="1016000" y="2342592"/>
-            <a:ext cx="2750840" cy="274241"/>
-          </a:xfrm>
-          <a:prstGeom prst="rect">
-            <a:avLst/>
-          </a:prstGeom>
-          <a:noFill/>
-          <a:ln/>
-        </p:spPr>
-        <p:txBody>
-          <a:bodyPr wrap="none" lIns="0" tIns="0" rIns="0" bIns="0" rtlCol="0" anchor="t"/>
-          <a:lstStyle/>
-          <a:p>
-            <a:pPr algn="l" indent="0" marL="0">
-              <a:lnSpc>
-                <a:spcPts val="2160"/>
+                <a:spcPts val="1800"/>
               </a:lnSpc>
               <a:buNone/>
             </a:pPr>
             <a:r>
               <a:rPr lang="pt-BR" altLang="en-US" sz="1800" b="1" dirty="0">
                 <a:solidFill>
-                  <a:srgbClr val="F5F3EE"/>
-                </a:solidFill>
-                <a:latin typeface="Calibri" pitchFamily="34" charset="0"/>
-                <a:ea typeface="Calibri" pitchFamily="34" charset="-122"/>
-                <a:cs typeface="Calibri" pitchFamily="34" charset="-120"/>
-              </a:rPr>
-              <a:t>Noradrenalina</a:t>
+                  <a:srgbClr val="B9581A"/>
+                </a:solidFill>
+                <a:latin typeface="Calibri" pitchFamily="34" charset="0"/>
+                <a:ea typeface="Calibri" pitchFamily="34" charset="-122"/>
+                <a:cs typeface="Calibri" pitchFamily="34" charset="-120"/>
+              </a:rPr>
+              <a:t>→</a:t>
             </a:r>
             <a:endParaRPr lang="en-US" sz="1800" dirty="0"/>
           </a:p>
@@ -6129,102 +5967,110 @@
       </p:sp>
       <p:sp>
         <p:nvSpPr>
-          <p:cNvPr id="7" name="1ª linha, iniciada cedo, mesmo em veia p"/>
-          <p:cNvSpPr txBox="1"/>
-          <p:nvPr/>
-        </p:nvSpPr>
-        <p:spPr>
-          <a:xfrm>
-            <a:off x="1016000" y="2658901"/>
-            <a:ext cx="2750840" cy="462161"/>
-          </a:xfrm>
-          <a:prstGeom prst="rect">
-            <a:avLst/>
-          </a:prstGeom>
-          <a:noFill/>
-          <a:ln/>
-        </p:spPr>
-        <p:txBody>
-          <a:bodyPr wrap="square" lIns="0" tIns="0" rIns="0" bIns="0" rtlCol="0" anchor="t"/>
-          <a:lstStyle/>
-          <a:p>
-            <a:pPr algn="l" indent="0" marL="0">
-              <a:lnSpc>
-                <a:spcPts val="1820"/>
-              </a:lnSpc>
-              <a:buNone/>
-            </a:pPr>
-            <a:r>
-              <a:rPr lang="pt-BR" altLang="en-US" sz="1300" dirty="0">
-                <a:solidFill>
-                  <a:srgbClr val="C9CFD6"/>
-                </a:solidFill>
-                <a:latin typeface="Calibri" pitchFamily="34" charset="0"/>
-                <a:ea typeface="Calibri" pitchFamily="34" charset="-122"/>
-                <a:cs typeface="Calibri" pitchFamily="34" charset="-120"/>
-              </a:rPr>
-              <a:t>1ª linha, iniciada cedo, mesmo em veia periférica.</a:t>
-            </a:r>
-            <a:endParaRPr lang="en-US" sz="1300" dirty="0"/>
-          </a:p>
-        </p:txBody>
-      </p:sp>
-      <p:sp>
-        <p:nvSpPr>
-          <p:cNvPr id="8" name="→"/>
-          <p:cNvSpPr txBox="1"/>
-          <p:nvPr/>
-        </p:nvSpPr>
-        <p:spPr>
-          <a:xfrm>
-            <a:off x="4077990" y="2445319"/>
-            <a:ext cx="341015" cy="355600"/>
-          </a:xfrm>
-          <a:prstGeom prst="rect">
-            <a:avLst/>
-          </a:prstGeom>
-          <a:noFill/>
-          <a:ln/>
-        </p:spPr>
-        <p:txBody>
-          <a:bodyPr wrap="none" lIns="0" tIns="0" rIns="0" bIns="0" rtlCol="0" anchor="t"/>
-          <a:lstStyle/>
-          <a:p>
-            <a:pPr algn="l" indent="0" marL="0">
-              <a:lnSpc>
-                <a:spcPts val="2800"/>
-              </a:lnSpc>
-              <a:buNone/>
-            </a:pPr>
-            <a:r>
-              <a:rPr lang="pt-BR" altLang="en-US" sz="2800" b="1" dirty="0">
-                <a:solidFill>
-                  <a:srgbClr val="B9581A"/>
-                </a:solidFill>
-                <a:latin typeface="Calibri" pitchFamily="34" charset="0"/>
-                <a:ea typeface="Calibri" pitchFamily="34" charset="-122"/>
-                <a:cs typeface="Calibri" pitchFamily="34" charset="-120"/>
-              </a:rPr>
-              <a:t>→</a:t>
-            </a:r>
-            <a:endParaRPr lang="en-US" sz="2800" dirty="0"/>
-          </a:p>
-        </p:txBody>
-      </p:sp>
-      <p:sp>
-        <p:nvSpPr>
-          <p:cNvPr id="9" name="Cartão"/>
+          <p:cNvPr id="6" name="Afastar plano profundo, hipovolemia, com"/>
           <p:cNvSpPr/>
           <p:nvPr/>
         </p:nvSpPr>
         <p:spPr>
           <a:xfrm>
-            <a:off x="4526955" y="1879501"/>
-            <a:ext cx="3138190" cy="1457722"/>
+            <a:off x="2143026" y="1559520"/>
+            <a:ext cx="5803999" cy="353020"/>
           </a:xfrm>
           <a:prstGeom prst="roundRect">
             <a:avLst>
-              <a:gd name="adj" fmla="val 5227"/>
+              <a:gd name="adj" fmla="val 21585"/>
+            </a:avLst>
+          </a:prstGeom>
+          <a:solidFill>
+            <a:srgbClr val="FFFDF8"/>
+          </a:solidFill>
+          <a:ln w="6350">
+            <a:solidFill>
+              <a:srgbClr val="E2DDD2"/>
+            </a:solidFill>
+          </a:ln>
+        </p:spPr>
+        <p:txBody>
+          <a:bodyPr wrap="none" lIns="133350" tIns="69850" rIns="133350" bIns="69850" rtlCol="0" anchor="ctr"/>
+          <a:lstStyle/>
+          <a:p>
+            <a:pPr algn="ctr" indent="0" marL="0">
+              <a:lnSpc>
+                <a:spcPts val="1680"/>
+              </a:lnSpc>
+              <a:buNone/>
+            </a:pPr>
+            <a:r>
+              <a:rPr lang="pt-BR" altLang="en-US" sz="1200" b="1" dirty="0">
+                <a:solidFill>
+                  <a:srgbClr val="1B2A3A"/>
+                </a:solidFill>
+                <a:latin typeface="Calibri" pitchFamily="34" charset="0"/>
+                <a:ea typeface="Calibri" pitchFamily="34" charset="-122"/>
+                <a:cs typeface="Calibri" pitchFamily="34" charset="-120"/>
+              </a:rPr>
+              <a:t>Afastar plano profundo, hipovolemia, compressão aortocava, pneumotórax e anafilaxia</a:t>
+            </a:r>
+            <a:endParaRPr lang="en-US" sz="1200" dirty="0"/>
+          </a:p>
+        </p:txBody>
+      </p:sp>
+      <p:sp>
+        <p:nvSpPr>
+          <p:cNvPr id="7" name="→"/>
+          <p:cNvSpPr txBox="1"/>
+          <p:nvPr/>
+        </p:nvSpPr>
+        <p:spPr>
+          <a:xfrm>
+            <a:off x="8048625" y="1631217"/>
+            <a:ext cx="226020" cy="228600"/>
+          </a:xfrm>
+          <a:prstGeom prst="rect">
+            <a:avLst/>
+          </a:prstGeom>
+          <a:noFill/>
+          <a:ln/>
+        </p:spPr>
+        <p:txBody>
+          <a:bodyPr wrap="none" lIns="0" tIns="0" rIns="0" bIns="0" rtlCol="0" anchor="t"/>
+          <a:lstStyle/>
+          <a:p>
+            <a:pPr algn="l" indent="0" marL="0">
+              <a:lnSpc>
+                <a:spcPts val="1800"/>
+              </a:lnSpc>
+              <a:buNone/>
+            </a:pPr>
+            <a:r>
+              <a:rPr lang="pt-BR" altLang="en-US" sz="1800" b="1" dirty="0">
+                <a:solidFill>
+                  <a:srgbClr val="B9581A"/>
+                </a:solidFill>
+                <a:latin typeface="Calibri" pitchFamily="34" charset="0"/>
+                <a:ea typeface="Calibri" pitchFamily="34" charset="-122"/>
+                <a:cs typeface="Calibri" pitchFamily="34" charset="-120"/>
+              </a:rPr>
+              <a:t>→</a:t>
+            </a:r>
+            <a:endParaRPr lang="en-US" sz="1800" dirty="0"/>
+          </a:p>
+        </p:txBody>
+      </p:sp>
+      <p:sp>
+        <p:nvSpPr>
+          <p:cNvPr id="8" name="Qual mecanismo?"/>
+          <p:cNvSpPr/>
+          <p:nvPr/>
+        </p:nvSpPr>
+        <p:spPr>
+          <a:xfrm>
+            <a:off x="8357195" y="1574701"/>
+            <a:ext cx="1289546" cy="322560"/>
+          </a:xfrm>
+          <a:prstGeom prst="roundRect">
+            <a:avLst>
+              <a:gd name="adj" fmla="val 23624"/>
             </a:avLst>
           </a:prstGeom>
           <a:solidFill>
@@ -6232,78 +6078,18 @@
           </a:solidFill>
           <a:ln/>
         </p:spPr>
-      </p:sp>
-      <p:sp>
-        <p:nvSpPr>
-          <p:cNvPr id="10" name="PASSO 2"/>
-          <p:cNvSpPr txBox="1"/>
-          <p:nvPr/>
-        </p:nvSpPr>
-        <p:spPr>
-          <a:xfrm>
-            <a:off x="4730155" y="2070737"/>
-            <a:ext cx="2750840" cy="213320"/>
-          </a:xfrm>
-          <a:prstGeom prst="rect">
-            <a:avLst/>
-          </a:prstGeom>
-          <a:noFill/>
-          <a:ln/>
-        </p:spPr>
-        <p:txBody>
-          <a:bodyPr wrap="none" lIns="0" tIns="0" rIns="0" bIns="0" rtlCol="0" anchor="t"/>
-          <a:lstStyle/>
-          <a:p>
-            <a:pPr algn="l" indent="0" marL="0">
-              <a:lnSpc>
-                <a:spcPts val="1680"/>
-              </a:lnSpc>
-              <a:buNone/>
-            </a:pPr>
-            <a:r>
-              <a:rPr lang="pt-BR" altLang="en-US" sz="1200" b="1" spc="100" kern="0" dirty="0">
-                <a:solidFill>
-                  <a:srgbClr val="E49A5C"/>
-                </a:solidFill>
-                <a:latin typeface="Calibri" pitchFamily="34" charset="0"/>
-                <a:ea typeface="Calibri" pitchFamily="34" charset="-122"/>
-                <a:cs typeface="Calibri" pitchFamily="34" charset="-120"/>
-              </a:rPr>
-              <a:t>PASSO 2</a:t>
-            </a:r>
-            <a:endParaRPr lang="en-US" sz="1200" dirty="0"/>
-          </a:p>
-        </p:txBody>
-      </p:sp>
-      <p:sp>
-        <p:nvSpPr>
-          <p:cNvPr id="11" name="+ Vasopressina"/>
-          <p:cNvSpPr txBox="1"/>
-          <p:nvPr/>
-        </p:nvSpPr>
-        <p:spPr>
-          <a:xfrm>
-            <a:off x="4730155" y="2342592"/>
-            <a:ext cx="2750840" cy="274241"/>
-          </a:xfrm>
-          <a:prstGeom prst="rect">
-            <a:avLst/>
-          </a:prstGeom>
-          <a:noFill/>
-          <a:ln/>
-        </p:spPr>
-        <p:txBody>
-          <a:bodyPr wrap="none" lIns="0" tIns="0" rIns="0" bIns="0" rtlCol="0" anchor="t"/>
-          <a:lstStyle/>
-          <a:p>
-            <a:pPr algn="l" indent="0" marL="0">
-              <a:lnSpc>
-                <a:spcPts val="2160"/>
-              </a:lnSpc>
-              <a:buNone/>
-            </a:pPr>
-            <a:r>
-              <a:rPr lang="pt-BR" altLang="en-US" sz="1800" b="1" dirty="0">
+        <p:txBody>
+          <a:bodyPr wrap="none" lIns="127000" tIns="63500" rIns="127000" bIns="63500" rtlCol="0" anchor="ctr"/>
+          <a:lstStyle/>
+          <a:p>
+            <a:pPr algn="ctr" indent="0" marL="0">
+              <a:lnSpc>
+                <a:spcPts val="1540"/>
+              </a:lnSpc>
+              <a:buNone/>
+            </a:pPr>
+            <a:r>
+              <a:rPr lang="pt-BR" altLang="en-US" sz="1100" b="1" dirty="0">
                 <a:solidFill>
                   <a:srgbClr val="F5F3EE"/>
                 </a:solidFill>
@@ -6311,258 +6097,26 @@
                 <a:ea typeface="Calibri" pitchFamily="34" charset="-122"/>
                 <a:cs typeface="Calibri" pitchFamily="34" charset="-120"/>
               </a:rPr>
-              <a:t>+ Vasopressina</a:t>
-            </a:r>
-            <a:endParaRPr lang="en-US" sz="1800" dirty="0"/>
-          </a:p>
-        </p:txBody>
-      </p:sp>
-      <p:sp>
-        <p:nvSpPr>
-          <p:cNvPr id="12" name="Quando a dose de NA está subindo."/>
-          <p:cNvSpPr txBox="1"/>
-          <p:nvPr/>
-        </p:nvSpPr>
-        <p:spPr>
-          <a:xfrm>
-            <a:off x="4730155" y="2658901"/>
-            <a:ext cx="2750840" cy="231080"/>
-          </a:xfrm>
-          <a:prstGeom prst="rect">
-            <a:avLst/>
-          </a:prstGeom>
-          <a:noFill/>
-          <a:ln/>
-        </p:spPr>
-        <p:txBody>
-          <a:bodyPr wrap="none" lIns="0" tIns="0" rIns="0" bIns="0" rtlCol="0" anchor="t"/>
-          <a:lstStyle/>
-          <a:p>
-            <a:pPr algn="l" indent="0" marL="0">
-              <a:lnSpc>
-                <a:spcPts val="1820"/>
-              </a:lnSpc>
-              <a:buNone/>
-            </a:pPr>
-            <a:r>
-              <a:rPr lang="pt-BR" altLang="en-US" sz="1300" dirty="0">
-                <a:solidFill>
-                  <a:srgbClr val="C9CFD6"/>
-                </a:solidFill>
-                <a:latin typeface="Calibri" pitchFamily="34" charset="0"/>
-                <a:ea typeface="Calibri" pitchFamily="34" charset="-122"/>
-                <a:cs typeface="Calibri" pitchFamily="34" charset="-120"/>
-              </a:rPr>
-              <a:t>Quando a dose de NA está subindo.</a:t>
-            </a:r>
-            <a:endParaRPr lang="en-US" sz="1300" dirty="0"/>
-          </a:p>
-        </p:txBody>
-      </p:sp>
-      <p:sp>
-        <p:nvSpPr>
-          <p:cNvPr id="13" name="→"/>
-          <p:cNvSpPr txBox="1"/>
-          <p:nvPr/>
-        </p:nvSpPr>
-        <p:spPr>
-          <a:xfrm>
-            <a:off x="7792145" y="2445319"/>
-            <a:ext cx="341015" cy="355600"/>
-          </a:xfrm>
-          <a:prstGeom prst="rect">
-            <a:avLst/>
-          </a:prstGeom>
-          <a:noFill/>
-          <a:ln/>
-        </p:spPr>
-        <p:txBody>
-          <a:bodyPr wrap="none" lIns="0" tIns="0" rIns="0" bIns="0" rtlCol="0" anchor="t"/>
-          <a:lstStyle/>
-          <a:p>
-            <a:pPr algn="l" indent="0" marL="0">
-              <a:lnSpc>
-                <a:spcPts val="2800"/>
-              </a:lnSpc>
-              <a:buNone/>
-            </a:pPr>
-            <a:r>
-              <a:rPr lang="pt-BR" altLang="en-US" sz="2800" b="1" dirty="0">
-                <a:solidFill>
-                  <a:srgbClr val="B9581A"/>
-                </a:solidFill>
-                <a:latin typeface="Calibri" pitchFamily="34" charset="0"/>
-                <a:ea typeface="Calibri" pitchFamily="34" charset="-122"/>
-                <a:cs typeface="Calibri" pitchFamily="34" charset="-120"/>
-              </a:rPr>
-              <a:t>→</a:t>
-            </a:r>
-            <a:endParaRPr lang="en-US" sz="2800" dirty="0"/>
-          </a:p>
-        </p:txBody>
-      </p:sp>
-      <p:sp>
-        <p:nvSpPr>
-          <p:cNvPr id="14" name="Cartão"/>
+              <a:t>Qual mecanismo?</a:t>
+            </a:r>
+            <a:endParaRPr lang="en-US" sz="1100" dirty="0"/>
+          </a:p>
+        </p:txBody>
+      </p:sp>
+      <p:sp>
+        <p:nvSpPr>
+          <p:cNvPr id="9" name="Cartão"/>
           <p:cNvSpPr/>
           <p:nvPr/>
         </p:nvSpPr>
         <p:spPr>
           <a:xfrm>
-            <a:off x="8241109" y="1879501"/>
-            <a:ext cx="3138190" cy="1457722"/>
+            <a:off x="812800" y="2052241"/>
+            <a:ext cx="3437434" cy="1144587"/>
           </a:xfrm>
           <a:prstGeom prst="roundRect">
             <a:avLst>
-              <a:gd name="adj" fmla="val 5227"/>
-            </a:avLst>
-          </a:prstGeom>
-          <a:solidFill>
-            <a:srgbClr val="1B2A3A"/>
-          </a:solidFill>
-          <a:ln/>
-        </p:spPr>
-      </p:sp>
-      <p:sp>
-        <p:nvSpPr>
-          <p:cNvPr id="15" name="PASSO 3"/>
-          <p:cNvSpPr txBox="1"/>
-          <p:nvPr/>
-        </p:nvSpPr>
-        <p:spPr>
-          <a:xfrm>
-            <a:off x="8444309" y="2070737"/>
-            <a:ext cx="2750840" cy="213320"/>
-          </a:xfrm>
-          <a:prstGeom prst="rect">
-            <a:avLst/>
-          </a:prstGeom>
-          <a:noFill/>
-          <a:ln/>
-        </p:spPr>
-        <p:txBody>
-          <a:bodyPr wrap="none" lIns="0" tIns="0" rIns="0" bIns="0" rtlCol="0" anchor="t"/>
-          <a:lstStyle/>
-          <a:p>
-            <a:pPr algn="l" indent="0" marL="0">
-              <a:lnSpc>
-                <a:spcPts val="1680"/>
-              </a:lnSpc>
-              <a:buNone/>
-            </a:pPr>
-            <a:r>
-              <a:rPr lang="pt-BR" altLang="en-US" sz="1200" b="1" spc="100" kern="0" dirty="0">
-                <a:solidFill>
-                  <a:srgbClr val="E49A5C"/>
-                </a:solidFill>
-                <a:latin typeface="Calibri" pitchFamily="34" charset="0"/>
-                <a:ea typeface="Calibri" pitchFamily="34" charset="-122"/>
-                <a:cs typeface="Calibri" pitchFamily="34" charset="-120"/>
-              </a:rPr>
-              <a:t>PASSO 3</a:t>
-            </a:r>
-            <a:endParaRPr lang="en-US" sz="1200" dirty="0"/>
-          </a:p>
-        </p:txBody>
-      </p:sp>
-      <p:sp>
-        <p:nvSpPr>
-          <p:cNvPr id="16" name="+ Adrenalina"/>
-          <p:cNvSpPr txBox="1"/>
-          <p:nvPr/>
-        </p:nvSpPr>
-        <p:spPr>
-          <a:xfrm>
-            <a:off x="8444309" y="2342592"/>
-            <a:ext cx="2750840" cy="274241"/>
-          </a:xfrm>
-          <a:prstGeom prst="rect">
-            <a:avLst/>
-          </a:prstGeom>
-          <a:noFill/>
-          <a:ln/>
-        </p:spPr>
-        <p:txBody>
-          <a:bodyPr wrap="none" lIns="0" tIns="0" rIns="0" bIns="0" rtlCol="0" anchor="t"/>
-          <a:lstStyle/>
-          <a:p>
-            <a:pPr algn="l" indent="0" marL="0">
-              <a:lnSpc>
-                <a:spcPts val="2160"/>
-              </a:lnSpc>
-              <a:buNone/>
-            </a:pPr>
-            <a:r>
-              <a:rPr lang="pt-BR" altLang="en-US" sz="1800" b="1" dirty="0">
-                <a:solidFill>
-                  <a:srgbClr val="F5F3EE"/>
-                </a:solidFill>
-                <a:latin typeface="Calibri" pitchFamily="34" charset="0"/>
-                <a:ea typeface="Calibri" pitchFamily="34" charset="-122"/>
-                <a:cs typeface="Calibri" pitchFamily="34" charset="-120"/>
-              </a:rPr>
-              <a:t>+ Adrenalina</a:t>
-            </a:r>
-            <a:endParaRPr lang="en-US" sz="1800" dirty="0"/>
-          </a:p>
-        </p:txBody>
-      </p:sp>
-      <p:sp>
-        <p:nvSpPr>
-          <p:cNvPr id="17" name="Se a PAM continuar inadequada."/>
-          <p:cNvSpPr txBox="1"/>
-          <p:nvPr/>
-        </p:nvSpPr>
-        <p:spPr>
-          <a:xfrm>
-            <a:off x="8444309" y="2658901"/>
-            <a:ext cx="2750840" cy="231080"/>
-          </a:xfrm>
-          <a:prstGeom prst="rect">
-            <a:avLst/>
-          </a:prstGeom>
-          <a:noFill/>
-          <a:ln/>
-        </p:spPr>
-        <p:txBody>
-          <a:bodyPr wrap="none" lIns="0" tIns="0" rIns="0" bIns="0" rtlCol="0" anchor="t"/>
-          <a:lstStyle/>
-          <a:p>
-            <a:pPr algn="l" indent="0" marL="0">
-              <a:lnSpc>
-                <a:spcPts val="1820"/>
-              </a:lnSpc>
-              <a:buNone/>
-            </a:pPr>
-            <a:r>
-              <a:rPr lang="pt-BR" altLang="en-US" sz="1300" dirty="0">
-                <a:solidFill>
-                  <a:srgbClr val="C9CFD6"/>
-                </a:solidFill>
-                <a:latin typeface="Calibri" pitchFamily="34" charset="0"/>
-                <a:ea typeface="Calibri" pitchFamily="34" charset="-122"/>
-                <a:cs typeface="Calibri" pitchFamily="34" charset="-120"/>
-              </a:rPr>
-              <a:t>Se a PAM continuar inadequada.</a:t>
-            </a:r>
-            <a:endParaRPr lang="en-US" sz="1300" dirty="0"/>
-          </a:p>
-        </p:txBody>
-      </p:sp>
-      <p:sp>
-        <p:nvSpPr>
-          <p:cNvPr id="18" name="Cartão"/>
-          <p:cNvSpPr/>
-          <p:nvPr/>
-        </p:nvSpPr>
-        <p:spPr>
-          <a:xfrm>
-            <a:off x="812800" y="3540423"/>
-            <a:ext cx="10566400" cy="1219200"/>
-          </a:xfrm>
-          <a:prstGeom prst="roundRect">
-            <a:avLst>
-              <a:gd name="adj" fmla="val 6250"/>
+              <a:gd name="adj" fmla="val 6657"/>
             </a:avLst>
           </a:prstGeom>
           <a:solidFill>
@@ -6578,14 +6132,175 @@
       </p:sp>
       <p:sp>
         <p:nvSpPr>
-          <p:cNvPr id="19" name="Em comum"/>
-          <p:cNvSpPr txBox="1"/>
-          <p:nvPr/>
-        </p:nvSpPr>
-        <p:spPr>
-          <a:xfrm>
-            <a:off x="1073150" y="3875835"/>
-            <a:ext cx="1834555" cy="497780"/>
+          <p:cNvPr id="10" name="Tônus baixo, FC normal ou alta"/>
+          <p:cNvSpPr/>
+          <p:nvPr/>
+        </p:nvSpPr>
+        <p:spPr>
+          <a:xfrm>
+            <a:off x="819150" y="2058591"/>
+            <a:ext cx="3424734" cy="334963"/>
+          </a:xfrm>
+          <a:prstGeom prst="roundRect">
+            <a:avLst>
+              <a:gd name="adj" fmla="val 22749"/>
+            </a:avLst>
+          </a:prstGeom>
+          <a:solidFill>
+            <a:srgbClr val="1B2A3A"/>
+          </a:solidFill>
+          <a:ln/>
+        </p:spPr>
+        <p:txBody>
+          <a:bodyPr wrap="none" lIns="114300" tIns="76200" rIns="114300" bIns="76200" rtlCol="0" anchor="ctr"/>
+          <a:lstStyle/>
+          <a:p>
+            <a:pPr algn="ctr" indent="0" marL="0">
+              <a:lnSpc>
+                <a:spcPts val="1438"/>
+              </a:lnSpc>
+              <a:buNone/>
+            </a:pPr>
+            <a:r>
+              <a:rPr lang="pt-BR" altLang="en-US" sz="1150" b="1" dirty="0">
+                <a:solidFill>
+                  <a:srgbClr val="F5F3EE"/>
+                </a:solidFill>
+                <a:latin typeface="Calibri" pitchFamily="34" charset="0"/>
+                <a:ea typeface="Calibri" pitchFamily="34" charset="-122"/>
+                <a:cs typeface="Calibri" pitchFamily="34" charset="-120"/>
+              </a:rPr>
+              <a:t>Tônus baixo, FC normal ou alta</a:t>
+            </a:r>
+            <a:endParaRPr lang="en-US" sz="1150" dirty="0"/>
+          </a:p>
+        </p:txBody>
+      </p:sp>
+      <p:sp>
+        <p:nvSpPr>
+          <p:cNvPr id="11" name="Fenilefrina 50–100 mcg ou NA 5–10 mcg; N"/>
+          <p:cNvSpPr txBox="1"/>
+          <p:nvPr/>
+        </p:nvSpPr>
+        <p:spPr>
+          <a:xfrm>
+            <a:off x="933450" y="2474754"/>
+            <a:ext cx="3215184" cy="412750"/>
+          </a:xfrm>
+          <a:prstGeom prst="rect">
+            <a:avLst/>
+          </a:prstGeom>
+          <a:noFill/>
+          <a:ln/>
+        </p:spPr>
+        <p:txBody>
+          <a:bodyPr wrap="square" lIns="0" tIns="0" rIns="0" bIns="0" rtlCol="0" anchor="t"/>
+          <a:lstStyle/>
+          <a:p>
+            <a:pPr algn="l" indent="0" marL="0">
+              <a:lnSpc>
+                <a:spcPts val="1625"/>
+              </a:lnSpc>
+              <a:buNone/>
+            </a:pPr>
+            <a:r>
+              <a:rPr lang="pt-BR" altLang="en-US" sz="1250" b="1" dirty="0">
+                <a:solidFill>
+                  <a:srgbClr val="1B2A3A"/>
+                </a:solidFill>
+                <a:latin typeface="Calibri" pitchFamily="34" charset="0"/>
+                <a:ea typeface="Calibri" pitchFamily="34" charset="-122"/>
+                <a:cs typeface="Calibri" pitchFamily="34" charset="-120"/>
+              </a:rPr>
+              <a:t>Fenilefrina 50–100 mcg ou NA 5–10 mcg; NA em infusão se persistir</a:t>
+            </a:r>
+            <a:endParaRPr lang="en-US" sz="1250" dirty="0"/>
+          </a:p>
+        </p:txBody>
+      </p:sp>
+      <p:sp>
+        <p:nvSpPr>
+          <p:cNvPr id="12" name="Cartão"/>
+          <p:cNvSpPr/>
+          <p:nvPr/>
+        </p:nvSpPr>
+        <p:spPr>
+          <a:xfrm>
+            <a:off x="4377234" y="2052241"/>
+            <a:ext cx="3437434" cy="1144587"/>
+          </a:xfrm>
+          <a:prstGeom prst="roundRect">
+            <a:avLst>
+              <a:gd name="adj" fmla="val 6657"/>
+            </a:avLst>
+          </a:prstGeom>
+          <a:solidFill>
+            <a:srgbClr val="FFFDF8"/>
+          </a:solidFill>
+          <a:ln w="6350">
+            <a:solidFill>
+              <a:srgbClr val="E2DDD2"/>
+            </a:solidFill>
+            <a:prstDash val="solid"/>
+          </a:ln>
+        </p:spPr>
+      </p:sp>
+      <p:sp>
+        <p:nvSpPr>
+          <p:cNvPr id="13" name="Tônus baixo com bradicardia"/>
+          <p:cNvSpPr/>
+          <p:nvPr/>
+        </p:nvSpPr>
+        <p:spPr>
+          <a:xfrm>
+            <a:off x="4383584" y="2058591"/>
+            <a:ext cx="3424734" cy="334963"/>
+          </a:xfrm>
+          <a:prstGeom prst="roundRect">
+            <a:avLst>
+              <a:gd name="adj" fmla="val 22749"/>
+            </a:avLst>
+          </a:prstGeom>
+          <a:solidFill>
+            <a:srgbClr val="1B2A3A"/>
+          </a:solidFill>
+          <a:ln/>
+        </p:spPr>
+        <p:txBody>
+          <a:bodyPr wrap="none" lIns="114300" tIns="76200" rIns="114300" bIns="76200" rtlCol="0" anchor="ctr"/>
+          <a:lstStyle/>
+          <a:p>
+            <a:pPr algn="ctr" indent="0" marL="0">
+              <a:lnSpc>
+                <a:spcPts val="1438"/>
+              </a:lnSpc>
+              <a:buNone/>
+            </a:pPr>
+            <a:r>
+              <a:rPr lang="pt-BR" altLang="en-US" sz="1150" b="1" dirty="0">
+                <a:solidFill>
+                  <a:srgbClr val="F5F3EE"/>
+                </a:solidFill>
+                <a:latin typeface="Calibri" pitchFamily="34" charset="0"/>
+                <a:ea typeface="Calibri" pitchFamily="34" charset="-122"/>
+                <a:cs typeface="Calibri" pitchFamily="34" charset="-120"/>
+              </a:rPr>
+              <a:t>Tônus baixo com bradicardia</a:t>
+            </a:r>
+            <a:endParaRPr lang="en-US" sz="1150" dirty="0"/>
+          </a:p>
+        </p:txBody>
+      </p:sp>
+      <p:sp>
+        <p:nvSpPr>
+          <p:cNvPr id="14" name="Efedrina 5–10 mg; adrenalina se grave"/>
+          <p:cNvSpPr txBox="1"/>
+          <p:nvPr/>
+        </p:nvSpPr>
+        <p:spPr>
+          <a:xfrm>
+            <a:off x="4497884" y="2474754"/>
+            <a:ext cx="3215184" cy="206375"/>
           </a:xfrm>
           <a:prstGeom prst="rect">
             <a:avLst/>
@@ -6599,12 +6314,567 @@
           <a:p>
             <a:pPr algn="l" indent="0" marL="0">
               <a:lnSpc>
-                <a:spcPts val="3920"/>
-              </a:lnSpc>
-              <a:buNone/>
-            </a:pPr>
-            <a:r>
-              <a:rPr lang="pt-BR" altLang="en-US" sz="2800" dirty="0">
+                <a:spcPts val="1625"/>
+              </a:lnSpc>
+              <a:buNone/>
+            </a:pPr>
+            <a:r>
+              <a:rPr lang="pt-BR" altLang="en-US" sz="1250" b="1" dirty="0">
+                <a:solidFill>
+                  <a:srgbClr val="1B2A3A"/>
+                </a:solidFill>
+                <a:latin typeface="Calibri" pitchFamily="34" charset="0"/>
+                <a:ea typeface="Calibri" pitchFamily="34" charset="-122"/>
+                <a:cs typeface="Calibri" pitchFamily="34" charset="-120"/>
+              </a:rPr>
+              <a:t>Efedrina 5–10 mg; adrenalina se grave</a:t>
+            </a:r>
+            <a:endParaRPr lang="en-US" sz="1250" dirty="0"/>
+          </a:p>
+        </p:txBody>
+      </p:sp>
+      <p:sp>
+        <p:nvSpPr>
+          <p:cNvPr id="15" name="Cartão"/>
+          <p:cNvSpPr/>
+          <p:nvPr/>
+        </p:nvSpPr>
+        <p:spPr>
+          <a:xfrm>
+            <a:off x="7941667" y="2052241"/>
+            <a:ext cx="3437434" cy="1144587"/>
+          </a:xfrm>
+          <a:prstGeom prst="roundRect">
+            <a:avLst>
+              <a:gd name="adj" fmla="val 6657"/>
+            </a:avLst>
+          </a:prstGeom>
+          <a:solidFill>
+            <a:srgbClr val="FFFDF8"/>
+          </a:solidFill>
+          <a:ln w="6350">
+            <a:solidFill>
+              <a:srgbClr val="E2DDD2"/>
+            </a:solidFill>
+            <a:prstDash val="solid"/>
+          </a:ln>
+        </p:spPr>
+      </p:sp>
+      <p:sp>
+        <p:nvSpPr>
+          <p:cNvPr id="16" name="Baixo débito com hipoperfusão"/>
+          <p:cNvSpPr/>
+          <p:nvPr/>
+        </p:nvSpPr>
+        <p:spPr>
+          <a:xfrm>
+            <a:off x="7948017" y="2058591"/>
+            <a:ext cx="3424734" cy="334963"/>
+          </a:xfrm>
+          <a:prstGeom prst="roundRect">
+            <a:avLst>
+              <a:gd name="adj" fmla="val 22749"/>
+            </a:avLst>
+          </a:prstGeom>
+          <a:solidFill>
+            <a:srgbClr val="1B2A3A"/>
+          </a:solidFill>
+          <a:ln/>
+        </p:spPr>
+        <p:txBody>
+          <a:bodyPr wrap="none" lIns="114300" tIns="76200" rIns="114300" bIns="76200" rtlCol="0" anchor="ctr"/>
+          <a:lstStyle/>
+          <a:p>
+            <a:pPr algn="ctr" indent="0" marL="0">
+              <a:lnSpc>
+                <a:spcPts val="1438"/>
+              </a:lnSpc>
+              <a:buNone/>
+            </a:pPr>
+            <a:r>
+              <a:rPr lang="pt-BR" altLang="en-US" sz="1150" b="1" dirty="0">
+                <a:solidFill>
+                  <a:srgbClr val="F5F3EE"/>
+                </a:solidFill>
+                <a:latin typeface="Calibri" pitchFamily="34" charset="0"/>
+                <a:ea typeface="Calibri" pitchFamily="34" charset="-122"/>
+                <a:cs typeface="Calibri" pitchFamily="34" charset="-120"/>
+              </a:rPr>
+              <a:t>Baixo débito com hipoperfusão</a:t>
+            </a:r>
+            <a:endParaRPr lang="en-US" sz="1150" dirty="0"/>
+          </a:p>
+        </p:txBody>
+      </p:sp>
+      <p:sp>
+        <p:nvSpPr>
+          <p:cNvPr id="17" name="Dobutamina (ou adrenalina no choque sépt"/>
+          <p:cNvSpPr txBox="1"/>
+          <p:nvPr/>
+        </p:nvSpPr>
+        <p:spPr>
+          <a:xfrm>
+            <a:off x="8062317" y="2474754"/>
+            <a:ext cx="3215184" cy="619125"/>
+          </a:xfrm>
+          <a:prstGeom prst="rect">
+            <a:avLst/>
+          </a:prstGeom>
+          <a:noFill/>
+          <a:ln/>
+        </p:spPr>
+        <p:txBody>
+          <a:bodyPr wrap="square" lIns="0" tIns="0" rIns="0" bIns="0" rtlCol="0" anchor="t"/>
+          <a:lstStyle/>
+          <a:p>
+            <a:pPr algn="l" indent="0" marL="0">
+              <a:lnSpc>
+                <a:spcPts val="1625"/>
+              </a:lnSpc>
+              <a:buNone/>
+            </a:pPr>
+            <a:r>
+              <a:rPr lang="pt-BR" altLang="en-US" sz="1250" b="1" dirty="0">
+                <a:solidFill>
+                  <a:srgbClr val="1B2A3A"/>
+                </a:solidFill>
+                <a:latin typeface="Calibri" pitchFamily="34" charset="0"/>
+                <a:ea typeface="Calibri" pitchFamily="34" charset="-122"/>
+                <a:cs typeface="Calibri" pitchFamily="34" charset="-120"/>
+              </a:rPr>
+              <a:t>Dobutamina (ou adrenalina no choque séptico); milrinona no VD com hipertensão pulmonar; NA se a PAM cair</a:t>
+            </a:r>
+            <a:endParaRPr lang="en-US" sz="1250" dirty="0"/>
+          </a:p>
+        </p:txBody>
+      </p:sp>
+      <p:sp>
+        <p:nvSpPr>
+          <p:cNvPr id="18" name="Cartão"/>
+          <p:cNvSpPr/>
+          <p:nvPr/>
+        </p:nvSpPr>
+        <p:spPr>
+          <a:xfrm>
+            <a:off x="812800" y="3298428"/>
+            <a:ext cx="3437434" cy="1144587"/>
+          </a:xfrm>
+          <a:prstGeom prst="roundRect">
+            <a:avLst>
+              <a:gd name="adj" fmla="val 6657"/>
+            </a:avLst>
+          </a:prstGeom>
+          <a:solidFill>
+            <a:srgbClr val="FFFDF8"/>
+          </a:solidFill>
+          <a:ln w="6350">
+            <a:solidFill>
+              <a:srgbClr val="E2DDD2"/>
+            </a:solidFill>
+            <a:prstDash val="solid"/>
+          </a:ln>
+        </p:spPr>
+      </p:sp>
+      <p:sp>
+        <p:nvSpPr>
+          <p:cNvPr id="19" name="Vasoplegia persistente ou refratária"/>
+          <p:cNvSpPr/>
+          <p:nvPr/>
+        </p:nvSpPr>
+        <p:spPr>
+          <a:xfrm>
+            <a:off x="819150" y="3304778"/>
+            <a:ext cx="3424734" cy="334963"/>
+          </a:xfrm>
+          <a:prstGeom prst="roundRect">
+            <a:avLst>
+              <a:gd name="adj" fmla="val 22749"/>
+            </a:avLst>
+          </a:prstGeom>
+          <a:solidFill>
+            <a:srgbClr val="1B2A3A"/>
+          </a:solidFill>
+          <a:ln/>
+        </p:spPr>
+        <p:txBody>
+          <a:bodyPr wrap="none" lIns="114300" tIns="76200" rIns="114300" bIns="76200" rtlCol="0" anchor="ctr"/>
+          <a:lstStyle/>
+          <a:p>
+            <a:pPr algn="ctr" indent="0" marL="0">
+              <a:lnSpc>
+                <a:spcPts val="1438"/>
+              </a:lnSpc>
+              <a:buNone/>
+            </a:pPr>
+            <a:r>
+              <a:rPr lang="pt-BR" altLang="en-US" sz="1150" b="1" dirty="0">
+                <a:solidFill>
+                  <a:srgbClr val="F5F3EE"/>
+                </a:solidFill>
+                <a:latin typeface="Calibri" pitchFamily="34" charset="0"/>
+                <a:ea typeface="Calibri" pitchFamily="34" charset="-122"/>
+                <a:cs typeface="Calibri" pitchFamily="34" charset="-120"/>
+              </a:rPr>
+              <a:t>Vasoplegia persistente ou refratária</a:t>
+            </a:r>
+            <a:endParaRPr lang="en-US" sz="1150" dirty="0"/>
+          </a:p>
+        </p:txBody>
+      </p:sp>
+      <p:sp>
+        <p:nvSpPr>
+          <p:cNvPr id="20" name="NA em escalada → vasopressina → adrenali"/>
+          <p:cNvSpPr txBox="1"/>
+          <p:nvPr/>
+        </p:nvSpPr>
+        <p:spPr>
+          <a:xfrm>
+            <a:off x="933450" y="3720941"/>
+            <a:ext cx="3215184" cy="619125"/>
+          </a:xfrm>
+          <a:prstGeom prst="rect">
+            <a:avLst/>
+          </a:prstGeom>
+          <a:noFill/>
+          <a:ln/>
+        </p:spPr>
+        <p:txBody>
+          <a:bodyPr wrap="square" lIns="0" tIns="0" rIns="0" bIns="0" rtlCol="0" anchor="t"/>
+          <a:lstStyle/>
+          <a:p>
+            <a:pPr algn="l" indent="0" marL="0">
+              <a:lnSpc>
+                <a:spcPts val="1625"/>
+              </a:lnSpc>
+              <a:buNone/>
+            </a:pPr>
+            <a:r>
+              <a:rPr lang="pt-BR" altLang="en-US" sz="1250" b="1" dirty="0">
+                <a:solidFill>
+                  <a:srgbClr val="1B2A3A"/>
+                </a:solidFill>
+                <a:latin typeface="Calibri" pitchFamily="34" charset="0"/>
+                <a:ea typeface="Calibri" pitchFamily="34" charset="-122"/>
+                <a:cs typeface="Calibri" pitchFamily="34" charset="-120"/>
+              </a:rPr>
+              <a:t>NA em escalada → vasopressina → adrenalina (SSC 2026); azul de metileno como resgate (pós-CEC, IECA/BRA, reperfusão hepática)</a:t>
+            </a:r>
+            <a:endParaRPr lang="en-US" sz="1250" dirty="0"/>
+          </a:p>
+        </p:txBody>
+      </p:sp>
+      <p:sp>
+        <p:nvSpPr>
+          <p:cNvPr id="21" name="Cartão"/>
+          <p:cNvSpPr/>
+          <p:nvPr/>
+        </p:nvSpPr>
+        <p:spPr>
+          <a:xfrm>
+            <a:off x="4377234" y="3298428"/>
+            <a:ext cx="3437434" cy="1144587"/>
+          </a:xfrm>
+          <a:prstGeom prst="roundRect">
+            <a:avLst>
+              <a:gd name="adj" fmla="val 6657"/>
+            </a:avLst>
+          </a:prstGeom>
+          <a:solidFill>
+            <a:srgbClr val="FFFDF8"/>
+          </a:solidFill>
+          <a:ln w="6350">
+            <a:solidFill>
+              <a:srgbClr val="E2DDD2"/>
+            </a:solidFill>
+            <a:prstDash val="solid"/>
+          </a:ln>
+        </p:spPr>
+      </p:sp>
+      <p:sp>
+        <p:nvSpPr>
+          <p:cNvPr id="22" name="Pré-carga baixa"/>
+          <p:cNvSpPr/>
+          <p:nvPr/>
+        </p:nvSpPr>
+        <p:spPr>
+          <a:xfrm>
+            <a:off x="4383584" y="3304778"/>
+            <a:ext cx="3424734" cy="334963"/>
+          </a:xfrm>
+          <a:prstGeom prst="roundRect">
+            <a:avLst>
+              <a:gd name="adj" fmla="val 22749"/>
+            </a:avLst>
+          </a:prstGeom>
+          <a:solidFill>
+            <a:srgbClr val="1B2A3A"/>
+          </a:solidFill>
+          <a:ln/>
+        </p:spPr>
+        <p:txBody>
+          <a:bodyPr wrap="none" lIns="114300" tIns="76200" rIns="114300" bIns="76200" rtlCol="0" anchor="ctr"/>
+          <a:lstStyle/>
+          <a:p>
+            <a:pPr algn="ctr" indent="0" marL="0">
+              <a:lnSpc>
+                <a:spcPts val="1438"/>
+              </a:lnSpc>
+              <a:buNone/>
+            </a:pPr>
+            <a:r>
+              <a:rPr lang="pt-BR" altLang="en-US" sz="1150" b="1" dirty="0">
+                <a:solidFill>
+                  <a:srgbClr val="F5F3EE"/>
+                </a:solidFill>
+                <a:latin typeface="Calibri" pitchFamily="34" charset="0"/>
+                <a:ea typeface="Calibri" pitchFamily="34" charset="-122"/>
+                <a:cs typeface="Calibri" pitchFamily="34" charset="-120"/>
+              </a:rPr>
+              <a:t>Pré-carga baixa</a:t>
+            </a:r>
+            <a:endParaRPr lang="en-US" sz="1150" dirty="0"/>
+          </a:p>
+        </p:txBody>
+      </p:sp>
+      <p:sp>
+        <p:nvSpPr>
+          <p:cNvPr id="23" name="Volume, se o débito responde"/>
+          <p:cNvSpPr txBox="1"/>
+          <p:nvPr/>
+        </p:nvSpPr>
+        <p:spPr>
+          <a:xfrm>
+            <a:off x="4497884" y="3720941"/>
+            <a:ext cx="3215184" cy="206375"/>
+          </a:xfrm>
+          <a:prstGeom prst="rect">
+            <a:avLst/>
+          </a:prstGeom>
+          <a:noFill/>
+          <a:ln/>
+        </p:spPr>
+        <p:txBody>
+          <a:bodyPr wrap="none" lIns="0" tIns="0" rIns="0" bIns="0" rtlCol="0" anchor="t"/>
+          <a:lstStyle/>
+          <a:p>
+            <a:pPr algn="l" indent="0" marL="0">
+              <a:lnSpc>
+                <a:spcPts val="1625"/>
+              </a:lnSpc>
+              <a:buNone/>
+            </a:pPr>
+            <a:r>
+              <a:rPr lang="pt-BR" altLang="en-US" sz="1250" b="1" dirty="0">
+                <a:solidFill>
+                  <a:srgbClr val="1B2A3A"/>
+                </a:solidFill>
+                <a:latin typeface="Calibri" pitchFamily="34" charset="0"/>
+                <a:ea typeface="Calibri" pitchFamily="34" charset="-122"/>
+                <a:cs typeface="Calibri" pitchFamily="34" charset="-120"/>
+              </a:rPr>
+              <a:t>Volume, se o débito responde</a:t>
+            </a:r>
+            <a:endParaRPr lang="en-US" sz="1250" dirty="0"/>
+          </a:p>
+        </p:txBody>
+      </p:sp>
+      <p:sp>
+        <p:nvSpPr>
+          <p:cNvPr id="24" name="Cartão"/>
+          <p:cNvSpPr/>
+          <p:nvPr/>
+        </p:nvSpPr>
+        <p:spPr>
+          <a:xfrm>
+            <a:off x="7941667" y="3298428"/>
+            <a:ext cx="3437434" cy="1144587"/>
+          </a:xfrm>
+          <a:prstGeom prst="roundRect">
+            <a:avLst>
+              <a:gd name="adj" fmla="val 6657"/>
+            </a:avLst>
+          </a:prstGeom>
+          <a:solidFill>
+            <a:srgbClr val="FFFDF8"/>
+          </a:solidFill>
+          <a:ln w="6350">
+            <a:solidFill>
+              <a:srgbClr val="E2DDD2"/>
+            </a:solidFill>
+            <a:prstDash val="solid"/>
+          </a:ln>
+        </p:spPr>
+      </p:sp>
+      <p:sp>
+        <p:nvSpPr>
+          <p:cNvPr id="25" name="Anafilaxia"/>
+          <p:cNvSpPr/>
+          <p:nvPr/>
+        </p:nvSpPr>
+        <p:spPr>
+          <a:xfrm>
+            <a:off x="7948017" y="3304778"/>
+            <a:ext cx="3424734" cy="334963"/>
+          </a:xfrm>
+          <a:prstGeom prst="roundRect">
+            <a:avLst>
+              <a:gd name="adj" fmla="val 22749"/>
+            </a:avLst>
+          </a:prstGeom>
+          <a:solidFill>
+            <a:srgbClr val="1B2A3A"/>
+          </a:solidFill>
+          <a:ln/>
+        </p:spPr>
+        <p:txBody>
+          <a:bodyPr wrap="none" lIns="114300" tIns="76200" rIns="114300" bIns="76200" rtlCol="0" anchor="ctr"/>
+          <a:lstStyle/>
+          <a:p>
+            <a:pPr algn="ctr" indent="0" marL="0">
+              <a:lnSpc>
+                <a:spcPts val="1438"/>
+              </a:lnSpc>
+              <a:buNone/>
+            </a:pPr>
+            <a:r>
+              <a:rPr lang="pt-BR" altLang="en-US" sz="1150" b="1" dirty="0">
+                <a:solidFill>
+                  <a:srgbClr val="F5F3EE"/>
+                </a:solidFill>
+                <a:latin typeface="Calibri" pitchFamily="34" charset="0"/>
+                <a:ea typeface="Calibri" pitchFamily="34" charset="-122"/>
+                <a:cs typeface="Calibri" pitchFamily="34" charset="-120"/>
+              </a:rPr>
+              <a:t>Anafilaxia</a:t>
+            </a:r>
+            <a:endParaRPr lang="en-US" sz="1150" dirty="0"/>
+          </a:p>
+        </p:txBody>
+      </p:sp>
+      <p:sp>
+        <p:nvSpPr>
+          <p:cNvPr id="26" name="Adrenalina: bolus titulados; infusão apó"/>
+          <p:cNvSpPr txBox="1"/>
+          <p:nvPr/>
+        </p:nvSpPr>
+        <p:spPr>
+          <a:xfrm>
+            <a:off x="8062317" y="3720941"/>
+            <a:ext cx="3215184" cy="412750"/>
+          </a:xfrm>
+          <a:prstGeom prst="rect">
+            <a:avLst/>
+          </a:prstGeom>
+          <a:noFill/>
+          <a:ln/>
+        </p:spPr>
+        <p:txBody>
+          <a:bodyPr wrap="square" lIns="0" tIns="0" rIns="0" bIns="0" rtlCol="0" anchor="t"/>
+          <a:lstStyle/>
+          <a:p>
+            <a:pPr algn="l" indent="0" marL="0">
+              <a:lnSpc>
+                <a:spcPts val="1625"/>
+              </a:lnSpc>
+              <a:buNone/>
+            </a:pPr>
+            <a:r>
+              <a:rPr lang="pt-BR" altLang="en-US" sz="1250" b="1" dirty="0">
+                <a:solidFill>
+                  <a:srgbClr val="1B2A3A"/>
+                </a:solidFill>
+                <a:latin typeface="Calibri" pitchFamily="34" charset="0"/>
+                <a:ea typeface="Calibri" pitchFamily="34" charset="-122"/>
+                <a:cs typeface="Calibri" pitchFamily="34" charset="-120"/>
+              </a:rPr>
+              <a:t>Adrenalina: bolus titulados; infusão após mais de três bolus</a:t>
+            </a:r>
+            <a:endParaRPr lang="en-US" sz="1250" dirty="0"/>
+          </a:p>
+        </p:txBody>
+      </p:sp>
+      <p:sp>
+        <p:nvSpPr>
+          <p:cNvPr id="27" name="Transplante hepático (UFRJ): em 19 pacie"/>
+          <p:cNvSpPr txBox="1"/>
+          <p:nvPr/>
+        </p:nvSpPr>
+        <p:spPr>
+          <a:xfrm>
+            <a:off x="812800" y="4572635"/>
+            <a:ext cx="10585450" cy="642938"/>
+          </a:xfrm>
+          <a:prstGeom prst="rect">
+            <a:avLst/>
+          </a:prstGeom>
+          <a:noFill/>
+          <a:ln/>
+        </p:spPr>
+        <p:txBody>
+          <a:bodyPr wrap="square" lIns="0" tIns="0" rIns="0" bIns="0" rtlCol="0" anchor="t"/>
+          <a:lstStyle/>
+          <a:p>
+            <a:pPr algn="l" indent="0" marL="0">
+              <a:lnSpc>
+                <a:spcPts val="1688"/>
+              </a:lnSpc>
+              <a:buNone/>
+            </a:pPr>
+            <a:r>
+              <a:rPr lang="pt-BR" altLang="en-US" sz="1250" b="1" dirty="0">
+                <a:solidFill>
+                  <a:srgbClr val="2C3A48"/>
+                </a:solidFill>
+                <a:latin typeface="Calibri" pitchFamily="34" charset="0"/>
+                <a:ea typeface="Calibri" pitchFamily="34" charset="-122"/>
+                <a:cs typeface="Calibri" pitchFamily="34" charset="-120"/>
+              </a:rPr>
+              <a:t>Transplante hepático (UFRJ):</a:t>
+            </a:r>
+            <a:r>
+              <a:rPr lang="pt-BR" altLang="en-US" sz="1250" dirty="0">
+                <a:solidFill>
+                  <a:srgbClr val="2C3A48"/>
+                </a:solidFill>
+                <a:latin typeface="Calibri" pitchFamily="34" charset="0"/>
+                <a:ea typeface="Calibri" pitchFamily="34" charset="-122"/>
+                <a:cs typeface="Calibri" pitchFamily="34" charset="-120"/>
+              </a:rPr>
+              <a:t> em 19 pacientes selecionados, a função sistólica do VD ao ETE manteve-se preservada nos momentos avaliados, inclusive 30 min após a reperfusão. O estudo não mediu os primeiros minutos da reperfusão nem a causa da instabilidade aguda; a lição é usar o eco para separar disfunção de VD de vasoplegia antes de escolher entre inotrópico e vasopressor (Gouvêa et al., PLoS One 2022).</a:t>
+            </a:r>
+            <a:endParaRPr lang="en-US" sz="1250" dirty="0"/>
+          </a:p>
+        </p:txBody>
+      </p:sp>
+      <p:sp>
+        <p:nvSpPr>
+          <p:cNvPr id="28" name="A droga certa corrige o componente da PA"/>
+          <p:cNvSpPr txBox="1"/>
+          <p:nvPr/>
+        </p:nvSpPr>
+        <p:spPr>
+          <a:xfrm>
+            <a:off x="803275" y="5357543"/>
+            <a:ext cx="10585450" cy="247650"/>
+          </a:xfrm>
+          <a:prstGeom prst="rect">
+            <a:avLst/>
+          </a:prstGeom>
+          <a:noFill/>
+          <a:ln/>
+        </p:spPr>
+        <p:txBody>
+          <a:bodyPr wrap="none" lIns="0" tIns="0" rIns="0" bIns="0" rtlCol="0" anchor="t"/>
+          <a:lstStyle/>
+          <a:p>
+            <a:pPr algn="ctr" indent="0" marL="0">
+              <a:lnSpc>
+                <a:spcPts val="1950"/>
+              </a:lnSpc>
+              <a:buNone/>
+            </a:pPr>
+            <a:r>
+              <a:rPr lang="pt-BR" altLang="en-US" sz="1500" dirty="0">
                 <a:solidFill>
                   <a:srgbClr val="B9581A"/>
                 </a:solidFill>
@@ -6612,49 +6882,7 @@
                 <a:ea typeface="Georgia" pitchFamily="34" charset="-122"/>
                 <a:cs typeface="Georgia" pitchFamily="34" charset="-120"/>
               </a:rPr>
-              <a:t>Em comum</a:t>
-            </a:r>
-            <a:endParaRPr lang="en-US" sz="2800" dirty="0"/>
-          </a:p>
-        </p:txBody>
-      </p:sp>
-      <p:sp>
-        <p:nvSpPr>
-          <p:cNvPr id="20" name="Vasopressor cedo, pelo mecanismo: tônus "/>
-          <p:cNvSpPr txBox="1"/>
-          <p:nvPr/>
-        </p:nvSpPr>
-        <p:spPr>
-          <a:xfrm>
-            <a:off x="3295055" y="3735018"/>
-            <a:ext cx="7842845" cy="800100"/>
-          </a:xfrm>
-          <a:prstGeom prst="rect">
-            <a:avLst/>
-          </a:prstGeom>
-          <a:noFill/>
-          <a:ln/>
-        </p:spPr>
-        <p:txBody>
-          <a:bodyPr wrap="square" lIns="0" tIns="0" rIns="0" bIns="0" rtlCol="0" anchor="t"/>
-          <a:lstStyle/>
-          <a:p>
-            <a:pPr algn="l" indent="0" marL="0">
-              <a:lnSpc>
-                <a:spcPts val="2100"/>
-              </a:lnSpc>
-              <a:buNone/>
-            </a:pPr>
-            <a:r>
-              <a:rPr lang="pt-BR" altLang="en-US" sz="1500" dirty="0">
-                <a:solidFill>
-                  <a:srgbClr val="1B2A3A"/>
-                </a:solidFill>
-                <a:latin typeface="Calibri" pitchFamily="34" charset="0"/>
-                <a:ea typeface="Calibri" pitchFamily="34" charset="-122"/>
-                <a:cs typeface="Calibri" pitchFamily="34" charset="-120"/>
-              </a:rPr>
-              <a:t>Vasopressor cedo, pelo mecanismo: tônus com noradrenalina, outra via com vasopressina, e adrenalina quando as duas não bastam. Inotrópico reservado à disfunção cardíaca com hipoperfusão.</a:t>
+              <a:t>A droga certa corrige o componente da PAM que falha, na menor dose eficaz e pelo menor tempo.</a:t>
             </a:r>
             <a:endParaRPr lang="en-US" sz="1500" dirty="0"/>
           </a:p>
@@ -6662,14 +6890,14 @@
       </p:sp>
       <p:sp>
         <p:nvSpPr>
-          <p:cNvPr id="21" name="Prescott, Crit Care Med 2026 (Surviving "/>
-          <p:cNvSpPr txBox="1"/>
-          <p:nvPr/>
-        </p:nvSpPr>
-        <p:spPr>
-          <a:xfrm>
-            <a:off x="812800" y="6226316"/>
-            <a:ext cx="10433050" cy="213320"/>
+          <p:cNvPr id="29" name="Gouvêa, PLoS One 2022 · SSC 2026 · Hajja"/>
+          <p:cNvSpPr txBox="1"/>
+          <p:nvPr/>
+        </p:nvSpPr>
+        <p:spPr>
+          <a:xfrm>
+            <a:off x="812800" y="6245073"/>
+            <a:ext cx="10433050" cy="195560"/>
           </a:xfrm>
           <a:prstGeom prst="rect">
             <a:avLst/>
@@ -6683,12 +6911,12 @@
           <a:p>
             <a:pPr algn="l" indent="0" marL="0">
               <a:lnSpc>
-                <a:spcPts val="1680"/>
-              </a:lnSpc>
-              <a:buNone/>
-            </a:pPr>
-            <a:r>
-              <a:rPr lang="pt-BR" altLang="en-US" sz="1200" dirty="0">
+                <a:spcPts val="1540"/>
+              </a:lnSpc>
+              <a:buNone/>
+            </a:pPr>
+            <a:r>
+              <a:rPr lang="pt-BR" altLang="en-US" sz="1100" dirty="0">
                 <a:solidFill>
                   <a:srgbClr val="56606B"/>
                 </a:solidFill>
@@ -6696,15 +6924,15 @@
                 <a:ea typeface="Calibri" pitchFamily="34" charset="-122"/>
                 <a:cs typeface="Calibri" pitchFamily="34" charset="-120"/>
               </a:rPr>
-              <a:t>Prescott, Crit Care Med 2026 (Surviving Sepsis Campaign)</a:t>
-            </a:r>
-            <a:endParaRPr lang="en-US" sz="1200" dirty="0"/>
+              <a:t>Gouvêa, PLoS One 2022 · SSC 2026 · Hajjar, Anesthesiology 2017 (VANCS) · Miller’s Anesthesia, 10ª ed. (2025), cap. 16, 33, 56, 79</a:t>
+            </a:r>
+            <a:endParaRPr lang="en-US" sz="1100" dirty="0"/>
           </a:p>
         </p:txBody>
       </p:sp>
       <p:pic>
         <p:nvPicPr>
-          <p:cNvPr id="22" name="Símbolo da UFRJ" descr="Símbolo da UFRJ">    </p:cNvPr>
+          <p:cNvPr id="30" name="Símbolo da UFRJ" descr="Símbolo da UFRJ">    </p:cNvPr>
           <p:cNvPicPr>
             <a:picLocks noChangeAspect="1"/>
           </p:cNvPicPr>
@@ -6740,1972 +6968,6 @@
 <file path=ppt/slides/slide14.xml><?xml version="1.0" encoding="utf-8"?>
 <p:sld xmlns:a="http://schemas.openxmlformats.org/drawingml/2006/main" xmlns:r="http://schemas.openxmlformats.org/officeDocument/2006/relationships" xmlns:p="http://schemas.openxmlformats.org/presentationml/2006/main">
   <p:cSld name="Slide 14">
-    <p:bg>
-      <p:bgPr>
-        <a:solidFill>
-          <a:srgbClr val="F5F3EE"/>
-        </a:solidFill>
-      </p:bgPr>
-    </p:bg>
-    <p:spTree>
-      <p:nvGrpSpPr>
-        <p:cNvPr id="1" name=""/>
-        <p:cNvGrpSpPr/>
-        <p:nvPr/>
-      </p:nvGrpSpPr>
-      <p:grpSpPr>
-        <a:xfrm>
-          <a:off x="0" y="0"/>
-          <a:ext cx="0" cy="0"/>
-          <a:chOff x="0" y="0"/>
-          <a:chExt cx="0" cy="0"/>
-        </a:xfrm>
-      </p:grpSpPr>
-      <p:sp>
-        <p:nvSpPr>
-          <p:cNvPr id="2" name="06 · PERIOPERATÓRIO"/>
-          <p:cNvSpPr txBox="1"/>
-          <p:nvPr/>
-        </p:nvSpPr>
-        <p:spPr>
-          <a:xfrm>
-            <a:off x="812800" y="800837"/>
-            <a:ext cx="10585450" cy="213320"/>
-          </a:xfrm>
-          <a:prstGeom prst="rect">
-            <a:avLst/>
-          </a:prstGeom>
-          <a:noFill/>
-          <a:ln/>
-        </p:spPr>
-        <p:txBody>
-          <a:bodyPr wrap="none" lIns="0" tIns="0" rIns="0" bIns="0" rtlCol="0" anchor="t"/>
-          <a:lstStyle/>
-          <a:p>
-            <a:pPr algn="l" indent="0" marL="0">
-              <a:lnSpc>
-                <a:spcPts val="1680"/>
-              </a:lnSpc>
-              <a:buNone/>
-            </a:pPr>
-            <a:r>
-              <a:rPr lang="pt-BR" altLang="en-US" sz="1200" b="1" spc="100" kern="0" dirty="0">
-                <a:solidFill>
-                  <a:srgbClr val="B9581A"/>
-                </a:solidFill>
-                <a:latin typeface="Calibri" pitchFamily="34" charset="0"/>
-                <a:ea typeface="Calibri" pitchFamily="34" charset="-122"/>
-                <a:cs typeface="Calibri" pitchFamily="34" charset="-120"/>
-              </a:rPr>
-              <a:t>06 · PERIOPERATÓRIO</a:t>
-            </a:r>
-            <a:endParaRPr lang="en-US" sz="1200" dirty="0"/>
-          </a:p>
-        </p:txBody>
-      </p:sp>
-      <p:sp>
-        <p:nvSpPr>
-          <p:cNvPr id="3" name="Text 0"/>
-          <p:cNvSpPr/>
-          <p:nvPr>
-            <p:ph type="title"/>
-          </p:nvPr>
-        </p:nvSpPr>
-        <p:spPr>
-          <a:xfrm>
-            <a:off x="812800" y="1135442"/>
-            <a:ext cx="10718800" cy="894080"/>
-          </a:xfrm>
-          <a:prstGeom prst="rect">
-            <a:avLst/>
-          </a:prstGeom>
-          <a:noFill/>
-          <a:ln/>
-        </p:spPr>
-        <p:txBody>
-          <a:bodyPr wrap="square" lIns="0" tIns="0" rIns="0" bIns="0" rtlCol="0" anchor="t"/>
-          <a:lstStyle/>
-          <a:p>
-            <a:pPr algn="l" indent="0" marL="0">
-              <a:lnSpc>
-                <a:spcPts val="3520"/>
-              </a:lnSpc>
-              <a:buNone/>
-            </a:pPr>
-            <a:r>
-              <a:rPr lang="pt-BR" altLang="en-US" sz="3200" dirty="0">
-                <a:solidFill>
-                  <a:srgbClr val="1B2A3A"/>
-                </a:solidFill>
-                <a:latin typeface="Georgia" pitchFamily="34" charset="0"/>
-                <a:ea typeface="Georgia" pitchFamily="34" charset="-122"/>
-                <a:cs typeface="Georgia" pitchFamily="34" charset="-120"/>
-              </a:rPr>
-              <a:t>Escolha da droga no intraoperatório</a:t>
-            </a:r>
-            <a:endParaRPr lang="en-US" sz="3200" dirty="0"/>
-          </a:p>
-        </p:txBody>
-      </p:sp>
-      <p:sp>
-        <p:nvSpPr>
-          <p:cNvPr id="4" name="Hipotensão"/>
-          <p:cNvSpPr/>
-          <p:nvPr/>
-        </p:nvSpPr>
-        <p:spPr>
-          <a:xfrm>
-            <a:off x="812800" y="1835051"/>
-            <a:ext cx="1005979" cy="391120"/>
-          </a:xfrm>
-          <a:prstGeom prst="roundRect">
-            <a:avLst>
-              <a:gd name="adj" fmla="val 19483"/>
-            </a:avLst>
-          </a:prstGeom>
-          <a:solidFill>
-            <a:srgbClr val="1B2A3A"/>
-          </a:solidFill>
-          <a:ln/>
-        </p:spPr>
-        <p:txBody>
-          <a:bodyPr wrap="none" lIns="139700" tIns="88900" rIns="139700" bIns="88900" rtlCol="0" anchor="ctr"/>
-          <a:lstStyle/>
-          <a:p>
-            <a:pPr algn="ctr" indent="0" marL="0">
-              <a:lnSpc>
-                <a:spcPts val="1680"/>
-              </a:lnSpc>
-              <a:buNone/>
-            </a:pPr>
-            <a:r>
-              <a:rPr lang="pt-BR" altLang="en-US" sz="1200" b="1" dirty="0">
-                <a:solidFill>
-                  <a:srgbClr val="F5F3EE"/>
-                </a:solidFill>
-                <a:latin typeface="Calibri" pitchFamily="34" charset="0"/>
-                <a:ea typeface="Calibri" pitchFamily="34" charset="-122"/>
-                <a:cs typeface="Calibri" pitchFamily="34" charset="-120"/>
-              </a:rPr>
-              <a:t>Hipotensão</a:t>
-            </a:r>
-            <a:endParaRPr lang="en-US" sz="1200" dirty="0"/>
-          </a:p>
-        </p:txBody>
-      </p:sp>
-      <p:sp>
-        <p:nvSpPr>
-          <p:cNvPr id="5" name="→"/>
-          <p:cNvSpPr txBox="1"/>
-          <p:nvPr/>
-        </p:nvSpPr>
-        <p:spPr>
-          <a:xfrm>
-            <a:off x="1920379" y="1902506"/>
-            <a:ext cx="272058" cy="279400"/>
-          </a:xfrm>
-          <a:prstGeom prst="rect">
-            <a:avLst/>
-          </a:prstGeom>
-          <a:noFill/>
-          <a:ln/>
-        </p:spPr>
-        <p:txBody>
-          <a:bodyPr wrap="none" lIns="0" tIns="0" rIns="0" bIns="0" rtlCol="0" anchor="t"/>
-          <a:lstStyle/>
-          <a:p>
-            <a:pPr algn="l" indent="0" marL="0">
-              <a:lnSpc>
-                <a:spcPts val="2200"/>
-              </a:lnSpc>
-              <a:buNone/>
-            </a:pPr>
-            <a:r>
-              <a:rPr lang="pt-BR" altLang="en-US" sz="2200" b="1" dirty="0">
-                <a:solidFill>
-                  <a:srgbClr val="B9581A"/>
-                </a:solidFill>
-                <a:latin typeface="Calibri" pitchFamily="34" charset="0"/>
-                <a:ea typeface="Calibri" pitchFamily="34" charset="-122"/>
-                <a:cs typeface="Calibri" pitchFamily="34" charset="-120"/>
-              </a:rPr>
-              <a:t>→</a:t>
-            </a:r>
-            <a:endParaRPr lang="en-US" sz="2200" dirty="0"/>
-          </a:p>
-        </p:txBody>
-      </p:sp>
-      <p:sp>
-        <p:nvSpPr>
-          <p:cNvPr id="6" name="Afastar plano profundo, hipovolemia, com"/>
-          <p:cNvSpPr/>
-          <p:nvPr/>
-        </p:nvSpPr>
-        <p:spPr>
-          <a:xfrm>
-            <a:off x="2274987" y="1828701"/>
-            <a:ext cx="5829399" cy="403820"/>
-          </a:xfrm>
-          <a:prstGeom prst="roundRect">
-            <a:avLst>
-              <a:gd name="adj" fmla="val 18870"/>
-            </a:avLst>
-          </a:prstGeom>
-          <a:solidFill>
-            <a:srgbClr val="FFFDF8"/>
-          </a:solidFill>
-          <a:ln w="6350">
-            <a:solidFill>
-              <a:srgbClr val="E2DDD2"/>
-            </a:solidFill>
-          </a:ln>
-        </p:spPr>
-        <p:txBody>
-          <a:bodyPr wrap="none" lIns="146050" tIns="95250" rIns="146050" bIns="95250" rtlCol="0" anchor="ctr"/>
-          <a:lstStyle/>
-          <a:p>
-            <a:pPr algn="ctr" indent="0" marL="0">
-              <a:lnSpc>
-                <a:spcPts val="1680"/>
-              </a:lnSpc>
-              <a:buNone/>
-            </a:pPr>
-            <a:r>
-              <a:rPr lang="pt-BR" altLang="en-US" sz="1200" b="1" dirty="0">
-                <a:solidFill>
-                  <a:srgbClr val="1B2A3A"/>
-                </a:solidFill>
-                <a:latin typeface="Calibri" pitchFamily="34" charset="0"/>
-                <a:ea typeface="Calibri" pitchFamily="34" charset="-122"/>
-                <a:cs typeface="Calibri" pitchFamily="34" charset="-120"/>
-              </a:rPr>
-              <a:t>Afastar plano profundo, hipovolemia, compressão aortocava, pneumotórax e anafilaxia</a:t>
-            </a:r>
-            <a:endParaRPr lang="en-US" sz="1200" dirty="0"/>
-          </a:p>
-        </p:txBody>
-      </p:sp>
-      <p:sp>
-        <p:nvSpPr>
-          <p:cNvPr id="7" name="→"/>
-          <p:cNvSpPr txBox="1"/>
-          <p:nvPr/>
-        </p:nvSpPr>
-        <p:spPr>
-          <a:xfrm>
-            <a:off x="8205986" y="1902506"/>
-            <a:ext cx="272058" cy="279400"/>
-          </a:xfrm>
-          <a:prstGeom prst="rect">
-            <a:avLst/>
-          </a:prstGeom>
-          <a:noFill/>
-          <a:ln/>
-        </p:spPr>
-        <p:txBody>
-          <a:bodyPr wrap="none" lIns="0" tIns="0" rIns="0" bIns="0" rtlCol="0" anchor="t"/>
-          <a:lstStyle/>
-          <a:p>
-            <a:pPr algn="l" indent="0" marL="0">
-              <a:lnSpc>
-                <a:spcPts val="2200"/>
-              </a:lnSpc>
-              <a:buNone/>
-            </a:pPr>
-            <a:r>
-              <a:rPr lang="pt-BR" altLang="en-US" sz="2200" b="1" dirty="0">
-                <a:solidFill>
-                  <a:srgbClr val="B9581A"/>
-                </a:solidFill>
-                <a:latin typeface="Calibri" pitchFamily="34" charset="0"/>
-                <a:ea typeface="Calibri" pitchFamily="34" charset="-122"/>
-                <a:cs typeface="Calibri" pitchFamily="34" charset="-120"/>
-              </a:rPr>
-              <a:t>→</a:t>
-            </a:r>
-            <a:endParaRPr lang="en-US" sz="2200" dirty="0"/>
-          </a:p>
-        </p:txBody>
-      </p:sp>
-      <p:sp>
-        <p:nvSpPr>
-          <p:cNvPr id="8" name="Qual mecanismo?"/>
-          <p:cNvSpPr/>
-          <p:nvPr/>
-        </p:nvSpPr>
-        <p:spPr>
-          <a:xfrm>
-            <a:off x="8560594" y="1835051"/>
-            <a:ext cx="1409105" cy="391120"/>
-          </a:xfrm>
-          <a:prstGeom prst="roundRect">
-            <a:avLst>
-              <a:gd name="adj" fmla="val 19483"/>
-            </a:avLst>
-          </a:prstGeom>
-          <a:solidFill>
-            <a:srgbClr val="1B2A3A"/>
-          </a:solidFill>
-          <a:ln/>
-        </p:spPr>
-        <p:txBody>
-          <a:bodyPr wrap="none" lIns="139700" tIns="88900" rIns="139700" bIns="88900" rtlCol="0" anchor="ctr"/>
-          <a:lstStyle/>
-          <a:p>
-            <a:pPr algn="ctr" indent="0" marL="0">
-              <a:lnSpc>
-                <a:spcPts val="1680"/>
-              </a:lnSpc>
-              <a:buNone/>
-            </a:pPr>
-            <a:r>
-              <a:rPr lang="pt-BR" altLang="en-US" sz="1200" b="1" dirty="0">
-                <a:solidFill>
-                  <a:srgbClr val="F5F3EE"/>
-                </a:solidFill>
-                <a:latin typeface="Calibri" pitchFamily="34" charset="0"/>
-                <a:ea typeface="Calibri" pitchFamily="34" charset="-122"/>
-                <a:cs typeface="Calibri" pitchFamily="34" charset="-120"/>
-              </a:rPr>
-              <a:t>Qual mecanismo?</a:t>
-            </a:r>
-            <a:endParaRPr lang="en-US" sz="1200" dirty="0"/>
-          </a:p>
-        </p:txBody>
-      </p:sp>
-      <p:sp>
-        <p:nvSpPr>
-          <p:cNvPr id="9" name="Cartão"/>
-          <p:cNvSpPr/>
-          <p:nvPr/>
-        </p:nvSpPr>
-        <p:spPr>
-          <a:xfrm>
-            <a:off x="812800" y="2486521"/>
-            <a:ext cx="2011660" cy="1740694"/>
-          </a:xfrm>
-          <a:prstGeom prst="roundRect">
-            <a:avLst>
-              <a:gd name="adj" fmla="val 4378"/>
-            </a:avLst>
-          </a:prstGeom>
-          <a:solidFill>
-            <a:srgbClr val="FFFDF8"/>
-          </a:solidFill>
-          <a:ln w="6350">
-            <a:solidFill>
-              <a:srgbClr val="E2DDD2"/>
-            </a:solidFill>
-            <a:prstDash val="solid"/>
-          </a:ln>
-        </p:spPr>
-      </p:sp>
-      <p:sp>
-        <p:nvSpPr>
-          <p:cNvPr id="10" name="Tônus baixo, FC normal ou alta"/>
-          <p:cNvSpPr/>
-          <p:nvPr/>
-        </p:nvSpPr>
-        <p:spPr>
-          <a:xfrm>
-            <a:off x="819150" y="2492871"/>
-            <a:ext cx="1998960" cy="573881"/>
-          </a:xfrm>
-          <a:prstGeom prst="roundRect">
-            <a:avLst>
-              <a:gd name="adj" fmla="val 13278"/>
-            </a:avLst>
-          </a:prstGeom>
-          <a:solidFill>
-            <a:srgbClr val="1B2A3A"/>
-          </a:solidFill>
-          <a:ln/>
-        </p:spPr>
-        <p:txBody>
-          <a:bodyPr wrap="square" lIns="127000" tIns="88900" rIns="127000" bIns="88900" rtlCol="0" anchor="t"/>
-          <a:lstStyle/>
-          <a:p>
-            <a:pPr algn="l" indent="0" marL="0">
-              <a:lnSpc>
-                <a:spcPts val="1560"/>
-              </a:lnSpc>
-              <a:buNone/>
-            </a:pPr>
-            <a:r>
-              <a:rPr lang="pt-BR" altLang="en-US" sz="1200" b="1" dirty="0">
-                <a:solidFill>
-                  <a:srgbClr val="F5F3EE"/>
-                </a:solidFill>
-                <a:latin typeface="Calibri" pitchFamily="34" charset="0"/>
-                <a:ea typeface="Calibri" pitchFamily="34" charset="-122"/>
-                <a:cs typeface="Calibri" pitchFamily="34" charset="-120"/>
-              </a:rPr>
-              <a:t>Tônus baixo, FC normal ou alta</a:t>
-            </a:r>
-            <a:endParaRPr lang="en-US" sz="1200" dirty="0"/>
-          </a:p>
-        </p:txBody>
-      </p:sp>
-      <p:sp>
-        <p:nvSpPr>
-          <p:cNvPr id="11" name="Fenilefrina 50–100 mcg ou NA 5–10 mcg; i"/>
-          <p:cNvSpPr txBox="1"/>
-          <p:nvPr/>
-        </p:nvSpPr>
-        <p:spPr>
-          <a:xfrm>
-            <a:off x="946150" y="3170165"/>
-            <a:ext cx="1764010" cy="694134"/>
-          </a:xfrm>
-          <a:prstGeom prst="rect">
-            <a:avLst/>
-          </a:prstGeom>
-          <a:noFill/>
-          <a:ln/>
-        </p:spPr>
-        <p:txBody>
-          <a:bodyPr wrap="square" lIns="0" tIns="0" rIns="0" bIns="0" rtlCol="0" anchor="t"/>
-          <a:lstStyle/>
-          <a:p>
-            <a:pPr algn="l" indent="0" marL="0">
-              <a:lnSpc>
-                <a:spcPts val="1823"/>
-              </a:lnSpc>
-              <a:buNone/>
-            </a:pPr>
-            <a:r>
-              <a:rPr lang="pt-BR" altLang="en-US" sz="1350" b="1" dirty="0">
-                <a:solidFill>
-                  <a:srgbClr val="1B2A3A"/>
-                </a:solidFill>
-                <a:latin typeface="Calibri" pitchFamily="34" charset="0"/>
-                <a:ea typeface="Calibri" pitchFamily="34" charset="-122"/>
-                <a:cs typeface="Calibri" pitchFamily="34" charset="-120"/>
-              </a:rPr>
-              <a:t>Fenilefrina 50–100 mcg ou NA 5–10 mcg; infusão se persistir</a:t>
-            </a:r>
-            <a:endParaRPr lang="en-US" sz="1350" dirty="0"/>
-          </a:p>
-        </p:txBody>
-      </p:sp>
-      <p:sp>
-        <p:nvSpPr>
-          <p:cNvPr id="12" name="Cartão"/>
-          <p:cNvSpPr/>
-          <p:nvPr/>
-        </p:nvSpPr>
-        <p:spPr>
-          <a:xfrm>
-            <a:off x="2951460" y="2486521"/>
-            <a:ext cx="2011660" cy="1740694"/>
-          </a:xfrm>
-          <a:prstGeom prst="roundRect">
-            <a:avLst>
-              <a:gd name="adj" fmla="val 4378"/>
-            </a:avLst>
-          </a:prstGeom>
-          <a:solidFill>
-            <a:srgbClr val="FFFDF8"/>
-          </a:solidFill>
-          <a:ln w="6350">
-            <a:solidFill>
-              <a:srgbClr val="E2DDD2"/>
-            </a:solidFill>
-            <a:prstDash val="solid"/>
-          </a:ln>
-        </p:spPr>
-      </p:sp>
-      <p:sp>
-        <p:nvSpPr>
-          <p:cNvPr id="13" name="Tônus baixo com bradicardia"/>
-          <p:cNvSpPr/>
-          <p:nvPr/>
-        </p:nvSpPr>
-        <p:spPr>
-          <a:xfrm>
-            <a:off x="2957810" y="2492871"/>
-            <a:ext cx="1998960" cy="573881"/>
-          </a:xfrm>
-          <a:prstGeom prst="roundRect">
-            <a:avLst>
-              <a:gd name="adj" fmla="val 13278"/>
-            </a:avLst>
-          </a:prstGeom>
-          <a:solidFill>
-            <a:srgbClr val="1B2A3A"/>
-          </a:solidFill>
-          <a:ln/>
-        </p:spPr>
-        <p:txBody>
-          <a:bodyPr wrap="square" lIns="127000" tIns="88900" rIns="127000" bIns="88900" rtlCol="0" anchor="t"/>
-          <a:lstStyle/>
-          <a:p>
-            <a:pPr algn="l" indent="0" marL="0">
-              <a:lnSpc>
-                <a:spcPts val="1560"/>
-              </a:lnSpc>
-              <a:buNone/>
-            </a:pPr>
-            <a:r>
-              <a:rPr lang="pt-BR" altLang="en-US" sz="1200" b="1" dirty="0">
-                <a:solidFill>
-                  <a:srgbClr val="F5F3EE"/>
-                </a:solidFill>
-                <a:latin typeface="Calibri" pitchFamily="34" charset="0"/>
-                <a:ea typeface="Calibri" pitchFamily="34" charset="-122"/>
-                <a:cs typeface="Calibri" pitchFamily="34" charset="-120"/>
-              </a:rPr>
-              <a:t>Tônus baixo com bradicardia</a:t>
-            </a:r>
-            <a:endParaRPr lang="en-US" sz="1200" dirty="0"/>
-          </a:p>
-        </p:txBody>
-      </p:sp>
-      <p:sp>
-        <p:nvSpPr>
-          <p:cNvPr id="14" name="Efedrina 5–10 mg; adrenalina se grave"/>
-          <p:cNvSpPr txBox="1"/>
-          <p:nvPr/>
-        </p:nvSpPr>
-        <p:spPr>
-          <a:xfrm>
-            <a:off x="3084810" y="3170165"/>
-            <a:ext cx="1764010" cy="462756"/>
-          </a:xfrm>
-          <a:prstGeom prst="rect">
-            <a:avLst/>
-          </a:prstGeom>
-          <a:noFill/>
-          <a:ln/>
-        </p:spPr>
-        <p:txBody>
-          <a:bodyPr wrap="square" lIns="0" tIns="0" rIns="0" bIns="0" rtlCol="0" anchor="t"/>
-          <a:lstStyle/>
-          <a:p>
-            <a:pPr algn="l" indent="0" marL="0">
-              <a:lnSpc>
-                <a:spcPts val="1823"/>
-              </a:lnSpc>
-              <a:buNone/>
-            </a:pPr>
-            <a:r>
-              <a:rPr lang="pt-BR" altLang="en-US" sz="1350" b="1" dirty="0">
-                <a:solidFill>
-                  <a:srgbClr val="1B2A3A"/>
-                </a:solidFill>
-                <a:latin typeface="Calibri" pitchFamily="34" charset="0"/>
-                <a:ea typeface="Calibri" pitchFamily="34" charset="-122"/>
-                <a:cs typeface="Calibri" pitchFamily="34" charset="-120"/>
-              </a:rPr>
-              <a:t>Efedrina 5–10 mg; adrenalina se grave</a:t>
-            </a:r>
-            <a:endParaRPr lang="en-US" sz="1350" dirty="0"/>
-          </a:p>
-        </p:txBody>
-      </p:sp>
-      <p:sp>
-        <p:nvSpPr>
-          <p:cNvPr id="15" name="Cartão"/>
-          <p:cNvSpPr/>
-          <p:nvPr/>
-        </p:nvSpPr>
-        <p:spPr>
-          <a:xfrm>
-            <a:off x="5090120" y="2486521"/>
-            <a:ext cx="2011660" cy="1740694"/>
-          </a:xfrm>
-          <a:prstGeom prst="roundRect">
-            <a:avLst>
-              <a:gd name="adj" fmla="val 4378"/>
-            </a:avLst>
-          </a:prstGeom>
-          <a:solidFill>
-            <a:srgbClr val="FFFDF8"/>
-          </a:solidFill>
-          <a:ln w="6350">
-            <a:solidFill>
-              <a:srgbClr val="E2DDD2"/>
-            </a:solidFill>
-            <a:prstDash val="solid"/>
-          </a:ln>
-        </p:spPr>
-      </p:sp>
-      <p:sp>
-        <p:nvSpPr>
-          <p:cNvPr id="16" name="Baixo débito com hipoperfusão"/>
-          <p:cNvSpPr/>
-          <p:nvPr/>
-        </p:nvSpPr>
-        <p:spPr>
-          <a:xfrm>
-            <a:off x="5096470" y="2492871"/>
-            <a:ext cx="1998960" cy="573881"/>
-          </a:xfrm>
-          <a:prstGeom prst="roundRect">
-            <a:avLst>
-              <a:gd name="adj" fmla="val 13278"/>
-            </a:avLst>
-          </a:prstGeom>
-          <a:solidFill>
-            <a:srgbClr val="1B2A3A"/>
-          </a:solidFill>
-          <a:ln/>
-        </p:spPr>
-        <p:txBody>
-          <a:bodyPr wrap="square" lIns="127000" tIns="88900" rIns="127000" bIns="88900" rtlCol="0" anchor="t"/>
-          <a:lstStyle/>
-          <a:p>
-            <a:pPr algn="l" indent="0" marL="0">
-              <a:lnSpc>
-                <a:spcPts val="1560"/>
-              </a:lnSpc>
-              <a:buNone/>
-            </a:pPr>
-            <a:r>
-              <a:rPr lang="pt-BR" altLang="en-US" sz="1200" b="1" dirty="0">
-                <a:solidFill>
-                  <a:srgbClr val="F5F3EE"/>
-                </a:solidFill>
-                <a:latin typeface="Calibri" pitchFamily="34" charset="0"/>
-                <a:ea typeface="Calibri" pitchFamily="34" charset="-122"/>
-                <a:cs typeface="Calibri" pitchFamily="34" charset="-120"/>
-              </a:rPr>
-              <a:t>Baixo débito com hipoperfusão</a:t>
-            </a:r>
-            <a:endParaRPr lang="en-US" sz="1200" dirty="0"/>
-          </a:p>
-        </p:txBody>
-      </p:sp>
-      <p:sp>
-        <p:nvSpPr>
-          <p:cNvPr id="17" name="Dobutamina; milrinona no VD com hiperten"/>
-          <p:cNvSpPr txBox="1"/>
-          <p:nvPr/>
-        </p:nvSpPr>
-        <p:spPr>
-          <a:xfrm>
-            <a:off x="5223470" y="3170165"/>
-            <a:ext cx="1764010" cy="925512"/>
-          </a:xfrm>
-          <a:prstGeom prst="rect">
-            <a:avLst/>
-          </a:prstGeom>
-          <a:noFill/>
-          <a:ln/>
-        </p:spPr>
-        <p:txBody>
-          <a:bodyPr wrap="square" lIns="0" tIns="0" rIns="0" bIns="0" rtlCol="0" anchor="t"/>
-          <a:lstStyle/>
-          <a:p>
-            <a:pPr algn="l" indent="0" marL="0">
-              <a:lnSpc>
-                <a:spcPts val="1823"/>
-              </a:lnSpc>
-              <a:buNone/>
-            </a:pPr>
-            <a:r>
-              <a:rPr lang="pt-BR" altLang="en-US" sz="1350" b="1" dirty="0">
-                <a:solidFill>
-                  <a:srgbClr val="1B2A3A"/>
-                </a:solidFill>
-                <a:latin typeface="Calibri" pitchFamily="34" charset="0"/>
-                <a:ea typeface="Calibri" pitchFamily="34" charset="-122"/>
-                <a:cs typeface="Calibri" pitchFamily="34" charset="-120"/>
-              </a:rPr>
-              <a:t>Dobutamina; milrinona no VD com hipertensão pulmonar; NA se a PAM cair</a:t>
-            </a:r>
-            <a:endParaRPr lang="en-US" sz="1350" dirty="0"/>
-          </a:p>
-        </p:txBody>
-      </p:sp>
-      <p:sp>
-        <p:nvSpPr>
-          <p:cNvPr id="18" name="Cartão"/>
-          <p:cNvSpPr/>
-          <p:nvPr/>
-        </p:nvSpPr>
-        <p:spPr>
-          <a:xfrm>
-            <a:off x="7228780" y="2486521"/>
-            <a:ext cx="2011660" cy="1740694"/>
-          </a:xfrm>
-          <a:prstGeom prst="roundRect">
-            <a:avLst>
-              <a:gd name="adj" fmla="val 4378"/>
-            </a:avLst>
-          </a:prstGeom>
-          <a:solidFill>
-            <a:srgbClr val="FFFDF8"/>
-          </a:solidFill>
-          <a:ln w="6350">
-            <a:solidFill>
-              <a:srgbClr val="E2DDD2"/>
-            </a:solidFill>
-            <a:prstDash val="solid"/>
-          </a:ln>
-        </p:spPr>
-      </p:sp>
-      <p:sp>
-        <p:nvSpPr>
-          <p:cNvPr id="19" name="Vasoplegia refratária"/>
-          <p:cNvSpPr/>
-          <p:nvPr/>
-        </p:nvSpPr>
-        <p:spPr>
-          <a:xfrm>
-            <a:off x="7235130" y="2492871"/>
-            <a:ext cx="1998960" cy="571500"/>
-          </a:xfrm>
-          <a:prstGeom prst="roundRect">
-            <a:avLst>
-              <a:gd name="adj" fmla="val 13333"/>
-            </a:avLst>
-          </a:prstGeom>
-          <a:solidFill>
-            <a:srgbClr val="1B2A3A"/>
-          </a:solidFill>
-          <a:ln/>
-        </p:spPr>
-        <p:txBody>
-          <a:bodyPr wrap="square" lIns="127000" tIns="88900" rIns="127000" bIns="88900" rtlCol="0" anchor="t"/>
-          <a:lstStyle/>
-          <a:p>
-            <a:pPr algn="l" indent="0" marL="0">
-              <a:lnSpc>
-                <a:spcPts val="1560"/>
-              </a:lnSpc>
-              <a:buNone/>
-            </a:pPr>
-            <a:r>
-              <a:rPr lang="pt-BR" altLang="en-US" sz="1200" b="1" dirty="0">
-                <a:solidFill>
-                  <a:srgbClr val="F5F3EE"/>
-                </a:solidFill>
-                <a:latin typeface="Calibri" pitchFamily="34" charset="0"/>
-                <a:ea typeface="Calibri" pitchFamily="34" charset="-122"/>
-                <a:cs typeface="Calibri" pitchFamily="34" charset="-120"/>
-              </a:rPr>
-              <a:t>Vasoplegia refratária</a:t>
-            </a:r>
-            <a:endParaRPr lang="en-US" sz="1200" dirty="0"/>
-          </a:p>
-        </p:txBody>
-      </p:sp>
-      <p:sp>
-        <p:nvSpPr>
-          <p:cNvPr id="20" name="Vasopressina; azul de metileno como resg"/>
-          <p:cNvSpPr txBox="1"/>
-          <p:nvPr/>
-        </p:nvSpPr>
-        <p:spPr>
-          <a:xfrm>
-            <a:off x="7362130" y="3167784"/>
-            <a:ext cx="1764010" cy="925512"/>
-          </a:xfrm>
-          <a:prstGeom prst="rect">
-            <a:avLst/>
-          </a:prstGeom>
-          <a:noFill/>
-          <a:ln/>
-        </p:spPr>
-        <p:txBody>
-          <a:bodyPr wrap="square" lIns="0" tIns="0" rIns="0" bIns="0" rtlCol="0" anchor="t"/>
-          <a:lstStyle/>
-          <a:p>
-            <a:pPr algn="l" indent="0" marL="0">
-              <a:lnSpc>
-                <a:spcPts val="1823"/>
-              </a:lnSpc>
-              <a:buNone/>
-            </a:pPr>
-            <a:r>
-              <a:rPr lang="pt-BR" altLang="en-US" sz="1350" b="1" dirty="0">
-                <a:solidFill>
-                  <a:srgbClr val="1B2A3A"/>
-                </a:solidFill>
-                <a:latin typeface="Calibri" pitchFamily="34" charset="0"/>
-                <a:ea typeface="Calibri" pitchFamily="34" charset="-122"/>
-                <a:cs typeface="Calibri" pitchFamily="34" charset="-120"/>
-              </a:rPr>
-              <a:t>Vasopressina; azul de metileno como resgate (pós-CEC, IECA/BRA, reperfusão hepática)</a:t>
-            </a:r>
-            <a:endParaRPr lang="en-US" sz="1350" dirty="0"/>
-          </a:p>
-        </p:txBody>
-      </p:sp>
-      <p:sp>
-        <p:nvSpPr>
-          <p:cNvPr id="21" name="Cartão"/>
-          <p:cNvSpPr/>
-          <p:nvPr/>
-        </p:nvSpPr>
-        <p:spPr>
-          <a:xfrm>
-            <a:off x="9367441" y="2486521"/>
-            <a:ext cx="2011660" cy="1740694"/>
-          </a:xfrm>
-          <a:prstGeom prst="roundRect">
-            <a:avLst>
-              <a:gd name="adj" fmla="val 4378"/>
-            </a:avLst>
-          </a:prstGeom>
-          <a:solidFill>
-            <a:srgbClr val="FFFDF8"/>
-          </a:solidFill>
-          <a:ln w="6350">
-            <a:solidFill>
-              <a:srgbClr val="E2DDD2"/>
-            </a:solidFill>
-            <a:prstDash val="solid"/>
-          </a:ln>
-        </p:spPr>
-      </p:sp>
-      <p:sp>
-        <p:nvSpPr>
-          <p:cNvPr id="22" name="Pré-carga baixa"/>
-          <p:cNvSpPr/>
-          <p:nvPr/>
-        </p:nvSpPr>
-        <p:spPr>
-          <a:xfrm>
-            <a:off x="9373791" y="2492871"/>
-            <a:ext cx="1998960" cy="571500"/>
-          </a:xfrm>
-          <a:prstGeom prst="roundRect">
-            <a:avLst>
-              <a:gd name="adj" fmla="val 13333"/>
-            </a:avLst>
-          </a:prstGeom>
-          <a:solidFill>
-            <a:srgbClr val="1B2A3A"/>
-          </a:solidFill>
-          <a:ln/>
-        </p:spPr>
-        <p:txBody>
-          <a:bodyPr wrap="square" lIns="127000" tIns="88900" rIns="127000" bIns="88900" rtlCol="0" anchor="t"/>
-          <a:lstStyle/>
-          <a:p>
-            <a:pPr algn="l" indent="0" marL="0">
-              <a:lnSpc>
-                <a:spcPts val="1560"/>
-              </a:lnSpc>
-              <a:buNone/>
-            </a:pPr>
-            <a:r>
-              <a:rPr lang="pt-BR" altLang="en-US" sz="1200" b="1" dirty="0">
-                <a:solidFill>
-                  <a:srgbClr val="F5F3EE"/>
-                </a:solidFill>
-                <a:latin typeface="Calibri" pitchFamily="34" charset="0"/>
-                <a:ea typeface="Calibri" pitchFamily="34" charset="-122"/>
-                <a:cs typeface="Calibri" pitchFamily="34" charset="-120"/>
-              </a:rPr>
-              <a:t>Pré-carga baixa</a:t>
-            </a:r>
-            <a:endParaRPr lang="en-US" sz="1200" dirty="0"/>
-          </a:p>
-        </p:txBody>
-      </p:sp>
-      <p:sp>
-        <p:nvSpPr>
-          <p:cNvPr id="23" name="Volume, se o débito responde"/>
-          <p:cNvSpPr txBox="1"/>
-          <p:nvPr/>
-        </p:nvSpPr>
-        <p:spPr>
-          <a:xfrm>
-            <a:off x="9500791" y="3167784"/>
-            <a:ext cx="1764010" cy="462756"/>
-          </a:xfrm>
-          <a:prstGeom prst="rect">
-            <a:avLst/>
-          </a:prstGeom>
-          <a:noFill/>
-          <a:ln/>
-        </p:spPr>
-        <p:txBody>
-          <a:bodyPr wrap="square" lIns="0" tIns="0" rIns="0" bIns="0" rtlCol="0" anchor="t"/>
-          <a:lstStyle/>
-          <a:p>
-            <a:pPr algn="l" indent="0" marL="0">
-              <a:lnSpc>
-                <a:spcPts val="1823"/>
-              </a:lnSpc>
-              <a:buNone/>
-            </a:pPr>
-            <a:r>
-              <a:rPr lang="pt-BR" altLang="en-US" sz="1350" b="1" dirty="0">
-                <a:solidFill>
-                  <a:srgbClr val="1B2A3A"/>
-                </a:solidFill>
-                <a:latin typeface="Calibri" pitchFamily="34" charset="0"/>
-                <a:ea typeface="Calibri" pitchFamily="34" charset="-122"/>
-                <a:cs typeface="Calibri" pitchFamily="34" charset="-120"/>
-              </a:rPr>
-              <a:t>Volume, se o débito responde</a:t>
-            </a:r>
-            <a:endParaRPr lang="en-US" sz="1350" dirty="0"/>
-          </a:p>
-        </p:txBody>
-      </p:sp>
-      <p:sp>
-        <p:nvSpPr>
-          <p:cNvPr id="24" name="Transplante hepático (UFRJ): em 19 pacie"/>
-          <p:cNvSpPr txBox="1"/>
-          <p:nvPr/>
-        </p:nvSpPr>
-        <p:spPr>
-          <a:xfrm>
-            <a:off x="812800" y="4468254"/>
-            <a:ext cx="10585450" cy="693241"/>
-          </a:xfrm>
-          <a:prstGeom prst="rect">
-            <a:avLst/>
-          </a:prstGeom>
-          <a:noFill/>
-          <a:ln/>
-        </p:spPr>
-        <p:txBody>
-          <a:bodyPr wrap="square" lIns="0" tIns="0" rIns="0" bIns="0" rtlCol="0" anchor="t"/>
-          <a:lstStyle/>
-          <a:p>
-            <a:pPr algn="l" indent="0" marL="0">
-              <a:lnSpc>
-                <a:spcPts val="1820"/>
-              </a:lnSpc>
-              <a:buNone/>
-            </a:pPr>
-            <a:r>
-              <a:rPr lang="pt-BR" altLang="en-US" sz="1300" b="1" dirty="0">
-                <a:solidFill>
-                  <a:srgbClr val="2C3A48"/>
-                </a:solidFill>
-                <a:latin typeface="Calibri" pitchFamily="34" charset="0"/>
-                <a:ea typeface="Calibri" pitchFamily="34" charset="-122"/>
-                <a:cs typeface="Calibri" pitchFamily="34" charset="-120"/>
-              </a:rPr>
-              <a:t>Transplante hepático (UFRJ):</a:t>
-            </a:r>
-            <a:r>
-              <a:rPr lang="pt-BR" altLang="en-US" sz="1300" dirty="0">
-                <a:solidFill>
-                  <a:srgbClr val="2C3A48"/>
-                </a:solidFill>
-                <a:latin typeface="Calibri" pitchFamily="34" charset="0"/>
-                <a:ea typeface="Calibri" pitchFamily="34" charset="-122"/>
-                <a:cs typeface="Calibri" pitchFamily="34" charset="-120"/>
-              </a:rPr>
-              <a:t> em 19 pacientes selecionados, a função sistólica do VD ao ETE manteve-se preservada nos momentos avaliados, inclusive 30 min após a reperfusão. O estudo não mediu os primeiros minutos da reperfusão nem a causa da instabilidade aguda; a lição é usar o eco para separar disfunção de VD de vasoplegia antes de escolher entre inotrópico e vasopressor (Gouvêa et al., PLoS One 2022).</a:t>
-            </a:r>
-            <a:endParaRPr lang="en-US" sz="1300" dirty="0"/>
-          </a:p>
-        </p:txBody>
-      </p:sp>
-      <p:sp>
-        <p:nvSpPr>
-          <p:cNvPr id="25" name="Gouvêa, PLoS One 2022 · Hajjar, Anesthes"/>
-          <p:cNvSpPr txBox="1"/>
-          <p:nvPr/>
-        </p:nvSpPr>
-        <p:spPr>
-          <a:xfrm>
-            <a:off x="812800" y="6226316"/>
-            <a:ext cx="10433050" cy="213320"/>
-          </a:xfrm>
-          <a:prstGeom prst="rect">
-            <a:avLst/>
-          </a:prstGeom>
-          <a:noFill/>
-          <a:ln/>
-        </p:spPr>
-        <p:txBody>
-          <a:bodyPr wrap="none" lIns="0" tIns="0" rIns="0" bIns="0" rtlCol="0" anchor="t"/>
-          <a:lstStyle/>
-          <a:p>
-            <a:pPr algn="l" indent="0" marL="0">
-              <a:lnSpc>
-                <a:spcPts val="1680"/>
-              </a:lnSpc>
-              <a:buNone/>
-            </a:pPr>
-            <a:r>
-              <a:rPr lang="pt-BR" altLang="en-US" sz="1200" dirty="0">
-                <a:solidFill>
-                  <a:srgbClr val="56606B"/>
-                </a:solidFill>
-                <a:latin typeface="Calibri" pitchFamily="34" charset="0"/>
-                <a:ea typeface="Calibri" pitchFamily="34" charset="-122"/>
-                <a:cs typeface="Calibri" pitchFamily="34" charset="-120"/>
-              </a:rPr>
-              <a:t>Gouvêa, PLoS One 2022 · Hajjar, Anesthesiology 2017 (VANCS) · Miller’s Anesthesia, 10ª ed. (2025), cap. 33, 56</a:t>
-            </a:r>
-            <a:endParaRPr lang="en-US" sz="1200" dirty="0"/>
-          </a:p>
-        </p:txBody>
-      </p:sp>
-      <p:pic>
-        <p:nvPicPr>
-          <p:cNvPr id="26" name="Símbolo da UFRJ" descr="Símbolo da UFRJ">    </p:cNvPr>
-          <p:cNvPicPr>
-            <a:picLocks noChangeAspect="1"/>
-          </p:cNvPicPr>
-          <p:nvPr/>
-        </p:nvPicPr>
-        <p:blipFill>
-          <a:blip r:embed="rId1"/>
-          <a:stretch>
-            <a:fillRect/>
-          </a:stretch>
-        </p:blipFill>
-        <p:spPr>
-          <a:xfrm>
-            <a:off x="11430000" y="5894381"/>
-            <a:ext cx="508000" cy="758838"/>
-          </a:xfrm>
-          <a:prstGeom prst="rect">
-            <a:avLst/>
-          </a:prstGeom>
-        </p:spPr>
-      </p:pic>
-    </p:spTree>
-  </p:cSld>
-  <p:clrMapOvr>
-    <a:masterClrMapping/>
-  </p:clrMapOvr>
-  <p:transition spd="med">
-    <p:fade/>
-  </p:transition>
-</p:sld>
-</file>
-
-<file path=ppt/slides/slide15.xml><?xml version="1.0" encoding="utf-8"?>
-<p:sld xmlns:a="http://schemas.openxmlformats.org/drawingml/2006/main" xmlns:r="http://schemas.openxmlformats.org/officeDocument/2006/relationships" xmlns:p="http://schemas.openxmlformats.org/presentationml/2006/main">
-  <p:cSld name="Slide 15">
-    <p:bg>
-      <p:bgPr>
-        <a:solidFill>
-          <a:srgbClr val="F5F3EE"/>
-        </a:solidFill>
-      </p:bgPr>
-    </p:bg>
-    <p:spTree>
-      <p:nvGrpSpPr>
-        <p:cNvPr id="1" name=""/>
-        <p:cNvGrpSpPr/>
-        <p:nvPr/>
-      </p:nvGrpSpPr>
-      <p:grpSpPr>
-        <a:xfrm>
-          <a:off x="0" y="0"/>
-          <a:ext cx="0" cy="0"/>
-          <a:chOff x="0" y="0"/>
-          <a:chExt cx="0" cy="0"/>
-        </a:xfrm>
-      </p:grpSpPr>
-      <p:sp>
-        <p:nvSpPr>
-          <p:cNvPr id="2" name="07 · MENSAGENS FINAIS"/>
-          <p:cNvSpPr txBox="1"/>
-          <p:nvPr/>
-        </p:nvSpPr>
-        <p:spPr>
-          <a:xfrm>
-            <a:off x="812800" y="800837"/>
-            <a:ext cx="10585450" cy="213320"/>
-          </a:xfrm>
-          <a:prstGeom prst="rect">
-            <a:avLst/>
-          </a:prstGeom>
-          <a:noFill/>
-          <a:ln/>
-        </p:spPr>
-        <p:txBody>
-          <a:bodyPr wrap="none" lIns="0" tIns="0" rIns="0" bIns="0" rtlCol="0" anchor="t"/>
-          <a:lstStyle/>
-          <a:p>
-            <a:pPr algn="l" indent="0" marL="0">
-              <a:lnSpc>
-                <a:spcPts val="1680"/>
-              </a:lnSpc>
-              <a:buNone/>
-            </a:pPr>
-            <a:r>
-              <a:rPr lang="pt-BR" altLang="en-US" sz="1200" b="1" spc="100" kern="0" dirty="0">
-                <a:solidFill>
-                  <a:srgbClr val="B9581A"/>
-                </a:solidFill>
-                <a:latin typeface="Calibri" pitchFamily="34" charset="0"/>
-                <a:ea typeface="Calibri" pitchFamily="34" charset="-122"/>
-                <a:cs typeface="Calibri" pitchFamily="34" charset="-120"/>
-              </a:rPr>
-              <a:t>07 · MENSAGENS FINAIS</a:t>
-            </a:r>
-            <a:endParaRPr lang="en-US" sz="1200" dirty="0"/>
-          </a:p>
-        </p:txBody>
-      </p:sp>
-      <p:sp>
-        <p:nvSpPr>
-          <p:cNvPr id="3" name="Text 0"/>
-          <p:cNvSpPr/>
-          <p:nvPr>
-            <p:ph type="title"/>
-          </p:nvPr>
-        </p:nvSpPr>
-        <p:spPr>
-          <a:xfrm>
-            <a:off x="812800" y="1135442"/>
-            <a:ext cx="10718800" cy="894080"/>
-          </a:xfrm>
-          <a:prstGeom prst="rect">
-            <a:avLst/>
-          </a:prstGeom>
-          <a:noFill/>
-          <a:ln/>
-        </p:spPr>
-        <p:txBody>
-          <a:bodyPr wrap="square" lIns="0" tIns="0" rIns="0" bIns="0" rtlCol="0" anchor="t"/>
-          <a:lstStyle/>
-          <a:p>
-            <a:pPr algn="l" indent="0" marL="0">
-              <a:lnSpc>
-                <a:spcPts val="3520"/>
-              </a:lnSpc>
-              <a:buNone/>
-            </a:pPr>
-            <a:r>
-              <a:rPr lang="pt-BR" altLang="en-US" sz="3200" dirty="0">
-                <a:solidFill>
-                  <a:srgbClr val="1B2A3A"/>
-                </a:solidFill>
-                <a:latin typeface="Georgia" pitchFamily="34" charset="0"/>
-                <a:ea typeface="Georgia" pitchFamily="34" charset="-122"/>
-                <a:cs typeface="Georgia" pitchFamily="34" charset="-120"/>
-              </a:rPr>
-              <a:t>Problema hemodinâmico e droga de escolha</a:t>
-            </a:r>
-            <a:endParaRPr lang="en-US" sz="3200" dirty="0"/>
-          </a:p>
-        </p:txBody>
-      </p:sp>
-      <p:graphicFrame>
-        <p:nvGraphicFramePr>
-          <p:cNvPr id="4" name="Tabela"/>
-          <p:cNvGraphicFramePr>
-            <a:graphicFrameLocks noGrp="1"/>
-          </p:cNvGraphicFramePr>
-          <p:nvPr>
-            <p:extLst>
-              <p:ext uri="{D42A27DB-BD31-4B8C-83A1-F6EECF244321}">
-                <p14:modId xmlns:p14="http://schemas.microsoft.com/office/powerpoint/2010/main" val="1579011935"/>
-              </p:ext>
-            </p:extLst>
-          </p:nvPr>
-        </p:nvGraphicFramePr>
-        <p:xfrm>
-          <a:off x="812800" y="1879501"/>
-          <a:ext cx="10566400" cy="914400"/>
-        </p:xfrm>
-        <a:graphic>
-          <a:graphicData uri="http://schemas.openxmlformats.org/drawingml/2006/table">
-            <a:tbl>
-              <a:tblPr/>
-              <a:tblGrid>
-                <a:gridCol w="3592513"/>
-                <a:gridCol w="6973888"/>
-              </a:tblGrid>
-              <a:tr h="417810">
-                <a:tc>
-                  <a:txBody>
-                    <a:bodyPr/>
-                    <a:lstStyle/>
-                    <a:p>
-                      <a:pPr algn="l" indent="0" marL="0">
-                        <a:lnSpc>
-                          <a:spcPts val="1890"/>
-                        </a:lnSpc>
-                        <a:buNone/>
-                      </a:pPr>
-                      <a:r>
-                        <a:rPr lang="pt-BR" altLang="en-US" sz="1350" b="1" dirty="0">
-                          <a:solidFill>
-                            <a:srgbClr val="F5F3EE"/>
-                          </a:solidFill>
-                          <a:latin typeface="Calibri" pitchFamily="34" charset="0"/>
-                          <a:ea typeface="Calibri" pitchFamily="34" charset="-122"/>
-                          <a:cs typeface="Calibri" pitchFamily="34" charset="-120"/>
-                        </a:rPr>
-                        <a:t>Problema</a:t>
-                      </a:r>
-                      <a:endParaRPr lang="en-US" sz="1200" dirty="0"/>
-                    </a:p>
-                  </a:txBody>
-                  <a:tcPr marL="127000" marR="127000" marT="88900" marB="88900" anchor="ctr">
-                    <a:lnL w="0" cap="flat" cmpd="sng" algn="ctr">
-                      <a:noFill/>
-                    </a:lnL>
-                    <a:lnR w="0" cap="flat" cmpd="sng" algn="ctr">
-                      <a:noFill/>
-                    </a:lnR>
-                    <a:lnT w="0" cap="flat" cmpd="sng" algn="ctr">
-                      <a:noFill/>
-                    </a:lnT>
-                    <a:lnB w="0" cap="flat" cmpd="sng" algn="ctr">
-                      <a:noFill/>
-                    </a:lnB>
-                    <a:solidFill>
-                      <a:srgbClr val="1B2A3A"/>
-                    </a:solidFill>
-                  </a:tcPr>
-                </a:tc>
-                <a:tc>
-                  <a:txBody>
-                    <a:bodyPr/>
-                    <a:lstStyle/>
-                    <a:p>
-                      <a:pPr algn="l" indent="0" marL="0">
-                        <a:lnSpc>
-                          <a:spcPts val="1890"/>
-                        </a:lnSpc>
-                        <a:buNone/>
-                      </a:pPr>
-                      <a:r>
-                        <a:rPr lang="pt-BR" altLang="en-US" sz="1350" b="1" dirty="0">
-                          <a:solidFill>
-                            <a:srgbClr val="F5F3EE"/>
-                          </a:solidFill>
-                          <a:latin typeface="Calibri" pitchFamily="34" charset="0"/>
-                          <a:ea typeface="Calibri" pitchFamily="34" charset="-122"/>
-                          <a:cs typeface="Calibri" pitchFamily="34" charset="-120"/>
-                        </a:rPr>
-                        <a:t>Conduta</a:t>
-                      </a:r>
-                      <a:endParaRPr lang="en-US" sz="1200" dirty="0"/>
-                    </a:p>
-                  </a:txBody>
-                  <a:tcPr marL="127000" marR="127000" marT="88900" marB="88900" anchor="ctr">
-                    <a:lnL w="0" cap="flat" cmpd="sng" algn="ctr">
-                      <a:noFill/>
-                    </a:lnL>
-                    <a:lnR w="0" cap="flat" cmpd="sng" algn="ctr">
-                      <a:noFill/>
-                    </a:lnR>
-                    <a:lnT w="0" cap="flat" cmpd="sng" algn="ctr">
-                      <a:noFill/>
-                    </a:lnT>
-                    <a:lnB w="0" cap="flat" cmpd="sng" algn="ctr">
-                      <a:noFill/>
-                    </a:lnB>
-                    <a:solidFill>
-                      <a:srgbClr val="1B2A3A"/>
-                    </a:solidFill>
-                  </a:tcPr>
-                </a:tc>
-              </a:tr>
-            </a:tbl>
-          </a:graphicData>
-        </a:graphic>
-      </p:graphicFrame>
-      <p:graphicFrame>
-        <p:nvGraphicFramePr>
-          <p:cNvPr id="5" name="Tabela"/>
-          <p:cNvGraphicFramePr>
-            <a:graphicFrameLocks noGrp="1"/>
-          </p:cNvGraphicFramePr>
-          <p:nvPr>
-            <p:extLst>
-              <p:ext uri="{D42A27DB-BD31-4B8C-83A1-F6EECF244321}">
-                <p14:modId xmlns:p14="http://schemas.microsoft.com/office/powerpoint/2010/main" val="1579011935"/>
-              </p:ext>
-            </p:extLst>
-          </p:nvPr>
-        </p:nvGraphicFramePr>
-        <p:xfrm>
-          <a:off x="812800" y="2297311"/>
-          <a:ext cx="10566400" cy="914400"/>
-        </p:xfrm>
-        <a:graphic>
-          <a:graphicData uri="http://schemas.openxmlformats.org/drawingml/2006/table">
-            <a:tbl>
-              <a:tblPr/>
-              <a:tblGrid>
-                <a:gridCol w="3592513"/>
-                <a:gridCol w="6973888"/>
-              </a:tblGrid>
-              <a:tr h="420985">
-                <a:tc>
-                  <a:txBody>
-                    <a:bodyPr/>
-                    <a:lstStyle/>
-                    <a:p>
-                      <a:pPr algn="l" indent="0" marL="0">
-                        <a:lnSpc>
-                          <a:spcPts val="1890"/>
-                        </a:lnSpc>
-                        <a:buNone/>
-                      </a:pPr>
-                      <a:r>
-                        <a:rPr lang="pt-BR" altLang="en-US" sz="1350" b="1" dirty="0">
-                          <a:solidFill>
-                            <a:srgbClr val="1B2A3A"/>
-                          </a:solidFill>
-                          <a:latin typeface="Calibri" pitchFamily="34" charset="0"/>
-                          <a:ea typeface="Calibri" pitchFamily="34" charset="-122"/>
-                          <a:cs typeface="Calibri" pitchFamily="34" charset="-120"/>
-                        </a:rPr>
-                        <a:t>Vasoplegia</a:t>
-                      </a:r>
-                      <a:endParaRPr lang="en-US" sz="1200" dirty="0"/>
-                    </a:p>
-                  </a:txBody>
-                  <a:tcPr marL="127000" marR="127000" marT="88900" marB="88900" anchor="ctr">
-                    <a:lnL w="0" cap="flat" cmpd="sng" algn="ctr">
-                      <a:noFill/>
-                    </a:lnL>
-                    <a:lnR w="0" cap="flat" cmpd="sng" algn="ctr">
-                      <a:noFill/>
-                    </a:lnR>
-                    <a:lnT w="0" cap="flat" cmpd="sng" algn="ctr">
-                      <a:noFill/>
-                    </a:lnT>
-                    <a:lnB w="6350" cap="flat" cmpd="sng" algn="ctr">
-                      <a:solidFill>
-                        <a:srgbClr val="E2DDD2"/>
-                      </a:solidFill>
-                      <a:prstDash val="solid"/>
-                      <a:round/>
-                      <a:headEnd type="none" w="med" len="med"/>
-                      <a:tailEnd type="none" w="med" len="med"/>
-                    </a:lnB>
-                  </a:tcPr>
-                </a:tc>
-                <a:tc>
-                  <a:txBody>
-                    <a:bodyPr/>
-                    <a:lstStyle/>
-                    <a:p>
-                      <a:pPr algn="l" indent="0" marL="0">
-                        <a:lnSpc>
-                          <a:spcPts val="1890"/>
-                        </a:lnSpc>
-                        <a:buNone/>
-                      </a:pPr>
-                      <a:r>
-                        <a:rPr lang="pt-BR" altLang="en-US" sz="1350" dirty="0">
-                          <a:solidFill>
-                            <a:srgbClr val="1B2A3A"/>
-                          </a:solidFill>
-                          <a:latin typeface="Calibri" pitchFamily="34" charset="0"/>
-                          <a:ea typeface="Calibri" pitchFamily="34" charset="-122"/>
-                          <a:cs typeface="Calibri" pitchFamily="34" charset="-120"/>
-                        </a:rPr>
-                        <a:t>Noradrenalina; vasopressina quando a dose sobe</a:t>
-                      </a:r>
-                      <a:endParaRPr lang="en-US" sz="1200" dirty="0"/>
-                    </a:p>
-                  </a:txBody>
-                  <a:tcPr marL="127000" marR="127000" marT="88900" marB="88900" anchor="ctr">
-                    <a:lnL w="0" cap="flat" cmpd="sng" algn="ctr">
-                      <a:noFill/>
-                    </a:lnL>
-                    <a:lnR w="0" cap="flat" cmpd="sng" algn="ctr">
-                      <a:noFill/>
-                    </a:lnR>
-                    <a:lnT w="0" cap="flat" cmpd="sng" algn="ctr">
-                      <a:noFill/>
-                    </a:lnT>
-                    <a:lnB w="6350" cap="flat" cmpd="sng" algn="ctr">
-                      <a:solidFill>
-                        <a:srgbClr val="E2DDD2"/>
-                      </a:solidFill>
-                      <a:prstDash val="solid"/>
-                      <a:round/>
-                      <a:headEnd type="none" w="med" len="med"/>
-                      <a:tailEnd type="none" w="med" len="med"/>
-                    </a:lnB>
-                  </a:tcPr>
-                </a:tc>
-              </a:tr>
-            </a:tbl>
-          </a:graphicData>
-        </a:graphic>
-      </p:graphicFrame>
-      <p:graphicFrame>
-        <p:nvGraphicFramePr>
-          <p:cNvPr id="6" name="Tabela"/>
-          <p:cNvGraphicFramePr>
-            <a:graphicFrameLocks noGrp="1"/>
-          </p:cNvGraphicFramePr>
-          <p:nvPr>
-            <p:extLst>
-              <p:ext uri="{D42A27DB-BD31-4B8C-83A1-F6EECF244321}">
-                <p14:modId xmlns:p14="http://schemas.microsoft.com/office/powerpoint/2010/main" val="1579011935"/>
-              </p:ext>
-            </p:extLst>
-          </p:nvPr>
-        </p:nvGraphicFramePr>
-        <p:xfrm>
-          <a:off x="812800" y="2721471"/>
-          <a:ext cx="10566400" cy="914400"/>
-        </p:xfrm>
-        <a:graphic>
-          <a:graphicData uri="http://schemas.openxmlformats.org/drawingml/2006/table">
-            <a:tbl>
-              <a:tblPr/>
-              <a:tblGrid>
-                <a:gridCol w="3592513"/>
-                <a:gridCol w="6973888"/>
-              </a:tblGrid>
-              <a:tr h="660995">
-                <a:tc>
-                  <a:txBody>
-                    <a:bodyPr/>
-                    <a:lstStyle/>
-                    <a:p>
-                      <a:pPr algn="l" indent="0" marL="0">
-                        <a:lnSpc>
-                          <a:spcPts val="1890"/>
-                        </a:lnSpc>
-                        <a:buNone/>
-                      </a:pPr>
-                      <a:r>
-                        <a:rPr lang="pt-BR" altLang="en-US" sz="1350" b="1" dirty="0">
-                          <a:solidFill>
-                            <a:srgbClr val="1B2A3A"/>
-                          </a:solidFill>
-                          <a:latin typeface="Calibri" pitchFamily="34" charset="0"/>
-                          <a:ea typeface="Calibri" pitchFamily="34" charset="-122"/>
-                          <a:cs typeface="Calibri" pitchFamily="34" charset="-120"/>
-                        </a:rPr>
-                        <a:t>Baixo débito com hipoperfusão</a:t>
-                      </a:r>
-                      <a:endParaRPr lang="en-US" sz="1200" dirty="0"/>
-                    </a:p>
-                  </a:txBody>
-                  <a:tcPr marL="127000" marR="127000" marT="88900" marB="88900" anchor="ctr">
-                    <a:lnL w="0" cap="flat" cmpd="sng" algn="ctr">
-                      <a:noFill/>
-                    </a:lnL>
-                    <a:lnR w="0" cap="flat" cmpd="sng" algn="ctr">
-                      <a:noFill/>
-                    </a:lnR>
-                    <a:lnT w="0" cap="flat" cmpd="sng" algn="ctr">
-                      <a:noFill/>
-                    </a:lnT>
-                    <a:lnB w="6350" cap="flat" cmpd="sng" algn="ctr">
-                      <a:solidFill>
-                        <a:srgbClr val="E2DDD2"/>
-                      </a:solidFill>
-                      <a:prstDash val="solid"/>
-                      <a:round/>
-                      <a:headEnd type="none" w="med" len="med"/>
-                      <a:tailEnd type="none" w="med" len="med"/>
-                    </a:lnB>
-                  </a:tcPr>
-                </a:tc>
-                <a:tc>
-                  <a:txBody>
-                    <a:bodyPr/>
-                    <a:lstStyle/>
-                    <a:p>
-                      <a:pPr algn="l" indent="0" marL="0">
-                        <a:lnSpc>
-                          <a:spcPts val="1890"/>
-                        </a:lnSpc>
-                        <a:buNone/>
-                      </a:pPr>
-                      <a:r>
-                        <a:rPr lang="pt-BR" altLang="en-US" sz="1350" dirty="0">
-                          <a:solidFill>
-                            <a:srgbClr val="1B2A3A"/>
-                          </a:solidFill>
-                          <a:latin typeface="Calibri" pitchFamily="34" charset="0"/>
-                          <a:ea typeface="Calibri" pitchFamily="34" charset="-122"/>
-                          <a:cs typeface="Calibri" pitchFamily="34" charset="-120"/>
-                        </a:rPr>
-                        <a:t>Dobutamina (ou adrenalina, no choque séptico); milrinona sobretudo no VD com hipertensão pulmonar</a:t>
-                      </a:r>
-                      <a:endParaRPr lang="en-US" sz="1200" dirty="0"/>
-                    </a:p>
-                  </a:txBody>
-                  <a:tcPr marL="127000" marR="127000" marT="88900" marB="88900" anchor="ctr">
-                    <a:lnL w="0" cap="flat" cmpd="sng" algn="ctr">
-                      <a:noFill/>
-                    </a:lnL>
-                    <a:lnR w="0" cap="flat" cmpd="sng" algn="ctr">
-                      <a:noFill/>
-                    </a:lnR>
-                    <a:lnT w="0" cap="flat" cmpd="sng" algn="ctr">
-                      <a:noFill/>
-                    </a:lnT>
-                    <a:lnB w="6350" cap="flat" cmpd="sng" algn="ctr">
-                      <a:solidFill>
-                        <a:srgbClr val="E2DDD2"/>
-                      </a:solidFill>
-                      <a:prstDash val="solid"/>
-                      <a:round/>
-                      <a:headEnd type="none" w="med" len="med"/>
-                      <a:tailEnd type="none" w="med" len="med"/>
-                    </a:lnB>
-                  </a:tcPr>
-                </a:tc>
-              </a:tr>
-            </a:tbl>
-          </a:graphicData>
-        </a:graphic>
-      </p:graphicFrame>
-      <p:graphicFrame>
-        <p:nvGraphicFramePr>
-          <p:cNvPr id="7" name="Tabela"/>
-          <p:cNvGraphicFramePr>
-            <a:graphicFrameLocks noGrp="1"/>
-          </p:cNvGraphicFramePr>
-          <p:nvPr>
-            <p:extLst>
-              <p:ext uri="{D42A27DB-BD31-4B8C-83A1-F6EECF244321}">
-                <p14:modId xmlns:p14="http://schemas.microsoft.com/office/powerpoint/2010/main" val="1579011935"/>
-              </p:ext>
-            </p:extLst>
-          </p:nvPr>
-        </p:nvGraphicFramePr>
-        <p:xfrm>
-          <a:off x="812800" y="3385641"/>
-          <a:ext cx="10566400" cy="914400"/>
-        </p:xfrm>
-        <a:graphic>
-          <a:graphicData uri="http://schemas.openxmlformats.org/drawingml/2006/table">
-            <a:tbl>
-              <a:tblPr/>
-              <a:tblGrid>
-                <a:gridCol w="3592513"/>
-                <a:gridCol w="6973888"/>
-              </a:tblGrid>
-              <a:tr h="420985">
-                <a:tc>
-                  <a:txBody>
-                    <a:bodyPr/>
-                    <a:lstStyle/>
-                    <a:p>
-                      <a:pPr algn="l" indent="0" marL="0">
-                        <a:lnSpc>
-                          <a:spcPts val="1890"/>
-                        </a:lnSpc>
-                        <a:buNone/>
-                      </a:pPr>
-                      <a:r>
-                        <a:rPr lang="pt-BR" altLang="en-US" sz="1350" b="1" dirty="0">
-                          <a:solidFill>
-                            <a:srgbClr val="1B2A3A"/>
-                          </a:solidFill>
-                          <a:latin typeface="Calibri" pitchFamily="34" charset="0"/>
-                          <a:ea typeface="Calibri" pitchFamily="34" charset="-122"/>
-                          <a:cs typeface="Calibri" pitchFamily="34" charset="-120"/>
-                        </a:rPr>
-                        <a:t>Hipotensão da anestesia com bradicardia</a:t>
-                      </a:r>
-                      <a:endParaRPr lang="en-US" sz="1200" dirty="0"/>
-                    </a:p>
-                  </a:txBody>
-                  <a:tcPr marL="127000" marR="127000" marT="88900" marB="88900" anchor="ctr">
-                    <a:lnL w="0" cap="flat" cmpd="sng" algn="ctr">
-                      <a:noFill/>
-                    </a:lnL>
-                    <a:lnR w="0" cap="flat" cmpd="sng" algn="ctr">
-                      <a:noFill/>
-                    </a:lnR>
-                    <a:lnT w="0" cap="flat" cmpd="sng" algn="ctr">
-                      <a:noFill/>
-                    </a:lnT>
-                    <a:lnB w="6350" cap="flat" cmpd="sng" algn="ctr">
-                      <a:solidFill>
-                        <a:srgbClr val="E2DDD2"/>
-                      </a:solidFill>
-                      <a:prstDash val="solid"/>
-                      <a:round/>
-                      <a:headEnd type="none" w="med" len="med"/>
-                      <a:tailEnd type="none" w="med" len="med"/>
-                    </a:lnB>
-                  </a:tcPr>
-                </a:tc>
-                <a:tc>
-                  <a:txBody>
-                    <a:bodyPr/>
-                    <a:lstStyle/>
-                    <a:p>
-                      <a:pPr algn="l" indent="0" marL="0">
-                        <a:lnSpc>
-                          <a:spcPts val="1890"/>
-                        </a:lnSpc>
-                        <a:buNone/>
-                      </a:pPr>
-                      <a:r>
-                        <a:rPr lang="pt-BR" altLang="en-US" sz="1350" dirty="0">
-                          <a:solidFill>
-                            <a:srgbClr val="1B2A3A"/>
-                          </a:solidFill>
-                          <a:latin typeface="Calibri" pitchFamily="34" charset="0"/>
-                          <a:ea typeface="Calibri" pitchFamily="34" charset="-122"/>
-                          <a:cs typeface="Calibri" pitchFamily="34" charset="-120"/>
-                        </a:rPr>
-                        <a:t>Efedrina; adrenalina se grave</a:t>
-                      </a:r>
-                      <a:endParaRPr lang="en-US" sz="1200" dirty="0"/>
-                    </a:p>
-                  </a:txBody>
-                  <a:tcPr marL="127000" marR="127000" marT="88900" marB="88900" anchor="ctr">
-                    <a:lnL w="0" cap="flat" cmpd="sng" algn="ctr">
-                      <a:noFill/>
-                    </a:lnL>
-                    <a:lnR w="0" cap="flat" cmpd="sng" algn="ctr">
-                      <a:noFill/>
-                    </a:lnR>
-                    <a:lnT w="0" cap="flat" cmpd="sng" algn="ctr">
-                      <a:noFill/>
-                    </a:lnT>
-                    <a:lnB w="6350" cap="flat" cmpd="sng" algn="ctr">
-                      <a:solidFill>
-                        <a:srgbClr val="E2DDD2"/>
-                      </a:solidFill>
-                      <a:prstDash val="solid"/>
-                      <a:round/>
-                      <a:headEnd type="none" w="med" len="med"/>
-                      <a:tailEnd type="none" w="med" len="med"/>
-                    </a:lnB>
-                  </a:tcPr>
-                </a:tc>
-              </a:tr>
-            </a:tbl>
-          </a:graphicData>
-        </a:graphic>
-      </p:graphicFrame>
-      <p:graphicFrame>
-        <p:nvGraphicFramePr>
-          <p:cNvPr id="8" name="Tabela"/>
-          <p:cNvGraphicFramePr>
-            <a:graphicFrameLocks noGrp="1"/>
-          </p:cNvGraphicFramePr>
-          <p:nvPr>
-            <p:extLst>
-              <p:ext uri="{D42A27DB-BD31-4B8C-83A1-F6EECF244321}">
-                <p14:modId xmlns:p14="http://schemas.microsoft.com/office/powerpoint/2010/main" val="1579011935"/>
-              </p:ext>
-            </p:extLst>
-          </p:nvPr>
-        </p:nvGraphicFramePr>
-        <p:xfrm>
-          <a:off x="812800" y="3809802"/>
-          <a:ext cx="10566400" cy="914400"/>
-        </p:xfrm>
-        <a:graphic>
-          <a:graphicData uri="http://schemas.openxmlformats.org/drawingml/2006/table">
-            <a:tbl>
-              <a:tblPr/>
-              <a:tblGrid>
-                <a:gridCol w="3592513"/>
-                <a:gridCol w="6973888"/>
-              </a:tblGrid>
-              <a:tr h="660995">
-                <a:tc>
-                  <a:txBody>
-                    <a:bodyPr/>
-                    <a:lstStyle/>
-                    <a:p>
-                      <a:pPr algn="l" indent="0" marL="0">
-                        <a:lnSpc>
-                          <a:spcPts val="1890"/>
-                        </a:lnSpc>
-                        <a:buNone/>
-                      </a:pPr>
-                      <a:r>
-                        <a:rPr lang="pt-BR" altLang="en-US" sz="1350" b="1" dirty="0">
-                          <a:solidFill>
-                            <a:srgbClr val="1B2A3A"/>
-                          </a:solidFill>
-                          <a:latin typeface="Calibri" pitchFamily="34" charset="0"/>
-                          <a:ea typeface="Calibri" pitchFamily="34" charset="-122"/>
-                          <a:cs typeface="Calibri" pitchFamily="34" charset="-120"/>
-                        </a:rPr>
-                        <a:t>Hipotensão da anestesia com FC normal ou alta</a:t>
-                      </a:r>
-                      <a:endParaRPr lang="en-US" sz="1200" dirty="0"/>
-                    </a:p>
-                  </a:txBody>
-                  <a:tcPr marL="127000" marR="127000" marT="88900" marB="88900" anchor="ctr">
-                    <a:lnL w="0" cap="flat" cmpd="sng" algn="ctr">
-                      <a:noFill/>
-                    </a:lnL>
-                    <a:lnR w="0" cap="flat" cmpd="sng" algn="ctr">
-                      <a:noFill/>
-                    </a:lnR>
-                    <a:lnT w="0" cap="flat" cmpd="sng" algn="ctr">
-                      <a:noFill/>
-                    </a:lnT>
-                    <a:lnB w="6350" cap="flat" cmpd="sng" algn="ctr">
-                      <a:solidFill>
-                        <a:srgbClr val="E2DDD2"/>
-                      </a:solidFill>
-                      <a:prstDash val="solid"/>
-                      <a:round/>
-                      <a:headEnd type="none" w="med" len="med"/>
-                      <a:tailEnd type="none" w="med" len="med"/>
-                    </a:lnB>
-                  </a:tcPr>
-                </a:tc>
-                <a:tc>
-                  <a:txBody>
-                    <a:bodyPr/>
-                    <a:lstStyle/>
-                    <a:p>
-                      <a:pPr algn="l" indent="0" marL="0">
-                        <a:lnSpc>
-                          <a:spcPts val="1890"/>
-                        </a:lnSpc>
-                        <a:buNone/>
-                      </a:pPr>
-                      <a:r>
-                        <a:rPr lang="pt-BR" altLang="en-US" sz="1350" dirty="0">
-                          <a:solidFill>
-                            <a:srgbClr val="1B2A3A"/>
-                          </a:solidFill>
-                          <a:latin typeface="Calibri" pitchFamily="34" charset="0"/>
-                          <a:ea typeface="Calibri" pitchFamily="34" charset="-122"/>
-                          <a:cs typeface="Calibri" pitchFamily="34" charset="-120"/>
-                        </a:rPr>
-                        <a:t>Fenilefrina</a:t>
-                      </a:r>
-                      <a:endParaRPr lang="en-US" sz="1200" dirty="0"/>
-                    </a:p>
-                  </a:txBody>
-                  <a:tcPr marL="127000" marR="127000" marT="88900" marB="88900" anchor="ctr">
-                    <a:lnL w="0" cap="flat" cmpd="sng" algn="ctr">
-                      <a:noFill/>
-                    </a:lnL>
-                    <a:lnR w="0" cap="flat" cmpd="sng" algn="ctr">
-                      <a:noFill/>
-                    </a:lnR>
-                    <a:lnT w="0" cap="flat" cmpd="sng" algn="ctr">
-                      <a:noFill/>
-                    </a:lnT>
-                    <a:lnB w="6350" cap="flat" cmpd="sng" algn="ctr">
-                      <a:solidFill>
-                        <a:srgbClr val="E2DDD2"/>
-                      </a:solidFill>
-                      <a:prstDash val="solid"/>
-                      <a:round/>
-                      <a:headEnd type="none" w="med" len="med"/>
-                      <a:tailEnd type="none" w="med" len="med"/>
-                    </a:lnB>
-                  </a:tcPr>
-                </a:tc>
-              </a:tr>
-            </a:tbl>
-          </a:graphicData>
-        </a:graphic>
-      </p:graphicFrame>
-      <p:graphicFrame>
-        <p:nvGraphicFramePr>
-          <p:cNvPr id="9" name="Tabela"/>
-          <p:cNvGraphicFramePr>
-            <a:graphicFrameLocks noGrp="1"/>
-          </p:cNvGraphicFramePr>
-          <p:nvPr>
-            <p:extLst>
-              <p:ext uri="{D42A27DB-BD31-4B8C-83A1-F6EECF244321}">
-                <p14:modId xmlns:p14="http://schemas.microsoft.com/office/powerpoint/2010/main" val="1579011935"/>
-              </p:ext>
-            </p:extLst>
-          </p:nvPr>
-        </p:nvGraphicFramePr>
-        <p:xfrm>
-          <a:off x="812800" y="4473972"/>
-          <a:ext cx="10566400" cy="914400"/>
-        </p:xfrm>
-        <a:graphic>
-          <a:graphicData uri="http://schemas.openxmlformats.org/drawingml/2006/table">
-            <a:tbl>
-              <a:tblPr/>
-              <a:tblGrid>
-                <a:gridCol w="3592513"/>
-                <a:gridCol w="6973888"/>
-              </a:tblGrid>
-              <a:tr h="420985">
-                <a:tc>
-                  <a:txBody>
-                    <a:bodyPr/>
-                    <a:lstStyle/>
-                    <a:p>
-                      <a:pPr algn="l" indent="0" marL="0">
-                        <a:lnSpc>
-                          <a:spcPts val="1890"/>
-                        </a:lnSpc>
-                        <a:buNone/>
-                      </a:pPr>
-                      <a:r>
-                        <a:rPr lang="pt-BR" altLang="en-US" sz="1350" b="1" dirty="0">
-                          <a:solidFill>
-                            <a:srgbClr val="1B2A3A"/>
-                          </a:solidFill>
-                          <a:latin typeface="Calibri" pitchFamily="34" charset="0"/>
-                          <a:ea typeface="Calibri" pitchFamily="34" charset="-122"/>
-                          <a:cs typeface="Calibri" pitchFamily="34" charset="-120"/>
-                        </a:rPr>
-                        <a:t>Anafilaxia</a:t>
-                      </a:r>
-                      <a:endParaRPr lang="en-US" sz="1200" dirty="0"/>
-                    </a:p>
-                  </a:txBody>
-                  <a:tcPr marL="127000" marR="127000" marT="88900" marB="88900" anchor="ctr">
-                    <a:lnL w="0" cap="flat" cmpd="sng" algn="ctr">
-                      <a:noFill/>
-                    </a:lnL>
-                    <a:lnR w="0" cap="flat" cmpd="sng" algn="ctr">
-                      <a:noFill/>
-                    </a:lnR>
-                    <a:lnT w="0" cap="flat" cmpd="sng" algn="ctr">
-                      <a:noFill/>
-                    </a:lnT>
-                    <a:lnB w="6350" cap="flat" cmpd="sng" algn="ctr">
-                      <a:solidFill>
-                        <a:srgbClr val="E2DDD2"/>
-                      </a:solidFill>
-                      <a:prstDash val="solid"/>
-                      <a:round/>
-                      <a:headEnd type="none" w="med" len="med"/>
-                      <a:tailEnd type="none" w="med" len="med"/>
-                    </a:lnB>
-                  </a:tcPr>
-                </a:tc>
-                <a:tc>
-                  <a:txBody>
-                    <a:bodyPr/>
-                    <a:lstStyle/>
-                    <a:p>
-                      <a:pPr algn="l" indent="0" marL="0">
-                        <a:lnSpc>
-                          <a:spcPts val="1890"/>
-                        </a:lnSpc>
-                        <a:buNone/>
-                      </a:pPr>
-                      <a:r>
-                        <a:rPr lang="pt-BR" altLang="en-US" sz="1350" dirty="0">
-                          <a:solidFill>
-                            <a:srgbClr val="1B2A3A"/>
-                          </a:solidFill>
-                          <a:latin typeface="Calibri" pitchFamily="34" charset="0"/>
-                          <a:ea typeface="Calibri" pitchFamily="34" charset="-122"/>
-                          <a:cs typeface="Calibri" pitchFamily="34" charset="-120"/>
-                        </a:rPr>
-                        <a:t>Adrenalina</a:t>
-                      </a:r>
-                      <a:endParaRPr lang="en-US" sz="1200" dirty="0"/>
-                    </a:p>
-                  </a:txBody>
-                  <a:tcPr marL="127000" marR="127000" marT="88900" marB="88900" anchor="ctr">
-                    <a:lnL w="0" cap="flat" cmpd="sng" algn="ctr">
-                      <a:noFill/>
-                    </a:lnL>
-                    <a:lnR w="0" cap="flat" cmpd="sng" algn="ctr">
-                      <a:noFill/>
-                    </a:lnR>
-                    <a:lnT w="0" cap="flat" cmpd="sng" algn="ctr">
-                      <a:noFill/>
-                    </a:lnT>
-                    <a:lnB w="6350" cap="flat" cmpd="sng" algn="ctr">
-                      <a:solidFill>
-                        <a:srgbClr val="E2DDD2"/>
-                      </a:solidFill>
-                      <a:prstDash val="solid"/>
-                      <a:round/>
-                      <a:headEnd type="none" w="med" len="med"/>
-                      <a:tailEnd type="none" w="med" len="med"/>
-                    </a:lnB>
-                  </a:tcPr>
-                </a:tc>
-              </a:tr>
-            </a:tbl>
-          </a:graphicData>
-        </a:graphic>
-      </p:graphicFrame>
-      <p:sp>
-        <p:nvSpPr>
-          <p:cNvPr id="10" name="SSC 2026 · Miller’s Anesthesia, 10ª ed. "/>
-          <p:cNvSpPr txBox="1"/>
-          <p:nvPr/>
-        </p:nvSpPr>
-        <p:spPr>
-          <a:xfrm>
-            <a:off x="812800" y="6226316"/>
-            <a:ext cx="10433050" cy="213320"/>
-          </a:xfrm>
-          <a:prstGeom prst="rect">
-            <a:avLst/>
-          </a:prstGeom>
-          <a:noFill/>
-          <a:ln/>
-        </p:spPr>
-        <p:txBody>
-          <a:bodyPr wrap="none" lIns="0" tIns="0" rIns="0" bIns="0" rtlCol="0" anchor="t"/>
-          <a:lstStyle/>
-          <a:p>
-            <a:pPr algn="l" indent="0" marL="0">
-              <a:lnSpc>
-                <a:spcPts val="1680"/>
-              </a:lnSpc>
-              <a:buNone/>
-            </a:pPr>
-            <a:r>
-              <a:rPr lang="pt-BR" altLang="en-US" sz="1200" dirty="0">
-                <a:solidFill>
-                  <a:srgbClr val="56606B"/>
-                </a:solidFill>
-                <a:latin typeface="Calibri" pitchFamily="34" charset="0"/>
-                <a:ea typeface="Calibri" pitchFamily="34" charset="-122"/>
-                <a:cs typeface="Calibri" pitchFamily="34" charset="-120"/>
-              </a:rPr>
-              <a:t>SSC 2026 · Miller’s Anesthesia, 10ª ed. (2025), cap. 16, 79</a:t>
-            </a:r>
-            <a:endParaRPr lang="en-US" sz="1200" dirty="0"/>
-          </a:p>
-        </p:txBody>
-      </p:sp>
-      <p:pic>
-        <p:nvPicPr>
-          <p:cNvPr id="11" name="Símbolo da UFRJ" descr="Símbolo da UFRJ">    </p:cNvPr>
-          <p:cNvPicPr>
-            <a:picLocks noChangeAspect="1"/>
-          </p:cNvPicPr>
-          <p:nvPr/>
-        </p:nvPicPr>
-        <p:blipFill>
-          <a:blip r:embed="rId1"/>
-          <a:stretch>
-            <a:fillRect/>
-          </a:stretch>
-        </p:blipFill>
-        <p:spPr>
-          <a:xfrm>
-            <a:off x="11430000" y="5894381"/>
-            <a:ext cx="508000" cy="758838"/>
-          </a:xfrm>
-          <a:prstGeom prst="rect">
-            <a:avLst/>
-          </a:prstGeom>
-        </p:spPr>
-      </p:pic>
-    </p:spTree>
-  </p:cSld>
-  <p:clrMapOvr>
-    <a:masterClrMapping/>
-  </p:clrMapOvr>
-  <p:transition spd="med">
-    <p:fade/>
-  </p:transition>
-</p:sld>
-</file>
-
-<file path=ppt/slides/slide16.xml><?xml version="1.0" encoding="utf-8"?>
-<p:sld xmlns:a="http://schemas.openxmlformats.org/drawingml/2006/main" xmlns:r="http://schemas.openxmlformats.org/officeDocument/2006/relationships" xmlns:p="http://schemas.openxmlformats.org/presentationml/2006/main">
-  <p:cSld name="Slide 16">
     <p:bg>
       <p:bgPr>
         <a:solidFill>

</xml_diff>

<commit_message>
Versão 45: slide 'Além das aminas' reduzido ao essencial; formatação revista (alturas das colunas, rodapés, recuo); 14 slides, 11 min 15 s
Co-Authored-By: Claude Fable 5.1 <noreply@anthropic.com>
Claude-Session: https://claude.ai/code/session_01W6cLQUtwNHu1UUeBJH2XLT
</commit_message>
<xml_diff>
--- a/apresentacao/Aminas_Vasoativas.pptx
+++ b/apresentacao/Aminas_Vasoativas.pptx
@@ -120,24 +120,24 @@
   <p:extLst>
     <p:ext uri="{521415D9-36F7-43E2-AB2F-B90AF26B5E84}">
       <p14:sectionLst xmlns:p14="http://schemas.microsoft.com/office/powerpoint/2010/main">
-        <p14:section name="Abertura e objetivos" id="{dcbd5c91-5621-1ac0-5a8f-572a134a23f5}">
+        <p14:section name="Abertura e objetivos" id="{85266978-4b45-a95c-5722-7312eebbce75}">
           <p14:sldIdLst>
             <p14:sldId id="256"/>
             <p14:sldId id="257"/>
           </p14:sldIdLst>
         </p14:section>
-        <p14:section name="01 · Fisiologia: pressão, débito e perfusão" id="{d9a92372-76d3-c3df-a335-e4c893811d43}">
+        <p14:section name="01 · Fisiologia: pressão, débito e perfusão" id="{1a9b62fd-9c58-7122-80e6-5fc3ba6dbf35}">
           <p14:sldIdLst>
             <p14:sldId id="258"/>
             <p14:sldId id="259"/>
           </p14:sldIdLst>
         </p14:section>
-        <p14:section name="02 · Receptores" id="{8e758864-2eb3-9243-0d8b-e8c0890af6a0}">
+        <p14:section name="02 · Receptores" id="{8da31c8c-a687-b0ea-0041-5ae8391fbc74}">
           <p14:sldIdLst>
             <p14:sldId id="260"/>
           </p14:sldIdLst>
         </p14:section>
-        <p14:section name="03 · Drogas: noradrenalina, adrenalina, dobutamina (e dopamina), milrinona (escolha), fenilefrina e efedrina" id="{77eb92aa-70bb-dda4-a4e9-2b5d24eeaa8b}">
+        <p14:section name="03 · Drogas: noradrenalina, adrenalina, dobutamina (e dopamina), milrinona (escolha), fenilefrina e efedrina" id="{f74d0e28-d962-2fc5-63f0-851bb30642ee}">
           <p14:sldIdLst>
             <p14:sldId id="261"/>
             <p14:sldId id="262"/>
@@ -147,17 +147,17 @@
             <p14:sldId id="266"/>
           </p14:sldIdLst>
         </p14:section>
-        <p14:section name="04 · Além das aminas: vasopressina, hidrocortisona e azul de metileno" id="{48770379-1c9b-d43c-5007-f4473d321528}">
+        <p14:section name="04 · Além das aminas: vasopressina, hidrocortisona e azul de metileno" id="{dd95bf7c-3cc3-7589-a2a4-0bd5f89b8c23}">
           <p14:sldIdLst>
             <p14:sldId id="267"/>
           </p14:sldIdLst>
         </p14:section>
-        <p14:section name="05 · Perioperatório: escolha da droga e mensagem final" id="{c81452d9-e1d0-2a8d-5bfd-e7d52c04bb7e}">
+        <p14:section name="05 · Perioperatório: escolha da droga e mensagem final" id="{48bccc8f-2484-17b0-cbf2-82aabe421ce4}">
           <p14:sldIdLst>
             <p14:sldId id="268"/>
           </p14:sldIdLst>
         </p14:section>
-        <p14:section name="06 · Encerramento" id="{2331789f-66fb-939b-bea9-72794b6ed4f1}">
+        <p14:section name="06 · Encerramento" id="{b01c6fda-3d56-e62d-d897-32af04d7ba90}">
           <p14:sldIdLst>
             <p14:sldId id="269"/>
           </p14:sldIdLst>
@@ -573,7 +573,7 @@
           <a:p>
             <a:r>
               <a:rPr lang="en-US" dirty="0"/>
-              <a:t>TEMPO: 25 s (0:00 → 0:25). Total previsto: 11 min 30 s nos 14 slides; ensaiar mirando 12 minutos.</a:t>
+              <a:t>TEMPO: 25 s (0:00 → 0:25). Total previsto: 11 min 15 s nos 14 slides; ensaiar mirando 12 minutos.</a:t>
             </a:r>
             <a:endParaRPr lang="en-US" dirty="0"/>
           </a:p>
@@ -879,14 +879,14 @@
           <a:p>
             <a:r>
               <a:rPr lang="en-US" dirty="0"/>
-              <a:t>FALA: Três recursos além das aminas. A vasopressina age no receptor V1, fora da via adrenérgica, e costuma manter efeito em acidose; no choque séptico há deficiência relativa do hormônio. No choque séptico, com noradrenalina em escalada, a dose é em geral fixa, 0,03 unidades por minuto; na vasoplegia após CEC, o VANCS titulou de 0,01 a 0,06 unidades por minuto; com IECA ou BRA, bolus pequenos ou infusão titulada; o risco é isquemia digital e mesentérica. A hidrocortisona restaura a resposta vascular às catecolaminas, 200 mg por dia no choque séptico. O azul de metileno inibe a via do óxido nítrico e fica como resgate na vasoplegia refratária: após CEC, onde há mais estudos, e na reperfusão do enxerto hepático, com base em relatos, séries e um ensaio pequeno; o uso profilático não mostrou benefício em uma coorte pareada. Outras indicações, apenas para citar: metemoglobinemia e choque séptico refratário. Cuidados: deficiência de G6PD, interferência na oximetria e no BIS, e síndrome serotoninérgica, inclusive com certos opioides.</a:t>
+              <a:t>FALA: Três recursos além das aminas. A vasopressina age no receptor V1, fora da via adrenérgica, e costuma manter efeito em acidose: no choque séptico com noradrenalina em escalada, dose em geral fixa de 0,03 unidades por minuto; na vasoplegia após CEC, dose titulada, como no VANCS; na hipotensão refratária com IECA ou BRA, bolus pequenos ou infusão; o risco é isquemia digital e mesentérica. A hidrocortisona restaura a resposta vascular às catecolaminas, 200 mg por dia no choque séptico. O azul de metileno inibe a via do óxido nítrico e fica como resgate na vasoplegia refratária, após CEC ou na reperfusão do enxerto hepático, onde a base são relatos e séries e o uso profilático não mostrou benefício. Cuidados: deficiência de G6PD, interferência na oximetria e síndrome serotoninérgica.</a:t>
             </a:r>
             <a:endParaRPr lang="en-US" dirty="0"/>
           </a:p>
           <a:p>
             <a:r>
               <a:rPr lang="en-US" dirty="0"/>
-              <a:t>TEMPO: 1 min 15 s (8:30 → 9:45)</a:t>
+              <a:t>TEMPO: 1 min (8:30 → 9:30)</a:t>
             </a:r>
             <a:endParaRPr lang="en-US" dirty="0"/>
           </a:p>
@@ -995,7 +995,7 @@
           <a:p>
             <a:r>
               <a:rPr lang="en-US" dirty="0"/>
-              <a:t>TEMPO: 1 min 35 s (9:45 → 11:20)</a:t>
+              <a:t>TEMPO: 1 min 35 s (9:30 → 11:05)</a:t>
             </a:r>
             <a:endParaRPr lang="en-US" dirty="0"/>
           </a:p>
@@ -1104,7 +1104,7 @@
           <a:p>
             <a:r>
               <a:rPr lang="en-US" dirty="0"/>
-              <a:t>TEMPO: 10 s (11:20 → 11:30)</a:t>
+              <a:t>TEMPO: 10 s (11:05 → 11:15)</a:t>
             </a:r>
             <a:endParaRPr lang="en-US" dirty="0"/>
           </a:p>
@@ -2223,7 +2223,7 @@
         </p:nvSpPr>
         <p:spPr>
           <a:xfrm>
-            <a:off x="812800" y="1007959"/>
+            <a:off x="812800" y="1109559"/>
             <a:ext cx="10718800" cy="838200"/>
           </a:xfrm>
           <a:prstGeom prst="rect">
@@ -5287,11 +5287,11 @@
         <p:spPr>
           <a:xfrm>
             <a:off x="812800" y="1879501"/>
-            <a:ext cx="4064000" cy="3517305"/>
+            <a:ext cx="4064000" cy="3268762"/>
           </a:xfrm>
           <a:prstGeom prst="roundRect">
             <a:avLst>
-              <a:gd name="adj" fmla="val 2166"/>
+              <a:gd name="adj" fmla="val 2331"/>
             </a:avLst>
           </a:prstGeom>
           <a:solidFill>
@@ -5386,7 +5386,7 @@
       </p:sp>
       <p:sp>
         <p:nvSpPr>
-          <p:cNvPr id="7" name="Choque séptico: dose em geral fixa, até "/>
+          <p:cNvPr id="7" name="Age fora da via adrenérgica; costuma man"/>
           <p:cNvSpPr txBox="1"/>
           <p:nvPr/>
         </p:nvSpPr>
@@ -5420,7 +5420,7 @@
                 <a:ea typeface="Calibri" pitchFamily="34" charset="-122"/>
                 <a:cs typeface="Calibri" pitchFamily="34" charset="-120"/>
               </a:rPr>
-              <a:t>Choque séptico: dose em geral fixa, até 0,04 U/min. Vasoplegia pós-CEC: titulada (0,01–0,06 U/min no VANCS). Costuma manter efeito com acidose e dessensibilização adrenérgica.</a:t>
+              <a:t>Age fora da via adrenérgica; costuma manter efeito com acidose. Choque séptico: dose em geral fixa. Vasoplegia pós-CEC: titulada (0,01–0,06 U/min no VANCS).</a:t>
             </a:r>
             <a:endParaRPr lang="en-US" sz="1350" dirty="0"/>
           </a:p>
@@ -5428,14 +5428,14 @@
       </p:sp>
       <p:sp>
         <p:nvSpPr>
-          <p:cNvPr id="8" name="Indicações: choque séptico com noradrena"/>
+          <p:cNvPr id="8" name="Indicações: noradrenalina em escalada, v"/>
           <p:cNvSpPr txBox="1"/>
           <p:nvPr/>
         </p:nvSpPr>
         <p:spPr>
           <a:xfrm>
             <a:off x="1066800" y="4132603"/>
-            <a:ext cx="3575050" cy="994172"/>
+            <a:ext cx="3575050" cy="745629"/>
           </a:xfrm>
           <a:prstGeom prst="rect">
             <a:avLst/>
@@ -5462,7 +5462,7 @@
                 <a:ea typeface="Calibri" pitchFamily="34" charset="-122"/>
                 <a:cs typeface="Calibri" pitchFamily="34" charset="-120"/>
               </a:rPr>
-              <a:t>Indicações: choque séptico com noradrenalina em escalada, vasoplegia pós-CEC e hipotensão refratária em uso de IECA/BRA. Risco: isquemia digital e mesentérica.</a:t>
+              <a:t>Indicações: noradrenalina em escalada, vasoplegia pós-CEC, hipotensão refratária com IECA/BRA. Risco: isquemia digital e mesentérica.</a:t>
             </a:r>
             <a:endParaRPr lang="en-US" sz="1350" dirty="0"/>
           </a:p>
@@ -5477,11 +5477,11 @@
         <p:spPr>
           <a:xfrm>
             <a:off x="5080000" y="1879501"/>
-            <a:ext cx="6299200" cy="827980"/>
+            <a:ext cx="6299200" cy="1583630"/>
           </a:xfrm>
           <a:prstGeom prst="roundRect">
             <a:avLst>
-              <a:gd name="adj" fmla="val 9203"/>
+              <a:gd name="adj" fmla="val 4812"/>
             </a:avLst>
           </a:prstGeom>
           <a:solidFill>
@@ -5503,7 +5503,7 @@
         </p:nvSpPr>
         <p:spPr>
           <a:xfrm>
-            <a:off x="5289550" y="2034727"/>
+            <a:off x="5289550" y="2412552"/>
             <a:ext cx="5899150" cy="228600"/>
           </a:xfrm>
           <a:prstGeom prst="rect">
@@ -5545,7 +5545,7 @@
         </p:nvSpPr>
         <p:spPr>
           <a:xfrm>
-            <a:off x="5289550" y="2304690"/>
+            <a:off x="5289550" y="2682515"/>
             <a:ext cx="5899150" cy="231080"/>
           </a:xfrm>
           <a:prstGeom prst="rect">
@@ -5587,12 +5587,12 @@
         </p:nvSpPr>
         <p:spPr>
           <a:xfrm>
-            <a:off x="5080000" y="2809081"/>
-            <a:ext cx="6299200" cy="1290141"/>
+            <a:off x="5080000" y="3564731"/>
+            <a:ext cx="6299200" cy="1583630"/>
           </a:xfrm>
           <a:prstGeom prst="roundRect">
             <a:avLst>
-              <a:gd name="adj" fmla="val 5906"/>
+              <a:gd name="adj" fmla="val 4812"/>
             </a:avLst>
           </a:prstGeom>
           <a:solidFill>
@@ -5614,7 +5614,7 @@
         </p:nvSpPr>
         <p:spPr>
           <a:xfrm>
-            <a:off x="5289550" y="2964307"/>
+            <a:off x="5289550" y="3866702"/>
             <a:ext cx="5899150" cy="228600"/>
           </a:xfrm>
           <a:prstGeom prst="rect">
@@ -5656,7 +5656,7 @@
         </p:nvSpPr>
         <p:spPr>
           <a:xfrm>
-            <a:off x="5289550" y="3234271"/>
+            <a:off x="5289550" y="4136665"/>
             <a:ext cx="5899150" cy="693241"/>
           </a:xfrm>
           <a:prstGeom prst="rect">
@@ -5684,7 +5684,7 @@
                 <a:ea typeface="Calibri" pitchFamily="34" charset="-122"/>
                 <a:cs typeface="Calibri" pitchFamily="34" charset="-120"/>
               </a:rPr>
-              <a:t>Inibe a via óxido nítrico–GMPc: resgate na vasoplegia refratária (pós-CEC; reperfusão do enxerto hepático, com base em relatos e séries). Também: metemoglobinemia; choque séptico refratário, em estudo.</a:t>
+              <a:t>Inibe a via óxido nítrico–GMPc: resgate na vasoplegia refratária (pós-CEC; reperfusão do enxerto hepático, com base em relatos e séries). Cuidados: deficiência de G6PD, oximetria, síndrome serotoninérgica.</a:t>
             </a:r>
             <a:endParaRPr lang="en-US" sz="1300" dirty="0"/>
           </a:p>
@@ -5698,8 +5698,8 @@
         </p:nvSpPr>
         <p:spPr>
           <a:xfrm>
-            <a:off x="812800" y="6245073"/>
-            <a:ext cx="10433050" cy="195560"/>
+            <a:off x="812800" y="6226316"/>
+            <a:ext cx="10433050" cy="213320"/>
           </a:xfrm>
           <a:prstGeom prst="rect">
             <a:avLst/>
@@ -5713,12 +5713,12 @@
           <a:p>
             <a:pPr algn="l" indent="0" marL="0">
               <a:lnSpc>
-                <a:spcPts val="1540"/>
-              </a:lnSpc>
-              <a:buNone/>
-            </a:pPr>
-            <a:r>
-              <a:rPr lang="pt-BR" altLang="en-US" sz="1100" dirty="0">
+                <a:spcPts val="1680"/>
+              </a:lnSpc>
+              <a:buNone/>
+            </a:pPr>
+            <a:r>
+              <a:rPr lang="pt-BR" altLang="en-US" sz="1200" dirty="0">
                 <a:solidFill>
                   <a:srgbClr val="56606B"/>
                 </a:solidFill>
@@ -5726,9 +5726,9 @@
                 <a:ea typeface="Calibri" pitchFamily="34" charset="-122"/>
                 <a:cs typeface="Calibri" pitchFamily="34" charset="-120"/>
               </a:rPr>
-              <a:t>SSC 2026 · Hajjar, Anesthesiology 2017 (VANCS) · Koelzow, Anesth Analg 2002 · Fukazawa, J Hepatobiliary Pancreat Sci 2011 · Miller’s Anesthesia, 10ª ed. (2025), cap. 79</a:t>
-            </a:r>
-            <a:endParaRPr lang="en-US" sz="1100" dirty="0"/>
+              <a:t>SSC 2026 · Hajjar, Anesthesiology 2017 (VANCS) · Koelzow 2002 · Fukazawa 2011 · Miller’s Anesthesia, 10ª ed. (2025), cap. 79</a:t>
+            </a:r>
+            <a:endParaRPr lang="en-US" sz="1200" dirty="0"/>
           </a:p>
         </p:txBody>
       </p:sp>
@@ -5799,7 +5799,7 @@
         </p:nvSpPr>
         <p:spPr>
           <a:xfrm>
-            <a:off x="812800" y="699237"/>
+            <a:off x="812800" y="800837"/>
             <a:ext cx="10585450" cy="213320"/>
           </a:xfrm>
           <a:prstGeom prst="rect">
@@ -5843,7 +5843,7 @@
         </p:nvSpPr>
         <p:spPr>
           <a:xfrm>
-            <a:off x="812800" y="1007959"/>
+            <a:off x="812800" y="1109559"/>
             <a:ext cx="10718800" cy="838200"/>
           </a:xfrm>
           <a:prstGeom prst="rect">
@@ -5885,7 +5885,7 @@
         </p:nvSpPr>
         <p:spPr>
           <a:xfrm>
-            <a:off x="812800" y="1574701"/>
+            <a:off x="812800" y="1676301"/>
             <a:ext cx="920055" cy="322560"/>
           </a:xfrm>
           <a:prstGeom prst="roundRect">
@@ -5931,7 +5931,7 @@
         </p:nvSpPr>
         <p:spPr>
           <a:xfrm>
-            <a:off x="1834455" y="1631217"/>
+            <a:off x="1834455" y="1732817"/>
             <a:ext cx="226020" cy="228600"/>
           </a:xfrm>
           <a:prstGeom prst="rect">
@@ -5973,7 +5973,7 @@
         </p:nvSpPr>
         <p:spPr>
           <a:xfrm>
-            <a:off x="2143026" y="1559520"/>
+            <a:off x="2143026" y="1661120"/>
             <a:ext cx="5803999" cy="353020"/>
           </a:xfrm>
           <a:prstGeom prst="roundRect">
@@ -6023,7 +6023,7 @@
         </p:nvSpPr>
         <p:spPr>
           <a:xfrm>
-            <a:off x="8048625" y="1631217"/>
+            <a:off x="8048625" y="1732817"/>
             <a:ext cx="226020" cy="228600"/>
           </a:xfrm>
           <a:prstGeom prst="rect">
@@ -6065,7 +6065,7 @@
         </p:nvSpPr>
         <p:spPr>
           <a:xfrm>
-            <a:off x="8357195" y="1574701"/>
+            <a:off x="8357195" y="1676301"/>
             <a:ext cx="1289546" cy="322560"/>
           </a:xfrm>
           <a:prstGeom prst="roundRect">
@@ -6111,7 +6111,7 @@
         </p:nvSpPr>
         <p:spPr>
           <a:xfrm>
-            <a:off x="812800" y="2052241"/>
+            <a:off x="812800" y="2153841"/>
             <a:ext cx="3437434" cy="1144587"/>
           </a:xfrm>
           <a:prstGeom prst="roundRect">
@@ -6138,7 +6138,7 @@
         </p:nvSpPr>
         <p:spPr>
           <a:xfrm>
-            <a:off x="819150" y="2058591"/>
+            <a:off x="819150" y="2160191"/>
             <a:ext cx="3424734" cy="334963"/>
           </a:xfrm>
           <a:prstGeom prst="roundRect">
@@ -6184,7 +6184,7 @@
         </p:nvSpPr>
         <p:spPr>
           <a:xfrm>
-            <a:off x="933450" y="2474754"/>
+            <a:off x="933450" y="2576354"/>
             <a:ext cx="3215184" cy="412750"/>
           </a:xfrm>
           <a:prstGeom prst="rect">
@@ -6226,7 +6226,7 @@
         </p:nvSpPr>
         <p:spPr>
           <a:xfrm>
-            <a:off x="4377234" y="2052241"/>
+            <a:off x="4377234" y="2153841"/>
             <a:ext cx="3437434" cy="1144587"/>
           </a:xfrm>
           <a:prstGeom prst="roundRect">
@@ -6253,7 +6253,7 @@
         </p:nvSpPr>
         <p:spPr>
           <a:xfrm>
-            <a:off x="4383584" y="2058591"/>
+            <a:off x="4383584" y="2160191"/>
             <a:ext cx="3424734" cy="334963"/>
           </a:xfrm>
           <a:prstGeom prst="roundRect">
@@ -6299,7 +6299,7 @@
         </p:nvSpPr>
         <p:spPr>
           <a:xfrm>
-            <a:off x="4497884" y="2474754"/>
+            <a:off x="4497884" y="2576354"/>
             <a:ext cx="3215184" cy="206375"/>
           </a:xfrm>
           <a:prstGeom prst="rect">
@@ -6341,7 +6341,7 @@
         </p:nvSpPr>
         <p:spPr>
           <a:xfrm>
-            <a:off x="7941667" y="2052241"/>
+            <a:off x="7941667" y="2153841"/>
             <a:ext cx="3437434" cy="1144587"/>
           </a:xfrm>
           <a:prstGeom prst="roundRect">
@@ -6368,7 +6368,7 @@
         </p:nvSpPr>
         <p:spPr>
           <a:xfrm>
-            <a:off x="7948017" y="2058591"/>
+            <a:off x="7948017" y="2160191"/>
             <a:ext cx="3424734" cy="334963"/>
           </a:xfrm>
           <a:prstGeom prst="roundRect">
@@ -6414,7 +6414,7 @@
         </p:nvSpPr>
         <p:spPr>
           <a:xfrm>
-            <a:off x="8062317" y="2474754"/>
+            <a:off x="8062317" y="2576354"/>
             <a:ext cx="3215184" cy="619125"/>
           </a:xfrm>
           <a:prstGeom prst="rect">
@@ -6456,7 +6456,7 @@
         </p:nvSpPr>
         <p:spPr>
           <a:xfrm>
-            <a:off x="812800" y="3298428"/>
+            <a:off x="812800" y="3400028"/>
             <a:ext cx="3437434" cy="1144587"/>
           </a:xfrm>
           <a:prstGeom prst="roundRect">
@@ -6483,7 +6483,7 @@
         </p:nvSpPr>
         <p:spPr>
           <a:xfrm>
-            <a:off x="819150" y="3304778"/>
+            <a:off x="819150" y="3406378"/>
             <a:ext cx="3424734" cy="334963"/>
           </a:xfrm>
           <a:prstGeom prst="roundRect">
@@ -6529,7 +6529,7 @@
         </p:nvSpPr>
         <p:spPr>
           <a:xfrm>
-            <a:off x="933450" y="3720941"/>
+            <a:off x="933450" y="3822541"/>
             <a:ext cx="3215184" cy="619125"/>
           </a:xfrm>
           <a:prstGeom prst="rect">
@@ -6571,7 +6571,7 @@
         </p:nvSpPr>
         <p:spPr>
           <a:xfrm>
-            <a:off x="4377234" y="3298428"/>
+            <a:off x="4377234" y="3400028"/>
             <a:ext cx="3437434" cy="1144587"/>
           </a:xfrm>
           <a:prstGeom prst="roundRect">
@@ -6598,7 +6598,7 @@
         </p:nvSpPr>
         <p:spPr>
           <a:xfrm>
-            <a:off x="4383584" y="3304778"/>
+            <a:off x="4383584" y="3406378"/>
             <a:ext cx="3424734" cy="334963"/>
           </a:xfrm>
           <a:prstGeom prst="roundRect">
@@ -6644,7 +6644,7 @@
         </p:nvSpPr>
         <p:spPr>
           <a:xfrm>
-            <a:off x="4497884" y="3720941"/>
+            <a:off x="4497884" y="3822541"/>
             <a:ext cx="3215184" cy="206375"/>
           </a:xfrm>
           <a:prstGeom prst="rect">
@@ -6686,7 +6686,7 @@
         </p:nvSpPr>
         <p:spPr>
           <a:xfrm>
-            <a:off x="7941667" y="3298428"/>
+            <a:off x="7941667" y="3400028"/>
             <a:ext cx="3437434" cy="1144587"/>
           </a:xfrm>
           <a:prstGeom prst="roundRect">
@@ -6713,7 +6713,7 @@
         </p:nvSpPr>
         <p:spPr>
           <a:xfrm>
-            <a:off x="7948017" y="3304778"/>
+            <a:off x="7948017" y="3406378"/>
             <a:ext cx="3424734" cy="334963"/>
           </a:xfrm>
           <a:prstGeom prst="roundRect">
@@ -6759,7 +6759,7 @@
         </p:nvSpPr>
         <p:spPr>
           <a:xfrm>
-            <a:off x="8062317" y="3720941"/>
+            <a:off x="8062317" y="3822541"/>
             <a:ext cx="3215184" cy="412750"/>
           </a:xfrm>
           <a:prstGeom prst="rect">
@@ -6801,7 +6801,7 @@
         </p:nvSpPr>
         <p:spPr>
           <a:xfrm>
-            <a:off x="812800" y="4572635"/>
+            <a:off x="812800" y="4674235"/>
             <a:ext cx="10585450" cy="642938"/>
           </a:xfrm>
           <a:prstGeom prst="rect">
@@ -6854,7 +6854,7 @@
         </p:nvSpPr>
         <p:spPr>
           <a:xfrm>
-            <a:off x="803275" y="5357543"/>
+            <a:off x="803275" y="5459143"/>
             <a:ext cx="10585450" cy="247650"/>
           </a:xfrm>
           <a:prstGeom prst="rect">
@@ -6896,8 +6896,8 @@
         </p:nvSpPr>
         <p:spPr>
           <a:xfrm>
-            <a:off x="812800" y="6245073"/>
-            <a:ext cx="10433050" cy="195560"/>
+            <a:off x="812800" y="6226316"/>
+            <a:ext cx="10433050" cy="213320"/>
           </a:xfrm>
           <a:prstGeom prst="rect">
             <a:avLst/>
@@ -6911,12 +6911,12 @@
           <a:p>
             <a:pPr algn="l" indent="0" marL="0">
               <a:lnSpc>
-                <a:spcPts val="1540"/>
-              </a:lnSpc>
-              <a:buNone/>
-            </a:pPr>
-            <a:r>
-              <a:rPr lang="pt-BR" altLang="en-US" sz="1100" dirty="0">
+                <a:spcPts val="1680"/>
+              </a:lnSpc>
+              <a:buNone/>
+            </a:pPr>
+            <a:r>
+              <a:rPr lang="pt-BR" altLang="en-US" sz="1200" dirty="0">
                 <a:solidFill>
                   <a:srgbClr val="56606B"/>
                 </a:solidFill>
@@ -6926,7 +6926,7 @@
               </a:rPr>
               <a:t>Gouvêa, PLoS One 2022 · SSC 2026 · Hajjar, Anesthesiology 2017 (VANCS) · Miller’s Anesthesia, 10ª ed. (2025), cap. 16, 33, 56, 79</a:t>
             </a:r>
-            <a:endParaRPr lang="en-US" sz="1100" dirty="0"/>
+            <a:endParaRPr lang="en-US" sz="1200" dirty="0"/>
           </a:p>
         </p:txBody>
       </p:sp>

</xml_diff>

<commit_message>
Versão 46: falas dos slides 10 a 13 resumidas (gravação própria do Bruno até a adrenalina); 10 min 20 s
Co-Authored-By: Claude Fable 5.1 <noreply@anthropic.com>
Claude-Session: https://claude.ai/code/session_01W6cLQUtwNHu1UUeBJH2XLT
</commit_message>
<xml_diff>
--- a/apresentacao/Aminas_Vasoativas.pptx
+++ b/apresentacao/Aminas_Vasoativas.pptx
@@ -120,24 +120,24 @@
   <p:extLst>
     <p:ext uri="{521415D9-36F7-43E2-AB2F-B90AF26B5E84}">
       <p14:sectionLst xmlns:p14="http://schemas.microsoft.com/office/powerpoint/2010/main">
-        <p14:section name="Abertura e objetivos" id="{85266978-4b45-a95c-5722-7312eebbce75}">
+        <p14:section name="Abertura e objetivos" id="{91f037bb-8260-f021-422c-8fa1bd6dee72}">
           <p14:sldIdLst>
             <p14:sldId id="256"/>
             <p14:sldId id="257"/>
           </p14:sldIdLst>
         </p14:section>
-        <p14:section name="01 · Fisiologia: pressão, débito e perfusão" id="{1a9b62fd-9c58-7122-80e6-5fc3ba6dbf35}">
+        <p14:section name="01 · Fisiologia: pressão, débito e perfusão" id="{c36e7cb6-3c88-ce9a-4816-a4e7b9eeb189}">
           <p14:sldIdLst>
             <p14:sldId id="258"/>
             <p14:sldId id="259"/>
           </p14:sldIdLst>
         </p14:section>
-        <p14:section name="02 · Receptores" id="{8da31c8c-a687-b0ea-0041-5ae8391fbc74}">
+        <p14:section name="02 · Receptores" id="{f0e3238f-0662-96b7-df77-cbc47975a8ba}">
           <p14:sldIdLst>
             <p14:sldId id="260"/>
           </p14:sldIdLst>
         </p14:section>
-        <p14:section name="03 · Drogas: noradrenalina, adrenalina, dobutamina (e dopamina), milrinona (escolha), fenilefrina e efedrina" id="{f74d0e28-d962-2fc5-63f0-851bb30642ee}">
+        <p14:section name="03 · Drogas: noradrenalina, adrenalina, dobutamina (e dopamina), milrinona (escolha), fenilefrina e efedrina" id="{0e75cbdc-cafd-3e3a-bec8-3b6f0e35161d}">
           <p14:sldIdLst>
             <p14:sldId id="261"/>
             <p14:sldId id="262"/>
@@ -147,17 +147,17 @@
             <p14:sldId id="266"/>
           </p14:sldIdLst>
         </p14:section>
-        <p14:section name="04 · Além das aminas: vasopressina, hidrocortisona e azul de metileno" id="{dd95bf7c-3cc3-7589-a2a4-0bd5f89b8c23}">
+        <p14:section name="04 · Além das aminas: vasopressina, hidrocortisona e azul de metileno" id="{17da6a65-aa31-1b7f-8df4-ab26f09a6568}">
           <p14:sldIdLst>
             <p14:sldId id="267"/>
           </p14:sldIdLst>
         </p14:section>
-        <p14:section name="05 · Perioperatório: escolha da droga e mensagem final" id="{48bccc8f-2484-17b0-cbf2-82aabe421ce4}">
+        <p14:section name="05 · Perioperatório: escolha da droga e mensagem final" id="{0857ad27-5f6f-d932-9f04-66ce83f6f06e}">
           <p14:sldIdLst>
             <p14:sldId id="268"/>
           </p14:sldIdLst>
         </p14:section>
-        <p14:section name="06 · Encerramento" id="{b01c6fda-3d56-e62d-d897-32af04d7ba90}">
+        <p14:section name="06 · Encerramento" id="{5ad6c519-d9d8-fe41-484b-564472bea535}">
           <p14:sldIdLst>
             <p14:sldId id="269"/>
           </p14:sldIdLst>
@@ -573,7 +573,7 @@
           <a:p>
             <a:r>
               <a:rPr lang="en-US" dirty="0"/>
-              <a:t>TEMPO: 25 s (0:00 → 0:25). Total previsto: 11 min 15 s nos 14 slides; ensaiar mirando 12 minutos.</a:t>
+              <a:t>TEMPO: 25 s (0:00 → 0:25). Total previsto: 10 min 25 s nos 14 slides; ensaiar mirando 12 minutos.</a:t>
             </a:r>
             <a:endParaRPr lang="en-US" dirty="0"/>
           </a:p>
@@ -668,14 +668,14 @@
           <a:p>
             <a:r>
               <a:rPr lang="en-US" dirty="0"/>
-              <a:t>FALA: Então, quando escolher? Primeiro, a indicação: inotrópico quando há disfunção ventricular com baixo débito e hipoperfusão, depois de otimizar volume e PAM; se a hipotensão é por vasoplegia, a droga é o vasopressor, e um inodilatador baixa ainda mais a pressão. Depois, o perfil, que está na tabela. Milrinona quando a circulação pulmonar e o VD são o problema, como na hipertensão pulmonar e na saída de CEC com resistência pulmonar alta, ou quando betabloqueio ou taquicardia limitam a dobutamina; a milrinona exige PAM sustentada, em geral com noradrenalina. Dobutamina, com vasopressor, quando o baixo débito vem com hipotensão ou vasoplegia, em que a vasodilatação e a meia-vida longa da milrinona pesam contra; na insuficiência renal; e para titulação rápida, com meia-vida de minutos. No choque séptico com disfunção miocárdica e hipoperfusão persistente, a Surviving Sepsis Campaign de 2026, a SSC, sugere dobutamina com noradrenalina, ou adrenalina, sem dados que a prefiram à milrinona: preferência prática, não superioridade demonstrada.</a:t>
+              <a:t>FALA: Então, quando escolher? Primeiro, a indicação: inotrópico quando há disfunção ventricular com baixo débito e hipoperfusão, depois de otimizar volume e PAM; se a hipotensão é por vasoplegia, a droga é o vasopressor. Depois, o perfil da tabela. Milrinona quando a circulação pulmonar e o VD são o problema, como na hipertensão pulmonar e na saída de CEC com resistência pulmonar alta, ou quando betabloqueio ou taquicardia limitam a dobutamina; a milrinona exige PAM sustentada, em geral com noradrenalina. Dobutamina, com vasopressor, quando o baixo débito vem com hipotensão ou vasoplegia, na insuficiência renal e para titulação rápida. No choque séptico, a Surviving Sepsis Campaign de 2026 sugere dobutamina com noradrenalina, ou adrenalina, sem dados que a prefiram à milrinona: preferência prática, não superioridade demonstrada.</a:t>
             </a:r>
             <a:endParaRPr lang="en-US" dirty="0"/>
           </a:p>
           <a:p>
             <a:r>
               <a:rPr lang="en-US" dirty="0"/>
-              <a:t>TEMPO: 1 min 15 s (6:25 → 7:40)</a:t>
+              <a:t>TEMPO: 1 min (6:25 → 7:25)</a:t>
             </a:r>
             <a:endParaRPr lang="en-US" dirty="0"/>
           </a:p>
@@ -777,14 +777,14 @@
           <a:p>
             <a:r>
               <a:rPr lang="en-US" dirty="0"/>
-              <a:t>FALA: Agora duas aminas simpaticomiméticas que não são catecolaminas, as drogas habituais de bolus do centro cirúrgico. Fenilefrina: agonista α1 direto, praticamente sem ação β; a PAM sobe pela resistência e a frequência cai por reflexo, o que pode reduzir o débito quando ele depende da frequência; é a escolha na hipotensão vasodilatadora com frequência normal ou alta. Efedrina: age diretamente em α e β e também, de forma indireta, libera noradrenalina das terminações; sobe pressão, frequência e débito, por isso é a escolha quando há bradicardia; perde efeito com doses repetidas, em parte porque depleta a noradrenalina, e na cesárea atravessa a placenta e associa-se a mais acidose fetal que a fenilefrina.</a:t>
+              <a:t>FALA: Duas aminas que não são catecolaminas, as drogas habituais de bolus do centro cirúrgico. Fenilefrina: agonista α1 direto; a PAM sobe pela resistência e a frequência cai por reflexo, o que pode reduzir o débito; é a escolha na hipotensão vasodilatadora com frequência normal ou alta. Efedrina: ação direta em α e β e indireta, liberando noradrenalina; sobe pressão, frequência e débito, por isso é a escolha quando há bradicardia; faz taquifilaxia e, na cesárea, associa-se a mais acidose fetal que a fenilefrina.</a:t>
             </a:r>
             <a:endParaRPr lang="en-US" dirty="0"/>
           </a:p>
           <a:p>
             <a:r>
               <a:rPr lang="en-US" dirty="0"/>
-              <a:t>TEMPO: 50 s (7:40 → 8:30)</a:t>
+              <a:t>TEMPO: 40 s (7:25 → 8:05)</a:t>
             </a:r>
             <a:endParaRPr lang="en-US" dirty="0"/>
           </a:p>
@@ -879,14 +879,14 @@
           <a:p>
             <a:r>
               <a:rPr lang="en-US" dirty="0"/>
-              <a:t>FALA: Três recursos além das aminas. A vasopressina age no receptor V1, fora da via adrenérgica, e costuma manter efeito em acidose: no choque séptico com noradrenalina em escalada, dose em geral fixa de 0,03 unidades por minuto; na vasoplegia após CEC, dose titulada, como no VANCS; na hipotensão refratária com IECA ou BRA, bolus pequenos ou infusão; o risco é isquemia digital e mesentérica. A hidrocortisona restaura a resposta vascular às catecolaminas, 200 mg por dia no choque séptico. O azul de metileno inibe a via do óxido nítrico e fica como resgate na vasoplegia refratária, após CEC ou na reperfusão do enxerto hepático, onde a base são relatos e séries e o uso profilático não mostrou benefício. Cuidados: deficiência de G6PD, interferência na oximetria e síndrome serotoninérgica.</a:t>
+              <a:t>FALA: Três recursos além das aminas. A vasopressina age no receptor V1, fora da via adrenérgica, e costuma manter efeito em acidose: no choque séptico com noradrenalina em escalada, dose em geral fixa de 0,03 unidades por minuto; na vasoplegia após CEC, dose titulada; o risco é isquemia digital e mesentérica. A hidrocortisona restaura a resposta vascular às catecolaminas, 200 mg por dia no choque séptico. O azul de metileno inibe a via do óxido nítrico e é o resgate na vasoplegia refratária, após CEC ou na reperfusão do enxerto hepático, com base em relatos e séries. Cuidados: deficiência de G6PD, oximetria e síndrome serotoninérgica.</a:t>
             </a:r>
             <a:endParaRPr lang="en-US" dirty="0"/>
           </a:p>
           <a:p>
             <a:r>
               <a:rPr lang="en-US" dirty="0"/>
-              <a:t>TEMPO: 1 min (8:30 → 9:30)</a:t>
+              <a:t>TEMPO: 50 s (8:05 → 8:55)</a:t>
             </a:r>
             <a:endParaRPr lang="en-US" dirty="0"/>
           </a:p>
@@ -988,14 +988,14 @@
           <a:p>
             <a:r>
               <a:rPr lang="en-US" dirty="0"/>
-              <a:t>FALA: No centro cirúrgico, antes da droga, afastar causas tratáveis: plano profundo, hipovolemia, compressão aortocava, pneumotórax e anafilaxia. Depois, o mecanismo: tônus baixo com frequência normal ou alta, agonista α1; bradicardia, efedrina ou, se grave, adrenalina; baixo débito com hipoperfusão, inotrópico, com noradrenalina se a PAM cair; vasoplegia persistente, a sequência da Surviving Sepsis Campaign de 2026: noradrenalina em escalada, depois vasopressina e, se a PAM seguir inadequada, adrenalina, com azul de metileno como resgate após CEC, com IECA ou BRA e na reperfusão do enxerto hepático; pré-carga baixa, volume; anafilaxia, adrenalina. Um dado do nosso serviço ajuda nessa decisão: Gouvêa, Diaz e colaboradores acompanharam por ecocardiografia transesofágica o VD de 19 pacientes selecionados em cinco fases do transplante hepático, e a função sistólica se manteve preservada nos momentos avaliados, inclusive trinta minutos após a reperfusão. Como não mediu os primeiros minutos da reperfusão, o estudo não diz se a instabilidade aguda é vasoplegia ou disfunção transitória do VD; o que fica para a prática é o método: usar o eco para separar disfunção de VD de vasoplegia antes de escolher entre inotrópico e vasopressor. Voltando à pergunta do início: a droga certa corrige o componente da PAM que falha, na menor dose eficaz e pelo menor tempo.</a:t>
+              <a:t>FALA: No centro cirúrgico, antes da droga, afastar causas tratáveis: plano profundo, hipovolemia, compressão aortocava, pneumotórax e anafilaxia. Depois, o mecanismo: tônus baixo, agonista α1; bradicardia, efedrina ou, se grave, adrenalina; baixo débito com hipoperfusão, inotrópico, com noradrenalina se a PAM cair; vasoplegia persistente, a sequência da Surviving Sepsis Campaign: noradrenalina, vasopressina e, se preciso, adrenalina, com azul de metileno como resgate; pré-carga baixa, volume; anafilaxia, adrenalina. Um dado do nosso serviço: Gouvêa, Diaz e colaboradores acompanharam por ecocardiografia transesofágica o VD de 19 pacientes em cinco fases do transplante hepático, e a função sistólica se manteve preservada, inclusive trinta minutos após a reperfusão. Como não mediu os primeiros minutos, o estudo não diz se a instabilidade aguda é vasoplegia ou disfunção transitória do VD; o que fica é o método: usar o eco para separar disfunção de VD de vasoplegia antes de escolher entre inotrópico e vasopressor. Voltando à pergunta do início: a droga certa corrige o componente da PAM que falha, na menor dose eficaz e pelo menor tempo.</a:t>
             </a:r>
             <a:endParaRPr lang="en-US" dirty="0"/>
           </a:p>
           <a:p>
             <a:r>
               <a:rPr lang="en-US" dirty="0"/>
-              <a:t>TEMPO: 1 min 35 s (9:30 → 11:05)</a:t>
+              <a:t>TEMPO: 1 min 20 s (8:55 → 10:15)</a:t>
             </a:r>
             <a:endParaRPr lang="en-US" dirty="0"/>
           </a:p>
@@ -1104,7 +1104,7 @@
           <a:p>
             <a:r>
               <a:rPr lang="en-US" dirty="0"/>
-              <a:t>TEMPO: 10 s (11:05 → 11:15)</a:t>
+              <a:t>TEMPO: 10 s (10:15 → 10:25)</a:t>
             </a:r>
             <a:endParaRPr lang="en-US" dirty="0"/>
           </a:p>

</xml_diff>

<commit_message>
Versão 47: sequência da SSC 2026 restrita ao choque séptico no slide de síntese (tela e fala); azul de metileno 'pode ser considerado como resgate'
Co-Authored-By: Claude Fable 5.1 <noreply@anthropic.com>
Claude-Session: https://claude.ai/code/session_01W6cLQUtwNHu1UUeBJH2XLT
</commit_message>
<xml_diff>
--- a/apresentacao/Aminas_Vasoativas.pptx
+++ b/apresentacao/Aminas_Vasoativas.pptx
@@ -120,24 +120,24 @@
   <p:extLst>
     <p:ext uri="{521415D9-36F7-43E2-AB2F-B90AF26B5E84}">
       <p14:sectionLst xmlns:p14="http://schemas.microsoft.com/office/powerpoint/2010/main">
-        <p14:section name="Abertura e objetivos" id="{91f037bb-8260-f021-422c-8fa1bd6dee72}">
+        <p14:section name="Abertura e objetivos" id="{db13688e-7fe4-3f58-d919-2afeebcbb797}">
           <p14:sldIdLst>
             <p14:sldId id="256"/>
             <p14:sldId id="257"/>
           </p14:sldIdLst>
         </p14:section>
-        <p14:section name="01 · Fisiologia: pressão, débito e perfusão" id="{c36e7cb6-3c88-ce9a-4816-a4e7b9eeb189}">
+        <p14:section name="01 · Fisiologia: pressão, débito e perfusão" id="{c9dd94b2-2cc2-1b94-fbf8-7a264c1a3b6b}">
           <p14:sldIdLst>
             <p14:sldId id="258"/>
             <p14:sldId id="259"/>
           </p14:sldIdLst>
         </p14:section>
-        <p14:section name="02 · Receptores" id="{f0e3238f-0662-96b7-df77-cbc47975a8ba}">
+        <p14:section name="02 · Receptores" id="{234aeb87-7aa9-4855-c21c-1f6f97a045d4}">
           <p14:sldIdLst>
             <p14:sldId id="260"/>
           </p14:sldIdLst>
         </p14:section>
-        <p14:section name="03 · Drogas: noradrenalina, adrenalina, dobutamina (e dopamina), milrinona (escolha), fenilefrina e efedrina" id="{0e75cbdc-cafd-3e3a-bec8-3b6f0e35161d}">
+        <p14:section name="03 · Drogas: noradrenalina, adrenalina, dobutamina (e dopamina), milrinona (escolha), fenilefrina e efedrina" id="{e824bf49-867d-8431-3b27-c0c5a7ba0ad4}">
           <p14:sldIdLst>
             <p14:sldId id="261"/>
             <p14:sldId id="262"/>
@@ -147,17 +147,17 @@
             <p14:sldId id="266"/>
           </p14:sldIdLst>
         </p14:section>
-        <p14:section name="04 · Além das aminas: vasopressina, hidrocortisona e azul de metileno" id="{17da6a65-aa31-1b7f-8df4-ab26f09a6568}">
+        <p14:section name="04 · Além das aminas: vasopressina, hidrocortisona e azul de metileno" id="{0f07f3c7-86d4-fb80-5b55-de4ae3c4a45c}">
           <p14:sldIdLst>
             <p14:sldId id="267"/>
           </p14:sldIdLst>
         </p14:section>
-        <p14:section name="05 · Perioperatório: escolha da droga e mensagem final" id="{0857ad27-5f6f-d932-9f04-66ce83f6f06e}">
+        <p14:section name="05 · Perioperatório: escolha da droga e mensagem final" id="{16c68812-707c-1a0b-c4c6-dc5f98620f1e}">
           <p14:sldIdLst>
             <p14:sldId id="268"/>
           </p14:sldIdLst>
         </p14:section>
-        <p14:section name="06 · Encerramento" id="{5ad6c519-d9d8-fe41-484b-564472bea535}">
+        <p14:section name="06 · Encerramento" id="{80dee039-2ab8-f57b-7e46-b8f7d38b75c3}">
           <p14:sldIdLst>
             <p14:sldId id="269"/>
           </p14:sldIdLst>
@@ -879,7 +879,7 @@
           <a:p>
             <a:r>
               <a:rPr lang="en-US" dirty="0"/>
-              <a:t>FALA: Três recursos além das aminas. A vasopressina age no receptor V1, fora da via adrenérgica, e costuma manter efeito em acidose: no choque séptico com noradrenalina em escalada, dose em geral fixa de 0,03 unidades por minuto; na vasoplegia após CEC, dose titulada; o risco é isquemia digital e mesentérica. A hidrocortisona restaura a resposta vascular às catecolaminas, 200 mg por dia no choque séptico. O azul de metileno inibe a via do óxido nítrico e é o resgate na vasoplegia refratária, após CEC ou na reperfusão do enxerto hepático, com base em relatos e séries. Cuidados: deficiência de G6PD, oximetria e síndrome serotoninérgica.</a:t>
+              <a:t>FALA: Três recursos além das aminas. A vasopressina age no receptor V1, fora da via adrenérgica, e costuma manter efeito em acidose: no choque séptico com noradrenalina em escalada, dose em geral fixa de 0,03 unidades por minuto; na vasoplegia após CEC, dose titulada; o risco é isquemia digital e mesentérica. A hidrocortisona restaura a resposta vascular às catecolaminas, 200 mg por dia no choque séptico. O azul de metileno inibe a via do óxido nítrico e pode ser considerado como resgate na vasoplegia refratária, após CEC ou na reperfusão do enxerto hepático, com base em relatos e séries. Cuidados: deficiência de G6PD, oximetria e síndrome serotoninérgica.</a:t>
             </a:r>
             <a:endParaRPr lang="en-US" dirty="0"/>
           </a:p>
@@ -988,7 +988,7 @@
           <a:p>
             <a:r>
               <a:rPr lang="en-US" dirty="0"/>
-              <a:t>FALA: No centro cirúrgico, antes da droga, afastar causas tratáveis: plano profundo, hipovolemia, compressão aortocava, pneumotórax e anafilaxia. Depois, o mecanismo: tônus baixo, agonista α1; bradicardia, efedrina ou, se grave, adrenalina; baixo débito com hipoperfusão, inotrópico, com noradrenalina se a PAM cair; vasoplegia persistente, a sequência da Surviving Sepsis Campaign: noradrenalina, vasopressina e, se preciso, adrenalina, com azul de metileno como resgate; pré-carga baixa, volume; anafilaxia, adrenalina. Um dado do nosso serviço: Gouvêa, Diaz e colaboradores acompanharam por ecocardiografia transesofágica o VD de 19 pacientes em cinco fases do transplante hepático, e a função sistólica se manteve preservada, inclusive trinta minutos após a reperfusão. Como não mediu os primeiros minutos, o estudo não diz se a instabilidade aguda é vasoplegia ou disfunção transitória do VD; o que fica é o método: usar o eco para separar disfunção de VD de vasoplegia antes de escolher entre inotrópico e vasopressor. Voltando à pergunta do início: a droga certa corrige o componente da PAM que falha, na menor dose eficaz e pelo menor tempo.</a:t>
+              <a:t>FALA: No centro cirúrgico, antes da droga, afastar causas tratáveis: plano profundo, hipovolemia, compressão aortocava, pneumotórax e anafilaxia. Depois, o mecanismo: tônus baixo, agonista α1; bradicardia, efedrina ou, se grave, adrenalina; baixo débito com hipoperfusão, inotrópico, com noradrenalina se a PAM cair; vasoplegia persistente, vasopressina, e, no choque séptico, a sequência da Surviving Sepsis Campaign: noradrenalina, depois vasopressina e, se preciso, adrenalina; azul de metileno como resgate em casos selecionados; pré-carga baixa, volume; anafilaxia, adrenalina. Um dado do nosso serviço: Gouvêa, Diaz e colaboradores acompanharam por ecocardiografia transesofágica o VD de 19 pacientes em cinco fases do transplante hepático, e a função sistólica se manteve preservada, inclusive trinta minutos após a reperfusão. Como não mediu os primeiros minutos, o estudo não diz se a instabilidade aguda é vasoplegia ou disfunção transitória do VD; o que fica é o método: usar o eco para separar disfunção de VD de vasoplegia antes de escolher entre inotrópico e vasopressor. Voltando à pergunta do início: a droga certa corrige o componente da PAM que falha, na menor dose eficaz e pelo menor tempo.</a:t>
             </a:r>
             <a:endParaRPr lang="en-US" dirty="0"/>
           </a:p>
@@ -6523,7 +6523,7 @@
       </p:sp>
       <p:sp>
         <p:nvSpPr>
-          <p:cNvPr id="20" name="NA em escalada → vasopressina → adrenali"/>
+          <p:cNvPr id="20" name="Vasopressina; no choque séptico, NA → va"/>
           <p:cNvSpPr txBox="1"/>
           <p:nvPr/>
         </p:nvSpPr>
@@ -6557,7 +6557,7 @@
                 <a:ea typeface="Calibri" pitchFamily="34" charset="-122"/>
                 <a:cs typeface="Calibri" pitchFamily="34" charset="-120"/>
               </a:rPr>
-              <a:t>NA em escalada → vasopressina → adrenalina (SSC 2026); azul de metileno como resgate (pós-CEC, IECA/BRA, reperfusão hepática)</a:t>
+              <a:t>Vasopressina; no choque séptico, NA → vasopressina → adrenalina (SSC 2026); azul de metileno como resgate</a:t>
             </a:r>
             <a:endParaRPr lang="en-US" sz="1250" dirty="0"/>
           </a:p>

</xml_diff>

<commit_message>
Versão 48: estudo de Gouvêa e Diaz retirado do slide de síntese (tela, fala, nota, rodapé e guia); 14 slides, 10 min
Co-Authored-By: Claude Fable 5.1 <noreply@anthropic.com>
Claude-Session: https://claude.ai/code/session_01W6cLQUtwNHu1UUeBJH2XLT
</commit_message>
<xml_diff>
--- a/apresentacao/Aminas_Vasoativas.pptx
+++ b/apresentacao/Aminas_Vasoativas.pptx
@@ -120,24 +120,24 @@
   <p:extLst>
     <p:ext uri="{521415D9-36F7-43E2-AB2F-B90AF26B5E84}">
       <p14:sectionLst xmlns:p14="http://schemas.microsoft.com/office/powerpoint/2010/main">
-        <p14:section name="Abertura e objetivos" id="{db13688e-7fe4-3f58-d919-2afeebcbb797}">
+        <p14:section name="Abertura e objetivos" id="{f10647b6-ef12-4766-beae-1b1b5c528beb}">
           <p14:sldIdLst>
             <p14:sldId id="256"/>
             <p14:sldId id="257"/>
           </p14:sldIdLst>
         </p14:section>
-        <p14:section name="01 · Fisiologia: pressão, débito e perfusão" id="{c9dd94b2-2cc2-1b94-fbf8-7a264c1a3b6b}">
+        <p14:section name="01 · Fisiologia: pressão, débito e perfusão" id="{db7d6926-8231-a237-8584-623647cc94d3}">
           <p14:sldIdLst>
             <p14:sldId id="258"/>
             <p14:sldId id="259"/>
           </p14:sldIdLst>
         </p14:section>
-        <p14:section name="02 · Receptores" id="{234aeb87-7aa9-4855-c21c-1f6f97a045d4}">
+        <p14:section name="02 · Receptores" id="{6ec7c805-6cc5-efd2-c5b8-fe53ba564418}">
           <p14:sldIdLst>
             <p14:sldId id="260"/>
           </p14:sldIdLst>
         </p14:section>
-        <p14:section name="03 · Drogas: noradrenalina, adrenalina, dobutamina (e dopamina), milrinona (escolha), fenilefrina e efedrina" id="{e824bf49-867d-8431-3b27-c0c5a7ba0ad4}">
+        <p14:section name="03 · Drogas: noradrenalina, adrenalina, dobutamina (e dopamina), milrinona (escolha), fenilefrina e efedrina" id="{40b04b43-5346-9895-56ed-3605b01baf1f}">
           <p14:sldIdLst>
             <p14:sldId id="261"/>
             <p14:sldId id="262"/>
@@ -147,17 +147,17 @@
             <p14:sldId id="266"/>
           </p14:sldIdLst>
         </p14:section>
-        <p14:section name="04 · Além das aminas: vasopressina, hidrocortisona e azul de metileno" id="{0f07f3c7-86d4-fb80-5b55-de4ae3c4a45c}">
+        <p14:section name="04 · Além das aminas: vasopressina, hidrocortisona e azul de metileno" id="{331aded4-bf74-e2bc-6c35-e9381cd8d1e3}">
           <p14:sldIdLst>
             <p14:sldId id="267"/>
           </p14:sldIdLst>
         </p14:section>
-        <p14:section name="05 · Perioperatório: escolha da droga e mensagem final" id="{16c68812-707c-1a0b-c4c6-dc5f98620f1e}">
+        <p14:section name="05 · Perioperatório: escolha da droga e mensagem final" id="{286f362b-6728-43f6-34c9-f64bc4866387}">
           <p14:sldIdLst>
             <p14:sldId id="268"/>
           </p14:sldIdLst>
         </p14:section>
-        <p14:section name="06 · Encerramento" id="{80dee039-2ab8-f57b-7e46-b8f7d38b75c3}">
+        <p14:section name="06 · Encerramento" id="{e40a9a66-86c4-50bc-c226-8e1fac8b3784}">
           <p14:sldIdLst>
             <p14:sldId id="269"/>
           </p14:sldIdLst>
@@ -573,7 +573,7 @@
           <a:p>
             <a:r>
               <a:rPr lang="en-US" dirty="0"/>
-              <a:t>TEMPO: 25 s (0:00 → 0:25). Total previsto: 10 min 25 s nos 14 slides; ensaiar mirando 12 minutos.</a:t>
+              <a:t>TEMPO: 25 s (0:00 → 0:25). Total previsto: 10 min 00 s nos 14 slides; ensaiar mirando 12 minutos.</a:t>
             </a:r>
             <a:endParaRPr lang="en-US" dirty="0"/>
           </a:p>
@@ -988,14 +988,14 @@
           <a:p>
             <a:r>
               <a:rPr lang="en-US" dirty="0"/>
-              <a:t>FALA: No centro cirúrgico, antes da droga, afastar causas tratáveis: plano profundo, hipovolemia, compressão aortocava, pneumotórax e anafilaxia. Depois, o mecanismo: tônus baixo, agonista α1; bradicardia, efedrina ou, se grave, adrenalina; baixo débito com hipoperfusão, inotrópico, com noradrenalina se a PAM cair; vasoplegia persistente, vasopressina, e, no choque séptico, a sequência da Surviving Sepsis Campaign: noradrenalina, depois vasopressina e, se preciso, adrenalina; azul de metileno como resgate em casos selecionados; pré-carga baixa, volume; anafilaxia, adrenalina. Um dado do nosso serviço: Gouvêa, Diaz e colaboradores acompanharam por ecocardiografia transesofágica o VD de 19 pacientes em cinco fases do transplante hepático, e a função sistólica se manteve preservada, inclusive trinta minutos após a reperfusão. Como não mediu os primeiros minutos, o estudo não diz se a instabilidade aguda é vasoplegia ou disfunção transitória do VD; o que fica é o método: usar o eco para separar disfunção de VD de vasoplegia antes de escolher entre inotrópico e vasopressor. Voltando à pergunta do início: a droga certa corrige o componente da PAM que falha, na menor dose eficaz e pelo menor tempo.</a:t>
+              <a:t>FALA: No centro cirúrgico, antes da droga, afastar causas tratáveis: plano profundo, hipovolemia, compressão aortocava, pneumotórax e anafilaxia. Depois, o mecanismo: tônus baixo, agonista α1; bradicardia, efedrina ou, se grave, adrenalina; baixo débito com hipoperfusão, inotrópico, com noradrenalina se a PAM cair; vasoplegia persistente, vasopressina, e, no choque séptico, a sequência da Surviving Sepsis Campaign: noradrenalina, depois vasopressina e, se preciso, adrenalina; azul de metileno como resgate em casos selecionados; pré-carga baixa, volume; anafilaxia, adrenalina. Na dúvida entre vasoplegia e falência de VD, o eco separa as duas antes de escolher entre vasopressor e inotrópico. Voltando à pergunta do início: a droga certa corrige o componente da PAM que falha, na menor dose eficaz e pelo menor tempo.</a:t>
             </a:r>
             <a:endParaRPr lang="en-US" dirty="0"/>
           </a:p>
           <a:p>
             <a:r>
               <a:rPr lang="en-US" dirty="0"/>
-              <a:t>TEMPO: 1 min 20 s (8:55 → 10:15)</a:t>
+              <a:t>TEMPO: 55 s (8:55 → 9:50)</a:t>
             </a:r>
             <a:endParaRPr lang="en-US" dirty="0"/>
           </a:p>
@@ -1009,7 +1009,7 @@
           <a:p>
             <a:r>
               <a:rPr lang="en-US" dirty="0"/>
-              <a:t>SE PERGUNTAREM: Gouvêa G, Feiner J, Joshi S, Diaz R, et al., PLoS One 2022;17(10):e0275301: estudo observacional, 19 adultos de 18 a 65 anos, TAPSE e variação fracional de área do VD em cinco fases (basal, fase de hepatectomia, fase anepática, 30 min após a reperfusão e fechamento); função sistólica do VD preservada nos cinco momentos; excluídos hipertensão portopulmonar, síndrome hepatopulmonar, doença cardiopulmonar e insuficiência hepática fulminante. População selecionada e medida feita 30 min depois da reperfusão: o estudo não mediu os primeiros minutos, quando ocorre a síndrome pós-reperfusão, não exclui disfunção transitória do VD nesse período e não permite atribuir a instabilidade aguda a vasoplegia. TAPSE e variação fracional de área dependem da carga, e o TAPSE mede apenas a excursão longitudinal do anel lateral; normais sob anestesia, com pós-carga baixa, afastam disfunção sistólica evidente nos momentos avaliados, não medem reserva contrátil. O estudo mediu a função do VD; não testou a capacidade do eco de diferenciar vasoplegia de disfunção ventricular na hipotensão aguda: essa é a aplicação clínica proposta na aula, não um resultado do estudo. Choque séptico (SSC 2026): noradrenalina em primeira linha, iniciada cedo, mesmo em veia periférica; vasopressina quando a dose de noradrenalina sobe, sem limiar definido; adrenalina se a PAM continuar inadequada; inotrópico reservado à disfunção cardíaca com hipoperfusão. VASSPR (JAMA 2026, n = 3.959; cluster-crossover em 13 hospitais): iniciar vasopressina com 0,1 vs. 0,4 mcg/kg/min de noradrenalina-equivalente não mudou a mortalidade (31,8% vs. 33,0%). OPTPRESS: alvo de PAM de 80–85 mmHg em idosos aumentou a mortalidade.</a:t>
+              <a:t>SE PERGUNTAREM: O eco separa vasoplegia de disfunção de VD pela função sistólica (variação fracional de área, TAPSE) e pelo tamanho das cavidades; o VTI seriado mostra a resposta à intervenção. Choque séptico (SSC 2026): noradrenalina em primeira linha, iniciada cedo, mesmo em veia periférica; vasopressina quando a dose de noradrenalina sobe, sem limiar definido; adrenalina se a PAM continuar inadequada; inotrópico reservado à disfunção cardíaca com hipoperfusão. VASSPR (JAMA 2026, n = 3.959; cluster-crossover em 13 hospitais): iniciar vasopressina com 0,1 vs. 0,4 mcg/kg/min de noradrenalina-equivalente não mudou a mortalidade (31,8% vs. 33,0%). OPTPRESS: alvo de PAM de 80–85 mmHg em idosos aumentou a mortalidade.</a:t>
             </a:r>
             <a:endParaRPr lang="en-US" dirty="0"/>
           </a:p>
@@ -1104,7 +1104,7 @@
           <a:p>
             <a:r>
               <a:rPr lang="en-US" dirty="0"/>
-              <a:t>TEMPO: 10 s (10:15 → 10:25)</a:t>
+              <a:t>TEMPO: 10 s (9:50 → 10:00)</a:t>
             </a:r>
             <a:endParaRPr lang="en-US" dirty="0"/>
           </a:p>
@@ -5885,7 +5885,7 @@
         </p:nvSpPr>
         <p:spPr>
           <a:xfrm>
-            <a:off x="812800" y="1676301"/>
+            <a:off x="812800" y="1714401"/>
             <a:ext cx="920055" cy="322560"/>
           </a:xfrm>
           <a:prstGeom prst="roundRect">
@@ -5931,7 +5931,7 @@
         </p:nvSpPr>
         <p:spPr>
           <a:xfrm>
-            <a:off x="1834455" y="1732817"/>
+            <a:off x="1834455" y="1770917"/>
             <a:ext cx="226020" cy="228600"/>
           </a:xfrm>
           <a:prstGeom prst="rect">
@@ -5973,7 +5973,7 @@
         </p:nvSpPr>
         <p:spPr>
           <a:xfrm>
-            <a:off x="2143026" y="1661120"/>
+            <a:off x="2143026" y="1699220"/>
             <a:ext cx="5803999" cy="353020"/>
           </a:xfrm>
           <a:prstGeom prst="roundRect">
@@ -6023,7 +6023,7 @@
         </p:nvSpPr>
         <p:spPr>
           <a:xfrm>
-            <a:off x="8048625" y="1732817"/>
+            <a:off x="8048625" y="1770917"/>
             <a:ext cx="226020" cy="228600"/>
           </a:xfrm>
           <a:prstGeom prst="rect">
@@ -6065,7 +6065,7 @@
         </p:nvSpPr>
         <p:spPr>
           <a:xfrm>
-            <a:off x="8357195" y="1676301"/>
+            <a:off x="8357195" y="1714401"/>
             <a:ext cx="1289546" cy="322560"/>
           </a:xfrm>
           <a:prstGeom prst="roundRect">
@@ -6111,7 +6111,7 @@
         </p:nvSpPr>
         <p:spPr>
           <a:xfrm>
-            <a:off x="812800" y="2153841"/>
+            <a:off x="812800" y="2230041"/>
             <a:ext cx="3437434" cy="1144587"/>
           </a:xfrm>
           <a:prstGeom prst="roundRect">
@@ -6138,7 +6138,7 @@
         </p:nvSpPr>
         <p:spPr>
           <a:xfrm>
-            <a:off x="819150" y="2160191"/>
+            <a:off x="819150" y="2236391"/>
             <a:ext cx="3424734" cy="334963"/>
           </a:xfrm>
           <a:prstGeom prst="roundRect">
@@ -6184,7 +6184,7 @@
         </p:nvSpPr>
         <p:spPr>
           <a:xfrm>
-            <a:off x="933450" y="2576354"/>
+            <a:off x="933450" y="2652554"/>
             <a:ext cx="3215184" cy="412750"/>
           </a:xfrm>
           <a:prstGeom prst="rect">
@@ -6226,7 +6226,7 @@
         </p:nvSpPr>
         <p:spPr>
           <a:xfrm>
-            <a:off x="4377234" y="2153841"/>
+            <a:off x="4377234" y="2230041"/>
             <a:ext cx="3437434" cy="1144587"/>
           </a:xfrm>
           <a:prstGeom prst="roundRect">
@@ -6253,7 +6253,7 @@
         </p:nvSpPr>
         <p:spPr>
           <a:xfrm>
-            <a:off x="4383584" y="2160191"/>
+            <a:off x="4383584" y="2236391"/>
             <a:ext cx="3424734" cy="334963"/>
           </a:xfrm>
           <a:prstGeom prst="roundRect">
@@ -6299,7 +6299,7 @@
         </p:nvSpPr>
         <p:spPr>
           <a:xfrm>
-            <a:off x="4497884" y="2576354"/>
+            <a:off x="4497884" y="2652554"/>
             <a:ext cx="3215184" cy="206375"/>
           </a:xfrm>
           <a:prstGeom prst="rect">
@@ -6341,7 +6341,7 @@
         </p:nvSpPr>
         <p:spPr>
           <a:xfrm>
-            <a:off x="7941667" y="2153841"/>
+            <a:off x="7941667" y="2230041"/>
             <a:ext cx="3437434" cy="1144587"/>
           </a:xfrm>
           <a:prstGeom prst="roundRect">
@@ -6368,7 +6368,7 @@
         </p:nvSpPr>
         <p:spPr>
           <a:xfrm>
-            <a:off x="7948017" y="2160191"/>
+            <a:off x="7948017" y="2236391"/>
             <a:ext cx="3424734" cy="334963"/>
           </a:xfrm>
           <a:prstGeom prst="roundRect">
@@ -6414,7 +6414,7 @@
         </p:nvSpPr>
         <p:spPr>
           <a:xfrm>
-            <a:off x="8062317" y="2576354"/>
+            <a:off x="8062317" y="2652554"/>
             <a:ext cx="3215184" cy="619125"/>
           </a:xfrm>
           <a:prstGeom prst="rect">
@@ -6456,7 +6456,7 @@
         </p:nvSpPr>
         <p:spPr>
           <a:xfrm>
-            <a:off x="812800" y="3400028"/>
+            <a:off x="812800" y="3476228"/>
             <a:ext cx="3437434" cy="1144587"/>
           </a:xfrm>
           <a:prstGeom prst="roundRect">
@@ -6483,7 +6483,7 @@
         </p:nvSpPr>
         <p:spPr>
           <a:xfrm>
-            <a:off x="819150" y="3406378"/>
+            <a:off x="819150" y="3482578"/>
             <a:ext cx="3424734" cy="334963"/>
           </a:xfrm>
           <a:prstGeom prst="roundRect">
@@ -6529,7 +6529,7 @@
         </p:nvSpPr>
         <p:spPr>
           <a:xfrm>
-            <a:off x="933450" y="3822541"/>
+            <a:off x="933450" y="3898741"/>
             <a:ext cx="3215184" cy="619125"/>
           </a:xfrm>
           <a:prstGeom prst="rect">
@@ -6571,7 +6571,7 @@
         </p:nvSpPr>
         <p:spPr>
           <a:xfrm>
-            <a:off x="4377234" y="3400028"/>
+            <a:off x="4377234" y="3476228"/>
             <a:ext cx="3437434" cy="1144587"/>
           </a:xfrm>
           <a:prstGeom prst="roundRect">
@@ -6598,7 +6598,7 @@
         </p:nvSpPr>
         <p:spPr>
           <a:xfrm>
-            <a:off x="4383584" y="3406378"/>
+            <a:off x="4383584" y="3482578"/>
             <a:ext cx="3424734" cy="334963"/>
           </a:xfrm>
           <a:prstGeom prst="roundRect">
@@ -6644,7 +6644,7 @@
         </p:nvSpPr>
         <p:spPr>
           <a:xfrm>
-            <a:off x="4497884" y="3822541"/>
+            <a:off x="4497884" y="3898741"/>
             <a:ext cx="3215184" cy="206375"/>
           </a:xfrm>
           <a:prstGeom prst="rect">
@@ -6686,7 +6686,7 @@
         </p:nvSpPr>
         <p:spPr>
           <a:xfrm>
-            <a:off x="7941667" y="3400028"/>
+            <a:off x="7941667" y="3476228"/>
             <a:ext cx="3437434" cy="1144587"/>
           </a:xfrm>
           <a:prstGeom prst="roundRect">
@@ -6713,7 +6713,7 @@
         </p:nvSpPr>
         <p:spPr>
           <a:xfrm>
-            <a:off x="7948017" y="3406378"/>
+            <a:off x="7948017" y="3482578"/>
             <a:ext cx="3424734" cy="334963"/>
           </a:xfrm>
           <a:prstGeom prst="roundRect">
@@ -6759,7 +6759,7 @@
         </p:nvSpPr>
         <p:spPr>
           <a:xfrm>
-            <a:off x="8062317" y="3822541"/>
+            <a:off x="8062317" y="3898741"/>
             <a:ext cx="3215184" cy="412750"/>
           </a:xfrm>
           <a:prstGeom prst="rect">
@@ -6795,66 +6795,13 @@
       </p:sp>
       <p:sp>
         <p:nvSpPr>
-          <p:cNvPr id="27" name="Transplante hepático (UFRJ): em 19 pacie"/>
-          <p:cNvSpPr txBox="1"/>
-          <p:nvPr/>
-        </p:nvSpPr>
-        <p:spPr>
-          <a:xfrm>
-            <a:off x="812800" y="4674235"/>
-            <a:ext cx="10585450" cy="642938"/>
-          </a:xfrm>
-          <a:prstGeom prst="rect">
-            <a:avLst/>
-          </a:prstGeom>
-          <a:noFill/>
-          <a:ln/>
-        </p:spPr>
-        <p:txBody>
-          <a:bodyPr wrap="square" lIns="0" tIns="0" rIns="0" bIns="0" rtlCol="0" anchor="t"/>
-          <a:lstStyle/>
-          <a:p>
-            <a:pPr algn="l" indent="0" marL="0">
-              <a:lnSpc>
-                <a:spcPts val="1688"/>
-              </a:lnSpc>
-              <a:buNone/>
-            </a:pPr>
-            <a:r>
-              <a:rPr lang="pt-BR" altLang="en-US" sz="1250" b="1" dirty="0">
-                <a:solidFill>
-                  <a:srgbClr val="2C3A48"/>
-                </a:solidFill>
-                <a:latin typeface="Calibri" pitchFamily="34" charset="0"/>
-                <a:ea typeface="Calibri" pitchFamily="34" charset="-122"/>
-                <a:cs typeface="Calibri" pitchFamily="34" charset="-120"/>
-              </a:rPr>
-              <a:t>Transplante hepático (UFRJ):</a:t>
-            </a:r>
-            <a:r>
-              <a:rPr lang="pt-BR" altLang="en-US" sz="1250" dirty="0">
-                <a:solidFill>
-                  <a:srgbClr val="2C3A48"/>
-                </a:solidFill>
-                <a:latin typeface="Calibri" pitchFamily="34" charset="0"/>
-                <a:ea typeface="Calibri" pitchFamily="34" charset="-122"/>
-                <a:cs typeface="Calibri" pitchFamily="34" charset="-120"/>
-              </a:rPr>
-              <a:t> em 19 pacientes selecionados, a função sistólica do VD ao ETE manteve-se preservada nos momentos avaliados, inclusive 30 min após a reperfusão. O estudo não mediu os primeiros minutos da reperfusão nem a causa da instabilidade aguda; a lição é usar o eco para separar disfunção de VD de vasoplegia antes de escolher entre inotrópico e vasopressor (Gouvêa et al., PLoS One 2022).</a:t>
-            </a:r>
-            <a:endParaRPr lang="en-US" sz="1250" dirty="0"/>
-          </a:p>
-        </p:txBody>
-      </p:sp>
-      <p:sp>
-        <p:nvSpPr>
-          <p:cNvPr id="28" name="A droga certa corrige o componente da PA"/>
-          <p:cNvSpPr txBox="1"/>
-          <p:nvPr/>
-        </p:nvSpPr>
-        <p:spPr>
-          <a:xfrm>
-            <a:off x="803275" y="5459143"/>
+          <p:cNvPr id="27" name="A droga certa corrige o componente da PA"/>
+          <p:cNvSpPr txBox="1"/>
+          <p:nvPr/>
+        </p:nvSpPr>
+        <p:spPr>
+          <a:xfrm>
+            <a:off x="803275" y="4790805"/>
             <a:ext cx="10585450" cy="247650"/>
           </a:xfrm>
           <a:prstGeom prst="rect">
@@ -6890,7 +6837,7 @@
       </p:sp>
       <p:sp>
         <p:nvSpPr>
-          <p:cNvPr id="29" name="Gouvêa, PLoS One 2022 · SSC 2026 · Hajja"/>
+          <p:cNvPr id="28" name="SSC 2026 · Hajjar, Anesthesiology 2017 ("/>
           <p:cNvSpPr txBox="1"/>
           <p:nvPr/>
         </p:nvSpPr>
@@ -6924,7 +6871,7 @@
                 <a:ea typeface="Calibri" pitchFamily="34" charset="-122"/>
                 <a:cs typeface="Calibri" pitchFamily="34" charset="-120"/>
               </a:rPr>
-              <a:t>Gouvêa, PLoS One 2022 · SSC 2026 · Hajjar, Anesthesiology 2017 (VANCS) · Miller’s Anesthesia, 10ª ed. (2025), cap. 16, 33, 56, 79</a:t>
+              <a:t>SSC 2026 · Hajjar, Anesthesiology 2017 (VANCS) · Miller’s Anesthesia, 10ª ed. (2025), cap. 16, 33, 56, 79</a:t>
             </a:r>
             <a:endParaRPr lang="en-US" sz="1200" dirty="0"/>
           </a:p>
@@ -6932,7 +6879,7 @@
       </p:sp>
       <p:pic>
         <p:nvPicPr>
-          <p:cNvPr id="30" name="Símbolo da UFRJ" descr="Símbolo da UFRJ">    </p:cNvPr>
+          <p:cNvPr id="29" name="Símbolo da UFRJ" descr="Símbolo da UFRJ">    </p:cNvPr>
           <p:cNvPicPr>
             <a:picLocks noChangeAspect="1"/>
           </p:cNvPicPr>

</xml_diff>